<commit_message>
feat: expand homepage and integrate founder mark
</commit_message>
<xml_diff>
--- a/public/materials/LRWA_Seed_Deck.pptx
+++ b/public/materials/LRWA_Seed_Deck.pptx
@@ -2,20 +2,20 @@
 <file path=ppt/presentation.xml><?xml version="1.0" encoding="utf-8"?>
 <p:presentation xmlns:p="http://schemas.openxmlformats.org/presentationml/2006/main">
   <p:sldMasterIdLst>
-    <p:sldMasterId xmlns:r="http://schemas.openxmlformats.org/officeDocument/2006/relationships" id="2147483648" r:id="Re33a4362675140db"/>
+    <p:sldMasterId xmlns:r="http://schemas.openxmlformats.org/officeDocument/2006/relationships" id="2147483648" r:id="R78d87bf24adc439f"/>
   </p:sldMasterIdLst>
   <p:notesMasterIdLst>
-    <p:notesMasterId xmlns:r="http://schemas.openxmlformats.org/officeDocument/2006/relationships" r:id="Rcdae09e78ff14079"/>
+    <p:notesMasterId xmlns:r="http://schemas.openxmlformats.org/officeDocument/2006/relationships" r:id="R55a4e5799406439a"/>
   </p:notesMasterIdLst>
   <p:sldIdLst>
-    <p:sldId xmlns:r="http://schemas.openxmlformats.org/officeDocument/2006/relationships" id="256" r:id="R829cc86e5a8b4b79"/>
-    <p:sldId xmlns:r="http://schemas.openxmlformats.org/officeDocument/2006/relationships" id="257" r:id="Rc1eaad2819854f0e"/>
-    <p:sldId xmlns:r="http://schemas.openxmlformats.org/officeDocument/2006/relationships" id="258" r:id="R7212dfae92c8498e"/>
-    <p:sldId xmlns:r="http://schemas.openxmlformats.org/officeDocument/2006/relationships" id="259" r:id="Rae66e301a3e047b9"/>
-    <p:sldId xmlns:r="http://schemas.openxmlformats.org/officeDocument/2006/relationships" id="260" r:id="Re1ffb3783c924683"/>
-    <p:sldId xmlns:r="http://schemas.openxmlformats.org/officeDocument/2006/relationships" id="261" r:id="R2b223ba4f6b54ffb"/>
-    <p:sldId xmlns:r="http://schemas.openxmlformats.org/officeDocument/2006/relationships" id="262" r:id="R4628a559de9f40f5"/>
-    <p:sldId xmlns:r="http://schemas.openxmlformats.org/officeDocument/2006/relationships" id="263" r:id="R2be8f82db1804efb"/>
+    <p:sldId xmlns:r="http://schemas.openxmlformats.org/officeDocument/2006/relationships" id="256" r:id="Rc5008b5ed46143cd"/>
+    <p:sldId xmlns:r="http://schemas.openxmlformats.org/officeDocument/2006/relationships" id="257" r:id="Rfcbc3e9ccb4142c4"/>
+    <p:sldId xmlns:r="http://schemas.openxmlformats.org/officeDocument/2006/relationships" id="258" r:id="R984f8158e977487b"/>
+    <p:sldId xmlns:r="http://schemas.openxmlformats.org/officeDocument/2006/relationships" id="259" r:id="R55353ca8d3df4ec7"/>
+    <p:sldId xmlns:r="http://schemas.openxmlformats.org/officeDocument/2006/relationships" id="260" r:id="Rbb5044b07394407a"/>
+    <p:sldId xmlns:r="http://schemas.openxmlformats.org/officeDocument/2006/relationships" id="261" r:id="R84c6221509ae425f"/>
+    <p:sldId xmlns:r="http://schemas.openxmlformats.org/officeDocument/2006/relationships" id="262" r:id="R431fdaa429304176"/>
+    <p:sldId xmlns:r="http://schemas.openxmlformats.org/officeDocument/2006/relationships" id="263" r:id="Ref604c7a0f0d457a"/>
   </p:sldIdLst>
   <p:sldSz cx="12192000" cy="6858000"/>
   <p:notesSz cx="6858000" cy="9144000"/>
@@ -477,6 +477,11 @@
               <a:t>- Founder and financing details intentionally omitted from this public deck.</a:t>
             </a:r>
           </a:p>
+          <a:p xmlns:a="http://schemas.openxmlformats.org/drawingml/2006/main">
+            <a:r>
+              <a:t>- User-provided LRWA brand asset: favicon.svg</a:t>
+            </a:r>
+          </a:p>
         </p:txBody>
       </p:sp>
       <p:sp>
@@ -544,7 +549,7 @@
           <a:lstStyle xmlns:a="http://schemas.openxmlformats.org/drawingml/2006/main"/>
           <a:p xmlns:a="http://schemas.openxmlformats.org/drawingml/2006/main">
             <a:r>
-              <a:t>A financial model can test whether numbers are internally consistent. It cannot independently establish whether stores are operating, customers are buying, suppliers are replenishing, or field behavior matches management's narrative. Teams assemble those signals manually under deal pressure, and the reasoning is difficult to rerun when a new question appears.</a:t>
+              <a:t>A financial model can test whether numbers are internally consistent. It cannot establish whether stores are operating, customers are buying, suppliers are replenishing, or field behavior matches management's narrative. Teams assemble those outside signals manually under deal pressure, and the reasoning is difficult to rerun when a new question appears.</a:t>
             </a:r>
           </a:p>
           <a:p xmlns:a="http://schemas.openxmlformats.org/drawingml/2006/main">
@@ -565,6 +570,11 @@
           <a:p xmlns:a="http://schemas.openxmlformats.org/drawingml/2006/main">
             <a:r>
               <a:t>- No market-size, time-saved, or cost-saved statistics are asserted.</a:t>
+            </a:r>
+          </a:p>
+          <a:p xmlns:a="http://schemas.openxmlformats.org/drawingml/2006/main">
+            <a:r>
+              <a:t>- User-provided LRWA brand asset: favicon.svg</a:t>
             </a:r>
           </a:p>
         </p:txBody>
@@ -634,7 +644,7 @@
           <a:lstStyle xmlns:a="http://schemas.openxmlformats.org/drawingml/2006/main"/>
           <a:p xmlns:a="http://schemas.openxmlformats.org/drawingml/2006/main">
             <a:r>
-              <a:t>LRWA compiles four declared operating metrics into 1,024 bounded probes across five independent evidence families. Specialist agents execute those tasks in an approved synthetic environment. The system records provenance, exposes uncertainty, and asks a human before the Skeptic's 20% corporate-order hypothesis changes the replay. The result remains unsupported after the gap narrows from 42.3% to 27.9%.</a:t>
+              <a:t>LRWA compiles four declared operating metrics into a planned aggregate quota of 1,024 parameterized probes across five logical evidence categories. The current synthetic demo produces five aggregate evidence receipts, one per category; it does not persist 1,024 raw observations, and the categories' statistical independence has not been established. The initial fixed scenario band is ¥1.72m to ¥2.14m with a heuristic policy score of 0.88. A separate unauthenticated UI/API interaction gate applies the preconfigured 20% corporate-order counterfactual; it is not identity-verified compliance approval. The fixed replay band is ¥2.12m to ¥2.72m with a heuristic policy score of 0.82. The result remains unsupported after the gap narrows from 42.3% to 27.9%.</a:t>
             </a:r>
           </a:p>
           <a:p xmlns:a="http://schemas.openxmlformats.org/drawingml/2006/main">
@@ -660,6 +670,11 @@
           <a:p xmlns:a="http://schemas.openxmlformats.org/drawingml/2006/main">
             <a:r>
               <a:t>- All displayed Morrow Coffee data is synthetic and illustrative.</a:t>
+            </a:r>
+          </a:p>
+          <a:p xmlns:a="http://schemas.openxmlformats.org/drawingml/2006/main">
+            <a:r>
+              <a:t>- User-provided LRWA brand asset: favicon.svg</a:t>
             </a:r>
           </a:p>
         </p:txBody>
@@ -729,7 +744,7 @@
           <a:lstStyle xmlns:a="http://schemas.openxmlformats.org/drawingml/2006/main"/>
           <a:p xmlns:a="http://schemas.openxmlformats.org/drawingml/2006/main">
             <a:r>
-              <a:t>The model is not the moat. The compounding layer is the system that maps a business claim into a valid sampling plan, preserves methodology and content hashes, and calibrates conclusions across independent evidence families. In the shipped synthetic case, the Skeptic proposes one falsifiable missing channel and a human must approve the deterministic replay.</a:t>
+              <a:t>The model is not the moat. The current demo maps a business claim into a declared aggregate sampling quota and preserves methodology and content hashes across five aggregate receipts. Five logical evidence categories feed the deterministic fixture; their statistical independence has not been established. The Skeptic presents a preconfigured missing-channel counterfactual, and a separate unauthenticated UI/API interaction starts the deterministic replay. Identity-verified approval remains a production requirement.</a:t>
             </a:r>
           </a:p>
           <a:p xmlns:a="http://schemas.openxmlformats.org/drawingml/2006/main">
@@ -744,7 +759,7 @@
           </a:p>
           <a:p xmlns:a="http://schemas.openxmlformats.org/drawingml/2006/main">
             <a:r>
-              <a:t>- System description and five evidence families: outputs/PITCH_DECK_OUTLINE.md</a:t>
+              <a:t>- System description and five evidence categories: outputs/PITCH_DECK_OUTLINE.md</a:t>
             </a:r>
           </a:p>
           <a:p xmlns:a="http://schemas.openxmlformats.org/drawingml/2006/main">
@@ -755,6 +770,11 @@
           <a:p xmlns:a="http://schemas.openxmlformats.org/drawingml/2006/main">
             <a:r>
               <a:t>- Backend behavior and audit events: lrwa-agent source repository.</a:t>
+            </a:r>
+          </a:p>
+          <a:p xmlns:a="http://schemas.openxmlformats.org/drawingml/2006/main">
+            <a:r>
+              <a:t>- User-provided LRWA brand asset: favicon.svg</a:t>
             </a:r>
           </a:p>
         </p:txBody>
@@ -852,6 +872,11 @@
               <a:t>- Design partner, paid mission, and portfolio expansion are go-to-market targets, not current traction.</a:t>
             </a:r>
           </a:p>
+          <a:p xmlns:a="http://schemas.openxmlformats.org/drawingml/2006/main">
+            <a:r>
+              <a:t>- User-provided LRWA brand asset: favicon.svg</a:t>
+            </a:r>
+          </a:p>
         </p:txBody>
       </p:sp>
       <p:sp>
@@ -947,6 +972,11 @@
               <a:t>- No competitor exclusivity or market-size claim is asserted.</a:t>
             </a:r>
           </a:p>
+          <a:p xmlns:a="http://schemas.openxmlformats.org/drawingml/2006/main">
+            <a:r>
+              <a:t>- User-provided LRWA brand asset: favicon.svg</a:t>
+            </a:r>
+          </a:p>
         </p:txBody>
       </p:sp>
       <p:sp>
@@ -1042,6 +1072,11 @@
               <a:t>- No pricing, recurring revenue, or customer renewal claim is asserted.</a:t>
             </a:r>
           </a:p>
+          <a:p xmlns:a="http://schemas.openxmlformats.org/drawingml/2006/main">
+            <a:r>
+              <a:t>- User-provided LRWA brand asset: favicon.svg</a:t>
+            </a:r>
+          </a:p>
         </p:txBody>
       </p:sp>
       <p:sp>
@@ -1135,6 +1170,11 @@
           <a:p xmlns:a="http://schemas.openxmlformats.org/drawingml/2006/main">
             <a:r>
               <a:t>- Design partners, paid pilot, and connector are target milestones, not current traction.</a:t>
+            </a:r>
+          </a:p>
+          <a:p xmlns:a="http://schemas.openxmlformats.org/drawingml/2006/main">
+            <a:r>
+              <a:t>- User-provided LRWA brand asset: favicon.svg</a:t>
             </a:r>
           </a:p>
         </p:txBody>
@@ -1202,7 +1242,7 @@
   </p:cSld>
   <p:clrMap bg1="lt1" tx1="dk1" bg2="lt2" tx2="dk2" accent1="accent1" accent2="accent2" accent3="accent3" accent4="accent4" accent5="accent5" accent6="accent6" hlink="hlink" folHlink="folHlink"/>
   <p:sldLayoutIdLst>
-    <p:sldLayoutId xmlns:r="http://schemas.openxmlformats.org/officeDocument/2006/relationships" id="2147483649" r:id="Rcad7a04393bf4430"/>
+    <p:sldLayoutId xmlns:r="http://schemas.openxmlformats.org/officeDocument/2006/relationships" id="2147483649" r:id="Rbf2d23e80f4d4b95"/>
   </p:sldLayoutIdLst>
   <p:txStyles>
     <p:titleStyle>
@@ -1757,7 +1797,7 @@
           <p:nvPr/>
         </p:nvPicPr>
         <p:blipFill>
-          <a:blip xmlns:r="http://schemas.openxmlformats.org/officeDocument/2006/relationships" xmlns:a="http://schemas.openxmlformats.org/drawingml/2006/main" r:embed="R8a66335ade7f48c2"/>
+          <a:blip xmlns:r="http://schemas.openxmlformats.org/officeDocument/2006/relationships" xmlns:a="http://schemas.openxmlformats.org/drawingml/2006/main" r:embed="Rc13c2659b2f04a7d"/>
           <a:srcRect xmlns:a="http://schemas.openxmlformats.org/drawingml/2006/main" l="0" t="27" r="0" b="27"/>
           <a:stretch xmlns:a="http://schemas.openxmlformats.org/drawingml/2006/main">
             <a:fillRect l="0" t="0" r="0" b="0"/>
@@ -1778,7 +1818,7 @@
           <p:cNvPr id="2" name="">
             <a:extLst xmlns:a="http://schemas.openxmlformats.org/drawingml/2006/main">
               <a:ext uri="{FF2B5EF4-FFF2-40B4-BE49-F238E27FC236}">
-                <a16:creationId xmlns:a16="http://schemas.microsoft.com/office/drawing/2014/main" id="{4342FC43-CEAB-4795-8A58-7E8E81B96846}"/>
+                <a16:creationId xmlns:a16="http://schemas.microsoft.com/office/drawing/2014/main" id="{4332B4AF-3E97-470C-A91A-B2E34DA8AA3D}"/>
               </a:ext>
             </a:extLst>
           </p:cNvPr>
@@ -1819,57 +1859,52 @@
           </a:ln>
         </p:spPr>
       </p:sp>
-      <p:sp>
-        <p:nvSpPr>
-          <p:cNvPr id="3" name="">
-            <a:extLst xmlns:a="http://schemas.openxmlformats.org/drawingml/2006/main">
-              <a:ext uri="{FF2B5EF4-FFF2-40B4-BE49-F238E27FC236}">
-                <a16:creationId xmlns:a16="http://schemas.microsoft.com/office/drawing/2014/main" id="{83380293-04CE-4F5D-ACD8-B15DDF8413BB}"/>
-              </a:ext>
-            </a:extLst>
-          </p:cNvPr>
-          <p:cNvSpPr>
-            <a:spLocks xmlns:a="http://schemas.openxmlformats.org/drawingml/2006/main" noGrp="1"/>
-          </p:cNvSpPr>
-          <p:nvPr/>
-        </p:nvSpPr>
-        <p:spPr>
-          <a:xfrm xmlns:a="http://schemas.openxmlformats.org/drawingml/2006/main" rot="0">
-            <a:off x="647700" y="542925"/>
-            <a:ext cx="76200" cy="76200"/>
-          </a:xfrm>
-          <a:prstGeom xmlns:a="http://schemas.openxmlformats.org/drawingml/2006/main" prst="rect">
-            <a:avLst/>
-          </a:prstGeom>
-          <a:solidFill xmlns:a="http://schemas.openxmlformats.org/drawingml/2006/main">
-            <a:srgbClr val="FF5B22"/>
-          </a:solidFill>
-          <a:ln xmlns:a="http://schemas.openxmlformats.org/drawingml/2006/main" w="0">
-            <a:solidFill>
-              <a:srgbClr val="FF5B22"/>
-            </a:solidFill>
-            <a:prstDash val="solid"/>
-          </a:ln>
-        </p:spPr>
-      </p:sp>
+      <p:pic>
+        <p:nvPicPr>
+          <p:cNvPr id="13" name=""/>
+          <p:cNvPicPr>
+            <a:picLocks xmlns:a="http://schemas.openxmlformats.org/drawingml/2006/main" noChangeAspect="1"/>
+          </p:cNvPicPr>
+          <p:nvPr/>
+        </p:nvPicPr>
+        <p:blipFill>
+          <a:blip xmlns:r="http://schemas.openxmlformats.org/officeDocument/2006/relationships" xmlns:a="http://schemas.openxmlformats.org/drawingml/2006/main" r:embed="Rc253a96c3ea1495f">
+            <a:extLst>
+              <a:ext uri="{96DAC541-7B7A-43D3-8B79-37D633B846F1}">
+                <asvg:svgBlip xmlns:asvg="http://schemas.microsoft.com/office/drawing/2016/SVG/main" r:embed="Ref280438f2064b23"/>
+              </a:ext>
+            </a:extLst>
+          </a:blip>
+          <a:stretch xmlns:a="http://schemas.openxmlformats.org/drawingml/2006/main"/>
+        </p:blipFill>
+        <p:spPr>
+          <a:xfrm xmlns:a="http://schemas.openxmlformats.org/drawingml/2006/main">
+            <a:off x="647700" y="428625"/>
+            <a:ext cx="419100" cy="419100"/>
+          </a:xfrm>
+          <a:prstGeom xmlns:a="http://schemas.openxmlformats.org/drawingml/2006/main" prst="rect">
+            <a:avLst/>
+          </a:prstGeom>
+        </p:spPr>
+      </p:pic>
       <p:sp>
         <p:nvSpPr>
           <p:cNvPr id="4" name="">
             <a:extLst xmlns:a="http://schemas.openxmlformats.org/drawingml/2006/main">
               <a:ext uri="{FF2B5EF4-FFF2-40B4-BE49-F238E27FC236}">
-                <a16:creationId xmlns:a16="http://schemas.microsoft.com/office/drawing/2014/main" id="{ED19A04E-82D7-48AE-98BB-C67FF210863C}"/>
-              </a:ext>
-            </a:extLst>
-          </p:cNvPr>
-          <p:cNvSpPr>
-            <a:spLocks xmlns:a="http://schemas.openxmlformats.org/drawingml/2006/main" noGrp="1"/>
-          </p:cNvSpPr>
-          <p:nvPr/>
-        </p:nvSpPr>
-        <p:spPr>
-          <a:xfrm xmlns:a="http://schemas.openxmlformats.org/drawingml/2006/main" rot="0">
-            <a:off x="819150" y="514350"/>
-            <a:ext cx="4476750" cy="209550"/>
+                <a16:creationId xmlns:a16="http://schemas.microsoft.com/office/drawing/2014/main" id="{2294A36D-21E3-400D-8F9F-889DD3A386FC}"/>
+              </a:ext>
+            </a:extLst>
+          </p:cNvPr>
+          <p:cNvSpPr>
+            <a:spLocks xmlns:a="http://schemas.openxmlformats.org/drawingml/2006/main" noGrp="1"/>
+          </p:cNvSpPr>
+          <p:nvPr/>
+        </p:nvSpPr>
+        <p:spPr>
+          <a:xfrm xmlns:a="http://schemas.openxmlformats.org/drawingml/2006/main" rot="0">
+            <a:off x="1200150" y="542925"/>
+            <a:ext cx="3429000" cy="209550"/>
           </a:xfrm>
           <a:prstGeom xmlns:a="http://schemas.openxmlformats.org/drawingml/2006/main" prst="rect">
             <a:avLst/>
@@ -1915,7 +1950,7 @@
           <p:cNvPr id="5" name="">
             <a:extLst xmlns:a="http://schemas.openxmlformats.org/drawingml/2006/main">
               <a:ext uri="{FF2B5EF4-FFF2-40B4-BE49-F238E27FC236}">
-                <a16:creationId xmlns:a16="http://schemas.microsoft.com/office/drawing/2014/main" id="{1C7D768D-F9DD-43AF-B9D5-B0B009F841FD}"/>
+                <a16:creationId xmlns:a16="http://schemas.microsoft.com/office/drawing/2014/main" id="{564758E1-D6A3-4721-90D0-B409FF387082}"/>
               </a:ext>
             </a:extLst>
           </p:cNvPr>
@@ -1977,7 +2012,7 @@
           <p:cNvPr id="6" name="">
             <a:extLst xmlns:a="http://schemas.openxmlformats.org/drawingml/2006/main">
               <a:ext uri="{FF2B5EF4-FFF2-40B4-BE49-F238E27FC236}">
-                <a16:creationId xmlns:a16="http://schemas.microsoft.com/office/drawing/2014/main" id="{0905FE68-4C8F-4987-BB0A-1E8944C4E9D1}"/>
+                <a16:creationId xmlns:a16="http://schemas.microsoft.com/office/drawing/2014/main" id="{3AF6BC12-2AC1-4FBD-A295-1D255A824DE2}"/>
               </a:ext>
             </a:extLst>
           </p:cNvPr>
@@ -2066,7 +2101,7 @@
           <p:cNvPr id="7" name="">
             <a:extLst xmlns:a="http://schemas.openxmlformats.org/drawingml/2006/main">
               <a:ext uri="{FF2B5EF4-FFF2-40B4-BE49-F238E27FC236}">
-                <a16:creationId xmlns:a16="http://schemas.microsoft.com/office/drawing/2014/main" id="{E9EA64E3-4E96-4269-BB99-9306AF20CCF7}"/>
+                <a16:creationId xmlns:a16="http://schemas.microsoft.com/office/drawing/2014/main" id="{67B5A8C7-21A8-49CB-A380-B3C580285800}"/>
               </a:ext>
             </a:extLst>
           </p:cNvPr>
@@ -2124,7 +2159,7 @@
           <p:cNvPr id="8" name="">
             <a:extLst xmlns:a="http://schemas.openxmlformats.org/drawingml/2006/main">
               <a:ext uri="{FF2B5EF4-FFF2-40B4-BE49-F238E27FC236}">
-                <a16:creationId xmlns:a16="http://schemas.microsoft.com/office/drawing/2014/main" id="{54C002A2-86AC-4C07-B88E-C23EF76958A7}"/>
+                <a16:creationId xmlns:a16="http://schemas.microsoft.com/office/drawing/2014/main" id="{CFA4FF81-0C67-43D6-BB1A-EED01AF949CA}"/>
               </a:ext>
             </a:extLst>
           </p:cNvPr>
@@ -2155,7 +2190,7 @@
           <p:cNvPr id="9" name="">
             <a:extLst xmlns:a="http://schemas.openxmlformats.org/drawingml/2006/main">
               <a:ext uri="{FF2B5EF4-FFF2-40B4-BE49-F238E27FC236}">
-                <a16:creationId xmlns:a16="http://schemas.microsoft.com/office/drawing/2014/main" id="{6F679558-6054-45A3-B11D-72EA74E37AAC}"/>
+                <a16:creationId xmlns:a16="http://schemas.microsoft.com/office/drawing/2014/main" id="{87E900D5-5D04-435B-84F4-4D4ABCB423CE}"/>
               </a:ext>
             </a:extLst>
           </p:cNvPr>
@@ -2213,7 +2248,7 @@
           <p:cNvPr id="10" name="">
             <a:extLst xmlns:a="http://schemas.openxmlformats.org/drawingml/2006/main">
               <a:ext uri="{FF2B5EF4-FFF2-40B4-BE49-F238E27FC236}">
-                <a16:creationId xmlns:a16="http://schemas.microsoft.com/office/drawing/2014/main" id="{067C3EF2-2EE8-4A97-9914-DB0D734DFC66}"/>
+                <a16:creationId xmlns:a16="http://schemas.microsoft.com/office/drawing/2014/main" id="{D76A491D-1FFA-428B-8092-F249A1E47C5C}"/>
               </a:ext>
             </a:extLst>
           </p:cNvPr>
@@ -2269,7 +2304,7 @@
     </p:spTree>
     <p:extLst>
       <p:ext uri="{BB962C8B-B14F-4D97-AF65-F5344CB8AC3E}">
-        <p14:creationId xmlns:p14="http://schemas.microsoft.com/office/powerpoint/2010/main" val="25056797"/>
+        <p14:creationId xmlns:p14="http://schemas.microsoft.com/office/powerpoint/2010/main" val="1493684667"/>
       </p:ext>
     </p:extLst>
   </p:cSld>
@@ -2297,10 +2332,10 @@
       </p:grpSpPr>
       <p:sp>
         <p:nvSpPr>
-          <p:cNvPr id="29" name="">
-            <a:extLst xmlns:a="http://schemas.openxmlformats.org/drawingml/2006/main">
-              <a:ext uri="{FF2B5EF4-FFF2-40B4-BE49-F238E27FC236}">
-                <a16:creationId xmlns:a16="http://schemas.microsoft.com/office/drawing/2014/main" id="{D1220DD2-BD79-4426-89F1-E3DA76B577D8}"/>
+          <p:cNvPr id="30" name="">
+            <a:extLst xmlns:a="http://schemas.openxmlformats.org/drawingml/2006/main">
+              <a:ext uri="{FF2B5EF4-FFF2-40B4-BE49-F238E27FC236}">
+                <a16:creationId xmlns:a16="http://schemas.microsoft.com/office/drawing/2014/main" id="{64CD463A-00EF-4280-B3CE-DC196C0E065B}"/>
               </a:ext>
             </a:extLst>
           </p:cNvPr>
@@ -2333,7 +2368,7 @@
           <p:cNvPr id="2" name="">
             <a:extLst xmlns:a="http://schemas.openxmlformats.org/drawingml/2006/main">
               <a:ext uri="{FF2B5EF4-FFF2-40B4-BE49-F238E27FC236}">
-                <a16:creationId xmlns:a16="http://schemas.microsoft.com/office/drawing/2014/main" id="{06E6B4B1-DBBC-4AC6-8971-B0C1CBC19019}"/>
+                <a16:creationId xmlns:a16="http://schemas.microsoft.com/office/drawing/2014/main" id="{E26DA48C-8F6B-4635-9455-D6A2BE436237}"/>
               </a:ext>
             </a:extLst>
           </p:cNvPr>
@@ -2381,7 +2416,7 @@
                 <a:ea typeface="Courier New"/>
                 <a:cs typeface="Courier New"/>
               </a:rPr>
-              <a:t>LRWA / THE DECISION GAP</a:t>
+              <a:t>THE DECISION GAP</a:t>
             </a:r>
           </a:p>
         </p:txBody>
@@ -2391,7 +2426,7 @@
           <p:cNvPr id="3" name="">
             <a:extLst xmlns:a="http://schemas.openxmlformats.org/drawingml/2006/main">
               <a:ext uri="{FF2B5EF4-FFF2-40B4-BE49-F238E27FC236}">
-                <a16:creationId xmlns:a16="http://schemas.microsoft.com/office/drawing/2014/main" id="{0DF82DD8-2144-484A-B35C-5386366678BF}"/>
+                <a16:creationId xmlns:a16="http://schemas.microsoft.com/office/drawing/2014/main" id="{1F9959EC-2F2E-4C29-A240-7E2DE2A2701E}"/>
               </a:ext>
             </a:extLst>
           </p:cNvPr>
@@ -2449,7 +2484,7 @@
           <p:cNvPr id="4" name="">
             <a:extLst xmlns:a="http://schemas.openxmlformats.org/drawingml/2006/main">
               <a:ext uri="{FF2B5EF4-FFF2-40B4-BE49-F238E27FC236}">
-                <a16:creationId xmlns:a16="http://schemas.microsoft.com/office/drawing/2014/main" id="{54FD3278-BA8A-4E7C-9C4B-D9A2783A89E7}"/>
+                <a16:creationId xmlns:a16="http://schemas.microsoft.com/office/drawing/2014/main" id="{53291B57-D2D0-48D3-B9D5-6A79E4FEFA88}"/>
               </a:ext>
             </a:extLst>
           </p:cNvPr>
@@ -2475,24 +2510,52 @@
           </a:ln>
         </p:spPr>
       </p:sp>
-      <p:sp>
-        <p:nvSpPr>
-          <p:cNvPr id="5" name="">
-            <a:extLst xmlns:a="http://schemas.openxmlformats.org/drawingml/2006/main">
-              <a:ext uri="{FF2B5EF4-FFF2-40B4-BE49-F238E27FC236}">
-                <a16:creationId xmlns:a16="http://schemas.microsoft.com/office/drawing/2014/main" id="{5731C8EA-7536-48FC-A266-806FD932E3BC}"/>
-              </a:ext>
-            </a:extLst>
-          </p:cNvPr>
-          <p:cNvSpPr>
-            <a:spLocks xmlns:a="http://schemas.openxmlformats.org/drawingml/2006/main" noGrp="1"/>
-          </p:cNvSpPr>
-          <p:nvPr/>
-        </p:nvSpPr>
-        <p:spPr>
-          <a:xfrm xmlns:a="http://schemas.openxmlformats.org/drawingml/2006/main" rot="0">
-            <a:off x="609600" y="6562725"/>
-            <a:ext cx="2857500" cy="133350"/>
+      <p:pic>
+        <p:nvPicPr>
+          <p:cNvPr id="34" name=""/>
+          <p:cNvPicPr>
+            <a:picLocks xmlns:a="http://schemas.openxmlformats.org/drawingml/2006/main" noChangeAspect="1"/>
+          </p:cNvPicPr>
+          <p:nvPr/>
+        </p:nvPicPr>
+        <p:blipFill>
+          <a:blip xmlns:r="http://schemas.openxmlformats.org/officeDocument/2006/relationships" xmlns:a="http://schemas.openxmlformats.org/drawingml/2006/main" r:embed="R365dd1a019ea4f1d">
+            <a:extLst>
+              <a:ext uri="{96DAC541-7B7A-43D3-8B79-37D633B846F1}">
+                <asvg:svgBlip xmlns:asvg="http://schemas.microsoft.com/office/drawing/2016/SVG/main" r:embed="Rb9ad23a168414061"/>
+              </a:ext>
+            </a:extLst>
+          </a:blip>
+          <a:stretch xmlns:a="http://schemas.openxmlformats.org/drawingml/2006/main"/>
+        </p:blipFill>
+        <p:spPr>
+          <a:xfrm xmlns:a="http://schemas.openxmlformats.org/drawingml/2006/main">
+            <a:off x="609600" y="6524625"/>
+            <a:ext cx="171450" cy="171450"/>
+          </a:xfrm>
+          <a:prstGeom xmlns:a="http://schemas.openxmlformats.org/drawingml/2006/main" prst="rect">
+            <a:avLst/>
+          </a:prstGeom>
+        </p:spPr>
+      </p:pic>
+      <p:sp>
+        <p:nvSpPr>
+          <p:cNvPr id="6" name="">
+            <a:extLst xmlns:a="http://schemas.openxmlformats.org/drawingml/2006/main">
+              <a:ext uri="{FF2B5EF4-FFF2-40B4-BE49-F238E27FC236}">
+                <a16:creationId xmlns:a16="http://schemas.microsoft.com/office/drawing/2014/main" id="{13832000-5BEE-4C3A-85D2-C699A2B7CAC7}"/>
+              </a:ext>
+            </a:extLst>
+          </p:cNvPr>
+          <p:cNvSpPr>
+            <a:spLocks xmlns:a="http://schemas.openxmlformats.org/drawingml/2006/main" noGrp="1"/>
+          </p:cNvSpPr>
+          <p:nvPr/>
+        </p:nvSpPr>
+        <p:spPr>
+          <a:xfrm xmlns:a="http://schemas.openxmlformats.org/drawingml/2006/main" rot="0">
+            <a:off x="857250" y="6562725"/>
+            <a:ext cx="3238500" cy="133350"/>
           </a:xfrm>
           <a:prstGeom xmlns:a="http://schemas.openxmlformats.org/drawingml/2006/main" prst="rect">
             <a:avLst/>
@@ -2528,17 +2591,17 @@
                 <a:ea typeface="Courier New"/>
                 <a:cs typeface="Courier New"/>
               </a:rPr>
-              <a:t>LIVE REAL-WORLD ASSURANCE</a:t>
-            </a:r>
-          </a:p>
-        </p:txBody>
-      </p:sp>
-      <p:sp>
-        <p:nvSpPr>
-          <p:cNvPr id="6" name="">
-            <a:extLst xmlns:a="http://schemas.openxmlformats.org/drawingml/2006/main">
-              <a:ext uri="{FF2B5EF4-FFF2-40B4-BE49-F238E27FC236}">
-                <a16:creationId xmlns:a16="http://schemas.microsoft.com/office/drawing/2014/main" id="{EBF96CA8-7172-4BEA-B4A3-DCFB7A59B11B}"/>
+              <a:t>LRWA / LIVE REAL-WORLD ASSURANCE</a:t>
+            </a:r>
+          </a:p>
+        </p:txBody>
+      </p:sp>
+      <p:sp>
+        <p:nvSpPr>
+          <p:cNvPr id="7" name="">
+            <a:extLst xmlns:a="http://schemas.openxmlformats.org/drawingml/2006/main">
+              <a:ext uri="{FF2B5EF4-FFF2-40B4-BE49-F238E27FC236}">
+                <a16:creationId xmlns:a16="http://schemas.microsoft.com/office/drawing/2014/main" id="{E716E569-3BAC-4B50-B23D-36E388248CD1}"/>
               </a:ext>
             </a:extLst>
           </p:cNvPr>
@@ -2593,10 +2656,10 @@
       </p:sp>
       <p:sp>
         <p:nvSpPr>
-          <p:cNvPr id="7" name="">
-            <a:extLst xmlns:a="http://schemas.openxmlformats.org/drawingml/2006/main">
-              <a:ext uri="{FF2B5EF4-FFF2-40B4-BE49-F238E27FC236}">
-                <a16:creationId xmlns:a16="http://schemas.microsoft.com/office/drawing/2014/main" id="{5CC86299-EF12-4222-9CCB-62652D5F4928}"/>
+          <p:cNvPr id="8" name="">
+            <a:extLst xmlns:a="http://schemas.openxmlformats.org/drawingml/2006/main">
+              <a:ext uri="{FF2B5EF4-FFF2-40B4-BE49-F238E27FC236}">
+                <a16:creationId xmlns:a16="http://schemas.microsoft.com/office/drawing/2014/main" id="{A8E5CEAC-2096-421F-A5F5-C9DA2CDF51F8}"/>
               </a:ext>
             </a:extLst>
           </p:cNvPr>
@@ -2682,10 +2745,10 @@
       </p:sp>
       <p:sp>
         <p:nvSpPr>
-          <p:cNvPr id="8" name="">
-            <a:extLst xmlns:a="http://schemas.openxmlformats.org/drawingml/2006/main">
-              <a:ext uri="{FF2B5EF4-FFF2-40B4-BE49-F238E27FC236}">
-                <a16:creationId xmlns:a16="http://schemas.microsoft.com/office/drawing/2014/main" id="{B84D0BB3-B65E-4D3D-A7E7-3CE94A8A6B2B}"/>
+          <p:cNvPr id="9" name="">
+            <a:extLst xmlns:a="http://schemas.openxmlformats.org/drawingml/2006/main">
+              <a:ext uri="{FF2B5EF4-FFF2-40B4-BE49-F238E27FC236}">
+                <a16:creationId xmlns:a16="http://schemas.microsoft.com/office/drawing/2014/main" id="{45F58F9C-C10E-40FA-887B-C334AEDACC64}"/>
               </a:ext>
             </a:extLst>
           </p:cNvPr>
@@ -2744,10 +2807,10 @@
       </p:sp>
       <p:sp>
         <p:nvSpPr>
-          <p:cNvPr id="9" name="">
-            <a:extLst xmlns:a="http://schemas.openxmlformats.org/drawingml/2006/main">
-              <a:ext uri="{FF2B5EF4-FFF2-40B4-BE49-F238E27FC236}">
-                <a16:creationId xmlns:a16="http://schemas.microsoft.com/office/drawing/2014/main" id="{888CD4F8-9E1A-41E3-B68B-988BD3D3E3C0}"/>
+          <p:cNvPr id="10" name="">
+            <a:extLst xmlns:a="http://schemas.openxmlformats.org/drawingml/2006/main">
+              <a:ext uri="{FF2B5EF4-FFF2-40B4-BE49-F238E27FC236}">
+                <a16:creationId xmlns:a16="http://schemas.microsoft.com/office/drawing/2014/main" id="{DC745E8B-03D8-456F-A0B2-32F6D4AECA18}"/>
               </a:ext>
             </a:extLst>
           </p:cNvPr>
@@ -2775,10 +2838,10 @@
       </p:sp>
       <p:sp>
         <p:nvSpPr>
-          <p:cNvPr id="10" name="">
-            <a:extLst xmlns:a="http://schemas.openxmlformats.org/drawingml/2006/main">
-              <a:ext uri="{FF2B5EF4-FFF2-40B4-BE49-F238E27FC236}">
-                <a16:creationId xmlns:a16="http://schemas.microsoft.com/office/drawing/2014/main" id="{9828B2EC-D2FA-43CB-8D62-BCC61A974F51}"/>
+          <p:cNvPr id="11" name="">
+            <a:extLst xmlns:a="http://schemas.openxmlformats.org/drawingml/2006/main">
+              <a:ext uri="{FF2B5EF4-FFF2-40B4-BE49-F238E27FC236}">
+                <a16:creationId xmlns:a16="http://schemas.microsoft.com/office/drawing/2014/main" id="{4A49B920-00D6-40B4-9DBA-CBD5F388EBCD}"/>
               </a:ext>
             </a:extLst>
           </p:cNvPr>
@@ -2833,10 +2896,10 @@
       </p:sp>
       <p:sp>
         <p:nvSpPr>
-          <p:cNvPr id="11" name="">
-            <a:extLst xmlns:a="http://schemas.openxmlformats.org/drawingml/2006/main">
-              <a:ext uri="{FF2B5EF4-FFF2-40B4-BE49-F238E27FC236}">
-                <a16:creationId xmlns:a16="http://schemas.microsoft.com/office/drawing/2014/main" id="{3CEA09B4-F985-4DF2-AB73-71D230E51CB9}"/>
+          <p:cNvPr id="12" name="">
+            <a:extLst xmlns:a="http://schemas.openxmlformats.org/drawingml/2006/main">
+              <a:ext uri="{FF2B5EF4-FFF2-40B4-BE49-F238E27FC236}">
+                <a16:creationId xmlns:a16="http://schemas.microsoft.com/office/drawing/2014/main" id="{39802B49-1612-42EA-B338-7FF95D788024}"/>
               </a:ext>
             </a:extLst>
           </p:cNvPr>
@@ -2891,10 +2954,10 @@
       </p:sp>
       <p:sp>
         <p:nvSpPr>
-          <p:cNvPr id="12" name="">
-            <a:extLst xmlns:a="http://schemas.openxmlformats.org/drawingml/2006/main">
-              <a:ext uri="{FF2B5EF4-FFF2-40B4-BE49-F238E27FC236}">
-                <a16:creationId xmlns:a16="http://schemas.microsoft.com/office/drawing/2014/main" id="{926A4087-BD06-4777-B487-771700D6F988}"/>
+          <p:cNvPr id="13" name="">
+            <a:extLst xmlns:a="http://schemas.openxmlformats.org/drawingml/2006/main">
+              <a:ext uri="{FF2B5EF4-FFF2-40B4-BE49-F238E27FC236}">
+                <a16:creationId xmlns:a16="http://schemas.microsoft.com/office/drawing/2014/main" id="{1FF511FE-6EDA-48C2-A01C-CBA78C091FE6}"/>
               </a:ext>
             </a:extLst>
           </p:cNvPr>
@@ -2949,10 +3012,10 @@
       </p:sp>
       <p:sp>
         <p:nvSpPr>
-          <p:cNvPr id="13" name="">
-            <a:extLst xmlns:a="http://schemas.openxmlformats.org/drawingml/2006/main">
-              <a:ext uri="{FF2B5EF4-FFF2-40B4-BE49-F238E27FC236}">
-                <a16:creationId xmlns:a16="http://schemas.microsoft.com/office/drawing/2014/main" id="{466A74BD-A89A-40C6-8916-E548C4FA32D1}"/>
+          <p:cNvPr id="14" name="">
+            <a:extLst xmlns:a="http://schemas.openxmlformats.org/drawingml/2006/main">
+              <a:ext uri="{FF2B5EF4-FFF2-40B4-BE49-F238E27FC236}">
+                <a16:creationId xmlns:a16="http://schemas.microsoft.com/office/drawing/2014/main" id="{D5AA3CE8-B1B5-4143-B681-D920B8ABE898}"/>
               </a:ext>
             </a:extLst>
           </p:cNvPr>
@@ -2980,10 +3043,10 @@
       </p:sp>
       <p:sp>
         <p:nvSpPr>
-          <p:cNvPr id="14" name="">
-            <a:extLst xmlns:a="http://schemas.openxmlformats.org/drawingml/2006/main">
-              <a:ext uri="{FF2B5EF4-FFF2-40B4-BE49-F238E27FC236}">
-                <a16:creationId xmlns:a16="http://schemas.microsoft.com/office/drawing/2014/main" id="{E8C58C8A-7848-4351-A446-CF6B2B229A91}"/>
+          <p:cNvPr id="15" name="">
+            <a:extLst xmlns:a="http://schemas.openxmlformats.org/drawingml/2006/main">
+              <a:ext uri="{FF2B5EF4-FFF2-40B4-BE49-F238E27FC236}">
+                <a16:creationId xmlns:a16="http://schemas.microsoft.com/office/drawing/2014/main" id="{ED5487B9-41E9-47DB-80FC-01491E51594E}"/>
               </a:ext>
             </a:extLst>
           </p:cNvPr>
@@ -3038,10 +3101,10 @@
       </p:sp>
       <p:sp>
         <p:nvSpPr>
-          <p:cNvPr id="15" name="">
-            <a:extLst xmlns:a="http://schemas.openxmlformats.org/drawingml/2006/main">
-              <a:ext uri="{FF2B5EF4-FFF2-40B4-BE49-F238E27FC236}">
-                <a16:creationId xmlns:a16="http://schemas.microsoft.com/office/drawing/2014/main" id="{40E1123C-16D8-4FCB-A01E-FF4B861E8744}"/>
+          <p:cNvPr id="16" name="">
+            <a:extLst xmlns:a="http://schemas.openxmlformats.org/drawingml/2006/main">
+              <a:ext uri="{FF2B5EF4-FFF2-40B4-BE49-F238E27FC236}">
+                <a16:creationId xmlns:a16="http://schemas.microsoft.com/office/drawing/2014/main" id="{8C191981-2CEE-43AC-B036-71A433688C1D}"/>
               </a:ext>
             </a:extLst>
           </p:cNvPr>
@@ -3096,10 +3159,10 @@
       </p:sp>
       <p:sp>
         <p:nvSpPr>
-          <p:cNvPr id="16" name="">
-            <a:extLst xmlns:a="http://schemas.openxmlformats.org/drawingml/2006/main">
-              <a:ext uri="{FF2B5EF4-FFF2-40B4-BE49-F238E27FC236}">
-                <a16:creationId xmlns:a16="http://schemas.microsoft.com/office/drawing/2014/main" id="{AB11A2DD-D4E2-4933-A84E-A2187985A7A6}"/>
+          <p:cNvPr id="17" name="">
+            <a:extLst xmlns:a="http://schemas.openxmlformats.org/drawingml/2006/main">
+              <a:ext uri="{FF2B5EF4-FFF2-40B4-BE49-F238E27FC236}">
+                <a16:creationId xmlns:a16="http://schemas.microsoft.com/office/drawing/2014/main" id="{E2151DFE-6959-4B12-BBDC-1047AE276FAF}"/>
               </a:ext>
             </a:extLst>
           </p:cNvPr>
@@ -3127,10 +3190,10 @@
       </p:sp>
       <p:sp>
         <p:nvSpPr>
-          <p:cNvPr id="17" name="">
-            <a:extLst xmlns:a="http://schemas.openxmlformats.org/drawingml/2006/main">
-              <a:ext uri="{FF2B5EF4-FFF2-40B4-BE49-F238E27FC236}">
-                <a16:creationId xmlns:a16="http://schemas.microsoft.com/office/drawing/2014/main" id="{4D082F06-AB6D-4A09-A5B5-B08B13E415B0}"/>
+          <p:cNvPr id="18" name="">
+            <a:extLst xmlns:a="http://schemas.openxmlformats.org/drawingml/2006/main">
+              <a:ext uri="{FF2B5EF4-FFF2-40B4-BE49-F238E27FC236}">
+                <a16:creationId xmlns:a16="http://schemas.microsoft.com/office/drawing/2014/main" id="{9E2CABC1-ACD7-44D4-B83C-A7F31BC11147}"/>
               </a:ext>
             </a:extLst>
           </p:cNvPr>
@@ -3185,10 +3248,10 @@
       </p:sp>
       <p:sp>
         <p:nvSpPr>
-          <p:cNvPr id="18" name="">
-            <a:extLst xmlns:a="http://schemas.openxmlformats.org/drawingml/2006/main">
-              <a:ext uri="{FF2B5EF4-FFF2-40B4-BE49-F238E27FC236}">
-                <a16:creationId xmlns:a16="http://schemas.microsoft.com/office/drawing/2014/main" id="{71DDE28B-7ED6-46AC-99E5-00E180347C22}"/>
+          <p:cNvPr id="19" name="">
+            <a:extLst xmlns:a="http://schemas.openxmlformats.org/drawingml/2006/main">
+              <a:ext uri="{FF2B5EF4-FFF2-40B4-BE49-F238E27FC236}">
+                <a16:creationId xmlns:a16="http://schemas.microsoft.com/office/drawing/2014/main" id="{87940B08-60C1-4F42-94F2-C4EAB37EEB1F}"/>
               </a:ext>
             </a:extLst>
           </p:cNvPr>
@@ -3243,10 +3306,10 @@
       </p:sp>
       <p:sp>
         <p:nvSpPr>
-          <p:cNvPr id="19" name="">
-            <a:extLst xmlns:a="http://schemas.openxmlformats.org/drawingml/2006/main">
-              <a:ext uri="{FF2B5EF4-FFF2-40B4-BE49-F238E27FC236}">
-                <a16:creationId xmlns:a16="http://schemas.microsoft.com/office/drawing/2014/main" id="{1B96D450-0CC4-41E8-94FC-EFC3DB8956DF}"/>
+          <p:cNvPr id="20" name="">
+            <a:extLst xmlns:a="http://schemas.openxmlformats.org/drawingml/2006/main">
+              <a:ext uri="{FF2B5EF4-FFF2-40B4-BE49-F238E27FC236}">
+                <a16:creationId xmlns:a16="http://schemas.microsoft.com/office/drawing/2014/main" id="{9A1EF7B0-B510-4F3F-AAC3-8B1C91C148D5}"/>
               </a:ext>
             </a:extLst>
           </p:cNvPr>
@@ -3274,10 +3337,10 @@
       </p:sp>
       <p:sp>
         <p:nvSpPr>
-          <p:cNvPr id="20" name="">
-            <a:extLst xmlns:a="http://schemas.openxmlformats.org/drawingml/2006/main">
-              <a:ext uri="{FF2B5EF4-FFF2-40B4-BE49-F238E27FC236}">
-                <a16:creationId xmlns:a16="http://schemas.microsoft.com/office/drawing/2014/main" id="{49C3DFA1-3F5B-4AAB-96A7-A98C04C32A8D}"/>
+          <p:cNvPr id="21" name="">
+            <a:extLst xmlns:a="http://schemas.openxmlformats.org/drawingml/2006/main">
+              <a:ext uri="{FF2B5EF4-FFF2-40B4-BE49-F238E27FC236}">
+                <a16:creationId xmlns:a16="http://schemas.microsoft.com/office/drawing/2014/main" id="{0EC4C88F-3D8A-4F69-85AD-CF63A12BF9E9}"/>
               </a:ext>
             </a:extLst>
           </p:cNvPr>
@@ -3332,10 +3395,10 @@
       </p:sp>
       <p:sp>
         <p:nvSpPr>
-          <p:cNvPr id="21" name="">
-            <a:extLst xmlns:a="http://schemas.openxmlformats.org/drawingml/2006/main">
-              <a:ext uri="{FF2B5EF4-FFF2-40B4-BE49-F238E27FC236}">
-                <a16:creationId xmlns:a16="http://schemas.microsoft.com/office/drawing/2014/main" id="{5DB26AC8-0AB8-424B-96CC-670D447B9663}"/>
+          <p:cNvPr id="22" name="">
+            <a:extLst xmlns:a="http://schemas.openxmlformats.org/drawingml/2006/main">
+              <a:ext uri="{FF2B5EF4-FFF2-40B4-BE49-F238E27FC236}">
+                <a16:creationId xmlns:a16="http://schemas.microsoft.com/office/drawing/2014/main" id="{67D5C60D-8E7F-456C-8E22-F0FA4BC95E2C}"/>
               </a:ext>
             </a:extLst>
           </p:cNvPr>
@@ -3390,10 +3453,10 @@
       </p:sp>
       <p:sp>
         <p:nvSpPr>
-          <p:cNvPr id="22" name="">
-            <a:extLst xmlns:a="http://schemas.openxmlformats.org/drawingml/2006/main">
-              <a:ext uri="{FF2B5EF4-FFF2-40B4-BE49-F238E27FC236}">
-                <a16:creationId xmlns:a16="http://schemas.microsoft.com/office/drawing/2014/main" id="{74D8AA35-C714-4532-A180-B2AD98858781}"/>
+          <p:cNvPr id="23" name="">
+            <a:extLst xmlns:a="http://schemas.openxmlformats.org/drawingml/2006/main">
+              <a:ext uri="{FF2B5EF4-FFF2-40B4-BE49-F238E27FC236}">
+                <a16:creationId xmlns:a16="http://schemas.microsoft.com/office/drawing/2014/main" id="{CCAE9A05-FFA7-453A-ABA8-49D7898DFA4F}"/>
               </a:ext>
             </a:extLst>
           </p:cNvPr>
@@ -3421,10 +3484,10 @@
       </p:sp>
       <p:sp>
         <p:nvSpPr>
-          <p:cNvPr id="23" name="">
-            <a:extLst xmlns:a="http://schemas.openxmlformats.org/drawingml/2006/main">
-              <a:ext uri="{FF2B5EF4-FFF2-40B4-BE49-F238E27FC236}">
-                <a16:creationId xmlns:a16="http://schemas.microsoft.com/office/drawing/2014/main" id="{ABDEA468-F59A-4727-9698-B9CFDCD0424E}"/>
+          <p:cNvPr id="24" name="">
+            <a:extLst xmlns:a="http://schemas.openxmlformats.org/drawingml/2006/main">
+              <a:ext uri="{FF2B5EF4-FFF2-40B4-BE49-F238E27FC236}">
+                <a16:creationId xmlns:a16="http://schemas.microsoft.com/office/drawing/2014/main" id="{0AD0CB49-4294-4FF2-B016-9EFF4FDE73C1}"/>
               </a:ext>
             </a:extLst>
           </p:cNvPr>
@@ -3479,10 +3542,10 @@
       </p:sp>
       <p:sp>
         <p:nvSpPr>
-          <p:cNvPr id="24" name="">
-            <a:extLst xmlns:a="http://schemas.openxmlformats.org/drawingml/2006/main">
-              <a:ext uri="{FF2B5EF4-FFF2-40B4-BE49-F238E27FC236}">
-                <a16:creationId xmlns:a16="http://schemas.microsoft.com/office/drawing/2014/main" id="{60C24D0B-E212-4783-B7F5-637ADBAE5263}"/>
+          <p:cNvPr id="25" name="">
+            <a:extLst xmlns:a="http://schemas.openxmlformats.org/drawingml/2006/main">
+              <a:ext uri="{FF2B5EF4-FFF2-40B4-BE49-F238E27FC236}">
+                <a16:creationId xmlns:a16="http://schemas.microsoft.com/office/drawing/2014/main" id="{B27E38CB-267D-44D1-97D0-68946C17035B}"/>
               </a:ext>
             </a:extLst>
           </p:cNvPr>
@@ -3537,10 +3600,10 @@
       </p:sp>
       <p:sp>
         <p:nvSpPr>
-          <p:cNvPr id="25" name="">
-            <a:extLst xmlns:a="http://schemas.openxmlformats.org/drawingml/2006/main">
-              <a:ext uri="{FF2B5EF4-FFF2-40B4-BE49-F238E27FC236}">
-                <a16:creationId xmlns:a16="http://schemas.microsoft.com/office/drawing/2014/main" id="{A7836B3B-0E4A-4DEC-A113-DF06474847A6}"/>
+          <p:cNvPr id="26" name="">
+            <a:extLst xmlns:a="http://schemas.openxmlformats.org/drawingml/2006/main">
+              <a:ext uri="{FF2B5EF4-FFF2-40B4-BE49-F238E27FC236}">
+                <a16:creationId xmlns:a16="http://schemas.microsoft.com/office/drawing/2014/main" id="{47C924F4-4FC6-43A1-830A-A320144CB771}"/>
               </a:ext>
             </a:extLst>
           </p:cNvPr>
@@ -3568,10 +3631,10 @@
       </p:sp>
       <p:sp>
         <p:nvSpPr>
-          <p:cNvPr id="26" name="">
-            <a:extLst xmlns:a="http://schemas.openxmlformats.org/drawingml/2006/main">
-              <a:ext uri="{FF2B5EF4-FFF2-40B4-BE49-F238E27FC236}">
-                <a16:creationId xmlns:a16="http://schemas.microsoft.com/office/drawing/2014/main" id="{28E0DD17-FB17-448B-91BB-98A734DD3646}"/>
+          <p:cNvPr id="27" name="">
+            <a:extLst xmlns:a="http://schemas.openxmlformats.org/drawingml/2006/main">
+              <a:ext uri="{FF2B5EF4-FFF2-40B4-BE49-F238E27FC236}">
+                <a16:creationId xmlns:a16="http://schemas.microsoft.com/office/drawing/2014/main" id="{A1CAE69E-EAE6-436A-BF55-69BED4F72447}"/>
               </a:ext>
             </a:extLst>
           </p:cNvPr>
@@ -3603,10 +3666,10 @@
       </p:sp>
       <p:sp>
         <p:nvSpPr>
-          <p:cNvPr id="27" name="">
-            <a:extLst xmlns:a="http://schemas.openxmlformats.org/drawingml/2006/main">
-              <a:ext uri="{FF2B5EF4-FFF2-40B4-BE49-F238E27FC236}">
-                <a16:creationId xmlns:a16="http://schemas.microsoft.com/office/drawing/2014/main" id="{163F2861-EB81-4965-8565-01A38641A81B}"/>
+          <p:cNvPr id="28" name="">
+            <a:extLst xmlns:a="http://schemas.openxmlformats.org/drawingml/2006/main">
+              <a:ext uri="{FF2B5EF4-FFF2-40B4-BE49-F238E27FC236}">
+                <a16:creationId xmlns:a16="http://schemas.microsoft.com/office/drawing/2014/main" id="{A6AB9917-8D7B-41FE-BDA9-13D39C6240FB}"/>
               </a:ext>
             </a:extLst>
           </p:cNvPr>
@@ -3661,10 +3724,10 @@
       </p:sp>
       <p:sp>
         <p:nvSpPr>
-          <p:cNvPr id="28" name="">
-            <a:extLst xmlns:a="http://schemas.openxmlformats.org/drawingml/2006/main">
-              <a:ext uri="{FF2B5EF4-FFF2-40B4-BE49-F238E27FC236}">
-                <a16:creationId xmlns:a16="http://schemas.microsoft.com/office/drawing/2014/main" id="{C904B85B-4E2B-4FC8-857A-7C9FB0B7906C}"/>
+          <p:cNvPr id="29" name="">
+            <a:extLst xmlns:a="http://schemas.openxmlformats.org/drawingml/2006/main">
+              <a:ext uri="{FF2B5EF4-FFF2-40B4-BE49-F238E27FC236}">
+                <a16:creationId xmlns:a16="http://schemas.microsoft.com/office/drawing/2014/main" id="{FA8A8FBA-8456-448F-AC4A-D4A619B4CD3F}"/>
               </a:ext>
             </a:extLst>
           </p:cNvPr>
@@ -3712,7 +3775,7 @@
                 <a:ea typeface="Arial"/>
                 <a:cs typeface="Arial"/>
               </a:rPr>
-              <a:t>Do independent signals support the same claim?</a:t>
+              <a:t>Do outside signals support the same claim?</a:t>
             </a:r>
           </a:p>
         </p:txBody>
@@ -3720,7 +3783,7 @@
     </p:spTree>
     <p:extLst>
       <p:ext uri="{BB962C8B-B14F-4D97-AF65-F5344CB8AC3E}">
-        <p14:creationId xmlns:p14="http://schemas.microsoft.com/office/powerpoint/2010/main" val="1617006017"/>
+        <p14:creationId xmlns:p14="http://schemas.microsoft.com/office/powerpoint/2010/main" val="1494200858"/>
       </p:ext>
     </p:extLst>
   </p:cSld>
@@ -3748,10 +3811,10 @@
       </p:grpSpPr>
       <p:sp>
         <p:nvSpPr>
-          <p:cNvPr id="28" name="">
-            <a:extLst xmlns:a="http://schemas.openxmlformats.org/drawingml/2006/main">
-              <a:ext uri="{FF2B5EF4-FFF2-40B4-BE49-F238E27FC236}">
-                <a16:creationId xmlns:a16="http://schemas.microsoft.com/office/drawing/2014/main" id="{7F883C39-CFA9-4E5E-91EC-B032D7A36013}"/>
+          <p:cNvPr id="33" name="">
+            <a:extLst xmlns:a="http://schemas.openxmlformats.org/drawingml/2006/main">
+              <a:ext uri="{FF2B5EF4-FFF2-40B4-BE49-F238E27FC236}">
+                <a16:creationId xmlns:a16="http://schemas.microsoft.com/office/drawing/2014/main" id="{8DBDC765-1295-4937-9418-A50A2C4E803D}"/>
               </a:ext>
             </a:extLst>
           </p:cNvPr>
@@ -3784,7 +3847,7 @@
           <p:cNvPr id="2" name="">
             <a:extLst xmlns:a="http://schemas.openxmlformats.org/drawingml/2006/main">
               <a:ext uri="{FF2B5EF4-FFF2-40B4-BE49-F238E27FC236}">
-                <a16:creationId xmlns:a16="http://schemas.microsoft.com/office/drawing/2014/main" id="{C331D678-C1E8-4C46-B1AC-157C8A0278D8}"/>
+                <a16:creationId xmlns:a16="http://schemas.microsoft.com/office/drawing/2014/main" id="{D5BEAA8D-DFE3-4121-8B2C-6DF52BC7CB2F}"/>
               </a:ext>
             </a:extLst>
           </p:cNvPr>
@@ -3832,7 +3895,7 @@
                 <a:ea typeface="Courier New"/>
                 <a:cs typeface="Courier New"/>
               </a:rPr>
-              <a:t>LRWA / WORKING PRODUCT</a:t>
+              <a:t>WORKING PRODUCT</a:t>
             </a:r>
           </a:p>
         </p:txBody>
@@ -3842,7 +3905,7 @@
           <p:cNvPr id="3" name="">
             <a:extLst xmlns:a="http://schemas.openxmlformats.org/drawingml/2006/main">
               <a:ext uri="{FF2B5EF4-FFF2-40B4-BE49-F238E27FC236}">
-                <a16:creationId xmlns:a16="http://schemas.microsoft.com/office/drawing/2014/main" id="{B103BFB0-FA14-4FF3-85F0-DCE7DDA5FCFF}"/>
+                <a16:creationId xmlns:a16="http://schemas.microsoft.com/office/drawing/2014/main" id="{DF70D327-4322-4399-8A84-1F5636D98841}"/>
               </a:ext>
             </a:extLst>
           </p:cNvPr>
@@ -3900,7 +3963,7 @@
           <p:cNvPr id="4" name="">
             <a:extLst xmlns:a="http://schemas.openxmlformats.org/drawingml/2006/main">
               <a:ext uri="{FF2B5EF4-FFF2-40B4-BE49-F238E27FC236}">
-                <a16:creationId xmlns:a16="http://schemas.microsoft.com/office/drawing/2014/main" id="{D246862F-107E-4152-B072-F98CF4A26456}"/>
+                <a16:creationId xmlns:a16="http://schemas.microsoft.com/office/drawing/2014/main" id="{142979B1-B64D-4E68-A590-A5E1C630E8A9}"/>
               </a:ext>
             </a:extLst>
           </p:cNvPr>
@@ -3926,24 +3989,52 @@
           </a:ln>
         </p:spPr>
       </p:sp>
-      <p:sp>
-        <p:nvSpPr>
-          <p:cNvPr id="5" name="">
-            <a:extLst xmlns:a="http://schemas.openxmlformats.org/drawingml/2006/main">
-              <a:ext uri="{FF2B5EF4-FFF2-40B4-BE49-F238E27FC236}">
-                <a16:creationId xmlns:a16="http://schemas.microsoft.com/office/drawing/2014/main" id="{012B1D00-56D4-4D95-8BEE-373113ECD240}"/>
-              </a:ext>
-            </a:extLst>
-          </p:cNvPr>
-          <p:cNvSpPr>
-            <a:spLocks xmlns:a="http://schemas.openxmlformats.org/drawingml/2006/main" noGrp="1"/>
-          </p:cNvSpPr>
-          <p:nvPr/>
-        </p:nvSpPr>
-        <p:spPr>
-          <a:xfrm xmlns:a="http://schemas.openxmlformats.org/drawingml/2006/main" rot="0">
-            <a:off x="609600" y="6562725"/>
-            <a:ext cx="2857500" cy="133350"/>
+      <p:pic>
+        <p:nvPicPr>
+          <p:cNvPr id="37" name=""/>
+          <p:cNvPicPr>
+            <a:picLocks xmlns:a="http://schemas.openxmlformats.org/drawingml/2006/main" noChangeAspect="1"/>
+          </p:cNvPicPr>
+          <p:nvPr/>
+        </p:nvPicPr>
+        <p:blipFill>
+          <a:blip xmlns:r="http://schemas.openxmlformats.org/officeDocument/2006/relationships" xmlns:a="http://schemas.openxmlformats.org/drawingml/2006/main" r:embed="R6384576d466b4cd8">
+            <a:extLst>
+              <a:ext uri="{96DAC541-7B7A-43D3-8B79-37D633B846F1}">
+                <asvg:svgBlip xmlns:asvg="http://schemas.microsoft.com/office/drawing/2016/SVG/main" r:embed="Rc6ae1d8c14bc4fe7"/>
+              </a:ext>
+            </a:extLst>
+          </a:blip>
+          <a:stretch xmlns:a="http://schemas.openxmlformats.org/drawingml/2006/main"/>
+        </p:blipFill>
+        <p:spPr>
+          <a:xfrm xmlns:a="http://schemas.openxmlformats.org/drawingml/2006/main">
+            <a:off x="609600" y="6524625"/>
+            <a:ext cx="171450" cy="171450"/>
+          </a:xfrm>
+          <a:prstGeom xmlns:a="http://schemas.openxmlformats.org/drawingml/2006/main" prst="rect">
+            <a:avLst/>
+          </a:prstGeom>
+        </p:spPr>
+      </p:pic>
+      <p:sp>
+        <p:nvSpPr>
+          <p:cNvPr id="6" name="">
+            <a:extLst xmlns:a="http://schemas.openxmlformats.org/drawingml/2006/main">
+              <a:ext uri="{FF2B5EF4-FFF2-40B4-BE49-F238E27FC236}">
+                <a16:creationId xmlns:a16="http://schemas.microsoft.com/office/drawing/2014/main" id="{ED3DE9CF-D089-4AD1-A9B1-32CF7BB4CBAC}"/>
+              </a:ext>
+            </a:extLst>
+          </p:cNvPr>
+          <p:cNvSpPr>
+            <a:spLocks xmlns:a="http://schemas.openxmlformats.org/drawingml/2006/main" noGrp="1"/>
+          </p:cNvSpPr>
+          <p:nvPr/>
+        </p:nvSpPr>
+        <p:spPr>
+          <a:xfrm xmlns:a="http://schemas.openxmlformats.org/drawingml/2006/main" rot="0">
+            <a:off x="857250" y="6562725"/>
+            <a:ext cx="3238500" cy="133350"/>
           </a:xfrm>
           <a:prstGeom xmlns:a="http://schemas.openxmlformats.org/drawingml/2006/main" prst="rect">
             <a:avLst/>
@@ -3979,17 +4070,17 @@
                 <a:ea typeface="Courier New"/>
                 <a:cs typeface="Courier New"/>
               </a:rPr>
-              <a:t>LIVE REAL-WORLD ASSURANCE</a:t>
-            </a:r>
-          </a:p>
-        </p:txBody>
-      </p:sp>
-      <p:sp>
-        <p:nvSpPr>
-          <p:cNvPr id="6" name="">
-            <a:extLst xmlns:a="http://schemas.openxmlformats.org/drawingml/2006/main">
-              <a:ext uri="{FF2B5EF4-FFF2-40B4-BE49-F238E27FC236}">
-                <a16:creationId xmlns:a16="http://schemas.microsoft.com/office/drawing/2014/main" id="{C5B0A996-4D26-4459-99F6-21CA5BAF6505}"/>
+              <a:t>LRWA / LIVE REAL-WORLD ASSURANCE</a:t>
+            </a:r>
+          </a:p>
+        </p:txBody>
+      </p:sp>
+      <p:sp>
+        <p:nvSpPr>
+          <p:cNvPr id="7" name="">
+            <a:extLst xmlns:a="http://schemas.openxmlformats.org/drawingml/2006/main">
+              <a:ext uri="{FF2B5EF4-FFF2-40B4-BE49-F238E27FC236}">
+                <a16:creationId xmlns:a16="http://schemas.microsoft.com/office/drawing/2014/main" id="{168D0A55-6E3B-49D0-981D-BD643D4A82DD}"/>
               </a:ext>
             </a:extLst>
           </p:cNvPr>
@@ -4044,10 +4135,10 @@
       </p:sp>
       <p:sp>
         <p:nvSpPr>
-          <p:cNvPr id="7" name="">
-            <a:extLst xmlns:a="http://schemas.openxmlformats.org/drawingml/2006/main">
-              <a:ext uri="{FF2B5EF4-FFF2-40B4-BE49-F238E27FC236}">
-                <a16:creationId xmlns:a16="http://schemas.microsoft.com/office/drawing/2014/main" id="{A94893ED-2C57-4387-8F42-E55A5FCED9A6}"/>
+          <p:cNvPr id="8" name="">
+            <a:extLst xmlns:a="http://schemas.openxmlformats.org/drawingml/2006/main">
+              <a:ext uri="{FF2B5EF4-FFF2-40B4-BE49-F238E27FC236}">
+                <a16:creationId xmlns:a16="http://schemas.microsoft.com/office/drawing/2014/main" id="{F5AF53C4-F6DD-4535-B477-BE27DBF1663D}"/>
               </a:ext>
             </a:extLst>
           </p:cNvPr>
@@ -4106,10 +4197,10 @@
       </p:sp>
       <p:sp>
         <p:nvSpPr>
-          <p:cNvPr id="8" name="">
-            <a:extLst xmlns:a="http://schemas.openxmlformats.org/drawingml/2006/main">
-              <a:ext uri="{FF2B5EF4-FFF2-40B4-BE49-F238E27FC236}">
-                <a16:creationId xmlns:a16="http://schemas.microsoft.com/office/drawing/2014/main" id="{DF3BE328-6E67-4E4B-A0FC-F736C00E111C}"/>
+          <p:cNvPr id="9" name="">
+            <a:extLst xmlns:a="http://schemas.openxmlformats.org/drawingml/2006/main">
+              <a:ext uri="{FF2B5EF4-FFF2-40B4-BE49-F238E27FC236}">
+                <a16:creationId xmlns:a16="http://schemas.microsoft.com/office/drawing/2014/main" id="{6E496C76-041F-49D2-97B8-26C5788A83FD}"/>
               </a:ext>
             </a:extLst>
           </p:cNvPr>
@@ -4164,10 +4255,10 @@
       </p:sp>
       <p:sp>
         <p:nvSpPr>
-          <p:cNvPr id="9" name="mission-plan-shot-frame">
-            <a:extLst xmlns:a="http://schemas.openxmlformats.org/drawingml/2006/main">
-              <a:ext uri="{FF2B5EF4-FFF2-40B4-BE49-F238E27FC236}">
-                <a16:creationId xmlns:a16="http://schemas.microsoft.com/office/drawing/2014/main" id="{44730905-4C90-470C-B077-717A245FABBE}"/>
+          <p:cNvPr id="10" name="mission-plan-shot-frame">
+            <a:extLst xmlns:a="http://schemas.openxmlformats.org/drawingml/2006/main">
+              <a:ext uri="{FF2B5EF4-FFF2-40B4-BE49-F238E27FC236}">
+                <a16:creationId xmlns:a16="http://schemas.microsoft.com/office/drawing/2014/main" id="{5126DF97-4246-423C-9294-7DDFC03D403F}"/>
               </a:ext>
             </a:extLst>
           </p:cNvPr>
@@ -4205,14 +4296,14 @@
       </p:sp>
       <p:pic>
         <p:nvPicPr>
-          <p:cNvPr id="37" name=""/>
+          <p:cNvPr id="43" name=""/>
           <p:cNvPicPr>
             <a:picLocks xmlns:a="http://schemas.openxmlformats.org/drawingml/2006/main" noChangeAspect="1"/>
           </p:cNvPicPr>
           <p:nvPr/>
         </p:nvPicPr>
         <p:blipFill>
-          <a:blip xmlns:r="http://schemas.openxmlformats.org/officeDocument/2006/relationships" xmlns:a="http://schemas.openxmlformats.org/drawingml/2006/main" r:embed="Ref6a03314217434d"/>
+          <a:blip xmlns:r="http://schemas.openxmlformats.org/officeDocument/2006/relationships" xmlns:a="http://schemas.openxmlformats.org/drawingml/2006/main" r:embed="Rc3cf0df55066453f"/>
           <a:srcRect xmlns:a="http://schemas.openxmlformats.org/drawingml/2006/main" l="0" t="112" r="0" b="112"/>
           <a:stretch xmlns:a="http://schemas.openxmlformats.org/drawingml/2006/main">
             <a:fillRect l="0" t="0" r="0" b="0"/>
@@ -4232,10 +4323,10 @@
       </p:pic>
       <p:sp>
         <p:nvSpPr>
-          <p:cNvPr id="11" name="live-mission-shot-frame">
-            <a:extLst xmlns:a="http://schemas.openxmlformats.org/drawingml/2006/main">
-              <a:ext uri="{FF2B5EF4-FFF2-40B4-BE49-F238E27FC236}">
-                <a16:creationId xmlns:a16="http://schemas.microsoft.com/office/drawing/2014/main" id="{745735E8-82C2-4E84-947E-E132EFDEBC23}"/>
+          <p:cNvPr id="12" name="live-mission-shot-frame">
+            <a:extLst xmlns:a="http://schemas.openxmlformats.org/drawingml/2006/main">
+              <a:ext uri="{FF2B5EF4-FFF2-40B4-BE49-F238E27FC236}">
+                <a16:creationId xmlns:a16="http://schemas.microsoft.com/office/drawing/2014/main" id="{A79D9C4D-B69F-462D-ABA4-B8A6B8DE3AB3}"/>
               </a:ext>
             </a:extLst>
           </p:cNvPr>
@@ -4273,14 +4364,14 @@
       </p:sp>
       <p:pic>
         <p:nvPicPr>
-          <p:cNvPr id="39" name=""/>
+          <p:cNvPr id="45" name=""/>
           <p:cNvPicPr>
             <a:picLocks xmlns:a="http://schemas.openxmlformats.org/drawingml/2006/main" noChangeAspect="1"/>
           </p:cNvPicPr>
           <p:nvPr/>
         </p:nvPicPr>
         <p:blipFill>
-          <a:blip xmlns:r="http://schemas.openxmlformats.org/officeDocument/2006/relationships" xmlns:a="http://schemas.openxmlformats.org/drawingml/2006/main" r:embed="Rc412ae8a333b4968"/>
+          <a:blip xmlns:r="http://schemas.openxmlformats.org/officeDocument/2006/relationships" xmlns:a="http://schemas.openxmlformats.org/drawingml/2006/main" r:embed="Rd8a57a2621314e69"/>
           <a:srcRect xmlns:a="http://schemas.openxmlformats.org/drawingml/2006/main" l="0" t="112" r="0" b="112"/>
           <a:stretch xmlns:a="http://schemas.openxmlformats.org/drawingml/2006/main">
             <a:fillRect l="0" t="0" r="0" b="0"/>
@@ -4300,10 +4391,10 @@
       </p:pic>
       <p:sp>
         <p:nvSpPr>
-          <p:cNvPr id="13" name="findings-shot-frame">
-            <a:extLst xmlns:a="http://schemas.openxmlformats.org/drawingml/2006/main">
-              <a:ext uri="{FF2B5EF4-FFF2-40B4-BE49-F238E27FC236}">
-                <a16:creationId xmlns:a16="http://schemas.microsoft.com/office/drawing/2014/main" id="{13A75C8D-8917-4664-A605-971832BB63BC}"/>
+          <p:cNvPr id="14" name="findings-shot-frame">
+            <a:extLst xmlns:a="http://schemas.openxmlformats.org/drawingml/2006/main">
+              <a:ext uri="{FF2B5EF4-FFF2-40B4-BE49-F238E27FC236}">
+                <a16:creationId xmlns:a16="http://schemas.microsoft.com/office/drawing/2014/main" id="{5E72BB51-0EFF-4FD9-A92A-3499EE072584}"/>
               </a:ext>
             </a:extLst>
           </p:cNvPr>
@@ -4341,14 +4432,14 @@
       </p:sp>
       <p:pic>
         <p:nvPicPr>
-          <p:cNvPr id="41" name=""/>
+          <p:cNvPr id="47" name=""/>
           <p:cNvPicPr>
             <a:picLocks xmlns:a="http://schemas.openxmlformats.org/drawingml/2006/main" noChangeAspect="1"/>
           </p:cNvPicPr>
           <p:nvPr/>
         </p:nvPicPr>
         <p:blipFill>
-          <a:blip xmlns:r="http://schemas.openxmlformats.org/officeDocument/2006/relationships" xmlns:a="http://schemas.openxmlformats.org/drawingml/2006/main" r:embed="Ra96c2389d5b64882"/>
+          <a:blip xmlns:r="http://schemas.openxmlformats.org/officeDocument/2006/relationships" xmlns:a="http://schemas.openxmlformats.org/drawingml/2006/main" r:embed="R4c5dcdf757184e17"/>
           <a:srcRect xmlns:a="http://schemas.openxmlformats.org/drawingml/2006/main" l="0" t="112" r="0" b="112"/>
           <a:stretch xmlns:a="http://schemas.openxmlformats.org/drawingml/2006/main">
             <a:fillRect l="0" t="0" r="0" b="0"/>
@@ -4368,10 +4459,10 @@
       </p:pic>
       <p:sp>
         <p:nvSpPr>
-          <p:cNvPr id="15" name="">
-            <a:extLst xmlns:a="http://schemas.openxmlformats.org/drawingml/2006/main">
-              <a:ext uri="{FF2B5EF4-FFF2-40B4-BE49-F238E27FC236}">
-                <a16:creationId xmlns:a16="http://schemas.microsoft.com/office/drawing/2014/main" id="{A1BC4D4C-03C2-4B81-A5AC-527B3E20113E}"/>
+          <p:cNvPr id="16" name="">
+            <a:extLst xmlns:a="http://schemas.openxmlformats.org/drawingml/2006/main">
+              <a:ext uri="{FF2B5EF4-FFF2-40B4-BE49-F238E27FC236}">
+                <a16:creationId xmlns:a16="http://schemas.microsoft.com/office/drawing/2014/main" id="{3F99453A-4EA1-45E6-B16F-ADFADC005356}"/>
               </a:ext>
             </a:extLst>
           </p:cNvPr>
@@ -4419,17 +4510,17 @@
                 <a:ea typeface="Courier New"/>
                 <a:cs typeface="Courier New"/>
               </a:rPr>
-              <a:t>01  PLAN + APPROVE</a:t>
-            </a:r>
-          </a:p>
-        </p:txBody>
-      </p:sp>
-      <p:sp>
-        <p:nvSpPr>
-          <p:cNvPr id="16" name="">
-            <a:extLst xmlns:a="http://schemas.openxmlformats.org/drawingml/2006/main">
-              <a:ext uri="{FF2B5EF4-FFF2-40B4-BE49-F238E27FC236}">
-                <a16:creationId xmlns:a16="http://schemas.microsoft.com/office/drawing/2014/main" id="{3403BF7A-4417-41B7-9038-B30B1C310CD0}"/>
+              <a:t>01  PLAN + DEMO GATE</a:t>
+            </a:r>
+          </a:p>
+        </p:txBody>
+      </p:sp>
+      <p:sp>
+        <p:nvSpPr>
+          <p:cNvPr id="17" name="">
+            <a:extLst xmlns:a="http://schemas.openxmlformats.org/drawingml/2006/main">
+              <a:ext uri="{FF2B5EF4-FFF2-40B4-BE49-F238E27FC236}">
+                <a16:creationId xmlns:a16="http://schemas.microsoft.com/office/drawing/2014/main" id="{A36EE0F0-8BA6-42AC-9435-6C89CDDCF09F}"/>
               </a:ext>
             </a:extLst>
           </p:cNvPr>
@@ -4484,10 +4575,10 @@
       </p:sp>
       <p:sp>
         <p:nvSpPr>
-          <p:cNvPr id="17" name="">
-            <a:extLst xmlns:a="http://schemas.openxmlformats.org/drawingml/2006/main">
-              <a:ext uri="{FF2B5EF4-FFF2-40B4-BE49-F238E27FC236}">
-                <a16:creationId xmlns:a16="http://schemas.microsoft.com/office/drawing/2014/main" id="{DBA7D7BE-1FDE-4366-B749-94843DDAC0A8}"/>
+          <p:cNvPr id="18" name="">
+            <a:extLst xmlns:a="http://schemas.openxmlformats.org/drawingml/2006/main">
+              <a:ext uri="{FF2B5EF4-FFF2-40B4-BE49-F238E27FC236}">
+                <a16:creationId xmlns:a16="http://schemas.microsoft.com/office/drawing/2014/main" id="{7D04635E-F865-4793-B937-F2B343A535AA}"/>
               </a:ext>
             </a:extLst>
           </p:cNvPr>
@@ -4542,10 +4633,10 @@
       </p:sp>
       <p:sp>
         <p:nvSpPr>
-          <p:cNvPr id="18" name="">
-            <a:extLst xmlns:a="http://schemas.openxmlformats.org/drawingml/2006/main">
-              <a:ext uri="{FF2B5EF4-FFF2-40B4-BE49-F238E27FC236}">
-                <a16:creationId xmlns:a16="http://schemas.microsoft.com/office/drawing/2014/main" id="{C9CA9362-524E-4A11-9099-4269892C8542}"/>
+          <p:cNvPr id="19" name="">
+            <a:extLst xmlns:a="http://schemas.openxmlformats.org/drawingml/2006/main">
+              <a:ext uri="{FF2B5EF4-FFF2-40B4-BE49-F238E27FC236}">
+                <a16:creationId xmlns:a16="http://schemas.microsoft.com/office/drawing/2014/main" id="{3073BE6B-EA2E-4771-ABDB-E7534BAEF584}"/>
               </a:ext>
             </a:extLst>
           </p:cNvPr>
@@ -4593,17 +4684,17 @@
                 <a:ea typeface="Courier New"/>
                 <a:cs typeface="Courier New"/>
               </a:rPr>
-              <a:t>CLAIM  →  PROBE  →  CHALLENGE  →  APPROVE  →  DECIDE</a:t>
-            </a:r>
-          </a:p>
-        </p:txBody>
-      </p:sp>
-      <p:sp>
-        <p:nvSpPr>
-          <p:cNvPr id="19" name="">
-            <a:extLst xmlns:a="http://schemas.openxmlformats.org/drawingml/2006/main">
-              <a:ext uri="{FF2B5EF4-FFF2-40B4-BE49-F238E27FC236}">
-                <a16:creationId xmlns:a16="http://schemas.microsoft.com/office/drawing/2014/main" id="{0E21EB87-AF0B-4CEC-992C-C2A379D8EE7A}"/>
+              <a:t>CLAIM  →  PROBE  →  CHALLENGE  →  DEMO GATE  →  DECIDE</a:t>
+            </a:r>
+          </a:p>
+        </p:txBody>
+      </p:sp>
+      <p:sp>
+        <p:nvSpPr>
+          <p:cNvPr id="20" name="">
+            <a:extLst xmlns:a="http://schemas.openxmlformats.org/drawingml/2006/main">
+              <a:ext uri="{FF2B5EF4-FFF2-40B4-BE49-F238E27FC236}">
+                <a16:creationId xmlns:a16="http://schemas.microsoft.com/office/drawing/2014/main" id="{41552733-661D-4BF6-BC9D-F660BA1D2C94}"/>
               </a:ext>
             </a:extLst>
           </p:cNvPr>
@@ -4658,10 +4749,10 @@
       </p:sp>
       <p:sp>
         <p:nvSpPr>
-          <p:cNvPr id="20" name="">
-            <a:extLst xmlns:a="http://schemas.openxmlformats.org/drawingml/2006/main">
-              <a:ext uri="{FF2B5EF4-FFF2-40B4-BE49-F238E27FC236}">
-                <a16:creationId xmlns:a16="http://schemas.microsoft.com/office/drawing/2014/main" id="{897B738C-2AB4-46BE-AB4F-3BBD1413C80B}"/>
+          <p:cNvPr id="21" name="">
+            <a:extLst xmlns:a="http://schemas.openxmlformats.org/drawingml/2006/main">
+              <a:ext uri="{FF2B5EF4-FFF2-40B4-BE49-F238E27FC236}">
+                <a16:creationId xmlns:a16="http://schemas.microsoft.com/office/drawing/2014/main" id="{EA1E7971-11D6-481B-BF02-32685D9D60FD}"/>
               </a:ext>
             </a:extLst>
           </p:cNvPr>
@@ -4689,10 +4780,10 @@
       </p:sp>
       <p:sp>
         <p:nvSpPr>
-          <p:cNvPr id="21" name="">
-            <a:extLst xmlns:a="http://schemas.openxmlformats.org/drawingml/2006/main">
-              <a:ext uri="{FF2B5EF4-FFF2-40B4-BE49-F238E27FC236}">
-                <a16:creationId xmlns:a16="http://schemas.microsoft.com/office/drawing/2014/main" id="{C1552C4F-0224-45B2-A008-93342E60688E}"/>
+          <p:cNvPr id="22" name="">
+            <a:extLst xmlns:a="http://schemas.openxmlformats.org/drawingml/2006/main">
+              <a:ext uri="{FF2B5EF4-FFF2-40B4-BE49-F238E27FC236}">
+                <a16:creationId xmlns:a16="http://schemas.microsoft.com/office/drawing/2014/main" id="{DEEF7A17-B513-4597-9B30-B4251438DC6C}"/>
               </a:ext>
             </a:extLst>
           </p:cNvPr>
@@ -4740,17 +4831,17 @@
                 <a:ea typeface="Courier New"/>
                 <a:cs typeface="Courier New"/>
               </a:rPr>
-              <a:t>INITIAL ESTIMATE</a:t>
-            </a:r>
-          </a:p>
-        </p:txBody>
-      </p:sp>
-      <p:sp>
-        <p:nvSpPr>
-          <p:cNvPr id="22" name="">
-            <a:extLst xmlns:a="http://schemas.openxmlformats.org/drawingml/2006/main">
-              <a:ext uri="{FF2B5EF4-FFF2-40B4-BE49-F238E27FC236}">
-                <a16:creationId xmlns:a16="http://schemas.microsoft.com/office/drawing/2014/main" id="{C5FC24B3-1B5E-4785-892D-C73619F39AF2}"/>
+              <a:t>INITIAL SCENARIO</a:t>
+            </a:r>
+          </a:p>
+        </p:txBody>
+      </p:sp>
+      <p:sp>
+        <p:nvSpPr>
+          <p:cNvPr id="23" name="">
+            <a:extLst xmlns:a="http://schemas.openxmlformats.org/drawingml/2006/main">
+              <a:ext uri="{FF2B5EF4-FFF2-40B4-BE49-F238E27FC236}">
+                <a16:creationId xmlns:a16="http://schemas.microsoft.com/office/drawing/2014/main" id="{13ACCB97-739F-4403-AE49-1BA921070B7A}"/>
               </a:ext>
             </a:extLst>
           </p:cNvPr>
@@ -4805,22 +4896,22 @@
       </p:sp>
       <p:sp>
         <p:nvSpPr>
-          <p:cNvPr id="23" name="">
-            <a:extLst xmlns:a="http://schemas.openxmlformats.org/drawingml/2006/main">
-              <a:ext uri="{FF2B5EF4-FFF2-40B4-BE49-F238E27FC236}">
-                <a16:creationId xmlns:a16="http://schemas.microsoft.com/office/drawing/2014/main" id="{515B3524-44FA-47FD-9460-D3504886C179}"/>
-              </a:ext>
-            </a:extLst>
-          </p:cNvPr>
-          <p:cNvSpPr>
-            <a:spLocks xmlns:a="http://schemas.openxmlformats.org/drawingml/2006/main" noGrp="1"/>
-          </p:cNvSpPr>
-          <p:nvPr/>
-        </p:nvSpPr>
-        <p:spPr>
-          <a:xfrm xmlns:a="http://schemas.openxmlformats.org/drawingml/2006/main" rot="0">
-            <a:off x="7086600" y="5219700"/>
-            <a:ext cx="2714625" cy="228600"/>
+          <p:cNvPr id="24" name="">
+            <a:extLst xmlns:a="http://schemas.openxmlformats.org/drawingml/2006/main">
+              <a:ext uri="{FF2B5EF4-FFF2-40B4-BE49-F238E27FC236}">
+                <a16:creationId xmlns:a16="http://schemas.microsoft.com/office/drawing/2014/main" id="{E203E7C1-202A-4758-95B4-F51E78B0610E}"/>
+              </a:ext>
+            </a:extLst>
+          </p:cNvPr>
+          <p:cNvSpPr>
+            <a:spLocks xmlns:a="http://schemas.openxmlformats.org/drawingml/2006/main" noGrp="1"/>
+          </p:cNvSpPr>
+          <p:nvPr/>
+        </p:nvSpPr>
+        <p:spPr>
+          <a:xfrm xmlns:a="http://schemas.openxmlformats.org/drawingml/2006/main" rot="0">
+            <a:off x="7086600" y="5210175"/>
+            <a:ext cx="2381250" cy="152400"/>
           </a:xfrm>
           <a:prstGeom xmlns:a="http://schemas.openxmlformats.org/drawingml/2006/main" prst="rect">
             <a:avLst/>
@@ -4838,7 +4929,123 @@
           <a:lstStyle xmlns:a="http://schemas.openxmlformats.org/drawingml/2006/main"/>
           <a:p xmlns:a="http://schemas.openxmlformats.org/drawingml/2006/main">
             <a:pPr algn="l">
-              <a:defRPr sz="1350" b="0">
+              <a:defRPr sz="825" b="1">
+                <a:solidFill>
+                  <a:srgbClr val="6F6D6B"/>
+                </a:solidFill>
+                <a:latin typeface="Courier New"/>
+                <a:ea typeface="Courier New"/>
+                <a:cs typeface="Courier New"/>
+              </a:defRPr>
+            </a:pPr>
+            <a:r>
+              <a:rPr sz="825" b="1">
+                <a:solidFill>
+                  <a:srgbClr val="6F6D6B"/>
+                </a:solidFill>
+                <a:latin typeface="Courier New"/>
+                <a:ea typeface="Courier New"/>
+                <a:cs typeface="Courier New"/>
+              </a:rPr>
+              <a:t>FIXED SCENARIO BAND</a:t>
+            </a:r>
+          </a:p>
+        </p:txBody>
+      </p:sp>
+      <p:sp>
+        <p:nvSpPr>
+          <p:cNvPr id="25" name="">
+            <a:extLst xmlns:a="http://schemas.openxmlformats.org/drawingml/2006/main">
+              <a:ext uri="{FF2B5EF4-FFF2-40B4-BE49-F238E27FC236}">
+                <a16:creationId xmlns:a16="http://schemas.microsoft.com/office/drawing/2014/main" id="{C4E68BB7-B889-4FBD-BBE1-68057AEBC4A6}"/>
+              </a:ext>
+            </a:extLst>
+          </p:cNvPr>
+          <p:cNvSpPr>
+            <a:spLocks xmlns:a="http://schemas.openxmlformats.org/drawingml/2006/main" noGrp="1"/>
+          </p:cNvSpPr>
+          <p:nvPr/>
+        </p:nvSpPr>
+        <p:spPr>
+          <a:xfrm xmlns:a="http://schemas.openxmlformats.org/drawingml/2006/main" rot="0">
+            <a:off x="7086600" y="5381625"/>
+            <a:ext cx="2381250" cy="209550"/>
+          </a:xfrm>
+          <a:prstGeom xmlns:a="http://schemas.openxmlformats.org/drawingml/2006/main" prst="rect">
+            <a:avLst/>
+          </a:prstGeom>
+          <a:noFill xmlns:a="http://schemas.openxmlformats.org/drawingml/2006/main"/>
+          <a:ln xmlns:a="http://schemas.openxmlformats.org/drawingml/2006/main" w="0">
+            <a:noFill/>
+            <a:prstDash val="solid"/>
+          </a:ln>
+        </p:spPr>
+        <p:txBody>
+          <a:bodyPr xmlns:a="http://schemas.openxmlformats.org/drawingml/2006/main" wrap="square" lIns="0" tIns="0" rIns="0" bIns="0" anchor="t">
+            <a:normAutofit fontScale="100000"/>
+          </a:bodyPr>
+          <a:lstStyle xmlns:a="http://schemas.openxmlformats.org/drawingml/2006/main"/>
+          <a:p xmlns:a="http://schemas.openxmlformats.org/drawingml/2006/main">
+            <a:pPr algn="l">
+              <a:defRPr sz="1200" b="0">
+                <a:solidFill>
+                  <a:srgbClr val="F4F3EF"/>
+                </a:solidFill>
+                <a:latin typeface="Arial"/>
+                <a:ea typeface="Arial"/>
+                <a:cs typeface="Arial"/>
+              </a:defRPr>
+            </a:pPr>
+            <a:r>
+              <a:rPr sz="1200" b="0">
+                <a:solidFill>
+                  <a:srgbClr val="F4F3EF"/>
+                </a:solidFill>
+                <a:latin typeface="Arial"/>
+                <a:ea typeface="Arial"/>
+                <a:cs typeface="Arial"/>
+              </a:rPr>
+              <a:t>¥1.72m to ¥2.14m</a:t>
+            </a:r>
+          </a:p>
+        </p:txBody>
+      </p:sp>
+      <p:sp>
+        <p:nvSpPr>
+          <p:cNvPr id="26" name="">
+            <a:extLst xmlns:a="http://schemas.openxmlformats.org/drawingml/2006/main">
+              <a:ext uri="{FF2B5EF4-FFF2-40B4-BE49-F238E27FC236}">
+                <a16:creationId xmlns:a16="http://schemas.microsoft.com/office/drawing/2014/main" id="{0A42760A-1E14-4812-A2A1-2EF250D40A97}"/>
+              </a:ext>
+            </a:extLst>
+          </p:cNvPr>
+          <p:cNvSpPr>
+            <a:spLocks xmlns:a="http://schemas.openxmlformats.org/drawingml/2006/main" noGrp="1"/>
+          </p:cNvSpPr>
+          <p:nvPr/>
+        </p:nvSpPr>
+        <p:spPr>
+          <a:xfrm xmlns:a="http://schemas.openxmlformats.org/drawingml/2006/main" rot="0">
+            <a:off x="7086600" y="5610225"/>
+            <a:ext cx="2381250" cy="180975"/>
+          </a:xfrm>
+          <a:prstGeom xmlns:a="http://schemas.openxmlformats.org/drawingml/2006/main" prst="rect">
+            <a:avLst/>
+          </a:prstGeom>
+          <a:noFill xmlns:a="http://schemas.openxmlformats.org/drawingml/2006/main"/>
+          <a:ln xmlns:a="http://schemas.openxmlformats.org/drawingml/2006/main" w="0">
+            <a:noFill/>
+            <a:prstDash val="solid"/>
+          </a:ln>
+        </p:spPr>
+        <p:txBody>
+          <a:bodyPr xmlns:a="http://schemas.openxmlformats.org/drawingml/2006/main" wrap="square" lIns="0" tIns="0" rIns="0" bIns="0" anchor="t">
+            <a:normAutofit fontScale="100000"/>
+          </a:bodyPr>
+          <a:lstStyle xmlns:a="http://schemas.openxmlformats.org/drawingml/2006/main"/>
+          <a:p xmlns:a="http://schemas.openxmlformats.org/drawingml/2006/main">
+            <a:pPr algn="l">
+              <a:defRPr sz="975" b="0">
                 <a:solidFill>
                   <a:srgbClr val="A6A3A0"/>
                 </a:solidFill>
@@ -4848,7 +5055,7 @@
               </a:defRPr>
             </a:pPr>
             <a:r>
-              <a:rPr sz="1350" b="0">
+              <a:rPr sz="975" b="0">
                 <a:solidFill>
                   <a:srgbClr val="A6A3A0"/>
                 </a:solidFill>
@@ -4856,17 +5063,17 @@
                 <a:ea typeface="Arial"/>
                 <a:cs typeface="Arial"/>
               </a:rPr>
-              <a:t>42.3% gap  |  88% confidence</a:t>
-            </a:r>
-          </a:p>
-        </p:txBody>
-      </p:sp>
-      <p:sp>
-        <p:nvSpPr>
-          <p:cNvPr id="24" name="">
-            <a:extLst xmlns:a="http://schemas.openxmlformats.org/drawingml/2006/main">
-              <a:ext uri="{FF2B5EF4-FFF2-40B4-BE49-F238E27FC236}">
-                <a16:creationId xmlns:a16="http://schemas.microsoft.com/office/drawing/2014/main" id="{174446A1-D238-4FF7-99B1-6BDB7306141A}"/>
+              <a:t>42.3% gap  |  heuristic score 0.88</a:t>
+            </a:r>
+          </a:p>
+        </p:txBody>
+      </p:sp>
+      <p:sp>
+        <p:nvSpPr>
+          <p:cNvPr id="27" name="">
+            <a:extLst xmlns:a="http://schemas.openxmlformats.org/drawingml/2006/main">
+              <a:ext uri="{FF2B5EF4-FFF2-40B4-BE49-F238E27FC236}">
+                <a16:creationId xmlns:a16="http://schemas.microsoft.com/office/drawing/2014/main" id="{669F723F-66EE-462A-8F5B-A5D010473D0F}"/>
               </a:ext>
             </a:extLst>
           </p:cNvPr>
@@ -4921,10 +5128,10 @@
       </p:sp>
       <p:sp>
         <p:nvSpPr>
-          <p:cNvPr id="25" name="">
-            <a:extLst xmlns:a="http://schemas.openxmlformats.org/drawingml/2006/main">
-              <a:ext uri="{FF2B5EF4-FFF2-40B4-BE49-F238E27FC236}">
-                <a16:creationId xmlns:a16="http://schemas.microsoft.com/office/drawing/2014/main" id="{638B58DC-972D-431E-A13D-8123075CBDC0}"/>
+          <p:cNvPr id="28" name="">
+            <a:extLst xmlns:a="http://schemas.openxmlformats.org/drawingml/2006/main">
+              <a:ext uri="{FF2B5EF4-FFF2-40B4-BE49-F238E27FC236}">
+                <a16:creationId xmlns:a16="http://schemas.microsoft.com/office/drawing/2014/main" id="{271BB254-4757-45EC-B1FC-D06D57588380}"/>
               </a:ext>
             </a:extLst>
           </p:cNvPr>
@@ -4979,22 +5186,22 @@
       </p:sp>
       <p:sp>
         <p:nvSpPr>
-          <p:cNvPr id="26" name="">
-            <a:extLst xmlns:a="http://schemas.openxmlformats.org/drawingml/2006/main">
-              <a:ext uri="{FF2B5EF4-FFF2-40B4-BE49-F238E27FC236}">
-                <a16:creationId xmlns:a16="http://schemas.microsoft.com/office/drawing/2014/main" id="{ECBE8F3C-F330-4FDC-BE51-BB2FDC262A2F}"/>
-              </a:ext>
-            </a:extLst>
-          </p:cNvPr>
-          <p:cNvSpPr>
-            <a:spLocks xmlns:a="http://schemas.openxmlformats.org/drawingml/2006/main" noGrp="1"/>
-          </p:cNvSpPr>
-          <p:nvPr/>
-        </p:nvSpPr>
-        <p:spPr>
-          <a:xfrm xmlns:a="http://schemas.openxmlformats.org/drawingml/2006/main" rot="0">
-            <a:off x="9639300" y="5219700"/>
-            <a:ext cx="1943100" cy="438150"/>
+          <p:cNvPr id="29" name="">
+            <a:extLst xmlns:a="http://schemas.openxmlformats.org/drawingml/2006/main">
+              <a:ext uri="{FF2B5EF4-FFF2-40B4-BE49-F238E27FC236}">
+                <a16:creationId xmlns:a16="http://schemas.microsoft.com/office/drawing/2014/main" id="{FE40AFBB-311E-4E08-9823-E559417DD056}"/>
+              </a:ext>
+            </a:extLst>
+          </p:cNvPr>
+          <p:cNvSpPr>
+            <a:spLocks xmlns:a="http://schemas.openxmlformats.org/drawingml/2006/main" noGrp="1"/>
+          </p:cNvSpPr>
+          <p:nvPr/>
+        </p:nvSpPr>
+        <p:spPr>
+          <a:xfrm xmlns:a="http://schemas.openxmlformats.org/drawingml/2006/main" rot="0">
+            <a:off x="9639300" y="5210175"/>
+            <a:ext cx="1943100" cy="152400"/>
           </a:xfrm>
           <a:prstGeom xmlns:a="http://schemas.openxmlformats.org/drawingml/2006/main" prst="rect">
             <a:avLst/>
@@ -5012,11 +5219,123 @@
           <a:lstStyle xmlns:a="http://schemas.openxmlformats.org/drawingml/2006/main"/>
           <a:p xmlns:a="http://schemas.openxmlformats.org/drawingml/2006/main">
             <a:pPr algn="l">
-              <a:lnSpc>
-                <a:spcPct val="105000"/>
-              </a:lnSpc>
-              <a:buNone/>
-              <a:defRPr sz="1350" b="0">
+              <a:defRPr sz="825" b="1">
+                <a:solidFill>
+                  <a:srgbClr val="6F6D6B"/>
+                </a:solidFill>
+                <a:latin typeface="Courier New"/>
+                <a:ea typeface="Courier New"/>
+                <a:cs typeface="Courier New"/>
+              </a:defRPr>
+            </a:pPr>
+            <a:r>
+              <a:rPr sz="825" b="1">
+                <a:solidFill>
+                  <a:srgbClr val="6F6D6B"/>
+                </a:solidFill>
+                <a:latin typeface="Courier New"/>
+                <a:ea typeface="Courier New"/>
+                <a:cs typeface="Courier New"/>
+              </a:rPr>
+              <a:t>FIXED REPLAY BAND</a:t>
+            </a:r>
+          </a:p>
+        </p:txBody>
+      </p:sp>
+      <p:sp>
+        <p:nvSpPr>
+          <p:cNvPr id="30" name="">
+            <a:extLst xmlns:a="http://schemas.openxmlformats.org/drawingml/2006/main">
+              <a:ext uri="{FF2B5EF4-FFF2-40B4-BE49-F238E27FC236}">
+                <a16:creationId xmlns:a16="http://schemas.microsoft.com/office/drawing/2014/main" id="{98BD59CC-8337-4E9D-ABF1-23FA60D008B7}"/>
+              </a:ext>
+            </a:extLst>
+          </p:cNvPr>
+          <p:cNvSpPr>
+            <a:spLocks xmlns:a="http://schemas.openxmlformats.org/drawingml/2006/main" noGrp="1"/>
+          </p:cNvSpPr>
+          <p:nvPr/>
+        </p:nvSpPr>
+        <p:spPr>
+          <a:xfrm xmlns:a="http://schemas.openxmlformats.org/drawingml/2006/main" rot="0">
+            <a:off x="9639300" y="5381625"/>
+            <a:ext cx="1943100" cy="209550"/>
+          </a:xfrm>
+          <a:prstGeom xmlns:a="http://schemas.openxmlformats.org/drawingml/2006/main" prst="rect">
+            <a:avLst/>
+          </a:prstGeom>
+          <a:noFill xmlns:a="http://schemas.openxmlformats.org/drawingml/2006/main"/>
+          <a:ln xmlns:a="http://schemas.openxmlformats.org/drawingml/2006/main" w="0">
+            <a:noFill/>
+            <a:prstDash val="solid"/>
+          </a:ln>
+        </p:spPr>
+        <p:txBody>
+          <a:bodyPr xmlns:a="http://schemas.openxmlformats.org/drawingml/2006/main" wrap="square" lIns="0" tIns="0" rIns="0" bIns="0" anchor="t">
+            <a:normAutofit fontScale="100000"/>
+          </a:bodyPr>
+          <a:lstStyle xmlns:a="http://schemas.openxmlformats.org/drawingml/2006/main"/>
+          <a:p xmlns:a="http://schemas.openxmlformats.org/drawingml/2006/main">
+            <a:pPr algn="l">
+              <a:defRPr sz="1200" b="0">
+                <a:solidFill>
+                  <a:srgbClr val="F4F3EF"/>
+                </a:solidFill>
+                <a:latin typeface="Arial"/>
+                <a:ea typeface="Arial"/>
+                <a:cs typeface="Arial"/>
+              </a:defRPr>
+            </a:pPr>
+            <a:r>
+              <a:rPr sz="1200" b="0">
+                <a:solidFill>
+                  <a:srgbClr val="F4F3EF"/>
+                </a:solidFill>
+                <a:latin typeface="Arial"/>
+                <a:ea typeface="Arial"/>
+                <a:cs typeface="Arial"/>
+              </a:rPr>
+              <a:t>¥2.12m to ¥2.72m</a:t>
+            </a:r>
+          </a:p>
+        </p:txBody>
+      </p:sp>
+      <p:sp>
+        <p:nvSpPr>
+          <p:cNvPr id="31" name="">
+            <a:extLst xmlns:a="http://schemas.openxmlformats.org/drawingml/2006/main">
+              <a:ext uri="{FF2B5EF4-FFF2-40B4-BE49-F238E27FC236}">
+                <a16:creationId xmlns:a16="http://schemas.microsoft.com/office/drawing/2014/main" id="{EC02D924-0BCB-450E-A0F5-28E1A02B7A08}"/>
+              </a:ext>
+            </a:extLst>
+          </p:cNvPr>
+          <p:cNvSpPr>
+            <a:spLocks xmlns:a="http://schemas.openxmlformats.org/drawingml/2006/main" noGrp="1"/>
+          </p:cNvSpPr>
+          <p:nvPr/>
+        </p:nvSpPr>
+        <p:spPr>
+          <a:xfrm xmlns:a="http://schemas.openxmlformats.org/drawingml/2006/main" rot="0">
+            <a:off x="9639300" y="5610225"/>
+            <a:ext cx="1943100" cy="180975"/>
+          </a:xfrm>
+          <a:prstGeom xmlns:a="http://schemas.openxmlformats.org/drawingml/2006/main" prst="rect">
+            <a:avLst/>
+          </a:prstGeom>
+          <a:noFill xmlns:a="http://schemas.openxmlformats.org/drawingml/2006/main"/>
+          <a:ln xmlns:a="http://schemas.openxmlformats.org/drawingml/2006/main" w="0">
+            <a:noFill/>
+            <a:prstDash val="solid"/>
+          </a:ln>
+        </p:spPr>
+        <p:txBody>
+          <a:bodyPr xmlns:a="http://schemas.openxmlformats.org/drawingml/2006/main" wrap="square" lIns="0" tIns="0" rIns="0" bIns="0" anchor="t">
+            <a:normAutofit fontScale="100000"/>
+          </a:bodyPr>
+          <a:lstStyle xmlns:a="http://schemas.openxmlformats.org/drawingml/2006/main"/>
+          <a:p xmlns:a="http://schemas.openxmlformats.org/drawingml/2006/main">
+            <a:pPr algn="l">
+              <a:defRPr sz="975" b="0">
                 <a:solidFill>
                   <a:srgbClr val="A6A3A0"/>
                 </a:solidFill>
@@ -5026,7 +5345,7 @@
               </a:defRPr>
             </a:pPr>
             <a:r>
-              <a:rPr sz="1350" b="0">
+              <a:rPr sz="975" b="0">
                 <a:solidFill>
                   <a:srgbClr val="A6A3A0"/>
                 </a:solidFill>
@@ -5034,28 +5353,28 @@
                 <a:ea typeface="Arial"/>
                 <a:cs typeface="Arial"/>
               </a:rPr>
-              <a:t>27.9% gap  |  still unsupported</a:t>
-            </a:r>
-          </a:p>
-        </p:txBody>
-      </p:sp>
-      <p:sp>
-        <p:nvSpPr>
-          <p:cNvPr id="27" name="">
-            <a:extLst xmlns:a="http://schemas.openxmlformats.org/drawingml/2006/main">
-              <a:ext uri="{FF2B5EF4-FFF2-40B4-BE49-F238E27FC236}">
-                <a16:creationId xmlns:a16="http://schemas.microsoft.com/office/drawing/2014/main" id="{94BFFA33-7918-42FC-BD79-FA098BA613F2}"/>
-              </a:ext>
-            </a:extLst>
-          </p:cNvPr>
-          <p:cNvSpPr>
-            <a:spLocks xmlns:a="http://schemas.openxmlformats.org/drawingml/2006/main" noGrp="1"/>
-          </p:cNvSpPr>
-          <p:nvPr/>
-        </p:nvSpPr>
-        <p:spPr>
-          <a:xfrm xmlns:a="http://schemas.openxmlformats.org/drawingml/2006/main" rot="0">
-            <a:off x="7086600" y="5772150"/>
+              <a:t>27.9% gap  |  heuristic score 0.82</a:t>
+            </a:r>
+          </a:p>
+        </p:txBody>
+      </p:sp>
+      <p:sp>
+        <p:nvSpPr>
+          <p:cNvPr id="32" name="">
+            <a:extLst xmlns:a="http://schemas.openxmlformats.org/drawingml/2006/main">
+              <a:ext uri="{FF2B5EF4-FFF2-40B4-BE49-F238E27FC236}">
+                <a16:creationId xmlns:a16="http://schemas.microsoft.com/office/drawing/2014/main" id="{3CF45079-47FC-4A9A-BE77-F5F0F4575A3B}"/>
+              </a:ext>
+            </a:extLst>
+          </p:cNvPr>
+          <p:cNvSpPr>
+            <a:spLocks xmlns:a="http://schemas.openxmlformats.org/drawingml/2006/main" noGrp="1"/>
+          </p:cNvSpPr>
+          <p:nvPr/>
+        </p:nvSpPr>
+        <p:spPr>
+          <a:xfrm xmlns:a="http://schemas.openxmlformats.org/drawingml/2006/main" rot="0">
+            <a:off x="7086600" y="5953125"/>
             <a:ext cx="4495800" cy="190500"/>
           </a:xfrm>
           <a:prstGeom xmlns:a="http://schemas.openxmlformats.org/drawingml/2006/main" prst="rect">
@@ -5074,7 +5393,7 @@
           <a:lstStyle xmlns:a="http://schemas.openxmlformats.org/drawingml/2006/main"/>
           <a:p xmlns:a="http://schemas.openxmlformats.org/drawingml/2006/main">
             <a:pPr algn="r">
-              <a:defRPr sz="975" b="1">
+              <a:defRPr sz="825" b="1">
                 <a:solidFill>
                   <a:srgbClr val="F3C45E"/>
                 </a:solidFill>
@@ -5084,7 +5403,7 @@
               </a:defRPr>
             </a:pPr>
             <a:r>
-              <a:rPr sz="975" b="1">
+              <a:rPr sz="825" b="1">
                 <a:solidFill>
                   <a:srgbClr val="F3C45E"/>
                 </a:solidFill>
@@ -5092,7 +5411,7 @@
                 <a:ea typeface="Courier New"/>
                 <a:cs typeface="Courier New"/>
               </a:rPr>
-              <a:t>Declared ¥3.33m  |  1,024 probes  |  5 families</a:t>
+              <a:t>PLANNED QUOTA 1,024  |  5 LOGICAL CATEGORIES  |  5 AGGREGATE RECEIPTS</a:t>
             </a:r>
           </a:p>
         </p:txBody>
@@ -5100,7 +5419,7 @@
     </p:spTree>
     <p:extLst>
       <p:ext uri="{BB962C8B-B14F-4D97-AF65-F5344CB8AC3E}">
-        <p14:creationId xmlns:p14="http://schemas.microsoft.com/office/powerpoint/2010/main" val="204588250"/>
+        <p14:creationId xmlns:p14="http://schemas.microsoft.com/office/powerpoint/2010/main" val="202202135"/>
       </p:ext>
     </p:extLst>
   </p:cSld>
@@ -5128,10 +5447,10 @@
       </p:grpSpPr>
       <p:sp>
         <p:nvSpPr>
-          <p:cNvPr id="57" name="">
-            <a:extLst xmlns:a="http://schemas.openxmlformats.org/drawingml/2006/main">
-              <a:ext uri="{FF2B5EF4-FFF2-40B4-BE49-F238E27FC236}">
-                <a16:creationId xmlns:a16="http://schemas.microsoft.com/office/drawing/2014/main" id="{6BA4653B-1E69-4B0D-8A8E-D77141472B66}"/>
+          <p:cNvPr id="58" name="">
+            <a:extLst xmlns:a="http://schemas.openxmlformats.org/drawingml/2006/main">
+              <a:ext uri="{FF2B5EF4-FFF2-40B4-BE49-F238E27FC236}">
+                <a16:creationId xmlns:a16="http://schemas.microsoft.com/office/drawing/2014/main" id="{2AA0F2AA-0B88-4D25-8B01-060149849D7B}"/>
               </a:ext>
             </a:extLst>
           </p:cNvPr>
@@ -5164,7 +5483,7 @@
           <p:cNvPr id="2" name="">
             <a:extLst xmlns:a="http://schemas.openxmlformats.org/drawingml/2006/main">
               <a:ext uri="{FF2B5EF4-FFF2-40B4-BE49-F238E27FC236}">
-                <a16:creationId xmlns:a16="http://schemas.microsoft.com/office/drawing/2014/main" id="{61ABF102-762E-4A26-B622-C9C595F1334D}"/>
+                <a16:creationId xmlns:a16="http://schemas.microsoft.com/office/drawing/2014/main" id="{23CFB91A-8049-4A3B-B449-31ACA36FCBC3}"/>
               </a:ext>
             </a:extLst>
           </p:cNvPr>
@@ -5212,7 +5531,7 @@
                 <a:ea typeface="Courier New"/>
                 <a:cs typeface="Courier New"/>
               </a:rPr>
-              <a:t>LRWA / SYSTEM + MOAT</a:t>
+              <a:t>SYSTEM + MOAT</a:t>
             </a:r>
           </a:p>
         </p:txBody>
@@ -5222,7 +5541,7 @@
           <p:cNvPr id="3" name="">
             <a:extLst xmlns:a="http://schemas.openxmlformats.org/drawingml/2006/main">
               <a:ext uri="{FF2B5EF4-FFF2-40B4-BE49-F238E27FC236}">
-                <a16:creationId xmlns:a16="http://schemas.microsoft.com/office/drawing/2014/main" id="{BD13AFAA-A432-48DE-8AC5-F3E09FA6ED8A}"/>
+                <a16:creationId xmlns:a16="http://schemas.microsoft.com/office/drawing/2014/main" id="{AE3837B7-8C7B-4A26-BAFC-974A7F48B3AE}"/>
               </a:ext>
             </a:extLst>
           </p:cNvPr>
@@ -5280,7 +5599,7 @@
           <p:cNvPr id="4" name="">
             <a:extLst xmlns:a="http://schemas.openxmlformats.org/drawingml/2006/main">
               <a:ext uri="{FF2B5EF4-FFF2-40B4-BE49-F238E27FC236}">
-                <a16:creationId xmlns:a16="http://schemas.microsoft.com/office/drawing/2014/main" id="{0C577D44-B312-4182-A357-FDD329A8FD1F}"/>
+                <a16:creationId xmlns:a16="http://schemas.microsoft.com/office/drawing/2014/main" id="{A839038E-1A07-4D38-8B0D-E20B8559C248}"/>
               </a:ext>
             </a:extLst>
           </p:cNvPr>
@@ -5306,24 +5625,52 @@
           </a:ln>
         </p:spPr>
       </p:sp>
-      <p:sp>
-        <p:nvSpPr>
-          <p:cNvPr id="5" name="">
-            <a:extLst xmlns:a="http://schemas.openxmlformats.org/drawingml/2006/main">
-              <a:ext uri="{FF2B5EF4-FFF2-40B4-BE49-F238E27FC236}">
-                <a16:creationId xmlns:a16="http://schemas.microsoft.com/office/drawing/2014/main" id="{DDF65264-09F9-4066-8AB1-BE526FBF4D78}"/>
-              </a:ext>
-            </a:extLst>
-          </p:cNvPr>
-          <p:cNvSpPr>
-            <a:spLocks xmlns:a="http://schemas.openxmlformats.org/drawingml/2006/main" noGrp="1"/>
-          </p:cNvSpPr>
-          <p:nvPr/>
-        </p:nvSpPr>
-        <p:spPr>
-          <a:xfrm xmlns:a="http://schemas.openxmlformats.org/drawingml/2006/main" rot="0">
-            <a:off x="609600" y="6562725"/>
-            <a:ext cx="2857500" cy="133350"/>
+      <p:pic>
+        <p:nvPicPr>
+          <p:cNvPr id="62" name=""/>
+          <p:cNvPicPr>
+            <a:picLocks xmlns:a="http://schemas.openxmlformats.org/drawingml/2006/main" noChangeAspect="1"/>
+          </p:cNvPicPr>
+          <p:nvPr/>
+        </p:nvPicPr>
+        <p:blipFill>
+          <a:blip xmlns:r="http://schemas.openxmlformats.org/officeDocument/2006/relationships" xmlns:a="http://schemas.openxmlformats.org/drawingml/2006/main" r:embed="R60845cec1e064fd7">
+            <a:extLst>
+              <a:ext uri="{96DAC541-7B7A-43D3-8B79-37D633B846F1}">
+                <asvg:svgBlip xmlns:asvg="http://schemas.microsoft.com/office/drawing/2016/SVG/main" r:embed="R1a6918ac3b5a4d02"/>
+              </a:ext>
+            </a:extLst>
+          </a:blip>
+          <a:stretch xmlns:a="http://schemas.openxmlformats.org/drawingml/2006/main"/>
+        </p:blipFill>
+        <p:spPr>
+          <a:xfrm xmlns:a="http://schemas.openxmlformats.org/drawingml/2006/main">
+            <a:off x="609600" y="6524625"/>
+            <a:ext cx="171450" cy="171450"/>
+          </a:xfrm>
+          <a:prstGeom xmlns:a="http://schemas.openxmlformats.org/drawingml/2006/main" prst="rect">
+            <a:avLst/>
+          </a:prstGeom>
+        </p:spPr>
+      </p:pic>
+      <p:sp>
+        <p:nvSpPr>
+          <p:cNvPr id="6" name="">
+            <a:extLst xmlns:a="http://schemas.openxmlformats.org/drawingml/2006/main">
+              <a:ext uri="{FF2B5EF4-FFF2-40B4-BE49-F238E27FC236}">
+                <a16:creationId xmlns:a16="http://schemas.microsoft.com/office/drawing/2014/main" id="{6E0D8F94-3743-4BC6-913F-A1DC0FA8971D}"/>
+              </a:ext>
+            </a:extLst>
+          </p:cNvPr>
+          <p:cNvSpPr>
+            <a:spLocks xmlns:a="http://schemas.openxmlformats.org/drawingml/2006/main" noGrp="1"/>
+          </p:cNvSpPr>
+          <p:nvPr/>
+        </p:nvSpPr>
+        <p:spPr>
+          <a:xfrm xmlns:a="http://schemas.openxmlformats.org/drawingml/2006/main" rot="0">
+            <a:off x="857250" y="6562725"/>
+            <a:ext cx="3238500" cy="133350"/>
           </a:xfrm>
           <a:prstGeom xmlns:a="http://schemas.openxmlformats.org/drawingml/2006/main" prst="rect">
             <a:avLst/>
@@ -5359,17 +5706,17 @@
                 <a:ea typeface="Courier New"/>
                 <a:cs typeface="Courier New"/>
               </a:rPr>
-              <a:t>LIVE REAL-WORLD ASSURANCE</a:t>
-            </a:r>
-          </a:p>
-        </p:txBody>
-      </p:sp>
-      <p:sp>
-        <p:nvSpPr>
-          <p:cNvPr id="6" name="">
-            <a:extLst xmlns:a="http://schemas.openxmlformats.org/drawingml/2006/main">
-              <a:ext uri="{FF2B5EF4-FFF2-40B4-BE49-F238E27FC236}">
-                <a16:creationId xmlns:a16="http://schemas.microsoft.com/office/drawing/2014/main" id="{BF0A90A6-8347-4AA8-BD0F-943D82946FEE}"/>
+              <a:t>LRWA / LIVE REAL-WORLD ASSURANCE</a:t>
+            </a:r>
+          </a:p>
+        </p:txBody>
+      </p:sp>
+      <p:sp>
+        <p:nvSpPr>
+          <p:cNvPr id="7" name="">
+            <a:extLst xmlns:a="http://schemas.openxmlformats.org/drawingml/2006/main">
+              <a:ext uri="{FF2B5EF4-FFF2-40B4-BE49-F238E27FC236}">
+                <a16:creationId xmlns:a16="http://schemas.microsoft.com/office/drawing/2014/main" id="{4643127C-0DDD-4743-8907-6238C37C5DCD}"/>
               </a:ext>
             </a:extLst>
           </p:cNvPr>
@@ -5424,10 +5771,10 @@
       </p:sp>
       <p:sp>
         <p:nvSpPr>
-          <p:cNvPr id="7" name="">
-            <a:extLst xmlns:a="http://schemas.openxmlformats.org/drawingml/2006/main">
-              <a:ext uri="{FF2B5EF4-FFF2-40B4-BE49-F238E27FC236}">
-                <a16:creationId xmlns:a16="http://schemas.microsoft.com/office/drawing/2014/main" id="{E4BCC463-7494-4BD3-A7A4-6B6C500988A2}"/>
+          <p:cNvPr id="8" name="">
+            <a:extLst xmlns:a="http://schemas.openxmlformats.org/drawingml/2006/main">
+              <a:ext uri="{FF2B5EF4-FFF2-40B4-BE49-F238E27FC236}">
+                <a16:creationId xmlns:a16="http://schemas.microsoft.com/office/drawing/2014/main" id="{08CE3E67-3D4A-4C08-B81D-0B0E4C5326AD}"/>
               </a:ext>
             </a:extLst>
           </p:cNvPr>
@@ -5486,10 +5833,10 @@
       </p:sp>
       <p:sp>
         <p:nvSpPr>
-          <p:cNvPr id="8" name="">
-            <a:extLst xmlns:a="http://schemas.openxmlformats.org/drawingml/2006/main">
-              <a:ext uri="{FF2B5EF4-FFF2-40B4-BE49-F238E27FC236}">
-                <a16:creationId xmlns:a16="http://schemas.microsoft.com/office/drawing/2014/main" id="{3A98DC14-FEDA-4D67-8A19-AE80917A9267}"/>
+          <p:cNvPr id="9" name="">
+            <a:extLst xmlns:a="http://schemas.openxmlformats.org/drawingml/2006/main">
+              <a:ext uri="{FF2B5EF4-FFF2-40B4-BE49-F238E27FC236}">
+                <a16:creationId xmlns:a16="http://schemas.microsoft.com/office/drawing/2014/main" id="{C5A7F13D-4205-478E-A307-567C29EE53E0}"/>
               </a:ext>
             </a:extLst>
           </p:cNvPr>
@@ -5541,17 +5888,17 @@
                 <a:ea typeface="Arial"/>
                 <a:cs typeface="Arial"/>
               </a:rPr>
-              <a:t>Claim-to-observable mappings, mission outcomes, source calibration, and authorized connectors compound with every approved workflow.</a:t>
-            </a:r>
-          </a:p>
-        </p:txBody>
-      </p:sp>
-      <p:sp>
-        <p:nvSpPr>
-          <p:cNvPr id="9" name="">
-            <a:extLst xmlns:a="http://schemas.openxmlformats.org/drawingml/2006/main">
-              <a:ext uri="{FF2B5EF4-FFF2-40B4-BE49-F238E27FC236}">
-                <a16:creationId xmlns:a16="http://schemas.microsoft.com/office/drawing/2014/main" id="{8458492D-968B-4018-88ED-3C451D750056}"/>
+              <a:t>Claim-to-observable mappings and mission outcomes compound today; future source calibration and authorized connectors extend the loop.</a:t>
+            </a:r>
+          </a:p>
+        </p:txBody>
+      </p:sp>
+      <p:sp>
+        <p:nvSpPr>
+          <p:cNvPr id="10" name="">
+            <a:extLst xmlns:a="http://schemas.openxmlformats.org/drawingml/2006/main">
+              <a:ext uri="{FF2B5EF4-FFF2-40B4-BE49-F238E27FC236}">
+                <a16:creationId xmlns:a16="http://schemas.microsoft.com/office/drawing/2014/main" id="{494BEDDC-09BE-472C-8DE2-E9A01029D5B9}"/>
               </a:ext>
             </a:extLst>
           </p:cNvPr>
@@ -5579,10 +5926,10 @@
       </p:sp>
       <p:sp>
         <p:nvSpPr>
-          <p:cNvPr id="10" name="">
-            <a:extLst xmlns:a="http://schemas.openxmlformats.org/drawingml/2006/main">
-              <a:ext uri="{FF2B5EF4-FFF2-40B4-BE49-F238E27FC236}">
-                <a16:creationId xmlns:a16="http://schemas.microsoft.com/office/drawing/2014/main" id="{E257DAAA-15FF-4F55-9F6E-E9C3B473EF15}"/>
+          <p:cNvPr id="11" name="">
+            <a:extLst xmlns:a="http://schemas.openxmlformats.org/drawingml/2006/main">
+              <a:ext uri="{FF2B5EF4-FFF2-40B4-BE49-F238E27FC236}">
+                <a16:creationId xmlns:a16="http://schemas.microsoft.com/office/drawing/2014/main" id="{FCC86091-8E96-428D-AE8D-96236253C9FC}"/>
               </a:ext>
             </a:extLst>
           </p:cNvPr>
@@ -5610,10 +5957,10 @@
       </p:sp>
       <p:sp>
         <p:nvSpPr>
-          <p:cNvPr id="11" name="">
-            <a:extLst xmlns:a="http://schemas.openxmlformats.org/drawingml/2006/main">
-              <a:ext uri="{FF2B5EF4-FFF2-40B4-BE49-F238E27FC236}">
-                <a16:creationId xmlns:a16="http://schemas.microsoft.com/office/drawing/2014/main" id="{6F08A80A-619D-4C41-99CC-E1161CF0188A}"/>
+          <p:cNvPr id="12" name="">
+            <a:extLst xmlns:a="http://schemas.openxmlformats.org/drawingml/2006/main">
+              <a:ext uri="{FF2B5EF4-FFF2-40B4-BE49-F238E27FC236}">
+                <a16:creationId xmlns:a16="http://schemas.microsoft.com/office/drawing/2014/main" id="{4BC24F5A-C61F-4495-A5F4-F2C66C566077}"/>
               </a:ext>
             </a:extLst>
           </p:cNvPr>
@@ -5641,10 +5988,10 @@
       </p:sp>
       <p:sp>
         <p:nvSpPr>
-          <p:cNvPr id="12" name="">
-            <a:extLst xmlns:a="http://schemas.openxmlformats.org/drawingml/2006/main">
-              <a:ext uri="{FF2B5EF4-FFF2-40B4-BE49-F238E27FC236}">
-                <a16:creationId xmlns:a16="http://schemas.microsoft.com/office/drawing/2014/main" id="{9BDE2CCC-06FD-4C36-A7ED-041F8D77CBBB}"/>
+          <p:cNvPr id="13" name="">
+            <a:extLst xmlns:a="http://schemas.openxmlformats.org/drawingml/2006/main">
+              <a:ext uri="{FF2B5EF4-FFF2-40B4-BE49-F238E27FC236}">
+                <a16:creationId xmlns:a16="http://schemas.microsoft.com/office/drawing/2014/main" id="{1CE5F4FF-F7D0-4BB2-BEF6-B72A118745E2}"/>
               </a:ext>
             </a:extLst>
           </p:cNvPr>
@@ -5672,10 +6019,10 @@
       </p:sp>
       <p:sp>
         <p:nvSpPr>
-          <p:cNvPr id="13" name="">
-            <a:extLst xmlns:a="http://schemas.openxmlformats.org/drawingml/2006/main">
-              <a:ext uri="{FF2B5EF4-FFF2-40B4-BE49-F238E27FC236}">
-                <a16:creationId xmlns:a16="http://schemas.microsoft.com/office/drawing/2014/main" id="{1BE11E0E-31F5-4123-8EDD-97F1DC26462A}"/>
+          <p:cNvPr id="14" name="">
+            <a:extLst xmlns:a="http://schemas.openxmlformats.org/drawingml/2006/main">
+              <a:ext uri="{FF2B5EF4-FFF2-40B4-BE49-F238E27FC236}">
+                <a16:creationId xmlns:a16="http://schemas.microsoft.com/office/drawing/2014/main" id="{B009B1A1-A1FE-4A21-A101-7DEF4FF1185A}"/>
               </a:ext>
             </a:extLst>
           </p:cNvPr>
@@ -5703,10 +6050,10 @@
       </p:sp>
       <p:sp>
         <p:nvSpPr>
-          <p:cNvPr id="14" name="">
-            <a:extLst xmlns:a="http://schemas.openxmlformats.org/drawingml/2006/main">
-              <a:ext uri="{FF2B5EF4-FFF2-40B4-BE49-F238E27FC236}">
-                <a16:creationId xmlns:a16="http://schemas.microsoft.com/office/drawing/2014/main" id="{11AF22F7-A9BA-49B0-824C-1F6E34E88385}"/>
+          <p:cNvPr id="15" name="">
+            <a:extLst xmlns:a="http://schemas.openxmlformats.org/drawingml/2006/main">
+              <a:ext uri="{FF2B5EF4-FFF2-40B4-BE49-F238E27FC236}">
+                <a16:creationId xmlns:a16="http://schemas.microsoft.com/office/drawing/2014/main" id="{2A278626-F011-4BD1-BE54-BED2655CD2EA}"/>
               </a:ext>
             </a:extLst>
           </p:cNvPr>
@@ -5734,10 +6081,10 @@
       </p:sp>
       <p:sp>
         <p:nvSpPr>
-          <p:cNvPr id="15" name="">
-            <a:extLst xmlns:a="http://schemas.openxmlformats.org/drawingml/2006/main">
-              <a:ext uri="{FF2B5EF4-FFF2-40B4-BE49-F238E27FC236}">
-                <a16:creationId xmlns:a16="http://schemas.microsoft.com/office/drawing/2014/main" id="{2B65162A-E30A-4922-B7D0-91D72011F74C}"/>
+          <p:cNvPr id="16" name="">
+            <a:extLst xmlns:a="http://schemas.openxmlformats.org/drawingml/2006/main">
+              <a:ext uri="{FF2B5EF4-FFF2-40B4-BE49-F238E27FC236}">
+                <a16:creationId xmlns:a16="http://schemas.microsoft.com/office/drawing/2014/main" id="{6B2BD70C-7170-4432-9A2B-FF3CCC51A35E}"/>
               </a:ext>
             </a:extLst>
           </p:cNvPr>
@@ -5765,10 +6112,10 @@
       </p:sp>
       <p:sp>
         <p:nvSpPr>
-          <p:cNvPr id="16" name="">
-            <a:extLst xmlns:a="http://schemas.openxmlformats.org/drawingml/2006/main">
-              <a:ext uri="{FF2B5EF4-FFF2-40B4-BE49-F238E27FC236}">
-                <a16:creationId xmlns:a16="http://schemas.microsoft.com/office/drawing/2014/main" id="{31E8F8F0-BC4A-46AC-A511-643AE88A3985}"/>
+          <p:cNvPr id="17" name="">
+            <a:extLst xmlns:a="http://schemas.openxmlformats.org/drawingml/2006/main">
+              <a:ext uri="{FF2B5EF4-FFF2-40B4-BE49-F238E27FC236}">
+                <a16:creationId xmlns:a16="http://schemas.microsoft.com/office/drawing/2014/main" id="{EF8557AE-6D08-4340-A54A-1E81B6710129}"/>
               </a:ext>
             </a:extLst>
           </p:cNvPr>
@@ -5796,10 +6143,10 @@
       </p:sp>
       <p:sp>
         <p:nvSpPr>
-          <p:cNvPr id="17" name="">
-            <a:extLst xmlns:a="http://schemas.openxmlformats.org/drawingml/2006/main">
-              <a:ext uri="{FF2B5EF4-FFF2-40B4-BE49-F238E27FC236}">
-                <a16:creationId xmlns:a16="http://schemas.microsoft.com/office/drawing/2014/main" id="{C8A9CDD1-E81D-4635-909A-0FE3473CDFA6}"/>
+          <p:cNvPr id="18" name="">
+            <a:extLst xmlns:a="http://schemas.openxmlformats.org/drawingml/2006/main">
+              <a:ext uri="{FF2B5EF4-FFF2-40B4-BE49-F238E27FC236}">
+                <a16:creationId xmlns:a16="http://schemas.microsoft.com/office/drawing/2014/main" id="{75B08014-41AA-48BE-A344-643BE6B0E1C6}"/>
               </a:ext>
             </a:extLst>
           </p:cNvPr>
@@ -5831,10 +6178,10 @@
       </p:sp>
       <p:sp>
         <p:nvSpPr>
-          <p:cNvPr id="18" name="">
-            <a:extLst xmlns:a="http://schemas.openxmlformats.org/drawingml/2006/main">
-              <a:ext uri="{FF2B5EF4-FFF2-40B4-BE49-F238E27FC236}">
-                <a16:creationId xmlns:a16="http://schemas.microsoft.com/office/drawing/2014/main" id="{1A8CDBBA-DD70-405A-A5F6-E2335B01260A}"/>
+          <p:cNvPr id="19" name="">
+            <a:extLst xmlns:a="http://schemas.openxmlformats.org/drawingml/2006/main">
+              <a:ext uri="{FF2B5EF4-FFF2-40B4-BE49-F238E27FC236}">
+                <a16:creationId xmlns:a16="http://schemas.microsoft.com/office/drawing/2014/main" id="{B0E48B32-30C4-467B-B745-47869084C081}"/>
               </a:ext>
             </a:extLst>
           </p:cNvPr>
@@ -5889,10 +6236,10 @@
       </p:sp>
       <p:sp>
         <p:nvSpPr>
-          <p:cNvPr id="19" name="">
-            <a:extLst xmlns:a="http://schemas.openxmlformats.org/drawingml/2006/main">
-              <a:ext uri="{FF2B5EF4-FFF2-40B4-BE49-F238E27FC236}">
-                <a16:creationId xmlns:a16="http://schemas.microsoft.com/office/drawing/2014/main" id="{29C3597A-AF10-47C4-8155-69FC1ADE9F45}"/>
+          <p:cNvPr id="20" name="">
+            <a:extLst xmlns:a="http://schemas.openxmlformats.org/drawingml/2006/main">
+              <a:ext uri="{FF2B5EF4-FFF2-40B4-BE49-F238E27FC236}">
+                <a16:creationId xmlns:a16="http://schemas.microsoft.com/office/drawing/2014/main" id="{06F4734C-6131-4368-B80D-90EC26A6B574}"/>
               </a:ext>
             </a:extLst>
           </p:cNvPr>
@@ -5947,10 +6294,10 @@
       </p:sp>
       <p:sp>
         <p:nvSpPr>
-          <p:cNvPr id="20" name="">
-            <a:extLst xmlns:a="http://schemas.openxmlformats.org/drawingml/2006/main">
-              <a:ext uri="{FF2B5EF4-FFF2-40B4-BE49-F238E27FC236}">
-                <a16:creationId xmlns:a16="http://schemas.microsoft.com/office/drawing/2014/main" id="{9DC7D3A7-85E9-4F93-BBD1-7C741DAB1DB0}"/>
+          <p:cNvPr id="21" name="">
+            <a:extLst xmlns:a="http://schemas.openxmlformats.org/drawingml/2006/main">
+              <a:ext uri="{FF2B5EF4-FFF2-40B4-BE49-F238E27FC236}">
+                <a16:creationId xmlns:a16="http://schemas.microsoft.com/office/drawing/2014/main" id="{EA7B473B-B7F4-4301-B93B-BDDCFCBD383B}"/>
               </a:ext>
             </a:extLst>
           </p:cNvPr>
@@ -5982,10 +6329,10 @@
       </p:sp>
       <p:sp>
         <p:nvSpPr>
-          <p:cNvPr id="21" name="">
-            <a:extLst xmlns:a="http://schemas.openxmlformats.org/drawingml/2006/main">
-              <a:ext uri="{FF2B5EF4-FFF2-40B4-BE49-F238E27FC236}">
-                <a16:creationId xmlns:a16="http://schemas.microsoft.com/office/drawing/2014/main" id="{0C82BB0B-4C11-43C1-96A7-223A8707C3CC}"/>
+          <p:cNvPr id="22" name="">
+            <a:extLst xmlns:a="http://schemas.openxmlformats.org/drawingml/2006/main">
+              <a:ext uri="{FF2B5EF4-FFF2-40B4-BE49-F238E27FC236}">
+                <a16:creationId xmlns:a16="http://schemas.microsoft.com/office/drawing/2014/main" id="{ABA0B7B5-CA7C-49A9-863C-66DCA46359E0}"/>
               </a:ext>
             </a:extLst>
           </p:cNvPr>
@@ -6040,10 +6387,10 @@
       </p:sp>
       <p:sp>
         <p:nvSpPr>
-          <p:cNvPr id="22" name="">
-            <a:extLst xmlns:a="http://schemas.openxmlformats.org/drawingml/2006/main">
-              <a:ext uri="{FF2B5EF4-FFF2-40B4-BE49-F238E27FC236}">
-                <a16:creationId xmlns:a16="http://schemas.microsoft.com/office/drawing/2014/main" id="{D4178813-D590-4047-900D-A310685C9D01}"/>
+          <p:cNvPr id="23" name="">
+            <a:extLst xmlns:a="http://schemas.openxmlformats.org/drawingml/2006/main">
+              <a:ext uri="{FF2B5EF4-FFF2-40B4-BE49-F238E27FC236}">
+                <a16:creationId xmlns:a16="http://schemas.microsoft.com/office/drawing/2014/main" id="{084032AC-6EB4-4829-8EA5-5B54E0954030}"/>
               </a:ext>
             </a:extLst>
           </p:cNvPr>
@@ -6098,10 +6445,10 @@
       </p:sp>
       <p:sp>
         <p:nvSpPr>
-          <p:cNvPr id="23" name="">
-            <a:extLst xmlns:a="http://schemas.openxmlformats.org/drawingml/2006/main">
-              <a:ext uri="{FF2B5EF4-FFF2-40B4-BE49-F238E27FC236}">
-                <a16:creationId xmlns:a16="http://schemas.microsoft.com/office/drawing/2014/main" id="{4F0B184C-1531-4285-8EDE-AF044C58C67C}"/>
+          <p:cNvPr id="24" name="">
+            <a:extLst xmlns:a="http://schemas.openxmlformats.org/drawingml/2006/main">
+              <a:ext uri="{FF2B5EF4-FFF2-40B4-BE49-F238E27FC236}">
+                <a16:creationId xmlns:a16="http://schemas.microsoft.com/office/drawing/2014/main" id="{ED8BB02D-DE15-4E3A-BB86-06E3CD923C5D}"/>
               </a:ext>
             </a:extLst>
           </p:cNvPr>
@@ -6133,10 +6480,10 @@
       </p:sp>
       <p:sp>
         <p:nvSpPr>
-          <p:cNvPr id="24" name="">
-            <a:extLst xmlns:a="http://schemas.openxmlformats.org/drawingml/2006/main">
-              <a:ext uri="{FF2B5EF4-FFF2-40B4-BE49-F238E27FC236}">
-                <a16:creationId xmlns:a16="http://schemas.microsoft.com/office/drawing/2014/main" id="{6BC27429-7E30-495C-87B0-C0B4441C1B5C}"/>
+          <p:cNvPr id="25" name="">
+            <a:extLst xmlns:a="http://schemas.openxmlformats.org/drawingml/2006/main">
+              <a:ext uri="{FF2B5EF4-FFF2-40B4-BE49-F238E27FC236}">
+                <a16:creationId xmlns:a16="http://schemas.microsoft.com/office/drawing/2014/main" id="{1E995E87-6AB4-4400-9C02-C4B303D1A269}"/>
               </a:ext>
             </a:extLst>
           </p:cNvPr>
@@ -6191,10 +6538,10 @@
       </p:sp>
       <p:sp>
         <p:nvSpPr>
-          <p:cNvPr id="25" name="">
-            <a:extLst xmlns:a="http://schemas.openxmlformats.org/drawingml/2006/main">
-              <a:ext uri="{FF2B5EF4-FFF2-40B4-BE49-F238E27FC236}">
-                <a16:creationId xmlns:a16="http://schemas.microsoft.com/office/drawing/2014/main" id="{F0B1EB05-729B-465B-B12A-18C64179F3D7}"/>
+          <p:cNvPr id="26" name="">
+            <a:extLst xmlns:a="http://schemas.openxmlformats.org/drawingml/2006/main">
+              <a:ext uri="{FF2B5EF4-FFF2-40B4-BE49-F238E27FC236}">
+                <a16:creationId xmlns:a16="http://schemas.microsoft.com/office/drawing/2014/main" id="{892961D1-EC18-4BF9-AF40-F28D26F2F970}"/>
               </a:ext>
             </a:extLst>
           </p:cNvPr>
@@ -6249,10 +6596,10 @@
       </p:sp>
       <p:sp>
         <p:nvSpPr>
-          <p:cNvPr id="26" name="">
-            <a:extLst xmlns:a="http://schemas.openxmlformats.org/drawingml/2006/main">
-              <a:ext uri="{FF2B5EF4-FFF2-40B4-BE49-F238E27FC236}">
-                <a16:creationId xmlns:a16="http://schemas.microsoft.com/office/drawing/2014/main" id="{EC49022D-D925-4FFC-863F-1DC20C988C71}"/>
+          <p:cNvPr id="27" name="">
+            <a:extLst xmlns:a="http://schemas.openxmlformats.org/drawingml/2006/main">
+              <a:ext uri="{FF2B5EF4-FFF2-40B4-BE49-F238E27FC236}">
+                <a16:creationId xmlns:a16="http://schemas.microsoft.com/office/drawing/2014/main" id="{3169772A-01B4-4F81-B216-6F16BF0673ED}"/>
               </a:ext>
             </a:extLst>
           </p:cNvPr>
@@ -6284,10 +6631,10 @@
       </p:sp>
       <p:sp>
         <p:nvSpPr>
-          <p:cNvPr id="27" name="">
-            <a:extLst xmlns:a="http://schemas.openxmlformats.org/drawingml/2006/main">
-              <a:ext uri="{FF2B5EF4-FFF2-40B4-BE49-F238E27FC236}">
-                <a16:creationId xmlns:a16="http://schemas.microsoft.com/office/drawing/2014/main" id="{FAD99D46-E9AE-46D9-95B8-B74876911D9F}"/>
+          <p:cNvPr id="28" name="">
+            <a:extLst xmlns:a="http://schemas.openxmlformats.org/drawingml/2006/main">
+              <a:ext uri="{FF2B5EF4-FFF2-40B4-BE49-F238E27FC236}">
+                <a16:creationId xmlns:a16="http://schemas.microsoft.com/office/drawing/2014/main" id="{3B4AF8D0-402C-4AA6-8E46-F5036A8D8DCC}"/>
               </a:ext>
             </a:extLst>
           </p:cNvPr>
@@ -6342,10 +6689,10 @@
       </p:sp>
       <p:sp>
         <p:nvSpPr>
-          <p:cNvPr id="28" name="">
-            <a:extLst xmlns:a="http://schemas.openxmlformats.org/drawingml/2006/main">
-              <a:ext uri="{FF2B5EF4-FFF2-40B4-BE49-F238E27FC236}">
-                <a16:creationId xmlns:a16="http://schemas.microsoft.com/office/drawing/2014/main" id="{5AD5B6C7-E40C-41A7-8E34-22434498FA5F}"/>
+          <p:cNvPr id="29" name="">
+            <a:extLst xmlns:a="http://schemas.openxmlformats.org/drawingml/2006/main">
+              <a:ext uri="{FF2B5EF4-FFF2-40B4-BE49-F238E27FC236}">
+                <a16:creationId xmlns:a16="http://schemas.microsoft.com/office/drawing/2014/main" id="{366C20D6-58F9-4B79-A09B-B5CDDCCD96E0}"/>
               </a:ext>
             </a:extLst>
           </p:cNvPr>
@@ -6400,10 +6747,10 @@
       </p:sp>
       <p:sp>
         <p:nvSpPr>
-          <p:cNvPr id="29" name="">
-            <a:extLst xmlns:a="http://schemas.openxmlformats.org/drawingml/2006/main">
-              <a:ext uri="{FF2B5EF4-FFF2-40B4-BE49-F238E27FC236}">
-                <a16:creationId xmlns:a16="http://schemas.microsoft.com/office/drawing/2014/main" id="{FA4581F3-25D5-466E-8F87-EF8CC93B44D2}"/>
+          <p:cNvPr id="30" name="">
+            <a:extLst xmlns:a="http://schemas.openxmlformats.org/drawingml/2006/main">
+              <a:ext uri="{FF2B5EF4-FFF2-40B4-BE49-F238E27FC236}">
+                <a16:creationId xmlns:a16="http://schemas.microsoft.com/office/drawing/2014/main" id="{B4B84EEA-A488-45AF-A92A-D10B47981065}"/>
               </a:ext>
             </a:extLst>
           </p:cNvPr>
@@ -6435,10 +6782,10 @@
       </p:sp>
       <p:sp>
         <p:nvSpPr>
-          <p:cNvPr id="30" name="">
-            <a:extLst xmlns:a="http://schemas.openxmlformats.org/drawingml/2006/main">
-              <a:ext uri="{FF2B5EF4-FFF2-40B4-BE49-F238E27FC236}">
-                <a16:creationId xmlns:a16="http://schemas.microsoft.com/office/drawing/2014/main" id="{D28FEA2E-CF29-44AF-9883-4282AA4B5E4E}"/>
+          <p:cNvPr id="31" name="">
+            <a:extLst xmlns:a="http://schemas.openxmlformats.org/drawingml/2006/main">
+              <a:ext uri="{FF2B5EF4-FFF2-40B4-BE49-F238E27FC236}">
+                <a16:creationId xmlns:a16="http://schemas.microsoft.com/office/drawing/2014/main" id="{93C31C8D-6C25-4E87-9343-3B3DFD95A8FB}"/>
               </a:ext>
             </a:extLst>
           </p:cNvPr>
@@ -6493,10 +6840,10 @@
       </p:sp>
       <p:sp>
         <p:nvSpPr>
-          <p:cNvPr id="31" name="">
-            <a:extLst xmlns:a="http://schemas.openxmlformats.org/drawingml/2006/main">
-              <a:ext uri="{FF2B5EF4-FFF2-40B4-BE49-F238E27FC236}">
-                <a16:creationId xmlns:a16="http://schemas.microsoft.com/office/drawing/2014/main" id="{8E667ED5-5A66-4F61-99CF-33097EECA941}"/>
+          <p:cNvPr id="32" name="">
+            <a:extLst xmlns:a="http://schemas.openxmlformats.org/drawingml/2006/main">
+              <a:ext uri="{FF2B5EF4-FFF2-40B4-BE49-F238E27FC236}">
+                <a16:creationId xmlns:a16="http://schemas.microsoft.com/office/drawing/2014/main" id="{2CE92721-1B7E-4650-83BC-A594C09D74F8}"/>
               </a:ext>
             </a:extLst>
           </p:cNvPr>
@@ -6551,10 +6898,10 @@
       </p:sp>
       <p:sp>
         <p:nvSpPr>
-          <p:cNvPr id="32" name="">
-            <a:extLst xmlns:a="http://schemas.openxmlformats.org/drawingml/2006/main">
-              <a:ext uri="{FF2B5EF4-FFF2-40B4-BE49-F238E27FC236}">
-                <a16:creationId xmlns:a16="http://schemas.microsoft.com/office/drawing/2014/main" id="{893D3DC5-DFA4-4E00-BC5A-A1A405B3499F}"/>
+          <p:cNvPr id="33" name="">
+            <a:extLst xmlns:a="http://schemas.openxmlformats.org/drawingml/2006/main">
+              <a:ext uri="{FF2B5EF4-FFF2-40B4-BE49-F238E27FC236}">
+                <a16:creationId xmlns:a16="http://schemas.microsoft.com/office/drawing/2014/main" id="{4CD4A50D-032B-4B61-BB69-603D15CED44D}"/>
               </a:ext>
             </a:extLst>
           </p:cNvPr>
@@ -6586,10 +6933,10 @@
       </p:sp>
       <p:sp>
         <p:nvSpPr>
-          <p:cNvPr id="33" name="">
-            <a:extLst xmlns:a="http://schemas.openxmlformats.org/drawingml/2006/main">
-              <a:ext uri="{FF2B5EF4-FFF2-40B4-BE49-F238E27FC236}">
-                <a16:creationId xmlns:a16="http://schemas.microsoft.com/office/drawing/2014/main" id="{284DA486-C0F1-4DEE-A5E7-63889D20C21F}"/>
+          <p:cNvPr id="34" name="">
+            <a:extLst xmlns:a="http://schemas.openxmlformats.org/drawingml/2006/main">
+              <a:ext uri="{FF2B5EF4-FFF2-40B4-BE49-F238E27FC236}">
+                <a16:creationId xmlns:a16="http://schemas.microsoft.com/office/drawing/2014/main" id="{6FAAFFA1-7A4B-4C08-B872-F58C023F1E66}"/>
               </a:ext>
             </a:extLst>
           </p:cNvPr>
@@ -6644,10 +6991,10 @@
       </p:sp>
       <p:sp>
         <p:nvSpPr>
-          <p:cNvPr id="34" name="">
-            <a:extLst xmlns:a="http://schemas.openxmlformats.org/drawingml/2006/main">
-              <a:ext uri="{FF2B5EF4-FFF2-40B4-BE49-F238E27FC236}">
-                <a16:creationId xmlns:a16="http://schemas.microsoft.com/office/drawing/2014/main" id="{A9EAD97C-8936-4CEE-B464-DB6DD8BF6CFC}"/>
+          <p:cNvPr id="35" name="">
+            <a:extLst xmlns:a="http://schemas.openxmlformats.org/drawingml/2006/main">
+              <a:ext uri="{FF2B5EF4-FFF2-40B4-BE49-F238E27FC236}">
+                <a16:creationId xmlns:a16="http://schemas.microsoft.com/office/drawing/2014/main" id="{5AC62FD1-A9F5-467D-A6B1-8C3CBCA71BE1}"/>
               </a:ext>
             </a:extLst>
           </p:cNvPr>
@@ -6702,10 +7049,10 @@
       </p:sp>
       <p:sp>
         <p:nvSpPr>
-          <p:cNvPr id="35" name="">
-            <a:extLst xmlns:a="http://schemas.openxmlformats.org/drawingml/2006/main">
-              <a:ext uri="{FF2B5EF4-FFF2-40B4-BE49-F238E27FC236}">
-                <a16:creationId xmlns:a16="http://schemas.microsoft.com/office/drawing/2014/main" id="{32A22741-6470-4175-9739-AAB76ADAD12E}"/>
+          <p:cNvPr id="36" name="">
+            <a:extLst xmlns:a="http://schemas.openxmlformats.org/drawingml/2006/main">
+              <a:ext uri="{FF2B5EF4-FFF2-40B4-BE49-F238E27FC236}">
+                <a16:creationId xmlns:a16="http://schemas.microsoft.com/office/drawing/2014/main" id="{BF99E93E-5BD4-4C67-97A9-5B2C010F483B}"/>
               </a:ext>
             </a:extLst>
           </p:cNvPr>
@@ -6737,10 +7084,10 @@
       </p:sp>
       <p:sp>
         <p:nvSpPr>
-          <p:cNvPr id="36" name="">
-            <a:extLst xmlns:a="http://schemas.openxmlformats.org/drawingml/2006/main">
-              <a:ext uri="{FF2B5EF4-FFF2-40B4-BE49-F238E27FC236}">
-                <a16:creationId xmlns:a16="http://schemas.microsoft.com/office/drawing/2014/main" id="{5C1E1562-C0B2-4C31-909E-0FFA228A313D}"/>
+          <p:cNvPr id="37" name="">
+            <a:extLst xmlns:a="http://schemas.openxmlformats.org/drawingml/2006/main">
+              <a:ext uri="{FF2B5EF4-FFF2-40B4-BE49-F238E27FC236}">
+                <a16:creationId xmlns:a16="http://schemas.microsoft.com/office/drawing/2014/main" id="{84E9D1D4-9A8C-4C1D-A86F-7547B0DC4BA8}"/>
               </a:ext>
             </a:extLst>
           </p:cNvPr>
@@ -6795,10 +7142,10 @@
       </p:sp>
       <p:sp>
         <p:nvSpPr>
-          <p:cNvPr id="37" name="">
-            <a:extLst xmlns:a="http://schemas.openxmlformats.org/drawingml/2006/main">
-              <a:ext uri="{FF2B5EF4-FFF2-40B4-BE49-F238E27FC236}">
-                <a16:creationId xmlns:a16="http://schemas.microsoft.com/office/drawing/2014/main" id="{E2E6C59B-DF76-4BBC-97D8-EEFFB039D043}"/>
+          <p:cNvPr id="38" name="">
+            <a:extLst xmlns:a="http://schemas.openxmlformats.org/drawingml/2006/main">
+              <a:ext uri="{FF2B5EF4-FFF2-40B4-BE49-F238E27FC236}">
+                <a16:creationId xmlns:a16="http://schemas.microsoft.com/office/drawing/2014/main" id="{D7A87E01-0EAB-4F4C-A250-2AC2CA0A07DD}"/>
               </a:ext>
             </a:extLst>
           </p:cNvPr>
@@ -6853,10 +7200,10 @@
       </p:sp>
       <p:sp>
         <p:nvSpPr>
-          <p:cNvPr id="38" name="">
-            <a:extLst xmlns:a="http://schemas.openxmlformats.org/drawingml/2006/main">
-              <a:ext uri="{FF2B5EF4-FFF2-40B4-BE49-F238E27FC236}">
-                <a16:creationId xmlns:a16="http://schemas.microsoft.com/office/drawing/2014/main" id="{217A8DA0-4C7D-437A-9547-6C61B83436F1}"/>
+          <p:cNvPr id="39" name="">
+            <a:extLst xmlns:a="http://schemas.openxmlformats.org/drawingml/2006/main">
+              <a:ext uri="{FF2B5EF4-FFF2-40B4-BE49-F238E27FC236}">
+                <a16:creationId xmlns:a16="http://schemas.microsoft.com/office/drawing/2014/main" id="{4393A14B-A80F-4052-9F0A-8701B43D2F4A}"/>
               </a:ext>
             </a:extLst>
           </p:cNvPr>
@@ -6888,10 +7235,10 @@
       </p:sp>
       <p:sp>
         <p:nvSpPr>
-          <p:cNvPr id="39" name="">
-            <a:extLst xmlns:a="http://schemas.openxmlformats.org/drawingml/2006/main">
-              <a:ext uri="{FF2B5EF4-FFF2-40B4-BE49-F238E27FC236}">
-                <a16:creationId xmlns:a16="http://schemas.microsoft.com/office/drawing/2014/main" id="{F5F98407-E7AB-4EC0-B866-9FDA27C676C5}"/>
+          <p:cNvPr id="40" name="">
+            <a:extLst xmlns:a="http://schemas.openxmlformats.org/drawingml/2006/main">
+              <a:ext uri="{FF2B5EF4-FFF2-40B4-BE49-F238E27FC236}">
+                <a16:creationId xmlns:a16="http://schemas.microsoft.com/office/drawing/2014/main" id="{F795F274-D97B-48DB-918A-1BBFBA8A507B}"/>
               </a:ext>
             </a:extLst>
           </p:cNvPr>
@@ -6939,17 +7286,17 @@
                 <a:ea typeface="Courier New"/>
                 <a:cs typeface="Courier New"/>
               </a:rPr>
-              <a:t>HUMAN</a:t>
-            </a:r>
-          </a:p>
-        </p:txBody>
-      </p:sp>
-      <p:sp>
-        <p:nvSpPr>
-          <p:cNvPr id="40" name="">
-            <a:extLst xmlns:a="http://schemas.openxmlformats.org/drawingml/2006/main">
-              <a:ext uri="{FF2B5EF4-FFF2-40B4-BE49-F238E27FC236}">
-                <a16:creationId xmlns:a16="http://schemas.microsoft.com/office/drawing/2014/main" id="{659147EB-2C7A-4C4C-8F9F-A6A5A265D494}"/>
+              <a:t>DEMO GATE</a:t>
+            </a:r>
+          </a:p>
+        </p:txBody>
+      </p:sp>
+      <p:sp>
+        <p:nvSpPr>
+          <p:cNvPr id="41" name="">
+            <a:extLst xmlns:a="http://schemas.openxmlformats.org/drawingml/2006/main">
+              <a:ext uri="{FF2B5EF4-FFF2-40B4-BE49-F238E27FC236}">
+                <a16:creationId xmlns:a16="http://schemas.microsoft.com/office/drawing/2014/main" id="{7FEEAA10-3F37-486C-95E8-0DEC996AD9E6}"/>
               </a:ext>
             </a:extLst>
           </p:cNvPr>
@@ -6997,17 +7344,17 @@
                 <a:ea typeface="Arial"/>
                 <a:cs typeface="Arial"/>
               </a:rPr>
-              <a:t>Approve</a:t>
-            </a:r>
-          </a:p>
-        </p:txBody>
-      </p:sp>
-      <p:sp>
-        <p:nvSpPr>
-          <p:cNvPr id="41" name="">
-            <a:extLst xmlns:a="http://schemas.openxmlformats.org/drawingml/2006/main">
-              <a:ext uri="{FF2B5EF4-FFF2-40B4-BE49-F238E27FC236}">
-                <a16:creationId xmlns:a16="http://schemas.microsoft.com/office/drawing/2014/main" id="{E340183D-5D00-46FE-9AC1-765D24DB35BA}"/>
+              <a:t>Trigger</a:t>
+            </a:r>
+          </a:p>
+        </p:txBody>
+      </p:sp>
+      <p:sp>
+        <p:nvSpPr>
+          <p:cNvPr id="42" name="">
+            <a:extLst xmlns:a="http://schemas.openxmlformats.org/drawingml/2006/main">
+              <a:ext uri="{FF2B5EF4-FFF2-40B4-BE49-F238E27FC236}">
+                <a16:creationId xmlns:a16="http://schemas.microsoft.com/office/drawing/2014/main" id="{37E0609F-73CA-4361-8DB4-02A9D44BD6E6}"/>
               </a:ext>
             </a:extLst>
           </p:cNvPr>
@@ -7055,17 +7402,17 @@
                 <a:ea typeface="Courier New"/>
                 <a:cs typeface="Courier New"/>
               </a:rPr>
-              <a:t>FIVE INDEPENDENT EVIDENCE LANES</a:t>
-            </a:r>
-          </a:p>
-        </p:txBody>
-      </p:sp>
-      <p:sp>
-        <p:nvSpPr>
-          <p:cNvPr id="42" name="">
-            <a:extLst xmlns:a="http://schemas.openxmlformats.org/drawingml/2006/main">
-              <a:ext uri="{FF2B5EF4-FFF2-40B4-BE49-F238E27FC236}">
-                <a16:creationId xmlns:a16="http://schemas.microsoft.com/office/drawing/2014/main" id="{6FF5809B-8694-4DC4-AB20-0FDB5D43AE0E}"/>
+              <a:t>FIVE LOGICAL EVIDENCE CATEGORIES</a:t>
+            </a:r>
+          </a:p>
+        </p:txBody>
+      </p:sp>
+      <p:sp>
+        <p:nvSpPr>
+          <p:cNvPr id="43" name="">
+            <a:extLst xmlns:a="http://schemas.openxmlformats.org/drawingml/2006/main">
+              <a:ext uri="{FF2B5EF4-FFF2-40B4-BE49-F238E27FC236}">
+                <a16:creationId xmlns:a16="http://schemas.microsoft.com/office/drawing/2014/main" id="{F06043F4-DD0F-4161-80B0-AC2ABBA4F313}"/>
               </a:ext>
             </a:extLst>
           </p:cNvPr>
@@ -7093,10 +7440,10 @@
       </p:sp>
       <p:sp>
         <p:nvSpPr>
-          <p:cNvPr id="43" name="">
-            <a:extLst xmlns:a="http://schemas.openxmlformats.org/drawingml/2006/main">
-              <a:ext uri="{FF2B5EF4-FFF2-40B4-BE49-F238E27FC236}">
-                <a16:creationId xmlns:a16="http://schemas.microsoft.com/office/drawing/2014/main" id="{C82A9D95-22D3-45EC-97C9-76221D7EF05D}"/>
+          <p:cNvPr id="44" name="">
+            <a:extLst xmlns:a="http://schemas.openxmlformats.org/drawingml/2006/main">
+              <a:ext uri="{FF2B5EF4-FFF2-40B4-BE49-F238E27FC236}">
+                <a16:creationId xmlns:a16="http://schemas.microsoft.com/office/drawing/2014/main" id="{C2BC3E57-39C3-4F9B-82B5-C07E0DC589C1}"/>
               </a:ext>
             </a:extLst>
           </p:cNvPr>
@@ -7151,10 +7498,10 @@
       </p:sp>
       <p:sp>
         <p:nvSpPr>
-          <p:cNvPr id="44" name="">
-            <a:extLst xmlns:a="http://schemas.openxmlformats.org/drawingml/2006/main">
-              <a:ext uri="{FF2B5EF4-FFF2-40B4-BE49-F238E27FC236}">
-                <a16:creationId xmlns:a16="http://schemas.microsoft.com/office/drawing/2014/main" id="{24871A12-E74C-427E-9F0F-1A911B953E97}"/>
+          <p:cNvPr id="45" name="">
+            <a:extLst xmlns:a="http://schemas.openxmlformats.org/drawingml/2006/main">
+              <a:ext uri="{FF2B5EF4-FFF2-40B4-BE49-F238E27FC236}">
+                <a16:creationId xmlns:a16="http://schemas.microsoft.com/office/drawing/2014/main" id="{F86E03C1-9975-46E1-B72A-1967F99025AD}"/>
               </a:ext>
             </a:extLst>
           </p:cNvPr>
@@ -7182,10 +7529,10 @@
       </p:sp>
       <p:sp>
         <p:nvSpPr>
-          <p:cNvPr id="45" name="">
-            <a:extLst xmlns:a="http://schemas.openxmlformats.org/drawingml/2006/main">
-              <a:ext uri="{FF2B5EF4-FFF2-40B4-BE49-F238E27FC236}">
-                <a16:creationId xmlns:a16="http://schemas.microsoft.com/office/drawing/2014/main" id="{617C145C-33D8-4A24-AF56-5D4CC0536404}"/>
+          <p:cNvPr id="46" name="">
+            <a:extLst xmlns:a="http://schemas.openxmlformats.org/drawingml/2006/main">
+              <a:ext uri="{FF2B5EF4-FFF2-40B4-BE49-F238E27FC236}">
+                <a16:creationId xmlns:a16="http://schemas.microsoft.com/office/drawing/2014/main" id="{2DB626C0-C74E-424D-8CFB-281671F902D7}"/>
               </a:ext>
             </a:extLst>
           </p:cNvPr>
@@ -7240,10 +7587,10 @@
       </p:sp>
       <p:sp>
         <p:nvSpPr>
-          <p:cNvPr id="46" name="">
-            <a:extLst xmlns:a="http://schemas.openxmlformats.org/drawingml/2006/main">
-              <a:ext uri="{FF2B5EF4-FFF2-40B4-BE49-F238E27FC236}">
-                <a16:creationId xmlns:a16="http://schemas.microsoft.com/office/drawing/2014/main" id="{55D85C3E-72F2-41A0-B7FE-23A0189253B8}"/>
+          <p:cNvPr id="47" name="">
+            <a:extLst xmlns:a="http://schemas.openxmlformats.org/drawingml/2006/main">
+              <a:ext uri="{FF2B5EF4-FFF2-40B4-BE49-F238E27FC236}">
+                <a16:creationId xmlns:a16="http://schemas.microsoft.com/office/drawing/2014/main" id="{55E68136-DB13-41D7-9012-69DADB2D991E}"/>
               </a:ext>
             </a:extLst>
           </p:cNvPr>
@@ -7271,10 +7618,10 @@
       </p:sp>
       <p:sp>
         <p:nvSpPr>
-          <p:cNvPr id="47" name="">
-            <a:extLst xmlns:a="http://schemas.openxmlformats.org/drawingml/2006/main">
-              <a:ext uri="{FF2B5EF4-FFF2-40B4-BE49-F238E27FC236}">
-                <a16:creationId xmlns:a16="http://schemas.microsoft.com/office/drawing/2014/main" id="{D9D51F94-D49C-41A9-AD55-B8EE59E198DC}"/>
+          <p:cNvPr id="48" name="">
+            <a:extLst xmlns:a="http://schemas.openxmlformats.org/drawingml/2006/main">
+              <a:ext uri="{FF2B5EF4-FFF2-40B4-BE49-F238E27FC236}">
+                <a16:creationId xmlns:a16="http://schemas.microsoft.com/office/drawing/2014/main" id="{C1C94E1A-07DD-45C5-B155-1A3F5391B8C2}"/>
               </a:ext>
             </a:extLst>
           </p:cNvPr>
@@ -7329,10 +7676,10 @@
       </p:sp>
       <p:sp>
         <p:nvSpPr>
-          <p:cNvPr id="48" name="">
-            <a:extLst xmlns:a="http://schemas.openxmlformats.org/drawingml/2006/main">
-              <a:ext uri="{FF2B5EF4-FFF2-40B4-BE49-F238E27FC236}">
-                <a16:creationId xmlns:a16="http://schemas.microsoft.com/office/drawing/2014/main" id="{1D634A6D-EDB3-44D4-89AC-43C41280F2EF}"/>
+          <p:cNvPr id="49" name="">
+            <a:extLst xmlns:a="http://schemas.openxmlformats.org/drawingml/2006/main">
+              <a:ext uri="{FF2B5EF4-FFF2-40B4-BE49-F238E27FC236}">
+                <a16:creationId xmlns:a16="http://schemas.microsoft.com/office/drawing/2014/main" id="{E222BD4E-35A0-47DF-9934-76B1E4056661}"/>
               </a:ext>
             </a:extLst>
           </p:cNvPr>
@@ -7360,10 +7707,10 @@
       </p:sp>
       <p:sp>
         <p:nvSpPr>
-          <p:cNvPr id="49" name="">
-            <a:extLst xmlns:a="http://schemas.openxmlformats.org/drawingml/2006/main">
-              <a:ext uri="{FF2B5EF4-FFF2-40B4-BE49-F238E27FC236}">
-                <a16:creationId xmlns:a16="http://schemas.microsoft.com/office/drawing/2014/main" id="{100A1FC1-5797-49B7-BB0B-140CAC88B405}"/>
+          <p:cNvPr id="50" name="">
+            <a:extLst xmlns:a="http://schemas.openxmlformats.org/drawingml/2006/main">
+              <a:ext uri="{FF2B5EF4-FFF2-40B4-BE49-F238E27FC236}">
+                <a16:creationId xmlns:a16="http://schemas.microsoft.com/office/drawing/2014/main" id="{4610ECE2-0305-4717-B131-CAD3D641937B}"/>
               </a:ext>
             </a:extLst>
           </p:cNvPr>
@@ -7418,10 +7765,10 @@
       </p:sp>
       <p:sp>
         <p:nvSpPr>
-          <p:cNvPr id="50" name="">
-            <a:extLst xmlns:a="http://schemas.openxmlformats.org/drawingml/2006/main">
-              <a:ext uri="{FF2B5EF4-FFF2-40B4-BE49-F238E27FC236}">
-                <a16:creationId xmlns:a16="http://schemas.microsoft.com/office/drawing/2014/main" id="{C085514B-B189-41C0-9FAC-3F93075292A7}"/>
+          <p:cNvPr id="51" name="">
+            <a:extLst xmlns:a="http://schemas.openxmlformats.org/drawingml/2006/main">
+              <a:ext uri="{FF2B5EF4-FFF2-40B4-BE49-F238E27FC236}">
+                <a16:creationId xmlns:a16="http://schemas.microsoft.com/office/drawing/2014/main" id="{7404A199-2E90-4B8B-9609-2BBFED627E33}"/>
               </a:ext>
             </a:extLst>
           </p:cNvPr>
@@ -7449,10 +7796,10 @@
       </p:sp>
       <p:sp>
         <p:nvSpPr>
-          <p:cNvPr id="51" name="">
-            <a:extLst xmlns:a="http://schemas.openxmlformats.org/drawingml/2006/main">
-              <a:ext uri="{FF2B5EF4-FFF2-40B4-BE49-F238E27FC236}">
-                <a16:creationId xmlns:a16="http://schemas.microsoft.com/office/drawing/2014/main" id="{BA4BCB0A-497A-4380-85E3-B93E60B12E3E}"/>
+          <p:cNvPr id="52" name="">
+            <a:extLst xmlns:a="http://schemas.openxmlformats.org/drawingml/2006/main">
+              <a:ext uri="{FF2B5EF4-FFF2-40B4-BE49-F238E27FC236}">
+                <a16:creationId xmlns:a16="http://schemas.microsoft.com/office/drawing/2014/main" id="{EBB8A346-DCAC-4E43-A3BD-27201F2464FA}"/>
               </a:ext>
             </a:extLst>
           </p:cNvPr>
@@ -7507,10 +7854,10 @@
       </p:sp>
       <p:sp>
         <p:nvSpPr>
-          <p:cNvPr id="52" name="replay-shot-frame">
-            <a:extLst xmlns:a="http://schemas.openxmlformats.org/drawingml/2006/main">
-              <a:ext uri="{FF2B5EF4-FFF2-40B4-BE49-F238E27FC236}">
-                <a16:creationId xmlns:a16="http://schemas.microsoft.com/office/drawing/2014/main" id="{31DED053-73D2-4C67-8DD4-32F64269F507}"/>
+          <p:cNvPr id="53" name="replay-shot-frame">
+            <a:extLst xmlns:a="http://schemas.openxmlformats.org/drawingml/2006/main">
+              <a:ext uri="{FF2B5EF4-FFF2-40B4-BE49-F238E27FC236}">
+                <a16:creationId xmlns:a16="http://schemas.microsoft.com/office/drawing/2014/main" id="{D5487C67-895C-497F-983C-87064A8C5114}"/>
               </a:ext>
             </a:extLst>
           </p:cNvPr>
@@ -7548,14 +7895,14 @@
       </p:sp>
       <p:pic>
         <p:nvPicPr>
-          <p:cNvPr id="109" name=""/>
+          <p:cNvPr id="111" name=""/>
           <p:cNvPicPr>
             <a:picLocks xmlns:a="http://schemas.openxmlformats.org/drawingml/2006/main" noChangeAspect="1"/>
           </p:cNvPicPr>
           <p:nvPr/>
         </p:nvPicPr>
         <p:blipFill>
-          <a:blip xmlns:r="http://schemas.openxmlformats.org/officeDocument/2006/relationships" xmlns:a="http://schemas.openxmlformats.org/drawingml/2006/main" r:embed="R8a1686527da149e2"/>
+          <a:blip xmlns:r="http://schemas.openxmlformats.org/officeDocument/2006/relationships" xmlns:a="http://schemas.openxmlformats.org/drawingml/2006/main" r:embed="Ra751d907f8ad422e"/>
           <a:srcRect xmlns:a="http://schemas.openxmlformats.org/drawingml/2006/main" l="46" t="0" r="46" b="0"/>
           <a:stretch xmlns:a="http://schemas.openxmlformats.org/drawingml/2006/main">
             <a:fillRect l="0" t="0" r="0" b="0"/>
@@ -7575,10 +7922,10 @@
       </p:pic>
       <p:sp>
         <p:nvSpPr>
-          <p:cNvPr id="54" name="">
-            <a:extLst xmlns:a="http://schemas.openxmlformats.org/drawingml/2006/main">
-              <a:ext uri="{FF2B5EF4-FFF2-40B4-BE49-F238E27FC236}">
-                <a16:creationId xmlns:a16="http://schemas.microsoft.com/office/drawing/2014/main" id="{E8767E82-3705-41B6-9D99-B3F3D18801DA}"/>
+          <p:cNvPr id="55" name="">
+            <a:extLst xmlns:a="http://schemas.openxmlformats.org/drawingml/2006/main">
+              <a:ext uri="{FF2B5EF4-FFF2-40B4-BE49-F238E27FC236}">
+                <a16:creationId xmlns:a16="http://schemas.microsoft.com/office/drawing/2014/main" id="{4E7B4F99-34B2-4FC9-9211-646B2E9823C1}"/>
               </a:ext>
             </a:extLst>
           </p:cNvPr>
@@ -7633,10 +7980,10 @@
       </p:sp>
       <p:sp>
         <p:nvSpPr>
-          <p:cNvPr id="55" name="">
-            <a:extLst xmlns:a="http://schemas.openxmlformats.org/drawingml/2006/main">
-              <a:ext uri="{FF2B5EF4-FFF2-40B4-BE49-F238E27FC236}">
-                <a16:creationId xmlns:a16="http://schemas.microsoft.com/office/drawing/2014/main" id="{B3E8C611-0B96-4343-81DE-9451EBAD2884}"/>
+          <p:cNvPr id="56" name="">
+            <a:extLst xmlns:a="http://schemas.openxmlformats.org/drawingml/2006/main">
+              <a:ext uri="{FF2B5EF4-FFF2-40B4-BE49-F238E27FC236}">
+                <a16:creationId xmlns:a16="http://schemas.microsoft.com/office/drawing/2014/main" id="{F7E5D3FB-8A23-459B-A464-2A95D9A3A97F}"/>
               </a:ext>
             </a:extLst>
           </p:cNvPr>
@@ -7688,17 +8035,17 @@
                 <a:ea typeface="Arial"/>
                 <a:cs typeface="Arial"/>
               </a:rPr>
-              <a:t>The Skeptic can propose an alternative explanation. Only a human can authorize the replay.</a:t>
-            </a:r>
-          </a:p>
-        </p:txBody>
-      </p:sp>
-      <p:sp>
-        <p:nvSpPr>
-          <p:cNvPr id="56" name="">
-            <a:extLst xmlns:a="http://schemas.openxmlformats.org/drawingml/2006/main">
-              <a:ext uri="{FF2B5EF4-FFF2-40B4-BE49-F238E27FC236}">
-                <a16:creationId xmlns:a16="http://schemas.microsoft.com/office/drawing/2014/main" id="{55C276FE-A936-4CFE-AD01-DDDA69A058F3}"/>
+              <a:t>The Skeptic proposes an alternative. A separate demo interaction starts the deterministic replay.</a:t>
+            </a:r>
+          </a:p>
+        </p:txBody>
+      </p:sp>
+      <p:sp>
+        <p:nvSpPr>
+          <p:cNvPr id="57" name="">
+            <a:extLst xmlns:a="http://schemas.openxmlformats.org/drawingml/2006/main">
+              <a:ext uri="{FF2B5EF4-FFF2-40B4-BE49-F238E27FC236}">
+                <a16:creationId xmlns:a16="http://schemas.microsoft.com/office/drawing/2014/main" id="{794AE6B0-1923-49E2-A99F-44C695F44ECE}"/>
               </a:ext>
             </a:extLst>
           </p:cNvPr>
@@ -7746,7 +8093,7 @@
                 <a:ea typeface="Arial"/>
                 <a:cs typeface="Arial"/>
               </a:rPr>
-              <a:t>Provenance + content hashes remain attached to every evidence receipt.</a:t>
+              <a:t>Provenance + content hashes remain attached to each of the five aggregate receipts.</a:t>
             </a:r>
           </a:p>
         </p:txBody>
@@ -7754,7 +8101,7 @@
     </p:spTree>
     <p:extLst>
       <p:ext uri="{BB962C8B-B14F-4D97-AF65-F5344CB8AC3E}">
-        <p14:creationId xmlns:p14="http://schemas.microsoft.com/office/powerpoint/2010/main" val="1920328507"/>
+        <p14:creationId xmlns:p14="http://schemas.microsoft.com/office/powerpoint/2010/main" val="488294287"/>
       </p:ext>
     </p:extLst>
   </p:cSld>
@@ -7782,10 +8129,10 @@
       </p:grpSpPr>
       <p:sp>
         <p:nvSpPr>
-          <p:cNvPr id="30" name="">
-            <a:extLst xmlns:a="http://schemas.openxmlformats.org/drawingml/2006/main">
-              <a:ext uri="{FF2B5EF4-FFF2-40B4-BE49-F238E27FC236}">
-                <a16:creationId xmlns:a16="http://schemas.microsoft.com/office/drawing/2014/main" id="{E7856C6C-2C0C-40BF-A252-BA5B546F3B23}"/>
+          <p:cNvPr id="31" name="">
+            <a:extLst xmlns:a="http://schemas.openxmlformats.org/drawingml/2006/main">
+              <a:ext uri="{FF2B5EF4-FFF2-40B4-BE49-F238E27FC236}">
+                <a16:creationId xmlns:a16="http://schemas.microsoft.com/office/drawing/2014/main" id="{B5EFF40D-5A3A-40E1-8BEC-8374682CA078}"/>
               </a:ext>
             </a:extLst>
           </p:cNvPr>
@@ -7818,7 +8165,7 @@
           <p:cNvPr id="2" name="">
             <a:extLst xmlns:a="http://schemas.openxmlformats.org/drawingml/2006/main">
               <a:ext uri="{FF2B5EF4-FFF2-40B4-BE49-F238E27FC236}">
-                <a16:creationId xmlns:a16="http://schemas.microsoft.com/office/drawing/2014/main" id="{E50FC418-EFB1-45EF-B7A4-D66B973C0634}"/>
+                <a16:creationId xmlns:a16="http://schemas.microsoft.com/office/drawing/2014/main" id="{7282AF3E-B0D9-4A0D-8EA5-F8BDCC756F58}"/>
               </a:ext>
             </a:extLst>
           </p:cNvPr>
@@ -7866,7 +8213,7 @@
                 <a:ea typeface="Courier New"/>
                 <a:cs typeface="Courier New"/>
               </a:rPr>
-              <a:t>LRWA / INITIAL WEDGE</a:t>
+              <a:t>INITIAL WEDGE</a:t>
             </a:r>
           </a:p>
         </p:txBody>
@@ -7876,7 +8223,7 @@
           <p:cNvPr id="3" name="">
             <a:extLst xmlns:a="http://schemas.openxmlformats.org/drawingml/2006/main">
               <a:ext uri="{FF2B5EF4-FFF2-40B4-BE49-F238E27FC236}">
-                <a16:creationId xmlns:a16="http://schemas.microsoft.com/office/drawing/2014/main" id="{177DD135-6A4C-4AB4-93D0-DC63DC2FC2A4}"/>
+                <a16:creationId xmlns:a16="http://schemas.microsoft.com/office/drawing/2014/main" id="{482997E8-3706-4D12-B6ED-F6E5E455B0B4}"/>
               </a:ext>
             </a:extLst>
           </p:cNvPr>
@@ -7934,7 +8281,7 @@
           <p:cNvPr id="4" name="">
             <a:extLst xmlns:a="http://schemas.openxmlformats.org/drawingml/2006/main">
               <a:ext uri="{FF2B5EF4-FFF2-40B4-BE49-F238E27FC236}">
-                <a16:creationId xmlns:a16="http://schemas.microsoft.com/office/drawing/2014/main" id="{FC547468-47B6-467D-A874-D0E63361C77D}"/>
+                <a16:creationId xmlns:a16="http://schemas.microsoft.com/office/drawing/2014/main" id="{A49827C6-73B7-4C1A-B2F1-7EC2747ACB8D}"/>
               </a:ext>
             </a:extLst>
           </p:cNvPr>
@@ -7960,24 +8307,52 @@
           </a:ln>
         </p:spPr>
       </p:sp>
-      <p:sp>
-        <p:nvSpPr>
-          <p:cNvPr id="5" name="">
-            <a:extLst xmlns:a="http://schemas.openxmlformats.org/drawingml/2006/main">
-              <a:ext uri="{FF2B5EF4-FFF2-40B4-BE49-F238E27FC236}">
-                <a16:creationId xmlns:a16="http://schemas.microsoft.com/office/drawing/2014/main" id="{50203C9A-30F0-402B-B6B8-EFA397AC76A5}"/>
-              </a:ext>
-            </a:extLst>
-          </p:cNvPr>
-          <p:cNvSpPr>
-            <a:spLocks xmlns:a="http://schemas.openxmlformats.org/drawingml/2006/main" noGrp="1"/>
-          </p:cNvSpPr>
-          <p:nvPr/>
-        </p:nvSpPr>
-        <p:spPr>
-          <a:xfrm xmlns:a="http://schemas.openxmlformats.org/drawingml/2006/main" rot="0">
-            <a:off x="609600" y="6562725"/>
-            <a:ext cx="2857500" cy="133350"/>
+      <p:pic>
+        <p:nvPicPr>
+          <p:cNvPr id="35" name=""/>
+          <p:cNvPicPr>
+            <a:picLocks xmlns:a="http://schemas.openxmlformats.org/drawingml/2006/main" noChangeAspect="1"/>
+          </p:cNvPicPr>
+          <p:nvPr/>
+        </p:nvPicPr>
+        <p:blipFill>
+          <a:blip xmlns:r="http://schemas.openxmlformats.org/officeDocument/2006/relationships" xmlns:a="http://schemas.openxmlformats.org/drawingml/2006/main" r:embed="R1b4b78b2ae924a7c">
+            <a:extLst>
+              <a:ext uri="{96DAC541-7B7A-43D3-8B79-37D633B846F1}">
+                <asvg:svgBlip xmlns:asvg="http://schemas.microsoft.com/office/drawing/2016/SVG/main" r:embed="R53daed5d1d1d4d91"/>
+              </a:ext>
+            </a:extLst>
+          </a:blip>
+          <a:stretch xmlns:a="http://schemas.openxmlformats.org/drawingml/2006/main"/>
+        </p:blipFill>
+        <p:spPr>
+          <a:xfrm xmlns:a="http://schemas.openxmlformats.org/drawingml/2006/main">
+            <a:off x="609600" y="6524625"/>
+            <a:ext cx="171450" cy="171450"/>
+          </a:xfrm>
+          <a:prstGeom xmlns:a="http://schemas.openxmlformats.org/drawingml/2006/main" prst="rect">
+            <a:avLst/>
+          </a:prstGeom>
+        </p:spPr>
+      </p:pic>
+      <p:sp>
+        <p:nvSpPr>
+          <p:cNvPr id="6" name="">
+            <a:extLst xmlns:a="http://schemas.openxmlformats.org/drawingml/2006/main">
+              <a:ext uri="{FF2B5EF4-FFF2-40B4-BE49-F238E27FC236}">
+                <a16:creationId xmlns:a16="http://schemas.microsoft.com/office/drawing/2014/main" id="{9D019CA9-D4E7-497E-A67E-496C41F79B63}"/>
+              </a:ext>
+            </a:extLst>
+          </p:cNvPr>
+          <p:cNvSpPr>
+            <a:spLocks xmlns:a="http://schemas.openxmlformats.org/drawingml/2006/main" noGrp="1"/>
+          </p:cNvSpPr>
+          <p:nvPr/>
+        </p:nvSpPr>
+        <p:spPr>
+          <a:xfrm xmlns:a="http://schemas.openxmlformats.org/drawingml/2006/main" rot="0">
+            <a:off x="857250" y="6562725"/>
+            <a:ext cx="3238500" cy="133350"/>
           </a:xfrm>
           <a:prstGeom xmlns:a="http://schemas.openxmlformats.org/drawingml/2006/main" prst="rect">
             <a:avLst/>
@@ -8013,17 +8388,17 @@
                 <a:ea typeface="Courier New"/>
                 <a:cs typeface="Courier New"/>
               </a:rPr>
-              <a:t>LIVE REAL-WORLD ASSURANCE</a:t>
-            </a:r>
-          </a:p>
-        </p:txBody>
-      </p:sp>
-      <p:sp>
-        <p:nvSpPr>
-          <p:cNvPr id="6" name="">
-            <a:extLst xmlns:a="http://schemas.openxmlformats.org/drawingml/2006/main">
-              <a:ext uri="{FF2B5EF4-FFF2-40B4-BE49-F238E27FC236}">
-                <a16:creationId xmlns:a16="http://schemas.microsoft.com/office/drawing/2014/main" id="{0131C81C-997A-4783-93E5-48CC52012FB1}"/>
+              <a:t>LRWA / LIVE REAL-WORLD ASSURANCE</a:t>
+            </a:r>
+          </a:p>
+        </p:txBody>
+      </p:sp>
+      <p:sp>
+        <p:nvSpPr>
+          <p:cNvPr id="7" name="">
+            <a:extLst xmlns:a="http://schemas.openxmlformats.org/drawingml/2006/main">
+              <a:ext uri="{FF2B5EF4-FFF2-40B4-BE49-F238E27FC236}">
+                <a16:creationId xmlns:a16="http://schemas.microsoft.com/office/drawing/2014/main" id="{BBF2F6A5-7C91-4EEA-A07F-0C5A7ACBA7FE}"/>
               </a:ext>
             </a:extLst>
           </p:cNvPr>
@@ -8078,10 +8453,10 @@
       </p:sp>
       <p:sp>
         <p:nvSpPr>
-          <p:cNvPr id="7" name="">
-            <a:extLst xmlns:a="http://schemas.openxmlformats.org/drawingml/2006/main">
-              <a:ext uri="{FF2B5EF4-FFF2-40B4-BE49-F238E27FC236}">
-                <a16:creationId xmlns:a16="http://schemas.microsoft.com/office/drawing/2014/main" id="{6DF286EB-2207-4154-A271-29028BE9D13D}"/>
+          <p:cNvPr id="8" name="">
+            <a:extLst xmlns:a="http://schemas.openxmlformats.org/drawingml/2006/main">
+              <a:ext uri="{FF2B5EF4-FFF2-40B4-BE49-F238E27FC236}">
+                <a16:creationId xmlns:a16="http://schemas.microsoft.com/office/drawing/2014/main" id="{8DDD1033-A39D-4AB4-A9F2-982C38DF6A31}"/>
               </a:ext>
             </a:extLst>
           </p:cNvPr>
@@ -8140,10 +8515,10 @@
       </p:sp>
       <p:sp>
         <p:nvSpPr>
-          <p:cNvPr id="8" name="">
-            <a:extLst xmlns:a="http://schemas.openxmlformats.org/drawingml/2006/main">
-              <a:ext uri="{FF2B5EF4-FFF2-40B4-BE49-F238E27FC236}">
-                <a16:creationId xmlns:a16="http://schemas.microsoft.com/office/drawing/2014/main" id="{AC0B0D72-F88D-468A-AA4B-2EDE71CA0096}"/>
+          <p:cNvPr id="9" name="">
+            <a:extLst xmlns:a="http://schemas.openxmlformats.org/drawingml/2006/main">
+              <a:ext uri="{FF2B5EF4-FFF2-40B4-BE49-F238E27FC236}">
+                <a16:creationId xmlns:a16="http://schemas.microsoft.com/office/drawing/2014/main" id="{CB4160F9-B72E-4C4D-91B9-1DBD0B69015B}"/>
               </a:ext>
             </a:extLst>
           </p:cNvPr>
@@ -8198,10 +8573,10 @@
       </p:sp>
       <p:sp>
         <p:nvSpPr>
-          <p:cNvPr id="9" name="">
-            <a:extLst xmlns:a="http://schemas.openxmlformats.org/drawingml/2006/main">
-              <a:ext uri="{FF2B5EF4-FFF2-40B4-BE49-F238E27FC236}">
-                <a16:creationId xmlns:a16="http://schemas.microsoft.com/office/drawing/2014/main" id="{575BBCAF-E190-412D-A1A4-ABC104299B55}"/>
+          <p:cNvPr id="10" name="">
+            <a:extLst xmlns:a="http://schemas.openxmlformats.org/drawingml/2006/main">
+              <a:ext uri="{FF2B5EF4-FFF2-40B4-BE49-F238E27FC236}">
+                <a16:creationId xmlns:a16="http://schemas.microsoft.com/office/drawing/2014/main" id="{07F28D12-23EC-4852-BBE1-1D3B9F392DAC}"/>
               </a:ext>
             </a:extLst>
           </p:cNvPr>
@@ -8229,10 +8604,10 @@
       </p:sp>
       <p:sp>
         <p:nvSpPr>
-          <p:cNvPr id="10" name="">
-            <a:extLst xmlns:a="http://schemas.openxmlformats.org/drawingml/2006/main">
-              <a:ext uri="{FF2B5EF4-FFF2-40B4-BE49-F238E27FC236}">
-                <a16:creationId xmlns:a16="http://schemas.microsoft.com/office/drawing/2014/main" id="{F6A5194F-A288-467A-84E6-8A2510914837}"/>
+          <p:cNvPr id="11" name="">
+            <a:extLst xmlns:a="http://schemas.openxmlformats.org/drawingml/2006/main">
+              <a:ext uri="{FF2B5EF4-FFF2-40B4-BE49-F238E27FC236}">
+                <a16:creationId xmlns:a16="http://schemas.microsoft.com/office/drawing/2014/main" id="{529A3E7A-5F6C-487B-BD32-0187FAADD892}"/>
               </a:ext>
             </a:extLst>
           </p:cNvPr>
@@ -8262,10 +8637,10 @@
       </p:sp>
       <p:sp>
         <p:nvSpPr>
-          <p:cNvPr id="11" name="">
-            <a:extLst xmlns:a="http://schemas.openxmlformats.org/drawingml/2006/main">
-              <a:ext uri="{FF2B5EF4-FFF2-40B4-BE49-F238E27FC236}">
-                <a16:creationId xmlns:a16="http://schemas.microsoft.com/office/drawing/2014/main" id="{B5FD064D-1DD5-4145-B4DB-E7034F288D87}"/>
+          <p:cNvPr id="12" name="">
+            <a:extLst xmlns:a="http://schemas.openxmlformats.org/drawingml/2006/main">
+              <a:ext uri="{FF2B5EF4-FFF2-40B4-BE49-F238E27FC236}">
+                <a16:creationId xmlns:a16="http://schemas.microsoft.com/office/drawing/2014/main" id="{ADF1BF88-0CB6-4AC5-A6C0-DDD907835F75}"/>
               </a:ext>
             </a:extLst>
           </p:cNvPr>
@@ -8320,10 +8695,10 @@
       </p:sp>
       <p:sp>
         <p:nvSpPr>
-          <p:cNvPr id="12" name="">
-            <a:extLst xmlns:a="http://schemas.openxmlformats.org/drawingml/2006/main">
-              <a:ext uri="{FF2B5EF4-FFF2-40B4-BE49-F238E27FC236}">
-                <a16:creationId xmlns:a16="http://schemas.microsoft.com/office/drawing/2014/main" id="{DA7D3D68-6AD6-4AA1-8AEB-DCFA3AEAACE4}"/>
+          <p:cNvPr id="13" name="">
+            <a:extLst xmlns:a="http://schemas.openxmlformats.org/drawingml/2006/main">
+              <a:ext uri="{FF2B5EF4-FFF2-40B4-BE49-F238E27FC236}">
+                <a16:creationId xmlns:a16="http://schemas.microsoft.com/office/drawing/2014/main" id="{3E95993B-BA91-495A-BDE0-E02478AE39CF}"/>
               </a:ext>
             </a:extLst>
           </p:cNvPr>
@@ -8378,10 +8753,10 @@
       </p:sp>
       <p:sp>
         <p:nvSpPr>
-          <p:cNvPr id="13" name="">
-            <a:extLst xmlns:a="http://schemas.openxmlformats.org/drawingml/2006/main">
-              <a:ext uri="{FF2B5EF4-FFF2-40B4-BE49-F238E27FC236}">
-                <a16:creationId xmlns:a16="http://schemas.microsoft.com/office/drawing/2014/main" id="{48846217-7B0C-4916-A5D8-2125FF25BF90}"/>
+          <p:cNvPr id="14" name="">
+            <a:extLst xmlns:a="http://schemas.openxmlformats.org/drawingml/2006/main">
+              <a:ext uri="{FF2B5EF4-FFF2-40B4-BE49-F238E27FC236}">
+                <a16:creationId xmlns:a16="http://schemas.microsoft.com/office/drawing/2014/main" id="{E2FC45D6-D24B-4C5C-9547-8E6AE83A415E}"/>
               </a:ext>
             </a:extLst>
           </p:cNvPr>
@@ -8436,10 +8811,10 @@
       </p:sp>
       <p:sp>
         <p:nvSpPr>
-          <p:cNvPr id="14" name="">
-            <a:extLst xmlns:a="http://schemas.openxmlformats.org/drawingml/2006/main">
-              <a:ext uri="{FF2B5EF4-FFF2-40B4-BE49-F238E27FC236}">
-                <a16:creationId xmlns:a16="http://schemas.microsoft.com/office/drawing/2014/main" id="{329EF3EC-BB65-496F-B2DD-809D77859F5D}"/>
+          <p:cNvPr id="15" name="">
+            <a:extLst xmlns:a="http://schemas.openxmlformats.org/drawingml/2006/main">
+              <a:ext uri="{FF2B5EF4-FFF2-40B4-BE49-F238E27FC236}">
+                <a16:creationId xmlns:a16="http://schemas.microsoft.com/office/drawing/2014/main" id="{5AEEF901-E9AE-4CFE-991B-1F2D954029C3}"/>
               </a:ext>
             </a:extLst>
           </p:cNvPr>
@@ -8469,10 +8844,10 @@
       </p:sp>
       <p:sp>
         <p:nvSpPr>
-          <p:cNvPr id="15" name="">
-            <a:extLst xmlns:a="http://schemas.openxmlformats.org/drawingml/2006/main">
-              <a:ext uri="{FF2B5EF4-FFF2-40B4-BE49-F238E27FC236}">
-                <a16:creationId xmlns:a16="http://schemas.microsoft.com/office/drawing/2014/main" id="{32A0B4FB-BDED-488A-BF06-B3DF6570EEC6}"/>
+          <p:cNvPr id="16" name="">
+            <a:extLst xmlns:a="http://schemas.openxmlformats.org/drawingml/2006/main">
+              <a:ext uri="{FF2B5EF4-FFF2-40B4-BE49-F238E27FC236}">
+                <a16:creationId xmlns:a16="http://schemas.microsoft.com/office/drawing/2014/main" id="{AAB110E7-0E9C-4A11-82D6-9B803B9624A3}"/>
               </a:ext>
             </a:extLst>
           </p:cNvPr>
@@ -8527,10 +8902,10 @@
       </p:sp>
       <p:sp>
         <p:nvSpPr>
-          <p:cNvPr id="16" name="">
-            <a:extLst xmlns:a="http://schemas.openxmlformats.org/drawingml/2006/main">
-              <a:ext uri="{FF2B5EF4-FFF2-40B4-BE49-F238E27FC236}">
-                <a16:creationId xmlns:a16="http://schemas.microsoft.com/office/drawing/2014/main" id="{3E8D992B-2109-4BD9-AD40-6D878983A9AB}"/>
+          <p:cNvPr id="17" name="">
+            <a:extLst xmlns:a="http://schemas.openxmlformats.org/drawingml/2006/main">
+              <a:ext uri="{FF2B5EF4-FFF2-40B4-BE49-F238E27FC236}">
+                <a16:creationId xmlns:a16="http://schemas.microsoft.com/office/drawing/2014/main" id="{09AEE580-E682-48B0-98AD-EF40EF037BAC}"/>
               </a:ext>
             </a:extLst>
           </p:cNvPr>
@@ -8585,10 +8960,10 @@
       </p:sp>
       <p:sp>
         <p:nvSpPr>
-          <p:cNvPr id="17" name="">
-            <a:extLst xmlns:a="http://schemas.openxmlformats.org/drawingml/2006/main">
-              <a:ext uri="{FF2B5EF4-FFF2-40B4-BE49-F238E27FC236}">
-                <a16:creationId xmlns:a16="http://schemas.microsoft.com/office/drawing/2014/main" id="{A18C7F48-1B26-4F79-BDBD-2C7869364F34}"/>
+          <p:cNvPr id="18" name="">
+            <a:extLst xmlns:a="http://schemas.openxmlformats.org/drawingml/2006/main">
+              <a:ext uri="{FF2B5EF4-FFF2-40B4-BE49-F238E27FC236}">
+                <a16:creationId xmlns:a16="http://schemas.microsoft.com/office/drawing/2014/main" id="{A4A3EAA9-C9DD-4106-B8B1-54089C86196B}"/>
               </a:ext>
             </a:extLst>
           </p:cNvPr>
@@ -8643,10 +9018,10 @@
       </p:sp>
       <p:sp>
         <p:nvSpPr>
-          <p:cNvPr id="18" name="">
-            <a:extLst xmlns:a="http://schemas.openxmlformats.org/drawingml/2006/main">
-              <a:ext uri="{FF2B5EF4-FFF2-40B4-BE49-F238E27FC236}">
-                <a16:creationId xmlns:a16="http://schemas.microsoft.com/office/drawing/2014/main" id="{83A5EEAE-178B-469A-BCCD-4482955F6D5C}"/>
+          <p:cNvPr id="19" name="">
+            <a:extLst xmlns:a="http://schemas.openxmlformats.org/drawingml/2006/main">
+              <a:ext uri="{FF2B5EF4-FFF2-40B4-BE49-F238E27FC236}">
+                <a16:creationId xmlns:a16="http://schemas.microsoft.com/office/drawing/2014/main" id="{E23BF6B2-1A47-4078-8140-BA015F80F877}"/>
               </a:ext>
             </a:extLst>
           </p:cNvPr>
@@ -8676,10 +9051,10 @@
       </p:sp>
       <p:sp>
         <p:nvSpPr>
-          <p:cNvPr id="19" name="">
-            <a:extLst xmlns:a="http://schemas.openxmlformats.org/drawingml/2006/main">
-              <a:ext uri="{FF2B5EF4-FFF2-40B4-BE49-F238E27FC236}">
-                <a16:creationId xmlns:a16="http://schemas.microsoft.com/office/drawing/2014/main" id="{D405C76C-A613-4942-B3FF-69E7F3B4C79A}"/>
+          <p:cNvPr id="20" name="">
+            <a:extLst xmlns:a="http://schemas.openxmlformats.org/drawingml/2006/main">
+              <a:ext uri="{FF2B5EF4-FFF2-40B4-BE49-F238E27FC236}">
+                <a16:creationId xmlns:a16="http://schemas.microsoft.com/office/drawing/2014/main" id="{BDE5C8BD-A72D-4171-8C14-31DDF9F8CD85}"/>
               </a:ext>
             </a:extLst>
           </p:cNvPr>
@@ -8734,10 +9109,10 @@
       </p:sp>
       <p:sp>
         <p:nvSpPr>
-          <p:cNvPr id="20" name="">
-            <a:extLst xmlns:a="http://schemas.openxmlformats.org/drawingml/2006/main">
-              <a:ext uri="{FF2B5EF4-FFF2-40B4-BE49-F238E27FC236}">
-                <a16:creationId xmlns:a16="http://schemas.microsoft.com/office/drawing/2014/main" id="{E9B01F41-D778-45C5-B248-2BEB2D34AC94}"/>
+          <p:cNvPr id="21" name="">
+            <a:extLst xmlns:a="http://schemas.openxmlformats.org/drawingml/2006/main">
+              <a:ext uri="{FF2B5EF4-FFF2-40B4-BE49-F238E27FC236}">
+                <a16:creationId xmlns:a16="http://schemas.microsoft.com/office/drawing/2014/main" id="{24F31647-22C2-433A-8300-7E10316CB34C}"/>
               </a:ext>
             </a:extLst>
           </p:cNvPr>
@@ -8792,10 +9167,10 @@
       </p:sp>
       <p:sp>
         <p:nvSpPr>
-          <p:cNvPr id="21" name="">
-            <a:extLst xmlns:a="http://schemas.openxmlformats.org/drawingml/2006/main">
-              <a:ext uri="{FF2B5EF4-FFF2-40B4-BE49-F238E27FC236}">
-                <a16:creationId xmlns:a16="http://schemas.microsoft.com/office/drawing/2014/main" id="{B49B894A-4C15-4364-A3F7-9E0A09134009}"/>
+          <p:cNvPr id="22" name="">
+            <a:extLst xmlns:a="http://schemas.openxmlformats.org/drawingml/2006/main">
+              <a:ext uri="{FF2B5EF4-FFF2-40B4-BE49-F238E27FC236}">
+                <a16:creationId xmlns:a16="http://schemas.microsoft.com/office/drawing/2014/main" id="{B702C6E8-76B4-448A-9BB6-EC95000967EC}"/>
               </a:ext>
             </a:extLst>
           </p:cNvPr>
@@ -8850,10 +9225,10 @@
       </p:sp>
       <p:sp>
         <p:nvSpPr>
-          <p:cNvPr id="22" name="">
-            <a:extLst xmlns:a="http://schemas.openxmlformats.org/drawingml/2006/main">
-              <a:ext uri="{FF2B5EF4-FFF2-40B4-BE49-F238E27FC236}">
-                <a16:creationId xmlns:a16="http://schemas.microsoft.com/office/drawing/2014/main" id="{5E473827-4788-4CF9-98FD-61106B03601B}"/>
+          <p:cNvPr id="23" name="">
+            <a:extLst xmlns:a="http://schemas.openxmlformats.org/drawingml/2006/main">
+              <a:ext uri="{FF2B5EF4-FFF2-40B4-BE49-F238E27FC236}">
+                <a16:creationId xmlns:a16="http://schemas.microsoft.com/office/drawing/2014/main" id="{C79CF974-124B-48A9-9FE8-DAC34E370A33}"/>
               </a:ext>
             </a:extLst>
           </p:cNvPr>
@@ -8883,10 +9258,10 @@
       </p:sp>
       <p:sp>
         <p:nvSpPr>
-          <p:cNvPr id="23" name="">
-            <a:extLst xmlns:a="http://schemas.openxmlformats.org/drawingml/2006/main">
-              <a:ext uri="{FF2B5EF4-FFF2-40B4-BE49-F238E27FC236}">
-                <a16:creationId xmlns:a16="http://schemas.microsoft.com/office/drawing/2014/main" id="{EB20AA71-344A-4BB7-9492-6CF9D4A6B72D}"/>
+          <p:cNvPr id="24" name="">
+            <a:extLst xmlns:a="http://schemas.openxmlformats.org/drawingml/2006/main">
+              <a:ext uri="{FF2B5EF4-FFF2-40B4-BE49-F238E27FC236}">
+                <a16:creationId xmlns:a16="http://schemas.microsoft.com/office/drawing/2014/main" id="{C1BF475D-7B11-4C85-BC71-7F3DC7F6023B}"/>
               </a:ext>
             </a:extLst>
           </p:cNvPr>
@@ -8941,10 +9316,10 @@
       </p:sp>
       <p:sp>
         <p:nvSpPr>
-          <p:cNvPr id="24" name="">
-            <a:extLst xmlns:a="http://schemas.openxmlformats.org/drawingml/2006/main">
-              <a:ext uri="{FF2B5EF4-FFF2-40B4-BE49-F238E27FC236}">
-                <a16:creationId xmlns:a16="http://schemas.microsoft.com/office/drawing/2014/main" id="{77689F5C-7176-44D5-8E02-33CB993A4D9A}"/>
+          <p:cNvPr id="25" name="">
+            <a:extLst xmlns:a="http://schemas.openxmlformats.org/drawingml/2006/main">
+              <a:ext uri="{FF2B5EF4-FFF2-40B4-BE49-F238E27FC236}">
+                <a16:creationId xmlns:a16="http://schemas.microsoft.com/office/drawing/2014/main" id="{31F89086-1ECC-4A5E-8DD6-2F1B1312AFF2}"/>
               </a:ext>
             </a:extLst>
           </p:cNvPr>
@@ -8999,10 +9374,10 @@
       </p:sp>
       <p:sp>
         <p:nvSpPr>
-          <p:cNvPr id="25" name="">
-            <a:extLst xmlns:a="http://schemas.openxmlformats.org/drawingml/2006/main">
-              <a:ext uri="{FF2B5EF4-FFF2-40B4-BE49-F238E27FC236}">
-                <a16:creationId xmlns:a16="http://schemas.microsoft.com/office/drawing/2014/main" id="{3752A56E-2096-4C00-8F62-FABA1FC2922C}"/>
+          <p:cNvPr id="26" name="">
+            <a:extLst xmlns:a="http://schemas.openxmlformats.org/drawingml/2006/main">
+              <a:ext uri="{FF2B5EF4-FFF2-40B4-BE49-F238E27FC236}">
+                <a16:creationId xmlns:a16="http://schemas.microsoft.com/office/drawing/2014/main" id="{8CAFA2A2-BB3E-4426-862F-57F3E3484348}"/>
               </a:ext>
             </a:extLst>
           </p:cNvPr>
@@ -9057,10 +9432,10 @@
       </p:sp>
       <p:sp>
         <p:nvSpPr>
-          <p:cNvPr id="26" name="action-queue-shot-frame">
-            <a:extLst xmlns:a="http://schemas.openxmlformats.org/drawingml/2006/main">
-              <a:ext uri="{FF2B5EF4-FFF2-40B4-BE49-F238E27FC236}">
-                <a16:creationId xmlns:a16="http://schemas.microsoft.com/office/drawing/2014/main" id="{02B17916-4C99-4948-A09D-7D0B5C91C88C}"/>
+          <p:cNvPr id="27" name="action-queue-shot-frame">
+            <a:extLst xmlns:a="http://schemas.openxmlformats.org/drawingml/2006/main">
+              <a:ext uri="{FF2B5EF4-FFF2-40B4-BE49-F238E27FC236}">
+                <a16:creationId xmlns:a16="http://schemas.microsoft.com/office/drawing/2014/main" id="{B8EA4A7E-38EA-44DD-8C9E-F603C5255DF5}"/>
               </a:ext>
             </a:extLst>
           </p:cNvPr>
@@ -9098,14 +9473,14 @@
       </p:sp>
       <p:pic>
         <p:nvPicPr>
-          <p:cNvPr id="56" name=""/>
+          <p:cNvPr id="58" name=""/>
           <p:cNvPicPr>
             <a:picLocks xmlns:a="http://schemas.openxmlformats.org/drawingml/2006/main" noChangeAspect="1"/>
           </p:cNvPicPr>
           <p:nvPr/>
         </p:nvPicPr>
         <p:blipFill>
-          <a:blip xmlns:r="http://schemas.openxmlformats.org/officeDocument/2006/relationships" xmlns:a="http://schemas.openxmlformats.org/drawingml/2006/main" r:embed="Rb0792f203c85452e"/>
+          <a:blip xmlns:r="http://schemas.openxmlformats.org/officeDocument/2006/relationships" xmlns:a="http://schemas.openxmlformats.org/drawingml/2006/main" r:embed="R727ef6d6d28d453d"/>
           <a:srcRect xmlns:a="http://schemas.openxmlformats.org/drawingml/2006/main" l="33" t="0" r="33" b="0"/>
           <a:stretch xmlns:a="http://schemas.openxmlformats.org/drawingml/2006/main">
             <a:fillRect l="0" t="0" r="0" b="0"/>
@@ -9125,10 +9500,10 @@
       </p:pic>
       <p:sp>
         <p:nvSpPr>
-          <p:cNvPr id="28" name="">
-            <a:extLst xmlns:a="http://schemas.openxmlformats.org/drawingml/2006/main">
-              <a:ext uri="{FF2B5EF4-FFF2-40B4-BE49-F238E27FC236}">
-                <a16:creationId xmlns:a16="http://schemas.microsoft.com/office/drawing/2014/main" id="{103AA150-DF2E-4EAE-81D0-90CF989900F4}"/>
+          <p:cNvPr id="29" name="">
+            <a:extLst xmlns:a="http://schemas.openxmlformats.org/drawingml/2006/main">
+              <a:ext uri="{FF2B5EF4-FFF2-40B4-BE49-F238E27FC236}">
+                <a16:creationId xmlns:a16="http://schemas.microsoft.com/office/drawing/2014/main" id="{6165417F-55C8-4315-8127-AFBDC837428C}"/>
               </a:ext>
             </a:extLst>
           </p:cNvPr>
@@ -9183,10 +9558,10 @@
       </p:sp>
       <p:sp>
         <p:nvSpPr>
-          <p:cNvPr id="29" name="">
-            <a:extLst xmlns:a="http://schemas.openxmlformats.org/drawingml/2006/main">
-              <a:ext uri="{FF2B5EF4-FFF2-40B4-BE49-F238E27FC236}">
-                <a16:creationId xmlns:a16="http://schemas.microsoft.com/office/drawing/2014/main" id="{A284900F-09B9-4D15-9880-82BB381B2B74}"/>
+          <p:cNvPr id="30" name="">
+            <a:extLst xmlns:a="http://schemas.openxmlformats.org/drawingml/2006/main">
+              <a:ext uri="{FF2B5EF4-FFF2-40B4-BE49-F238E27FC236}">
+                <a16:creationId xmlns:a16="http://schemas.microsoft.com/office/drawing/2014/main" id="{E2794E91-A224-44CF-BF68-C0A4EFD026AC}"/>
               </a:ext>
             </a:extLst>
           </p:cNvPr>
@@ -9242,7 +9617,7 @@
     </p:spTree>
     <p:extLst>
       <p:ext uri="{BB962C8B-B14F-4D97-AF65-F5344CB8AC3E}">
-        <p14:creationId xmlns:p14="http://schemas.microsoft.com/office/powerpoint/2010/main" val="2140840194"/>
+        <p14:creationId xmlns:p14="http://schemas.microsoft.com/office/powerpoint/2010/main" val="585381479"/>
       </p:ext>
     </p:extLst>
   </p:cSld>
@@ -9270,10 +9645,10 @@
       </p:grpSpPr>
       <p:sp>
         <p:nvSpPr>
-          <p:cNvPr id="33" name="">
-            <a:extLst xmlns:a="http://schemas.openxmlformats.org/drawingml/2006/main">
-              <a:ext uri="{FF2B5EF4-FFF2-40B4-BE49-F238E27FC236}">
-                <a16:creationId xmlns:a16="http://schemas.microsoft.com/office/drawing/2014/main" id="{AF6BA4C6-6537-4FBB-A6B1-A3CF28CB2988}"/>
+          <p:cNvPr id="34" name="">
+            <a:extLst xmlns:a="http://schemas.openxmlformats.org/drawingml/2006/main">
+              <a:ext uri="{FF2B5EF4-FFF2-40B4-BE49-F238E27FC236}">
+                <a16:creationId xmlns:a16="http://schemas.microsoft.com/office/drawing/2014/main" id="{72C9A87E-F10C-4D65-A119-334B7D49F636}"/>
               </a:ext>
             </a:extLst>
           </p:cNvPr>
@@ -9306,7 +9681,7 @@
           <p:cNvPr id="2" name="">
             <a:extLst xmlns:a="http://schemas.openxmlformats.org/drawingml/2006/main">
               <a:ext uri="{FF2B5EF4-FFF2-40B4-BE49-F238E27FC236}">
-                <a16:creationId xmlns:a16="http://schemas.microsoft.com/office/drawing/2014/main" id="{D6B043D0-6E43-4F91-B4A2-5C21C752C940}"/>
+                <a16:creationId xmlns:a16="http://schemas.microsoft.com/office/drawing/2014/main" id="{7FDC1D58-3CD9-458F-82E9-38BAF0D06BE9}"/>
               </a:ext>
             </a:extLst>
           </p:cNvPr>
@@ -9354,7 +9729,7 @@
                 <a:ea typeface="Courier New"/>
                 <a:cs typeface="Courier New"/>
               </a:rPr>
-              <a:t>LRWA / CATEGORY POSITION</a:t>
+              <a:t>CATEGORY POSITION</a:t>
             </a:r>
           </a:p>
         </p:txBody>
@@ -9364,7 +9739,7 @@
           <p:cNvPr id="3" name="">
             <a:extLst xmlns:a="http://schemas.openxmlformats.org/drawingml/2006/main">
               <a:ext uri="{FF2B5EF4-FFF2-40B4-BE49-F238E27FC236}">
-                <a16:creationId xmlns:a16="http://schemas.microsoft.com/office/drawing/2014/main" id="{D0B6CA7F-5905-4EE1-8378-E7AA61DE654C}"/>
+                <a16:creationId xmlns:a16="http://schemas.microsoft.com/office/drawing/2014/main" id="{55BDEBB3-323E-4C10-BDF5-8D073A3D1304}"/>
               </a:ext>
             </a:extLst>
           </p:cNvPr>
@@ -9422,7 +9797,7 @@
           <p:cNvPr id="4" name="">
             <a:extLst xmlns:a="http://schemas.openxmlformats.org/drawingml/2006/main">
               <a:ext uri="{FF2B5EF4-FFF2-40B4-BE49-F238E27FC236}">
-                <a16:creationId xmlns:a16="http://schemas.microsoft.com/office/drawing/2014/main" id="{C0819BA4-4150-47E2-AF2F-B064204688C0}"/>
+                <a16:creationId xmlns:a16="http://schemas.microsoft.com/office/drawing/2014/main" id="{247B6235-1650-446F-90C9-3A77EF1C956A}"/>
               </a:ext>
             </a:extLst>
           </p:cNvPr>
@@ -9448,24 +9823,52 @@
           </a:ln>
         </p:spPr>
       </p:sp>
-      <p:sp>
-        <p:nvSpPr>
-          <p:cNvPr id="5" name="">
-            <a:extLst xmlns:a="http://schemas.openxmlformats.org/drawingml/2006/main">
-              <a:ext uri="{FF2B5EF4-FFF2-40B4-BE49-F238E27FC236}">
-                <a16:creationId xmlns:a16="http://schemas.microsoft.com/office/drawing/2014/main" id="{8FEF05FF-7C8B-4321-99E3-3B244D35AE12}"/>
-              </a:ext>
-            </a:extLst>
-          </p:cNvPr>
-          <p:cNvSpPr>
-            <a:spLocks xmlns:a="http://schemas.openxmlformats.org/drawingml/2006/main" noGrp="1"/>
-          </p:cNvSpPr>
-          <p:nvPr/>
-        </p:nvSpPr>
-        <p:spPr>
-          <a:xfrm xmlns:a="http://schemas.openxmlformats.org/drawingml/2006/main" rot="0">
-            <a:off x="609600" y="6562725"/>
-            <a:ext cx="2857500" cy="133350"/>
+      <p:pic>
+        <p:nvPicPr>
+          <p:cNvPr id="38" name=""/>
+          <p:cNvPicPr>
+            <a:picLocks xmlns:a="http://schemas.openxmlformats.org/drawingml/2006/main" noChangeAspect="1"/>
+          </p:cNvPicPr>
+          <p:nvPr/>
+        </p:nvPicPr>
+        <p:blipFill>
+          <a:blip xmlns:r="http://schemas.openxmlformats.org/officeDocument/2006/relationships" xmlns:a="http://schemas.openxmlformats.org/drawingml/2006/main" r:embed="Reb98867d40b04f94">
+            <a:extLst>
+              <a:ext uri="{96DAC541-7B7A-43D3-8B79-37D633B846F1}">
+                <asvg:svgBlip xmlns:asvg="http://schemas.microsoft.com/office/drawing/2016/SVG/main" r:embed="Rf0be59faed2e467e"/>
+              </a:ext>
+            </a:extLst>
+          </a:blip>
+          <a:stretch xmlns:a="http://schemas.openxmlformats.org/drawingml/2006/main"/>
+        </p:blipFill>
+        <p:spPr>
+          <a:xfrm xmlns:a="http://schemas.openxmlformats.org/drawingml/2006/main">
+            <a:off x="609600" y="6524625"/>
+            <a:ext cx="171450" cy="171450"/>
+          </a:xfrm>
+          <a:prstGeom xmlns:a="http://schemas.openxmlformats.org/drawingml/2006/main" prst="rect">
+            <a:avLst/>
+          </a:prstGeom>
+        </p:spPr>
+      </p:pic>
+      <p:sp>
+        <p:nvSpPr>
+          <p:cNvPr id="6" name="">
+            <a:extLst xmlns:a="http://schemas.openxmlformats.org/drawingml/2006/main">
+              <a:ext uri="{FF2B5EF4-FFF2-40B4-BE49-F238E27FC236}">
+                <a16:creationId xmlns:a16="http://schemas.microsoft.com/office/drawing/2014/main" id="{CACA81FE-74F8-47B4-8E76-9F97447C212D}"/>
+              </a:ext>
+            </a:extLst>
+          </p:cNvPr>
+          <p:cNvSpPr>
+            <a:spLocks xmlns:a="http://schemas.openxmlformats.org/drawingml/2006/main" noGrp="1"/>
+          </p:cNvSpPr>
+          <p:nvPr/>
+        </p:nvSpPr>
+        <p:spPr>
+          <a:xfrm xmlns:a="http://schemas.openxmlformats.org/drawingml/2006/main" rot="0">
+            <a:off x="857250" y="6562725"/>
+            <a:ext cx="3238500" cy="133350"/>
           </a:xfrm>
           <a:prstGeom xmlns:a="http://schemas.openxmlformats.org/drawingml/2006/main" prst="rect">
             <a:avLst/>
@@ -9501,17 +9904,17 @@
                 <a:ea typeface="Courier New"/>
                 <a:cs typeface="Courier New"/>
               </a:rPr>
-              <a:t>LIVE REAL-WORLD ASSURANCE</a:t>
-            </a:r>
-          </a:p>
-        </p:txBody>
-      </p:sp>
-      <p:sp>
-        <p:nvSpPr>
-          <p:cNvPr id="6" name="">
-            <a:extLst xmlns:a="http://schemas.openxmlformats.org/drawingml/2006/main">
-              <a:ext uri="{FF2B5EF4-FFF2-40B4-BE49-F238E27FC236}">
-                <a16:creationId xmlns:a16="http://schemas.microsoft.com/office/drawing/2014/main" id="{BA0180B9-5FD0-4554-B204-444C1E1F92BD}"/>
+              <a:t>LRWA / LIVE REAL-WORLD ASSURANCE</a:t>
+            </a:r>
+          </a:p>
+        </p:txBody>
+      </p:sp>
+      <p:sp>
+        <p:nvSpPr>
+          <p:cNvPr id="7" name="">
+            <a:extLst xmlns:a="http://schemas.openxmlformats.org/drawingml/2006/main">
+              <a:ext uri="{FF2B5EF4-FFF2-40B4-BE49-F238E27FC236}">
+                <a16:creationId xmlns:a16="http://schemas.microsoft.com/office/drawing/2014/main" id="{DE111D55-9915-4D83-911C-7D0A3792A17A}"/>
               </a:ext>
             </a:extLst>
           </p:cNvPr>
@@ -9566,10 +9969,10 @@
       </p:sp>
       <p:sp>
         <p:nvSpPr>
-          <p:cNvPr id="7" name="">
-            <a:extLst xmlns:a="http://schemas.openxmlformats.org/drawingml/2006/main">
-              <a:ext uri="{FF2B5EF4-FFF2-40B4-BE49-F238E27FC236}">
-                <a16:creationId xmlns:a16="http://schemas.microsoft.com/office/drawing/2014/main" id="{4D6A6ACB-3BA1-4A68-A1C0-FB00C29A73DD}"/>
+          <p:cNvPr id="8" name="">
+            <a:extLst xmlns:a="http://schemas.openxmlformats.org/drawingml/2006/main">
+              <a:ext uri="{FF2B5EF4-FFF2-40B4-BE49-F238E27FC236}">
+                <a16:creationId xmlns:a16="http://schemas.microsoft.com/office/drawing/2014/main" id="{23CF7380-50A6-4863-8FA6-8406FC199EC7}"/>
               </a:ext>
             </a:extLst>
           </p:cNvPr>
@@ -9628,10 +10031,10 @@
       </p:sp>
       <p:sp>
         <p:nvSpPr>
-          <p:cNvPr id="8" name="">
-            <a:extLst xmlns:a="http://schemas.openxmlformats.org/drawingml/2006/main">
-              <a:ext uri="{FF2B5EF4-FFF2-40B4-BE49-F238E27FC236}">
-                <a16:creationId xmlns:a16="http://schemas.microsoft.com/office/drawing/2014/main" id="{85D41806-D20A-4299-B141-6BA0218B6C6D}"/>
+          <p:cNvPr id="9" name="">
+            <a:extLst xmlns:a="http://schemas.openxmlformats.org/drawingml/2006/main">
+              <a:ext uri="{FF2B5EF4-FFF2-40B4-BE49-F238E27FC236}">
+                <a16:creationId xmlns:a16="http://schemas.microsoft.com/office/drawing/2014/main" id="{A2A37E7D-F0EE-4AA2-9241-E1B1894333E1}"/>
               </a:ext>
             </a:extLst>
           </p:cNvPr>
@@ -9690,10 +10093,10 @@
       </p:sp>
       <p:sp>
         <p:nvSpPr>
-          <p:cNvPr id="9" name="">
-            <a:extLst xmlns:a="http://schemas.openxmlformats.org/drawingml/2006/main">
-              <a:ext uri="{FF2B5EF4-FFF2-40B4-BE49-F238E27FC236}">
-                <a16:creationId xmlns:a16="http://schemas.microsoft.com/office/drawing/2014/main" id="{7FB6A5E7-52ED-4A6A-9D99-A67DA2B7ED77}"/>
+          <p:cNvPr id="10" name="">
+            <a:extLst xmlns:a="http://schemas.openxmlformats.org/drawingml/2006/main">
+              <a:ext uri="{FF2B5EF4-FFF2-40B4-BE49-F238E27FC236}">
+                <a16:creationId xmlns:a16="http://schemas.microsoft.com/office/drawing/2014/main" id="{B7716398-1995-4A44-8EE8-43F86567BECF}"/>
               </a:ext>
             </a:extLst>
           </p:cNvPr>
@@ -9748,10 +10151,10 @@
       </p:sp>
       <p:sp>
         <p:nvSpPr>
-          <p:cNvPr id="10" name="">
-            <a:extLst xmlns:a="http://schemas.openxmlformats.org/drawingml/2006/main">
-              <a:ext uri="{FF2B5EF4-FFF2-40B4-BE49-F238E27FC236}">
-                <a16:creationId xmlns:a16="http://schemas.microsoft.com/office/drawing/2014/main" id="{8650BBE0-40BD-4E87-B1F9-8F1D9F7FA7F1}"/>
+          <p:cNvPr id="11" name="">
+            <a:extLst xmlns:a="http://schemas.openxmlformats.org/drawingml/2006/main">
+              <a:ext uri="{FF2B5EF4-FFF2-40B4-BE49-F238E27FC236}">
+                <a16:creationId xmlns:a16="http://schemas.microsoft.com/office/drawing/2014/main" id="{13B74C2D-D171-4A77-93A2-EAA8982FADE2}"/>
               </a:ext>
             </a:extLst>
           </p:cNvPr>
@@ -9806,10 +10209,10 @@
       </p:sp>
       <p:sp>
         <p:nvSpPr>
-          <p:cNvPr id="11" name="">
-            <a:extLst xmlns:a="http://schemas.openxmlformats.org/drawingml/2006/main">
-              <a:ext uri="{FF2B5EF4-FFF2-40B4-BE49-F238E27FC236}">
-                <a16:creationId xmlns:a16="http://schemas.microsoft.com/office/drawing/2014/main" id="{7946F9DF-5073-4EE6-8F0C-84AE20F0A712}"/>
+          <p:cNvPr id="12" name="">
+            <a:extLst xmlns:a="http://schemas.openxmlformats.org/drawingml/2006/main">
+              <a:ext uri="{FF2B5EF4-FFF2-40B4-BE49-F238E27FC236}">
+                <a16:creationId xmlns:a16="http://schemas.microsoft.com/office/drawing/2014/main" id="{0FB94E3C-74D6-4D5C-AE49-3EE9C1AA2108}"/>
               </a:ext>
             </a:extLst>
           </p:cNvPr>
@@ -9868,10 +10271,10 @@
       </p:sp>
       <p:sp>
         <p:nvSpPr>
-          <p:cNvPr id="12" name="">
-            <a:extLst xmlns:a="http://schemas.openxmlformats.org/drawingml/2006/main">
-              <a:ext uri="{FF2B5EF4-FFF2-40B4-BE49-F238E27FC236}">
-                <a16:creationId xmlns:a16="http://schemas.microsoft.com/office/drawing/2014/main" id="{CC997434-4CFA-4CDE-84D3-E16EAC59E93C}"/>
+          <p:cNvPr id="13" name="">
+            <a:extLst xmlns:a="http://schemas.openxmlformats.org/drawingml/2006/main">
+              <a:ext uri="{FF2B5EF4-FFF2-40B4-BE49-F238E27FC236}">
+                <a16:creationId xmlns:a16="http://schemas.microsoft.com/office/drawing/2014/main" id="{DBE27312-3542-4F24-886D-08DC7E31E979}"/>
               </a:ext>
             </a:extLst>
           </p:cNvPr>
@@ -9926,10 +10329,10 @@
       </p:sp>
       <p:sp>
         <p:nvSpPr>
-          <p:cNvPr id="13" name="">
-            <a:extLst xmlns:a="http://schemas.openxmlformats.org/drawingml/2006/main">
-              <a:ext uri="{FF2B5EF4-FFF2-40B4-BE49-F238E27FC236}">
-                <a16:creationId xmlns:a16="http://schemas.microsoft.com/office/drawing/2014/main" id="{04C99606-5A63-4F33-A90F-24D1DCA53C18}"/>
+          <p:cNvPr id="14" name="">
+            <a:extLst xmlns:a="http://schemas.openxmlformats.org/drawingml/2006/main">
+              <a:ext uri="{FF2B5EF4-FFF2-40B4-BE49-F238E27FC236}">
+                <a16:creationId xmlns:a16="http://schemas.microsoft.com/office/drawing/2014/main" id="{262D70AC-FB5D-433A-8488-9C396F2F488F}"/>
               </a:ext>
             </a:extLst>
           </p:cNvPr>
@@ -9988,10 +10391,10 @@
       </p:sp>
       <p:sp>
         <p:nvSpPr>
-          <p:cNvPr id="14" name="">
-            <a:extLst xmlns:a="http://schemas.openxmlformats.org/drawingml/2006/main">
-              <a:ext uri="{FF2B5EF4-FFF2-40B4-BE49-F238E27FC236}">
-                <a16:creationId xmlns:a16="http://schemas.microsoft.com/office/drawing/2014/main" id="{15F0F1AB-377F-4B70-A53A-A02C11103110}"/>
+          <p:cNvPr id="15" name="">
+            <a:extLst xmlns:a="http://schemas.openxmlformats.org/drawingml/2006/main">
+              <a:ext uri="{FF2B5EF4-FFF2-40B4-BE49-F238E27FC236}">
+                <a16:creationId xmlns:a16="http://schemas.microsoft.com/office/drawing/2014/main" id="{1B97D740-A6E9-4710-ADA1-F3761AADFF03}"/>
               </a:ext>
             </a:extLst>
           </p:cNvPr>
@@ -10046,10 +10449,10 @@
       </p:sp>
       <p:sp>
         <p:nvSpPr>
-          <p:cNvPr id="15" name="">
-            <a:extLst xmlns:a="http://schemas.openxmlformats.org/drawingml/2006/main">
-              <a:ext uri="{FF2B5EF4-FFF2-40B4-BE49-F238E27FC236}">
-                <a16:creationId xmlns:a16="http://schemas.microsoft.com/office/drawing/2014/main" id="{1BFBEE61-8243-4A42-AC3E-7159E9ED0261}"/>
+          <p:cNvPr id="16" name="">
+            <a:extLst xmlns:a="http://schemas.openxmlformats.org/drawingml/2006/main">
+              <a:ext uri="{FF2B5EF4-FFF2-40B4-BE49-F238E27FC236}">
+                <a16:creationId xmlns:a16="http://schemas.microsoft.com/office/drawing/2014/main" id="{5178B79D-6EFF-4611-A580-A922916E4E94}"/>
               </a:ext>
             </a:extLst>
           </p:cNvPr>
@@ -10108,10 +10511,10 @@
       </p:sp>
       <p:sp>
         <p:nvSpPr>
-          <p:cNvPr id="16" name="">
-            <a:extLst xmlns:a="http://schemas.openxmlformats.org/drawingml/2006/main">
-              <a:ext uri="{FF2B5EF4-FFF2-40B4-BE49-F238E27FC236}">
-                <a16:creationId xmlns:a16="http://schemas.microsoft.com/office/drawing/2014/main" id="{CD2F9C33-5EBD-4363-AEAE-A1FD550FAE84}"/>
+          <p:cNvPr id="17" name="">
+            <a:extLst xmlns:a="http://schemas.openxmlformats.org/drawingml/2006/main">
+              <a:ext uri="{FF2B5EF4-FFF2-40B4-BE49-F238E27FC236}">
+                <a16:creationId xmlns:a16="http://schemas.microsoft.com/office/drawing/2014/main" id="{5FE28563-0181-4571-A714-5F8C8530CE9E}"/>
               </a:ext>
             </a:extLst>
           </p:cNvPr>
@@ -10139,10 +10542,10 @@
       </p:sp>
       <p:sp>
         <p:nvSpPr>
-          <p:cNvPr id="17" name="">
-            <a:extLst xmlns:a="http://schemas.openxmlformats.org/drawingml/2006/main">
-              <a:ext uri="{FF2B5EF4-FFF2-40B4-BE49-F238E27FC236}">
-                <a16:creationId xmlns:a16="http://schemas.microsoft.com/office/drawing/2014/main" id="{562CB040-4876-4E7A-9D9D-7AD5A20F777F}"/>
+          <p:cNvPr id="18" name="">
+            <a:extLst xmlns:a="http://schemas.openxmlformats.org/drawingml/2006/main">
+              <a:ext uri="{FF2B5EF4-FFF2-40B4-BE49-F238E27FC236}">
+                <a16:creationId xmlns:a16="http://schemas.microsoft.com/office/drawing/2014/main" id="{77A7F590-616B-4372-B1D5-A0BA9852597C}"/>
               </a:ext>
             </a:extLst>
           </p:cNvPr>
@@ -10197,10 +10600,10 @@
       </p:sp>
       <p:sp>
         <p:nvSpPr>
-          <p:cNvPr id="18" name="">
-            <a:extLst xmlns:a="http://schemas.openxmlformats.org/drawingml/2006/main">
-              <a:ext uri="{FF2B5EF4-FFF2-40B4-BE49-F238E27FC236}">
-                <a16:creationId xmlns:a16="http://schemas.microsoft.com/office/drawing/2014/main" id="{C3826E08-79D1-4AB6-AA7E-7C019B4D6D98}"/>
+          <p:cNvPr id="19" name="">
+            <a:extLst xmlns:a="http://schemas.openxmlformats.org/drawingml/2006/main">
+              <a:ext uri="{FF2B5EF4-FFF2-40B4-BE49-F238E27FC236}">
+                <a16:creationId xmlns:a16="http://schemas.microsoft.com/office/drawing/2014/main" id="{D709FA31-DB26-4AE6-83E8-BD4E244DDED1}"/>
               </a:ext>
             </a:extLst>
           </p:cNvPr>
@@ -10255,10 +10658,10 @@
       </p:sp>
       <p:sp>
         <p:nvSpPr>
-          <p:cNvPr id="19" name="">
-            <a:extLst xmlns:a="http://schemas.openxmlformats.org/drawingml/2006/main">
-              <a:ext uri="{FF2B5EF4-FFF2-40B4-BE49-F238E27FC236}">
-                <a16:creationId xmlns:a16="http://schemas.microsoft.com/office/drawing/2014/main" id="{8A92308B-2177-49F2-86BD-DD7884C4A387}"/>
+          <p:cNvPr id="20" name="">
+            <a:extLst xmlns:a="http://schemas.openxmlformats.org/drawingml/2006/main">
+              <a:ext uri="{FF2B5EF4-FFF2-40B4-BE49-F238E27FC236}">
+                <a16:creationId xmlns:a16="http://schemas.microsoft.com/office/drawing/2014/main" id="{83F29988-0D1F-4EE3-9391-6E4CA3C5E8C2}"/>
               </a:ext>
             </a:extLst>
           </p:cNvPr>
@@ -10313,10 +10716,10 @@
       </p:sp>
       <p:sp>
         <p:nvSpPr>
-          <p:cNvPr id="20" name="">
-            <a:extLst xmlns:a="http://schemas.openxmlformats.org/drawingml/2006/main">
-              <a:ext uri="{FF2B5EF4-FFF2-40B4-BE49-F238E27FC236}">
-                <a16:creationId xmlns:a16="http://schemas.microsoft.com/office/drawing/2014/main" id="{824ADAFD-C833-41DC-A379-F70D3212F9CD}"/>
+          <p:cNvPr id="21" name="">
+            <a:extLst xmlns:a="http://schemas.openxmlformats.org/drawingml/2006/main">
+              <a:ext uri="{FF2B5EF4-FFF2-40B4-BE49-F238E27FC236}">
+                <a16:creationId xmlns:a16="http://schemas.microsoft.com/office/drawing/2014/main" id="{D1D2240E-41D3-4CDD-AD8F-412F05DF88C6}"/>
               </a:ext>
             </a:extLst>
           </p:cNvPr>
@@ -10344,10 +10747,10 @@
       </p:sp>
       <p:sp>
         <p:nvSpPr>
-          <p:cNvPr id="21" name="">
-            <a:extLst xmlns:a="http://schemas.openxmlformats.org/drawingml/2006/main">
-              <a:ext uri="{FF2B5EF4-FFF2-40B4-BE49-F238E27FC236}">
-                <a16:creationId xmlns:a16="http://schemas.microsoft.com/office/drawing/2014/main" id="{58F6E865-46C7-4837-BD8C-5D3E82CE1EEC}"/>
+          <p:cNvPr id="22" name="">
+            <a:extLst xmlns:a="http://schemas.openxmlformats.org/drawingml/2006/main">
+              <a:ext uri="{FF2B5EF4-FFF2-40B4-BE49-F238E27FC236}">
+                <a16:creationId xmlns:a16="http://schemas.microsoft.com/office/drawing/2014/main" id="{28773471-B9AE-4C52-A682-0DA27854DB57}"/>
               </a:ext>
             </a:extLst>
           </p:cNvPr>
@@ -10402,10 +10805,10 @@
       </p:sp>
       <p:sp>
         <p:nvSpPr>
-          <p:cNvPr id="22" name="">
-            <a:extLst xmlns:a="http://schemas.openxmlformats.org/drawingml/2006/main">
-              <a:ext uri="{FF2B5EF4-FFF2-40B4-BE49-F238E27FC236}">
-                <a16:creationId xmlns:a16="http://schemas.microsoft.com/office/drawing/2014/main" id="{D40D62F5-0AC1-4220-A082-1B8F93A94E3C}"/>
+          <p:cNvPr id="23" name="">
+            <a:extLst xmlns:a="http://schemas.openxmlformats.org/drawingml/2006/main">
+              <a:ext uri="{FF2B5EF4-FFF2-40B4-BE49-F238E27FC236}">
+                <a16:creationId xmlns:a16="http://schemas.microsoft.com/office/drawing/2014/main" id="{42281C29-5685-4F8E-A161-19EF83663380}"/>
               </a:ext>
             </a:extLst>
           </p:cNvPr>
@@ -10460,10 +10863,10 @@
       </p:sp>
       <p:sp>
         <p:nvSpPr>
-          <p:cNvPr id="23" name="">
-            <a:extLst xmlns:a="http://schemas.openxmlformats.org/drawingml/2006/main">
-              <a:ext uri="{FF2B5EF4-FFF2-40B4-BE49-F238E27FC236}">
-                <a16:creationId xmlns:a16="http://schemas.microsoft.com/office/drawing/2014/main" id="{5E16FD16-E03A-42C5-855E-A051247F5248}"/>
+          <p:cNvPr id="24" name="">
+            <a:extLst xmlns:a="http://schemas.openxmlformats.org/drawingml/2006/main">
+              <a:ext uri="{FF2B5EF4-FFF2-40B4-BE49-F238E27FC236}">
+                <a16:creationId xmlns:a16="http://schemas.microsoft.com/office/drawing/2014/main" id="{6D2B30DC-CC39-4F78-BFF1-97E7A0E0869C}"/>
               </a:ext>
             </a:extLst>
           </p:cNvPr>
@@ -10491,10 +10894,10 @@
       </p:sp>
       <p:sp>
         <p:nvSpPr>
-          <p:cNvPr id="24" name="">
-            <a:extLst xmlns:a="http://schemas.openxmlformats.org/drawingml/2006/main">
-              <a:ext uri="{FF2B5EF4-FFF2-40B4-BE49-F238E27FC236}">
-                <a16:creationId xmlns:a16="http://schemas.microsoft.com/office/drawing/2014/main" id="{DFE6F5C3-E60A-4F28-BA49-C8A34397F75E}"/>
+          <p:cNvPr id="25" name="">
+            <a:extLst xmlns:a="http://schemas.openxmlformats.org/drawingml/2006/main">
+              <a:ext uri="{FF2B5EF4-FFF2-40B4-BE49-F238E27FC236}">
+                <a16:creationId xmlns:a16="http://schemas.microsoft.com/office/drawing/2014/main" id="{3E55E05D-E338-46B8-8274-3730F10A15B1}"/>
               </a:ext>
             </a:extLst>
           </p:cNvPr>
@@ -10549,10 +10952,10 @@
       </p:sp>
       <p:sp>
         <p:nvSpPr>
-          <p:cNvPr id="25" name="">
-            <a:extLst xmlns:a="http://schemas.openxmlformats.org/drawingml/2006/main">
-              <a:ext uri="{FF2B5EF4-FFF2-40B4-BE49-F238E27FC236}">
-                <a16:creationId xmlns:a16="http://schemas.microsoft.com/office/drawing/2014/main" id="{405D353F-9D6B-4687-BED1-1C372590C469}"/>
+          <p:cNvPr id="26" name="">
+            <a:extLst xmlns:a="http://schemas.openxmlformats.org/drawingml/2006/main">
+              <a:ext uri="{FF2B5EF4-FFF2-40B4-BE49-F238E27FC236}">
+                <a16:creationId xmlns:a16="http://schemas.microsoft.com/office/drawing/2014/main" id="{1D716EC1-3786-4AB2-9712-E76505C4EAE5}"/>
               </a:ext>
             </a:extLst>
           </p:cNvPr>
@@ -10607,10 +11010,10 @@
       </p:sp>
       <p:sp>
         <p:nvSpPr>
-          <p:cNvPr id="26" name="">
-            <a:extLst xmlns:a="http://schemas.openxmlformats.org/drawingml/2006/main">
-              <a:ext uri="{FF2B5EF4-FFF2-40B4-BE49-F238E27FC236}">
-                <a16:creationId xmlns:a16="http://schemas.microsoft.com/office/drawing/2014/main" id="{185E4EB6-B5BF-4A03-AA04-AF9649E807C0}"/>
+          <p:cNvPr id="27" name="">
+            <a:extLst xmlns:a="http://schemas.openxmlformats.org/drawingml/2006/main">
+              <a:ext uri="{FF2B5EF4-FFF2-40B4-BE49-F238E27FC236}">
+                <a16:creationId xmlns:a16="http://schemas.microsoft.com/office/drawing/2014/main" id="{A8A09D58-D220-44FE-B838-A9A1AE904BD7}"/>
               </a:ext>
             </a:extLst>
           </p:cNvPr>
@@ -10638,10 +11041,10 @@
       </p:sp>
       <p:sp>
         <p:nvSpPr>
-          <p:cNvPr id="27" name="">
-            <a:extLst xmlns:a="http://schemas.openxmlformats.org/drawingml/2006/main">
-              <a:ext uri="{FF2B5EF4-FFF2-40B4-BE49-F238E27FC236}">
-                <a16:creationId xmlns:a16="http://schemas.microsoft.com/office/drawing/2014/main" id="{DFCD0164-DC1A-4E6C-91D8-E4FDFF522678}"/>
+          <p:cNvPr id="28" name="">
+            <a:extLst xmlns:a="http://schemas.openxmlformats.org/drawingml/2006/main">
+              <a:ext uri="{FF2B5EF4-FFF2-40B4-BE49-F238E27FC236}">
+                <a16:creationId xmlns:a16="http://schemas.microsoft.com/office/drawing/2014/main" id="{5C7F90D7-5ED2-45A8-B7B9-DC8C84700D74}"/>
               </a:ext>
             </a:extLst>
           </p:cNvPr>
@@ -10696,10 +11099,10 @@
       </p:sp>
       <p:sp>
         <p:nvSpPr>
-          <p:cNvPr id="28" name="">
-            <a:extLst xmlns:a="http://schemas.openxmlformats.org/drawingml/2006/main">
-              <a:ext uri="{FF2B5EF4-FFF2-40B4-BE49-F238E27FC236}">
-                <a16:creationId xmlns:a16="http://schemas.microsoft.com/office/drawing/2014/main" id="{54AD403D-82FD-4A75-8A8D-EE4E7607E49F}"/>
+          <p:cNvPr id="29" name="">
+            <a:extLst xmlns:a="http://schemas.openxmlformats.org/drawingml/2006/main">
+              <a:ext uri="{FF2B5EF4-FFF2-40B4-BE49-F238E27FC236}">
+                <a16:creationId xmlns:a16="http://schemas.microsoft.com/office/drawing/2014/main" id="{AED83E7A-D5BD-4C22-87A9-7D346BB50B78}"/>
               </a:ext>
             </a:extLst>
           </p:cNvPr>
@@ -10754,10 +11157,10 @@
       </p:sp>
       <p:sp>
         <p:nvSpPr>
-          <p:cNvPr id="29" name="">
-            <a:extLst xmlns:a="http://schemas.openxmlformats.org/drawingml/2006/main">
-              <a:ext uri="{FF2B5EF4-FFF2-40B4-BE49-F238E27FC236}">
-                <a16:creationId xmlns:a16="http://schemas.microsoft.com/office/drawing/2014/main" id="{2A9CF736-1DB4-4E3D-99FD-9680FF8941C8}"/>
+          <p:cNvPr id="30" name="">
+            <a:extLst xmlns:a="http://schemas.openxmlformats.org/drawingml/2006/main">
+              <a:ext uri="{FF2B5EF4-FFF2-40B4-BE49-F238E27FC236}">
+                <a16:creationId xmlns:a16="http://schemas.microsoft.com/office/drawing/2014/main" id="{BAAC4396-7952-495C-A1A7-6A5CDACBACE1}"/>
               </a:ext>
             </a:extLst>
           </p:cNvPr>
@@ -10785,10 +11188,10 @@
       </p:sp>
       <p:sp>
         <p:nvSpPr>
-          <p:cNvPr id="30" name="">
-            <a:extLst xmlns:a="http://schemas.openxmlformats.org/drawingml/2006/main">
-              <a:ext uri="{FF2B5EF4-FFF2-40B4-BE49-F238E27FC236}">
-                <a16:creationId xmlns:a16="http://schemas.microsoft.com/office/drawing/2014/main" id="{E0ED4FB3-56D0-4056-BD82-3566351537ED}"/>
+          <p:cNvPr id="31" name="">
+            <a:extLst xmlns:a="http://schemas.openxmlformats.org/drawingml/2006/main">
+              <a:ext uri="{FF2B5EF4-FFF2-40B4-BE49-F238E27FC236}">
+                <a16:creationId xmlns:a16="http://schemas.microsoft.com/office/drawing/2014/main" id="{E7CF6709-1BFF-4A81-AAD0-C7F74481F833}"/>
               </a:ext>
             </a:extLst>
           </p:cNvPr>
@@ -10820,10 +11223,10 @@
       </p:sp>
       <p:sp>
         <p:nvSpPr>
-          <p:cNvPr id="31" name="">
-            <a:extLst xmlns:a="http://schemas.openxmlformats.org/drawingml/2006/main">
-              <a:ext uri="{FF2B5EF4-FFF2-40B4-BE49-F238E27FC236}">
-                <a16:creationId xmlns:a16="http://schemas.microsoft.com/office/drawing/2014/main" id="{7D6CCF31-38B3-477E-BF7E-1C2D7E0DA9A2}"/>
+          <p:cNvPr id="32" name="">
+            <a:extLst xmlns:a="http://schemas.openxmlformats.org/drawingml/2006/main">
+              <a:ext uri="{FF2B5EF4-FFF2-40B4-BE49-F238E27FC236}">
+                <a16:creationId xmlns:a16="http://schemas.microsoft.com/office/drawing/2014/main" id="{978D36D6-BE91-4E1F-94B3-EDFC66A6DC08}"/>
               </a:ext>
             </a:extLst>
           </p:cNvPr>
@@ -10878,10 +11281,10 @@
       </p:sp>
       <p:sp>
         <p:nvSpPr>
-          <p:cNvPr id="32" name="">
-            <a:extLst xmlns:a="http://schemas.openxmlformats.org/drawingml/2006/main">
-              <a:ext uri="{FF2B5EF4-FFF2-40B4-BE49-F238E27FC236}">
-                <a16:creationId xmlns:a16="http://schemas.microsoft.com/office/drawing/2014/main" id="{EF50A35C-2254-41BA-A36B-4198A67A516B}"/>
+          <p:cNvPr id="33" name="">
+            <a:extLst xmlns:a="http://schemas.openxmlformats.org/drawingml/2006/main">
+              <a:ext uri="{FF2B5EF4-FFF2-40B4-BE49-F238E27FC236}">
+                <a16:creationId xmlns:a16="http://schemas.microsoft.com/office/drawing/2014/main" id="{434D0E10-D4CA-4DD5-BA8A-22F3311314FC}"/>
               </a:ext>
             </a:extLst>
           </p:cNvPr>
@@ -10937,7 +11340,7 @@
     </p:spTree>
     <p:extLst>
       <p:ext uri="{BB962C8B-B14F-4D97-AF65-F5344CB8AC3E}">
-        <p14:creationId xmlns:p14="http://schemas.microsoft.com/office/powerpoint/2010/main" val="1780433103"/>
+        <p14:creationId xmlns:p14="http://schemas.microsoft.com/office/powerpoint/2010/main" val="1669156536"/>
       </p:ext>
     </p:extLst>
   </p:cSld>
@@ -10965,10 +11368,10 @@
       </p:grpSpPr>
       <p:sp>
         <p:nvSpPr>
-          <p:cNvPr id="34" name="">
-            <a:extLst xmlns:a="http://schemas.openxmlformats.org/drawingml/2006/main">
-              <a:ext uri="{FF2B5EF4-FFF2-40B4-BE49-F238E27FC236}">
-                <a16:creationId xmlns:a16="http://schemas.microsoft.com/office/drawing/2014/main" id="{2F41B5B9-D5D5-44F0-BBF5-2CA669DFE8C1}"/>
+          <p:cNvPr id="35" name="">
+            <a:extLst xmlns:a="http://schemas.openxmlformats.org/drawingml/2006/main">
+              <a:ext uri="{FF2B5EF4-FFF2-40B4-BE49-F238E27FC236}">
+                <a16:creationId xmlns:a16="http://schemas.microsoft.com/office/drawing/2014/main" id="{2FE25834-F772-46DF-A2DB-4AFD2D9EB42F}"/>
               </a:ext>
             </a:extLst>
           </p:cNvPr>
@@ -11001,7 +11404,7 @@
           <p:cNvPr id="2" name="">
             <a:extLst xmlns:a="http://schemas.openxmlformats.org/drawingml/2006/main">
               <a:ext uri="{FF2B5EF4-FFF2-40B4-BE49-F238E27FC236}">
-                <a16:creationId xmlns:a16="http://schemas.microsoft.com/office/drawing/2014/main" id="{8D67992E-12EA-4C3A-996E-5BCE65ADAE6E}"/>
+                <a16:creationId xmlns:a16="http://schemas.microsoft.com/office/drawing/2014/main" id="{2A29C29C-12EE-4550-9A7E-9319EA5599FC}"/>
               </a:ext>
             </a:extLst>
           </p:cNvPr>
@@ -11049,7 +11452,7 @@
                 <a:ea typeface="Courier New"/>
                 <a:cs typeface="Courier New"/>
               </a:rPr>
-              <a:t>LRWA / BUSINESS MODEL</a:t>
+              <a:t>BUSINESS MODEL</a:t>
             </a:r>
           </a:p>
         </p:txBody>
@@ -11059,7 +11462,7 @@
           <p:cNvPr id="3" name="">
             <a:extLst xmlns:a="http://schemas.openxmlformats.org/drawingml/2006/main">
               <a:ext uri="{FF2B5EF4-FFF2-40B4-BE49-F238E27FC236}">
-                <a16:creationId xmlns:a16="http://schemas.microsoft.com/office/drawing/2014/main" id="{C8FEFD83-6C23-4291-B115-3CEC7A5C80BD}"/>
+                <a16:creationId xmlns:a16="http://schemas.microsoft.com/office/drawing/2014/main" id="{704B0E42-6659-48B9-B577-AD707EAB6E15}"/>
               </a:ext>
             </a:extLst>
           </p:cNvPr>
@@ -11117,7 +11520,7 @@
           <p:cNvPr id="4" name="">
             <a:extLst xmlns:a="http://schemas.openxmlformats.org/drawingml/2006/main">
               <a:ext uri="{FF2B5EF4-FFF2-40B4-BE49-F238E27FC236}">
-                <a16:creationId xmlns:a16="http://schemas.microsoft.com/office/drawing/2014/main" id="{8E6FE12D-56DE-4ACB-9681-9B229F3BDA2B}"/>
+                <a16:creationId xmlns:a16="http://schemas.microsoft.com/office/drawing/2014/main" id="{312D3797-6E5C-42E8-819E-64239E22C296}"/>
               </a:ext>
             </a:extLst>
           </p:cNvPr>
@@ -11143,24 +11546,52 @@
           </a:ln>
         </p:spPr>
       </p:sp>
-      <p:sp>
-        <p:nvSpPr>
-          <p:cNvPr id="5" name="">
-            <a:extLst xmlns:a="http://schemas.openxmlformats.org/drawingml/2006/main">
-              <a:ext uri="{FF2B5EF4-FFF2-40B4-BE49-F238E27FC236}">
-                <a16:creationId xmlns:a16="http://schemas.microsoft.com/office/drawing/2014/main" id="{C7376424-DB3F-4CAD-8D57-2C2FBA625CFC}"/>
-              </a:ext>
-            </a:extLst>
-          </p:cNvPr>
-          <p:cNvSpPr>
-            <a:spLocks xmlns:a="http://schemas.openxmlformats.org/drawingml/2006/main" noGrp="1"/>
-          </p:cNvSpPr>
-          <p:nvPr/>
-        </p:nvSpPr>
-        <p:spPr>
-          <a:xfrm xmlns:a="http://schemas.openxmlformats.org/drawingml/2006/main" rot="0">
-            <a:off x="609600" y="6562725"/>
-            <a:ext cx="2857500" cy="133350"/>
+      <p:pic>
+        <p:nvPicPr>
+          <p:cNvPr id="39" name=""/>
+          <p:cNvPicPr>
+            <a:picLocks xmlns:a="http://schemas.openxmlformats.org/drawingml/2006/main" noChangeAspect="1"/>
+          </p:cNvPicPr>
+          <p:nvPr/>
+        </p:nvPicPr>
+        <p:blipFill>
+          <a:blip xmlns:r="http://schemas.openxmlformats.org/officeDocument/2006/relationships" xmlns:a="http://schemas.openxmlformats.org/drawingml/2006/main" r:embed="Re91169c4810d4b1d">
+            <a:extLst>
+              <a:ext uri="{96DAC541-7B7A-43D3-8B79-37D633B846F1}">
+                <asvg:svgBlip xmlns:asvg="http://schemas.microsoft.com/office/drawing/2016/SVG/main" r:embed="R272dc6684a1a41df"/>
+              </a:ext>
+            </a:extLst>
+          </a:blip>
+          <a:stretch xmlns:a="http://schemas.openxmlformats.org/drawingml/2006/main"/>
+        </p:blipFill>
+        <p:spPr>
+          <a:xfrm xmlns:a="http://schemas.openxmlformats.org/drawingml/2006/main">
+            <a:off x="609600" y="6524625"/>
+            <a:ext cx="171450" cy="171450"/>
+          </a:xfrm>
+          <a:prstGeom xmlns:a="http://schemas.openxmlformats.org/drawingml/2006/main" prst="rect">
+            <a:avLst/>
+          </a:prstGeom>
+        </p:spPr>
+      </p:pic>
+      <p:sp>
+        <p:nvSpPr>
+          <p:cNvPr id="6" name="">
+            <a:extLst xmlns:a="http://schemas.openxmlformats.org/drawingml/2006/main">
+              <a:ext uri="{FF2B5EF4-FFF2-40B4-BE49-F238E27FC236}">
+                <a16:creationId xmlns:a16="http://schemas.microsoft.com/office/drawing/2014/main" id="{8EBBF4B5-5026-4CD2-94B9-5EF3CD78A8FF}"/>
+              </a:ext>
+            </a:extLst>
+          </p:cNvPr>
+          <p:cNvSpPr>
+            <a:spLocks xmlns:a="http://schemas.openxmlformats.org/drawingml/2006/main" noGrp="1"/>
+          </p:cNvSpPr>
+          <p:nvPr/>
+        </p:nvSpPr>
+        <p:spPr>
+          <a:xfrm xmlns:a="http://schemas.openxmlformats.org/drawingml/2006/main" rot="0">
+            <a:off x="857250" y="6562725"/>
+            <a:ext cx="3238500" cy="133350"/>
           </a:xfrm>
           <a:prstGeom xmlns:a="http://schemas.openxmlformats.org/drawingml/2006/main" prst="rect">
             <a:avLst/>
@@ -11196,17 +11627,17 @@
                 <a:ea typeface="Courier New"/>
                 <a:cs typeface="Courier New"/>
               </a:rPr>
-              <a:t>LIVE REAL-WORLD ASSURANCE</a:t>
-            </a:r>
-          </a:p>
-        </p:txBody>
-      </p:sp>
-      <p:sp>
-        <p:nvSpPr>
-          <p:cNvPr id="6" name="">
-            <a:extLst xmlns:a="http://schemas.openxmlformats.org/drawingml/2006/main">
-              <a:ext uri="{FF2B5EF4-FFF2-40B4-BE49-F238E27FC236}">
-                <a16:creationId xmlns:a16="http://schemas.microsoft.com/office/drawing/2014/main" id="{C5B7817C-8069-4BF5-9FAB-147BE7901AE7}"/>
+              <a:t>LRWA / LIVE REAL-WORLD ASSURANCE</a:t>
+            </a:r>
+          </a:p>
+        </p:txBody>
+      </p:sp>
+      <p:sp>
+        <p:nvSpPr>
+          <p:cNvPr id="7" name="">
+            <a:extLst xmlns:a="http://schemas.openxmlformats.org/drawingml/2006/main">
+              <a:ext uri="{FF2B5EF4-FFF2-40B4-BE49-F238E27FC236}">
+                <a16:creationId xmlns:a16="http://schemas.microsoft.com/office/drawing/2014/main" id="{AC829477-469D-4E08-A54A-C74C6E680900}"/>
               </a:ext>
             </a:extLst>
           </p:cNvPr>
@@ -11261,10 +11692,10 @@
       </p:sp>
       <p:sp>
         <p:nvSpPr>
-          <p:cNvPr id="7" name="">
-            <a:extLst xmlns:a="http://schemas.openxmlformats.org/drawingml/2006/main">
-              <a:ext uri="{FF2B5EF4-FFF2-40B4-BE49-F238E27FC236}">
-                <a16:creationId xmlns:a16="http://schemas.microsoft.com/office/drawing/2014/main" id="{DBB45A62-4268-451D-AA3F-2B472CCDD2C2}"/>
+          <p:cNvPr id="8" name="">
+            <a:extLst xmlns:a="http://schemas.openxmlformats.org/drawingml/2006/main">
+              <a:ext uri="{FF2B5EF4-FFF2-40B4-BE49-F238E27FC236}">
+                <a16:creationId xmlns:a16="http://schemas.microsoft.com/office/drawing/2014/main" id="{5A3CABFC-295D-40DC-B285-CDFA27CD22FC}"/>
               </a:ext>
             </a:extLst>
           </p:cNvPr>
@@ -11323,10 +11754,10 @@
       </p:sp>
       <p:sp>
         <p:nvSpPr>
-          <p:cNvPr id="8" name="">
-            <a:extLst xmlns:a="http://schemas.openxmlformats.org/drawingml/2006/main">
-              <a:ext uri="{FF2B5EF4-FFF2-40B4-BE49-F238E27FC236}">
-                <a16:creationId xmlns:a16="http://schemas.microsoft.com/office/drawing/2014/main" id="{5A2A9C92-6047-45F9-9552-154AAF512698}"/>
+          <p:cNvPr id="9" name="">
+            <a:extLst xmlns:a="http://schemas.openxmlformats.org/drawingml/2006/main">
+              <a:ext uri="{FF2B5EF4-FFF2-40B4-BE49-F238E27FC236}">
+                <a16:creationId xmlns:a16="http://schemas.microsoft.com/office/drawing/2014/main" id="{2FDDB06C-C064-40BB-A79A-A71ADB646924}"/>
               </a:ext>
             </a:extLst>
           </p:cNvPr>
@@ -11381,10 +11812,10 @@
       </p:sp>
       <p:sp>
         <p:nvSpPr>
-          <p:cNvPr id="9" name="">
-            <a:extLst xmlns:a="http://schemas.openxmlformats.org/drawingml/2006/main">
-              <a:ext uri="{FF2B5EF4-FFF2-40B4-BE49-F238E27FC236}">
-                <a16:creationId xmlns:a16="http://schemas.microsoft.com/office/drawing/2014/main" id="{167ED839-0F0F-4C2E-A0DB-33C2E0080443}"/>
+          <p:cNvPr id="10" name="">
+            <a:extLst xmlns:a="http://schemas.openxmlformats.org/drawingml/2006/main">
+              <a:ext uri="{FF2B5EF4-FFF2-40B4-BE49-F238E27FC236}">
+                <a16:creationId xmlns:a16="http://schemas.microsoft.com/office/drawing/2014/main" id="{60B2700E-B968-4848-8D1B-514D2D6C3E07}"/>
               </a:ext>
             </a:extLst>
           </p:cNvPr>
@@ -11412,10 +11843,10 @@
       </p:sp>
       <p:sp>
         <p:nvSpPr>
-          <p:cNvPr id="10" name="">
-            <a:extLst xmlns:a="http://schemas.openxmlformats.org/drawingml/2006/main">
-              <a:ext uri="{FF2B5EF4-FFF2-40B4-BE49-F238E27FC236}">
-                <a16:creationId xmlns:a16="http://schemas.microsoft.com/office/drawing/2014/main" id="{33BF5FBF-6F97-439D-B9A0-C8B135020D48}"/>
+          <p:cNvPr id="11" name="">
+            <a:extLst xmlns:a="http://schemas.openxmlformats.org/drawingml/2006/main">
+              <a:ext uri="{FF2B5EF4-FFF2-40B4-BE49-F238E27FC236}">
+                <a16:creationId xmlns:a16="http://schemas.microsoft.com/office/drawing/2014/main" id="{493EF6A4-D39D-4758-AC0D-64B2E869528F}"/>
               </a:ext>
             </a:extLst>
           </p:cNvPr>
@@ -11443,10 +11874,10 @@
       </p:sp>
       <p:sp>
         <p:nvSpPr>
-          <p:cNvPr id="11" name="">
-            <a:extLst xmlns:a="http://schemas.openxmlformats.org/drawingml/2006/main">
-              <a:ext uri="{FF2B5EF4-FFF2-40B4-BE49-F238E27FC236}">
-                <a16:creationId xmlns:a16="http://schemas.microsoft.com/office/drawing/2014/main" id="{4D1B4305-F301-475A-8A81-31A4471160B0}"/>
+          <p:cNvPr id="12" name="">
+            <a:extLst xmlns:a="http://schemas.openxmlformats.org/drawingml/2006/main">
+              <a:ext uri="{FF2B5EF4-FFF2-40B4-BE49-F238E27FC236}">
+                <a16:creationId xmlns:a16="http://schemas.microsoft.com/office/drawing/2014/main" id="{20AC9C75-84C4-4A1A-814A-91D5B5D69455}"/>
               </a:ext>
             </a:extLst>
           </p:cNvPr>
@@ -11474,10 +11905,10 @@
       </p:sp>
       <p:sp>
         <p:nvSpPr>
-          <p:cNvPr id="12" name="">
-            <a:extLst xmlns:a="http://schemas.openxmlformats.org/drawingml/2006/main">
-              <a:ext uri="{FF2B5EF4-FFF2-40B4-BE49-F238E27FC236}">
-                <a16:creationId xmlns:a16="http://schemas.microsoft.com/office/drawing/2014/main" id="{5D0B62B0-CEC1-4C28-A512-977DE0987620}"/>
+          <p:cNvPr id="13" name="">
+            <a:extLst xmlns:a="http://schemas.openxmlformats.org/drawingml/2006/main">
+              <a:ext uri="{FF2B5EF4-FFF2-40B4-BE49-F238E27FC236}">
+                <a16:creationId xmlns:a16="http://schemas.microsoft.com/office/drawing/2014/main" id="{B15A7892-1CB8-4BE2-AC11-B8888B1F4BEC}"/>
               </a:ext>
             </a:extLst>
           </p:cNvPr>
@@ -11532,10 +11963,10 @@
       </p:sp>
       <p:sp>
         <p:nvSpPr>
-          <p:cNvPr id="13" name="">
-            <a:extLst xmlns:a="http://schemas.openxmlformats.org/drawingml/2006/main">
-              <a:ext uri="{FF2B5EF4-FFF2-40B4-BE49-F238E27FC236}">
-                <a16:creationId xmlns:a16="http://schemas.microsoft.com/office/drawing/2014/main" id="{95516FE4-C4B8-47BC-9E42-F7C78B3D37C4}"/>
+          <p:cNvPr id="14" name="">
+            <a:extLst xmlns:a="http://schemas.openxmlformats.org/drawingml/2006/main">
+              <a:ext uri="{FF2B5EF4-FFF2-40B4-BE49-F238E27FC236}">
+                <a16:creationId xmlns:a16="http://schemas.microsoft.com/office/drawing/2014/main" id="{6FAC9A9F-DB6C-42C2-AACC-3F24503A5654}"/>
               </a:ext>
             </a:extLst>
           </p:cNvPr>
@@ -11594,10 +12025,10 @@
       </p:sp>
       <p:sp>
         <p:nvSpPr>
-          <p:cNvPr id="14" name="">
-            <a:extLst xmlns:a="http://schemas.openxmlformats.org/drawingml/2006/main">
-              <a:ext uri="{FF2B5EF4-FFF2-40B4-BE49-F238E27FC236}">
-                <a16:creationId xmlns:a16="http://schemas.microsoft.com/office/drawing/2014/main" id="{91B36715-CD42-48E8-9EE6-FE05482B4B23}"/>
+          <p:cNvPr id="15" name="">
+            <a:extLst xmlns:a="http://schemas.openxmlformats.org/drawingml/2006/main">
+              <a:ext uri="{FF2B5EF4-FFF2-40B4-BE49-F238E27FC236}">
+                <a16:creationId xmlns:a16="http://schemas.microsoft.com/office/drawing/2014/main" id="{EAD7E55B-C434-400D-B9F6-8AEC6F7BA71E}"/>
               </a:ext>
             </a:extLst>
           </p:cNvPr>
@@ -11625,10 +12056,10 @@
       </p:sp>
       <p:sp>
         <p:nvSpPr>
-          <p:cNvPr id="15" name="">
-            <a:extLst xmlns:a="http://schemas.openxmlformats.org/drawingml/2006/main">
-              <a:ext uri="{FF2B5EF4-FFF2-40B4-BE49-F238E27FC236}">
-                <a16:creationId xmlns:a16="http://schemas.microsoft.com/office/drawing/2014/main" id="{42E99945-9C26-45C5-BA28-E7F364901D32}"/>
+          <p:cNvPr id="16" name="">
+            <a:extLst xmlns:a="http://schemas.openxmlformats.org/drawingml/2006/main">
+              <a:ext uri="{FF2B5EF4-FFF2-40B4-BE49-F238E27FC236}">
+                <a16:creationId xmlns:a16="http://schemas.microsoft.com/office/drawing/2014/main" id="{130DF629-5D93-4226-BA34-32E062B8CDC3}"/>
               </a:ext>
             </a:extLst>
           </p:cNvPr>
@@ -11714,10 +12145,10 @@
       </p:sp>
       <p:sp>
         <p:nvSpPr>
-          <p:cNvPr id="16" name="">
-            <a:extLst xmlns:a="http://schemas.openxmlformats.org/drawingml/2006/main">
-              <a:ext uri="{FF2B5EF4-FFF2-40B4-BE49-F238E27FC236}">
-                <a16:creationId xmlns:a16="http://schemas.microsoft.com/office/drawing/2014/main" id="{44E136AE-487E-43CA-95E2-4F6B83419BDD}"/>
+          <p:cNvPr id="17" name="">
+            <a:extLst xmlns:a="http://schemas.openxmlformats.org/drawingml/2006/main">
+              <a:ext uri="{FF2B5EF4-FFF2-40B4-BE49-F238E27FC236}">
+                <a16:creationId xmlns:a16="http://schemas.microsoft.com/office/drawing/2014/main" id="{61B0BED6-534F-45D3-B581-A0163BBD64C0}"/>
               </a:ext>
             </a:extLst>
           </p:cNvPr>
@@ -11772,10 +12203,10 @@
       </p:sp>
       <p:sp>
         <p:nvSpPr>
-          <p:cNvPr id="17" name="">
-            <a:extLst xmlns:a="http://schemas.openxmlformats.org/drawingml/2006/main">
-              <a:ext uri="{FF2B5EF4-FFF2-40B4-BE49-F238E27FC236}">
-                <a16:creationId xmlns:a16="http://schemas.microsoft.com/office/drawing/2014/main" id="{2AA500EB-2DAE-4079-8978-C2149F0F1DBA}"/>
+          <p:cNvPr id="18" name="">
+            <a:extLst xmlns:a="http://schemas.openxmlformats.org/drawingml/2006/main">
+              <a:ext uri="{FF2B5EF4-FFF2-40B4-BE49-F238E27FC236}">
+                <a16:creationId xmlns:a16="http://schemas.microsoft.com/office/drawing/2014/main" id="{6BD1ADA5-969F-4B4F-B4B4-1140845F53CC}"/>
               </a:ext>
             </a:extLst>
           </p:cNvPr>
@@ -11834,10 +12265,10 @@
       </p:sp>
       <p:sp>
         <p:nvSpPr>
-          <p:cNvPr id="18" name="">
-            <a:extLst xmlns:a="http://schemas.openxmlformats.org/drawingml/2006/main">
-              <a:ext uri="{FF2B5EF4-FFF2-40B4-BE49-F238E27FC236}">
-                <a16:creationId xmlns:a16="http://schemas.microsoft.com/office/drawing/2014/main" id="{25095940-89F9-4B31-8778-469E84F0FD2E}"/>
+          <p:cNvPr id="19" name="">
+            <a:extLst xmlns:a="http://schemas.openxmlformats.org/drawingml/2006/main">
+              <a:ext uri="{FF2B5EF4-FFF2-40B4-BE49-F238E27FC236}">
+                <a16:creationId xmlns:a16="http://schemas.microsoft.com/office/drawing/2014/main" id="{E9594453-46DB-423F-8C3B-9B898413FD28}"/>
               </a:ext>
             </a:extLst>
           </p:cNvPr>
@@ -11865,10 +12296,10 @@
       </p:sp>
       <p:sp>
         <p:nvSpPr>
-          <p:cNvPr id="19" name="">
-            <a:extLst xmlns:a="http://schemas.openxmlformats.org/drawingml/2006/main">
-              <a:ext uri="{FF2B5EF4-FFF2-40B4-BE49-F238E27FC236}">
-                <a16:creationId xmlns:a16="http://schemas.microsoft.com/office/drawing/2014/main" id="{134BBE6D-B52D-4E6C-8E55-A0AB75D984FF}"/>
+          <p:cNvPr id="20" name="">
+            <a:extLst xmlns:a="http://schemas.openxmlformats.org/drawingml/2006/main">
+              <a:ext uri="{FF2B5EF4-FFF2-40B4-BE49-F238E27FC236}">
+                <a16:creationId xmlns:a16="http://schemas.microsoft.com/office/drawing/2014/main" id="{EEDC58C1-8408-4D9C-B089-E4C33C9E46C3}"/>
               </a:ext>
             </a:extLst>
           </p:cNvPr>
@@ -11954,10 +12385,10 @@
       </p:sp>
       <p:sp>
         <p:nvSpPr>
-          <p:cNvPr id="20" name="">
-            <a:extLst xmlns:a="http://schemas.openxmlformats.org/drawingml/2006/main">
-              <a:ext uri="{FF2B5EF4-FFF2-40B4-BE49-F238E27FC236}">
-                <a16:creationId xmlns:a16="http://schemas.microsoft.com/office/drawing/2014/main" id="{AA8ED126-6B84-40D3-A944-FE8BFC5D39D2}"/>
+          <p:cNvPr id="21" name="">
+            <a:extLst xmlns:a="http://schemas.openxmlformats.org/drawingml/2006/main">
+              <a:ext uri="{FF2B5EF4-FFF2-40B4-BE49-F238E27FC236}">
+                <a16:creationId xmlns:a16="http://schemas.microsoft.com/office/drawing/2014/main" id="{617000DC-9C4A-4A31-9346-9C1532CBB389}"/>
               </a:ext>
             </a:extLst>
           </p:cNvPr>
@@ -12012,10 +12443,10 @@
       </p:sp>
       <p:sp>
         <p:nvSpPr>
-          <p:cNvPr id="21" name="">
-            <a:extLst xmlns:a="http://schemas.openxmlformats.org/drawingml/2006/main">
-              <a:ext uri="{FF2B5EF4-FFF2-40B4-BE49-F238E27FC236}">
-                <a16:creationId xmlns:a16="http://schemas.microsoft.com/office/drawing/2014/main" id="{278EA813-968D-4A4A-9306-12EA85E60BF3}"/>
+          <p:cNvPr id="22" name="">
+            <a:extLst xmlns:a="http://schemas.openxmlformats.org/drawingml/2006/main">
+              <a:ext uri="{FF2B5EF4-FFF2-40B4-BE49-F238E27FC236}">
+                <a16:creationId xmlns:a16="http://schemas.microsoft.com/office/drawing/2014/main" id="{0E6A547B-C885-4A83-8B69-776932364DCB}"/>
               </a:ext>
             </a:extLst>
           </p:cNvPr>
@@ -12074,10 +12505,10 @@
       </p:sp>
       <p:sp>
         <p:nvSpPr>
-          <p:cNvPr id="22" name="">
-            <a:extLst xmlns:a="http://schemas.openxmlformats.org/drawingml/2006/main">
-              <a:ext uri="{FF2B5EF4-FFF2-40B4-BE49-F238E27FC236}">
-                <a16:creationId xmlns:a16="http://schemas.microsoft.com/office/drawing/2014/main" id="{706B748D-0EB0-4EB1-9C61-95FE757B047F}"/>
+          <p:cNvPr id="23" name="">
+            <a:extLst xmlns:a="http://schemas.openxmlformats.org/drawingml/2006/main">
+              <a:ext uri="{FF2B5EF4-FFF2-40B4-BE49-F238E27FC236}">
+                <a16:creationId xmlns:a16="http://schemas.microsoft.com/office/drawing/2014/main" id="{957E6342-80A3-41D1-B08D-FEC089360E5B}"/>
               </a:ext>
             </a:extLst>
           </p:cNvPr>
@@ -12105,10 +12536,10 @@
       </p:sp>
       <p:sp>
         <p:nvSpPr>
-          <p:cNvPr id="23" name="">
-            <a:extLst xmlns:a="http://schemas.openxmlformats.org/drawingml/2006/main">
-              <a:ext uri="{FF2B5EF4-FFF2-40B4-BE49-F238E27FC236}">
-                <a16:creationId xmlns:a16="http://schemas.microsoft.com/office/drawing/2014/main" id="{C4471091-82D2-4A3E-BE47-438DB4CD274E}"/>
+          <p:cNvPr id="24" name="">
+            <a:extLst xmlns:a="http://schemas.openxmlformats.org/drawingml/2006/main">
+              <a:ext uri="{FF2B5EF4-FFF2-40B4-BE49-F238E27FC236}">
+                <a16:creationId xmlns:a16="http://schemas.microsoft.com/office/drawing/2014/main" id="{1AC7C1F6-435F-491B-B267-8895A6E685C1}"/>
               </a:ext>
             </a:extLst>
           </p:cNvPr>
@@ -12194,10 +12625,10 @@
       </p:sp>
       <p:sp>
         <p:nvSpPr>
-          <p:cNvPr id="24" name="">
-            <a:extLst xmlns:a="http://schemas.openxmlformats.org/drawingml/2006/main">
-              <a:ext uri="{FF2B5EF4-FFF2-40B4-BE49-F238E27FC236}">
-                <a16:creationId xmlns:a16="http://schemas.microsoft.com/office/drawing/2014/main" id="{27A416A1-C24C-41AB-9C36-6FAD28162D59}"/>
+          <p:cNvPr id="25" name="">
+            <a:extLst xmlns:a="http://schemas.openxmlformats.org/drawingml/2006/main">
+              <a:ext uri="{FF2B5EF4-FFF2-40B4-BE49-F238E27FC236}">
+                <a16:creationId xmlns:a16="http://schemas.microsoft.com/office/drawing/2014/main" id="{02EC10A7-B61D-47B2-9EEB-7B50F77B1672}"/>
               </a:ext>
             </a:extLst>
           </p:cNvPr>
@@ -12252,10 +12683,10 @@
       </p:sp>
       <p:sp>
         <p:nvSpPr>
-          <p:cNvPr id="25" name="">
-            <a:extLst xmlns:a="http://schemas.openxmlformats.org/drawingml/2006/main">
-              <a:ext uri="{FF2B5EF4-FFF2-40B4-BE49-F238E27FC236}">
-                <a16:creationId xmlns:a16="http://schemas.microsoft.com/office/drawing/2014/main" id="{21E2D6EF-5643-4554-83DB-F45565EF2F65}"/>
+          <p:cNvPr id="26" name="">
+            <a:extLst xmlns:a="http://schemas.openxmlformats.org/drawingml/2006/main">
+              <a:ext uri="{FF2B5EF4-FFF2-40B4-BE49-F238E27FC236}">
+                <a16:creationId xmlns:a16="http://schemas.microsoft.com/office/drawing/2014/main" id="{064F95E1-F485-4779-B31F-AEF19A339F5D}"/>
               </a:ext>
             </a:extLst>
           </p:cNvPr>
@@ -12314,10 +12745,10 @@
       </p:sp>
       <p:sp>
         <p:nvSpPr>
-          <p:cNvPr id="26" name="">
-            <a:extLst xmlns:a="http://schemas.openxmlformats.org/drawingml/2006/main">
-              <a:ext uri="{FF2B5EF4-FFF2-40B4-BE49-F238E27FC236}">
-                <a16:creationId xmlns:a16="http://schemas.microsoft.com/office/drawing/2014/main" id="{62B678E7-4F47-45B2-BA64-CF956B709930}"/>
+          <p:cNvPr id="27" name="">
+            <a:extLst xmlns:a="http://schemas.openxmlformats.org/drawingml/2006/main">
+              <a:ext uri="{FF2B5EF4-FFF2-40B4-BE49-F238E27FC236}">
+                <a16:creationId xmlns:a16="http://schemas.microsoft.com/office/drawing/2014/main" id="{E0D4E39B-D02C-42D8-9727-0806E78583E0}"/>
               </a:ext>
             </a:extLst>
           </p:cNvPr>
@@ -12345,10 +12776,10 @@
       </p:sp>
       <p:sp>
         <p:nvSpPr>
-          <p:cNvPr id="27" name="">
-            <a:extLst xmlns:a="http://schemas.openxmlformats.org/drawingml/2006/main">
-              <a:ext uri="{FF2B5EF4-FFF2-40B4-BE49-F238E27FC236}">
-                <a16:creationId xmlns:a16="http://schemas.microsoft.com/office/drawing/2014/main" id="{DDEDF03E-BA58-4BBD-9DD9-62B437B434A9}"/>
+          <p:cNvPr id="28" name="">
+            <a:extLst xmlns:a="http://schemas.openxmlformats.org/drawingml/2006/main">
+              <a:ext uri="{FF2B5EF4-FFF2-40B4-BE49-F238E27FC236}">
+                <a16:creationId xmlns:a16="http://schemas.microsoft.com/office/drawing/2014/main" id="{E643E110-75B7-4991-B95A-26F6928CD24B}"/>
               </a:ext>
             </a:extLst>
           </p:cNvPr>
@@ -12434,10 +12865,10 @@
       </p:sp>
       <p:sp>
         <p:nvSpPr>
-          <p:cNvPr id="28" name="">
-            <a:extLst xmlns:a="http://schemas.openxmlformats.org/drawingml/2006/main">
-              <a:ext uri="{FF2B5EF4-FFF2-40B4-BE49-F238E27FC236}">
-                <a16:creationId xmlns:a16="http://schemas.microsoft.com/office/drawing/2014/main" id="{6B4E4D09-C2E7-45E2-8756-FD9D2FA9F387}"/>
+          <p:cNvPr id="29" name="">
+            <a:extLst xmlns:a="http://schemas.openxmlformats.org/drawingml/2006/main">
+              <a:ext uri="{FF2B5EF4-FFF2-40B4-BE49-F238E27FC236}">
+                <a16:creationId xmlns:a16="http://schemas.microsoft.com/office/drawing/2014/main" id="{792553B9-1BC1-4BF2-AE4F-A7B01255EDC1}"/>
               </a:ext>
             </a:extLst>
           </p:cNvPr>
@@ -12492,10 +12923,10 @@
       </p:sp>
       <p:sp>
         <p:nvSpPr>
-          <p:cNvPr id="29" name="">
-            <a:extLst xmlns:a="http://schemas.openxmlformats.org/drawingml/2006/main">
-              <a:ext uri="{FF2B5EF4-FFF2-40B4-BE49-F238E27FC236}">
-                <a16:creationId xmlns:a16="http://schemas.microsoft.com/office/drawing/2014/main" id="{61740EE8-3157-4D72-BA69-7541F2114091}"/>
+          <p:cNvPr id="30" name="">
+            <a:extLst xmlns:a="http://schemas.openxmlformats.org/drawingml/2006/main">
+              <a:ext uri="{FF2B5EF4-FFF2-40B4-BE49-F238E27FC236}">
+                <a16:creationId xmlns:a16="http://schemas.microsoft.com/office/drawing/2014/main" id="{D2B771C2-EF93-42B5-8FF9-3CF643DD897C}"/>
               </a:ext>
             </a:extLst>
           </p:cNvPr>
@@ -12554,10 +12985,10 @@
       </p:sp>
       <p:sp>
         <p:nvSpPr>
-          <p:cNvPr id="30" name="">
-            <a:extLst xmlns:a="http://schemas.openxmlformats.org/drawingml/2006/main">
-              <a:ext uri="{FF2B5EF4-FFF2-40B4-BE49-F238E27FC236}">
-                <a16:creationId xmlns:a16="http://schemas.microsoft.com/office/drawing/2014/main" id="{7411D313-924B-409C-8F8A-05FC61EE778F}"/>
+          <p:cNvPr id="31" name="">
+            <a:extLst xmlns:a="http://schemas.openxmlformats.org/drawingml/2006/main">
+              <a:ext uri="{FF2B5EF4-FFF2-40B4-BE49-F238E27FC236}">
+                <a16:creationId xmlns:a16="http://schemas.microsoft.com/office/drawing/2014/main" id="{B4CF6CED-B2EF-4806-89DD-3F138F810FE5}"/>
               </a:ext>
             </a:extLst>
           </p:cNvPr>
@@ -12612,10 +13043,10 @@
       </p:sp>
       <p:sp>
         <p:nvSpPr>
-          <p:cNvPr id="31" name="mobile-plan-shot-frame">
-            <a:extLst xmlns:a="http://schemas.openxmlformats.org/drawingml/2006/main">
-              <a:ext uri="{FF2B5EF4-FFF2-40B4-BE49-F238E27FC236}">
-                <a16:creationId xmlns:a16="http://schemas.microsoft.com/office/drawing/2014/main" id="{6DCAE0B4-2E72-4F07-A1AC-DAA7F289EF70}"/>
+          <p:cNvPr id="32" name="mobile-plan-shot-frame">
+            <a:extLst xmlns:a="http://schemas.openxmlformats.org/drawingml/2006/main">
+              <a:ext uri="{FF2B5EF4-FFF2-40B4-BE49-F238E27FC236}">
+                <a16:creationId xmlns:a16="http://schemas.microsoft.com/office/drawing/2014/main" id="{8D87455D-C656-42B8-8DAF-92BA156BBAB8}"/>
               </a:ext>
             </a:extLst>
           </p:cNvPr>
@@ -12653,14 +13084,14 @@
       </p:sp>
       <p:pic>
         <p:nvPicPr>
-          <p:cNvPr id="65" name=""/>
+          <p:cNvPr id="67" name=""/>
           <p:cNvPicPr>
             <a:picLocks xmlns:a="http://schemas.openxmlformats.org/drawingml/2006/main" noChangeAspect="1"/>
           </p:cNvPicPr>
           <p:nvPr/>
         </p:nvPicPr>
         <p:blipFill>
-          <a:blip xmlns:r="http://schemas.openxmlformats.org/officeDocument/2006/relationships" xmlns:a="http://schemas.openxmlformats.org/drawingml/2006/main" r:embed="R4b54d8c25be04bee"/>
+          <a:blip xmlns:r="http://schemas.openxmlformats.org/officeDocument/2006/relationships" xmlns:a="http://schemas.openxmlformats.org/drawingml/2006/main" r:embed="R73dab8b451e34842"/>
           <a:srcRect xmlns:a="http://schemas.openxmlformats.org/drawingml/2006/main" l="59" t="0" r="59" b="0"/>
           <a:stretch xmlns:a="http://schemas.openxmlformats.org/drawingml/2006/main">
             <a:fillRect l="0" t="0" r="0" b="0"/>
@@ -12680,10 +13111,10 @@
       </p:pic>
       <p:sp>
         <p:nvSpPr>
-          <p:cNvPr id="33" name="">
-            <a:extLst xmlns:a="http://schemas.openxmlformats.org/drawingml/2006/main">
-              <a:ext uri="{FF2B5EF4-FFF2-40B4-BE49-F238E27FC236}">
-                <a16:creationId xmlns:a16="http://schemas.microsoft.com/office/drawing/2014/main" id="{9B28AA46-CCBD-4EBB-A3B2-D18480E78561}"/>
+          <p:cNvPr id="34" name="">
+            <a:extLst xmlns:a="http://schemas.openxmlformats.org/drawingml/2006/main">
+              <a:ext uri="{FF2B5EF4-FFF2-40B4-BE49-F238E27FC236}">
+                <a16:creationId xmlns:a16="http://schemas.microsoft.com/office/drawing/2014/main" id="{7253B942-C019-48B7-BF96-F780D3E3F82F}"/>
               </a:ext>
             </a:extLst>
           </p:cNvPr>
@@ -12739,7 +13170,7 @@
     </p:spTree>
     <p:extLst>
       <p:ext uri="{BB962C8B-B14F-4D97-AF65-F5344CB8AC3E}">
-        <p14:creationId xmlns:p14="http://schemas.microsoft.com/office/powerpoint/2010/main" val="2000460740"/>
+        <p14:creationId xmlns:p14="http://schemas.microsoft.com/office/powerpoint/2010/main" val="269301411"/>
       </p:ext>
     </p:extLst>
   </p:cSld>
@@ -12767,10 +13198,10 @@
       </p:grpSpPr>
       <p:sp>
         <p:nvSpPr>
-          <p:cNvPr id="31" name="">
-            <a:extLst xmlns:a="http://schemas.openxmlformats.org/drawingml/2006/main">
-              <a:ext uri="{FF2B5EF4-FFF2-40B4-BE49-F238E27FC236}">
-                <a16:creationId xmlns:a16="http://schemas.microsoft.com/office/drawing/2014/main" id="{D7246AB4-632F-4FA1-B013-C89329485796}"/>
+          <p:cNvPr id="32" name="">
+            <a:extLst xmlns:a="http://schemas.openxmlformats.org/drawingml/2006/main">
+              <a:ext uri="{FF2B5EF4-FFF2-40B4-BE49-F238E27FC236}">
+                <a16:creationId xmlns:a16="http://schemas.microsoft.com/office/drawing/2014/main" id="{EFC3FA8F-8C7F-475B-AD4B-4AB35E3B7B22}"/>
               </a:ext>
             </a:extLst>
           </p:cNvPr>
@@ -12803,7 +13234,7 @@
           <p:cNvPr id="2" name="">
             <a:extLst xmlns:a="http://schemas.openxmlformats.org/drawingml/2006/main">
               <a:ext uri="{FF2B5EF4-FFF2-40B4-BE49-F238E27FC236}">
-                <a16:creationId xmlns:a16="http://schemas.microsoft.com/office/drawing/2014/main" id="{8CA30314-09B6-4A24-A39C-05A6C213D343}"/>
+                <a16:creationId xmlns:a16="http://schemas.microsoft.com/office/drawing/2014/main" id="{431DF014-5A05-4F88-80C9-6F66B22B0F5D}"/>
               </a:ext>
             </a:extLst>
           </p:cNvPr>
@@ -12851,7 +13282,7 @@
                 <a:ea typeface="Courier New"/>
                 <a:cs typeface="Courier New"/>
               </a:rPr>
-              <a:t>LRWA / PROOF PLAN + ASK</a:t>
+              <a:t>PROOF PLAN + ASK</a:t>
             </a:r>
           </a:p>
         </p:txBody>
@@ -12861,7 +13292,7 @@
           <p:cNvPr id="3" name="">
             <a:extLst xmlns:a="http://schemas.openxmlformats.org/drawingml/2006/main">
               <a:ext uri="{FF2B5EF4-FFF2-40B4-BE49-F238E27FC236}">
-                <a16:creationId xmlns:a16="http://schemas.microsoft.com/office/drawing/2014/main" id="{D3A8D3A8-5DF1-4199-9467-25742A4A2E4C}"/>
+                <a16:creationId xmlns:a16="http://schemas.microsoft.com/office/drawing/2014/main" id="{AD0B13B6-6FF3-45B7-91D1-3A0090350A90}"/>
               </a:ext>
             </a:extLst>
           </p:cNvPr>
@@ -12919,7 +13350,7 @@
           <p:cNvPr id="4" name="">
             <a:extLst xmlns:a="http://schemas.openxmlformats.org/drawingml/2006/main">
               <a:ext uri="{FF2B5EF4-FFF2-40B4-BE49-F238E27FC236}">
-                <a16:creationId xmlns:a16="http://schemas.microsoft.com/office/drawing/2014/main" id="{C89103C1-5A92-47E6-A3BB-D488B60F008D}"/>
+                <a16:creationId xmlns:a16="http://schemas.microsoft.com/office/drawing/2014/main" id="{3A0AD1D6-925C-47F9-9E98-DABD97C31C9B}"/>
               </a:ext>
             </a:extLst>
           </p:cNvPr>
@@ -12945,24 +13376,52 @@
           </a:ln>
         </p:spPr>
       </p:sp>
-      <p:sp>
-        <p:nvSpPr>
-          <p:cNvPr id="5" name="">
-            <a:extLst xmlns:a="http://schemas.openxmlformats.org/drawingml/2006/main">
-              <a:ext uri="{FF2B5EF4-FFF2-40B4-BE49-F238E27FC236}">
-                <a16:creationId xmlns:a16="http://schemas.microsoft.com/office/drawing/2014/main" id="{BAD7B011-7D3E-4612-BFF5-B0A3BBF16EAC}"/>
-              </a:ext>
-            </a:extLst>
-          </p:cNvPr>
-          <p:cNvSpPr>
-            <a:spLocks xmlns:a="http://schemas.openxmlformats.org/drawingml/2006/main" noGrp="1"/>
-          </p:cNvSpPr>
-          <p:nvPr/>
-        </p:nvSpPr>
-        <p:spPr>
-          <a:xfrm xmlns:a="http://schemas.openxmlformats.org/drawingml/2006/main" rot="0">
-            <a:off x="609600" y="6562725"/>
-            <a:ext cx="2857500" cy="133350"/>
+      <p:pic>
+        <p:nvPicPr>
+          <p:cNvPr id="36" name=""/>
+          <p:cNvPicPr>
+            <a:picLocks xmlns:a="http://schemas.openxmlformats.org/drawingml/2006/main" noChangeAspect="1"/>
+          </p:cNvPicPr>
+          <p:nvPr/>
+        </p:nvPicPr>
+        <p:blipFill>
+          <a:blip xmlns:r="http://schemas.openxmlformats.org/officeDocument/2006/relationships" xmlns:a="http://schemas.openxmlformats.org/drawingml/2006/main" r:embed="R1052d474535e4a0e">
+            <a:extLst>
+              <a:ext uri="{96DAC541-7B7A-43D3-8B79-37D633B846F1}">
+                <asvg:svgBlip xmlns:asvg="http://schemas.microsoft.com/office/drawing/2016/SVG/main" r:embed="R306f0309abca48b8"/>
+              </a:ext>
+            </a:extLst>
+          </a:blip>
+          <a:stretch xmlns:a="http://schemas.openxmlformats.org/drawingml/2006/main"/>
+        </p:blipFill>
+        <p:spPr>
+          <a:xfrm xmlns:a="http://schemas.openxmlformats.org/drawingml/2006/main">
+            <a:off x="609600" y="6524625"/>
+            <a:ext cx="171450" cy="171450"/>
+          </a:xfrm>
+          <a:prstGeom xmlns:a="http://schemas.openxmlformats.org/drawingml/2006/main" prst="rect">
+            <a:avLst/>
+          </a:prstGeom>
+        </p:spPr>
+      </p:pic>
+      <p:sp>
+        <p:nvSpPr>
+          <p:cNvPr id="6" name="">
+            <a:extLst xmlns:a="http://schemas.openxmlformats.org/drawingml/2006/main">
+              <a:ext uri="{FF2B5EF4-FFF2-40B4-BE49-F238E27FC236}">
+                <a16:creationId xmlns:a16="http://schemas.microsoft.com/office/drawing/2014/main" id="{3DA138D0-D2FB-4E2F-9B4A-9308E6538D69}"/>
+              </a:ext>
+            </a:extLst>
+          </p:cNvPr>
+          <p:cNvSpPr>
+            <a:spLocks xmlns:a="http://schemas.openxmlformats.org/drawingml/2006/main" noGrp="1"/>
+          </p:cNvSpPr>
+          <p:nvPr/>
+        </p:nvSpPr>
+        <p:spPr>
+          <a:xfrm xmlns:a="http://schemas.openxmlformats.org/drawingml/2006/main" rot="0">
+            <a:off x="857250" y="6562725"/>
+            <a:ext cx="3238500" cy="133350"/>
           </a:xfrm>
           <a:prstGeom xmlns:a="http://schemas.openxmlformats.org/drawingml/2006/main" prst="rect">
             <a:avLst/>
@@ -12998,17 +13457,17 @@
                 <a:ea typeface="Courier New"/>
                 <a:cs typeface="Courier New"/>
               </a:rPr>
-              <a:t>LIVE REAL-WORLD ASSURANCE</a:t>
-            </a:r>
-          </a:p>
-        </p:txBody>
-      </p:sp>
-      <p:sp>
-        <p:nvSpPr>
-          <p:cNvPr id="6" name="">
-            <a:extLst xmlns:a="http://schemas.openxmlformats.org/drawingml/2006/main">
-              <a:ext uri="{FF2B5EF4-FFF2-40B4-BE49-F238E27FC236}">
-                <a16:creationId xmlns:a16="http://schemas.microsoft.com/office/drawing/2014/main" id="{90A0E5AB-E36F-4E79-827E-3FCA71AA078E}"/>
+              <a:t>LRWA / LIVE REAL-WORLD ASSURANCE</a:t>
+            </a:r>
+          </a:p>
+        </p:txBody>
+      </p:sp>
+      <p:sp>
+        <p:nvSpPr>
+          <p:cNvPr id="7" name="">
+            <a:extLst xmlns:a="http://schemas.openxmlformats.org/drawingml/2006/main">
+              <a:ext uri="{FF2B5EF4-FFF2-40B4-BE49-F238E27FC236}">
+                <a16:creationId xmlns:a16="http://schemas.microsoft.com/office/drawing/2014/main" id="{888113F4-62DB-4207-B8FF-2FC222E787D6}"/>
               </a:ext>
             </a:extLst>
           </p:cNvPr>
@@ -13063,10 +13522,10 @@
       </p:sp>
       <p:sp>
         <p:nvSpPr>
-          <p:cNvPr id="7" name="">
-            <a:extLst xmlns:a="http://schemas.openxmlformats.org/drawingml/2006/main">
-              <a:ext uri="{FF2B5EF4-FFF2-40B4-BE49-F238E27FC236}">
-                <a16:creationId xmlns:a16="http://schemas.microsoft.com/office/drawing/2014/main" id="{54FA1356-10E3-45BE-A1A2-02892A94BFF5}"/>
+          <p:cNvPr id="8" name="">
+            <a:extLst xmlns:a="http://schemas.openxmlformats.org/drawingml/2006/main">
+              <a:ext uri="{FF2B5EF4-FFF2-40B4-BE49-F238E27FC236}">
+                <a16:creationId xmlns:a16="http://schemas.microsoft.com/office/drawing/2014/main" id="{ECCD785E-C7B3-4214-A163-DC47849457A9}"/>
               </a:ext>
             </a:extLst>
           </p:cNvPr>
@@ -13125,10 +13584,10 @@
       </p:sp>
       <p:sp>
         <p:nvSpPr>
-          <p:cNvPr id="8" name="">
-            <a:extLst xmlns:a="http://schemas.openxmlformats.org/drawingml/2006/main">
-              <a:ext uri="{FF2B5EF4-FFF2-40B4-BE49-F238E27FC236}">
-                <a16:creationId xmlns:a16="http://schemas.microsoft.com/office/drawing/2014/main" id="{C53A0D9E-4CC1-4E43-AF37-9D5447C56D0A}"/>
+          <p:cNvPr id="9" name="">
+            <a:extLst xmlns:a="http://schemas.openxmlformats.org/drawingml/2006/main">
+              <a:ext uri="{FF2B5EF4-FFF2-40B4-BE49-F238E27FC236}">
+                <a16:creationId xmlns:a16="http://schemas.microsoft.com/office/drawing/2014/main" id="{74468D56-5642-4754-BACE-C414A0C641FA}"/>
               </a:ext>
             </a:extLst>
           </p:cNvPr>
@@ -13183,10 +13642,10 @@
       </p:sp>
       <p:sp>
         <p:nvSpPr>
-          <p:cNvPr id="9" name="">
-            <a:extLst xmlns:a="http://schemas.openxmlformats.org/drawingml/2006/main">
-              <a:ext uri="{FF2B5EF4-FFF2-40B4-BE49-F238E27FC236}">
-                <a16:creationId xmlns:a16="http://schemas.microsoft.com/office/drawing/2014/main" id="{2641B1D0-CD70-4C1A-B955-DB84169B5F55}"/>
+          <p:cNvPr id="10" name="">
+            <a:extLst xmlns:a="http://schemas.openxmlformats.org/drawingml/2006/main">
+              <a:ext uri="{FF2B5EF4-FFF2-40B4-BE49-F238E27FC236}">
+                <a16:creationId xmlns:a16="http://schemas.microsoft.com/office/drawing/2014/main" id="{DBFA81E9-DB10-4091-A2EA-6F8F11F0A1E8}"/>
               </a:ext>
             </a:extLst>
           </p:cNvPr>
@@ -13214,10 +13673,10 @@
       </p:sp>
       <p:sp>
         <p:nvSpPr>
-          <p:cNvPr id="10" name="">
-            <a:extLst xmlns:a="http://schemas.openxmlformats.org/drawingml/2006/main">
-              <a:ext uri="{FF2B5EF4-FFF2-40B4-BE49-F238E27FC236}">
-                <a16:creationId xmlns:a16="http://schemas.microsoft.com/office/drawing/2014/main" id="{C17802A4-C3A7-4EC2-9CB8-FF5B1965259D}"/>
+          <p:cNvPr id="11" name="">
+            <a:extLst xmlns:a="http://schemas.openxmlformats.org/drawingml/2006/main">
+              <a:ext uri="{FF2B5EF4-FFF2-40B4-BE49-F238E27FC236}">
+                <a16:creationId xmlns:a16="http://schemas.microsoft.com/office/drawing/2014/main" id="{AA4F0493-39C7-4C31-9A13-6CCFEDFE1423}"/>
               </a:ext>
             </a:extLst>
           </p:cNvPr>
@@ -13247,10 +13706,10 @@
       </p:sp>
       <p:sp>
         <p:nvSpPr>
-          <p:cNvPr id="11" name="">
-            <a:extLst xmlns:a="http://schemas.openxmlformats.org/drawingml/2006/main">
-              <a:ext uri="{FF2B5EF4-FFF2-40B4-BE49-F238E27FC236}">
-                <a16:creationId xmlns:a16="http://schemas.microsoft.com/office/drawing/2014/main" id="{C2EE0C18-A264-4AA8-9B55-22541228FFD4}"/>
+          <p:cNvPr id="12" name="">
+            <a:extLst xmlns:a="http://schemas.openxmlformats.org/drawingml/2006/main">
+              <a:ext uri="{FF2B5EF4-FFF2-40B4-BE49-F238E27FC236}">
+                <a16:creationId xmlns:a16="http://schemas.microsoft.com/office/drawing/2014/main" id="{56E17EB4-3941-409D-821F-49B999AB3462}"/>
               </a:ext>
             </a:extLst>
           </p:cNvPr>
@@ -13305,10 +13764,10 @@
       </p:sp>
       <p:sp>
         <p:nvSpPr>
-          <p:cNvPr id="12" name="">
-            <a:extLst xmlns:a="http://schemas.openxmlformats.org/drawingml/2006/main">
-              <a:ext uri="{FF2B5EF4-FFF2-40B4-BE49-F238E27FC236}">
-                <a16:creationId xmlns:a16="http://schemas.microsoft.com/office/drawing/2014/main" id="{96214333-560A-4B28-8205-125C6A7FADA0}"/>
+          <p:cNvPr id="13" name="">
+            <a:extLst xmlns:a="http://schemas.openxmlformats.org/drawingml/2006/main">
+              <a:ext uri="{FF2B5EF4-FFF2-40B4-BE49-F238E27FC236}">
+                <a16:creationId xmlns:a16="http://schemas.microsoft.com/office/drawing/2014/main" id="{846252E3-C6B9-46CD-AF6A-6AB5FDEDF28E}"/>
               </a:ext>
             </a:extLst>
           </p:cNvPr>
@@ -13363,10 +13822,10 @@
       </p:sp>
       <p:sp>
         <p:nvSpPr>
-          <p:cNvPr id="13" name="">
-            <a:extLst xmlns:a="http://schemas.openxmlformats.org/drawingml/2006/main">
-              <a:ext uri="{FF2B5EF4-FFF2-40B4-BE49-F238E27FC236}">
-                <a16:creationId xmlns:a16="http://schemas.microsoft.com/office/drawing/2014/main" id="{ABC8B1D1-3F85-493A-96A4-D212BC3A8C65}"/>
+          <p:cNvPr id="14" name="">
+            <a:extLst xmlns:a="http://schemas.openxmlformats.org/drawingml/2006/main">
+              <a:ext uri="{FF2B5EF4-FFF2-40B4-BE49-F238E27FC236}">
+                <a16:creationId xmlns:a16="http://schemas.microsoft.com/office/drawing/2014/main" id="{D721742A-DBAF-475A-88F9-790DCF5A24D6}"/>
               </a:ext>
             </a:extLst>
           </p:cNvPr>
@@ -13396,10 +13855,10 @@
       </p:sp>
       <p:sp>
         <p:nvSpPr>
-          <p:cNvPr id="14" name="">
-            <a:extLst xmlns:a="http://schemas.openxmlformats.org/drawingml/2006/main">
-              <a:ext uri="{FF2B5EF4-FFF2-40B4-BE49-F238E27FC236}">
-                <a16:creationId xmlns:a16="http://schemas.microsoft.com/office/drawing/2014/main" id="{47DE3C6A-8B6F-45D4-A8B8-F69B382482B9}"/>
+          <p:cNvPr id="15" name="">
+            <a:extLst xmlns:a="http://schemas.openxmlformats.org/drawingml/2006/main">
+              <a:ext uri="{FF2B5EF4-FFF2-40B4-BE49-F238E27FC236}">
+                <a16:creationId xmlns:a16="http://schemas.microsoft.com/office/drawing/2014/main" id="{93252838-0B5B-4E88-BBDD-922D2A582C94}"/>
               </a:ext>
             </a:extLst>
           </p:cNvPr>
@@ -13454,10 +13913,10 @@
       </p:sp>
       <p:sp>
         <p:nvSpPr>
-          <p:cNvPr id="15" name="">
-            <a:extLst xmlns:a="http://schemas.openxmlformats.org/drawingml/2006/main">
-              <a:ext uri="{FF2B5EF4-FFF2-40B4-BE49-F238E27FC236}">
-                <a16:creationId xmlns:a16="http://schemas.microsoft.com/office/drawing/2014/main" id="{F0F54FB0-4263-4E82-B7C6-6EFDDBEA7868}"/>
+          <p:cNvPr id="16" name="">
+            <a:extLst xmlns:a="http://schemas.openxmlformats.org/drawingml/2006/main">
+              <a:ext uri="{FF2B5EF4-FFF2-40B4-BE49-F238E27FC236}">
+                <a16:creationId xmlns:a16="http://schemas.microsoft.com/office/drawing/2014/main" id="{B1E79A80-D508-454C-B9F1-7F4509A8697A}"/>
               </a:ext>
             </a:extLst>
           </p:cNvPr>
@@ -13512,10 +13971,10 @@
       </p:sp>
       <p:sp>
         <p:nvSpPr>
-          <p:cNvPr id="16" name="">
-            <a:extLst xmlns:a="http://schemas.openxmlformats.org/drawingml/2006/main">
-              <a:ext uri="{FF2B5EF4-FFF2-40B4-BE49-F238E27FC236}">
-                <a16:creationId xmlns:a16="http://schemas.microsoft.com/office/drawing/2014/main" id="{AFF3A65C-2A49-40D4-8A2A-6A27275EE9A8}"/>
+          <p:cNvPr id="17" name="">
+            <a:extLst xmlns:a="http://schemas.openxmlformats.org/drawingml/2006/main">
+              <a:ext uri="{FF2B5EF4-FFF2-40B4-BE49-F238E27FC236}">
+                <a16:creationId xmlns:a16="http://schemas.microsoft.com/office/drawing/2014/main" id="{03CDBCFF-3AC2-46D1-A21B-B8BDE1E6F2A3}"/>
               </a:ext>
             </a:extLst>
           </p:cNvPr>
@@ -13545,10 +14004,10 @@
       </p:sp>
       <p:sp>
         <p:nvSpPr>
-          <p:cNvPr id="17" name="">
-            <a:extLst xmlns:a="http://schemas.openxmlformats.org/drawingml/2006/main">
-              <a:ext uri="{FF2B5EF4-FFF2-40B4-BE49-F238E27FC236}">
-                <a16:creationId xmlns:a16="http://schemas.microsoft.com/office/drawing/2014/main" id="{66258927-9B8B-4A48-96FE-A67167941D6F}"/>
+          <p:cNvPr id="18" name="">
+            <a:extLst xmlns:a="http://schemas.openxmlformats.org/drawingml/2006/main">
+              <a:ext uri="{FF2B5EF4-FFF2-40B4-BE49-F238E27FC236}">
+                <a16:creationId xmlns:a16="http://schemas.microsoft.com/office/drawing/2014/main" id="{7144E4DC-C654-4C02-876C-206A17F074DD}"/>
               </a:ext>
             </a:extLst>
           </p:cNvPr>
@@ -13603,10 +14062,10 @@
       </p:sp>
       <p:sp>
         <p:nvSpPr>
-          <p:cNvPr id="18" name="">
-            <a:extLst xmlns:a="http://schemas.openxmlformats.org/drawingml/2006/main">
-              <a:ext uri="{FF2B5EF4-FFF2-40B4-BE49-F238E27FC236}">
-                <a16:creationId xmlns:a16="http://schemas.microsoft.com/office/drawing/2014/main" id="{AE8A1E4C-4A83-4EFC-B450-39CCA65B651C}"/>
+          <p:cNvPr id="19" name="">
+            <a:extLst xmlns:a="http://schemas.openxmlformats.org/drawingml/2006/main">
+              <a:ext uri="{FF2B5EF4-FFF2-40B4-BE49-F238E27FC236}">
+                <a16:creationId xmlns:a16="http://schemas.microsoft.com/office/drawing/2014/main" id="{37DB81F5-614E-4156-8DB2-964A790DD8DE}"/>
               </a:ext>
             </a:extLst>
           </p:cNvPr>
@@ -13661,10 +14120,10 @@
       </p:sp>
       <p:sp>
         <p:nvSpPr>
-          <p:cNvPr id="19" name="">
-            <a:extLst xmlns:a="http://schemas.openxmlformats.org/drawingml/2006/main">
-              <a:ext uri="{FF2B5EF4-FFF2-40B4-BE49-F238E27FC236}">
-                <a16:creationId xmlns:a16="http://schemas.microsoft.com/office/drawing/2014/main" id="{5E151705-A246-4FB4-8139-F752285CE364}"/>
+          <p:cNvPr id="20" name="">
+            <a:extLst xmlns:a="http://schemas.openxmlformats.org/drawingml/2006/main">
+              <a:ext uri="{FF2B5EF4-FFF2-40B4-BE49-F238E27FC236}">
+                <a16:creationId xmlns:a16="http://schemas.microsoft.com/office/drawing/2014/main" id="{68B089F8-FF9E-4185-ACE8-20F620B32783}"/>
               </a:ext>
             </a:extLst>
           </p:cNvPr>
@@ -13694,10 +14153,10 @@
       </p:sp>
       <p:sp>
         <p:nvSpPr>
-          <p:cNvPr id="20" name="">
-            <a:extLst xmlns:a="http://schemas.openxmlformats.org/drawingml/2006/main">
-              <a:ext uri="{FF2B5EF4-FFF2-40B4-BE49-F238E27FC236}">
-                <a16:creationId xmlns:a16="http://schemas.microsoft.com/office/drawing/2014/main" id="{C40021B3-40CF-4D33-BCC6-F7E30B26C4FD}"/>
+          <p:cNvPr id="21" name="">
+            <a:extLst xmlns:a="http://schemas.openxmlformats.org/drawingml/2006/main">
+              <a:ext uri="{FF2B5EF4-FFF2-40B4-BE49-F238E27FC236}">
+                <a16:creationId xmlns:a16="http://schemas.microsoft.com/office/drawing/2014/main" id="{BBC638C2-AC24-4E9F-AAAF-AD1CFE56655B}"/>
               </a:ext>
             </a:extLst>
           </p:cNvPr>
@@ -13752,10 +14211,10 @@
       </p:sp>
       <p:sp>
         <p:nvSpPr>
-          <p:cNvPr id="21" name="">
-            <a:extLst xmlns:a="http://schemas.openxmlformats.org/drawingml/2006/main">
-              <a:ext uri="{FF2B5EF4-FFF2-40B4-BE49-F238E27FC236}">
-                <a16:creationId xmlns:a16="http://schemas.microsoft.com/office/drawing/2014/main" id="{C8730B8A-CEB2-4055-B5BA-91DA57D1D023}"/>
+          <p:cNvPr id="22" name="">
+            <a:extLst xmlns:a="http://schemas.openxmlformats.org/drawingml/2006/main">
+              <a:ext uri="{FF2B5EF4-FFF2-40B4-BE49-F238E27FC236}">
+                <a16:creationId xmlns:a16="http://schemas.microsoft.com/office/drawing/2014/main" id="{DE0B3DBC-2FE9-4DA7-BEEA-BA4682BAC1C7}"/>
               </a:ext>
             </a:extLst>
           </p:cNvPr>
@@ -13810,10 +14269,10 @@
       </p:sp>
       <p:sp>
         <p:nvSpPr>
-          <p:cNvPr id="22" name="">
-            <a:extLst xmlns:a="http://schemas.openxmlformats.org/drawingml/2006/main">
-              <a:ext uri="{FF2B5EF4-FFF2-40B4-BE49-F238E27FC236}">
-                <a16:creationId xmlns:a16="http://schemas.microsoft.com/office/drawing/2014/main" id="{9D25095B-0488-4A0F-8860-36FAF0583B58}"/>
+          <p:cNvPr id="23" name="">
+            <a:extLst xmlns:a="http://schemas.openxmlformats.org/drawingml/2006/main">
+              <a:ext uri="{FF2B5EF4-FFF2-40B4-BE49-F238E27FC236}">
+                <a16:creationId xmlns:a16="http://schemas.microsoft.com/office/drawing/2014/main" id="{CDC5FD2B-D55A-42DD-833E-5DDDAC25E099}"/>
               </a:ext>
             </a:extLst>
           </p:cNvPr>
@@ -13868,10 +14327,10 @@
       </p:sp>
       <p:sp>
         <p:nvSpPr>
-          <p:cNvPr id="23" name="">
-            <a:extLst xmlns:a="http://schemas.openxmlformats.org/drawingml/2006/main">
-              <a:ext uri="{FF2B5EF4-FFF2-40B4-BE49-F238E27FC236}">
-                <a16:creationId xmlns:a16="http://schemas.microsoft.com/office/drawing/2014/main" id="{F028310E-CDE2-42A3-B803-4EAB60B2159B}"/>
+          <p:cNvPr id="24" name="">
+            <a:extLst xmlns:a="http://schemas.openxmlformats.org/drawingml/2006/main">
+              <a:ext uri="{FF2B5EF4-FFF2-40B4-BE49-F238E27FC236}">
+                <a16:creationId xmlns:a16="http://schemas.microsoft.com/office/drawing/2014/main" id="{586B2F34-F294-4933-AA81-D944E5C1FE2D}"/>
               </a:ext>
             </a:extLst>
           </p:cNvPr>
@@ -13950,7 +14409,7 @@
                 <a:ea typeface="Arial"/>
                 <a:cs typeface="Arial"/>
               </a:rPr>
-              <a:t>•  1,024-probe ledger across five families</a:t>
+              <a:t>•  Planned 1,024-unit aggregate quota; 5 receipts</a:t>
             </a:r>
           </a:p>
           <a:p xmlns:a="http://schemas.openxmlformats.org/drawingml/2006/main">
@@ -13977,7 +14436,7 @@
                 <a:ea typeface="Arial"/>
                 <a:cs typeface="Arial"/>
               </a:rPr>
-              <a:t>•  Human-approved Skeptic replay</a:t>
+              <a:t>•  Skeptic replay behind a demo interaction gate</a:t>
             </a:r>
           </a:p>
           <a:p xmlns:a="http://schemas.openxmlformats.org/drawingml/2006/main">
@@ -14011,10 +14470,10 @@
       </p:sp>
       <p:sp>
         <p:nvSpPr>
-          <p:cNvPr id="24" name="">
-            <a:extLst xmlns:a="http://schemas.openxmlformats.org/drawingml/2006/main">
-              <a:ext uri="{FF2B5EF4-FFF2-40B4-BE49-F238E27FC236}">
-                <a16:creationId xmlns:a16="http://schemas.microsoft.com/office/drawing/2014/main" id="{F4D59240-0665-449A-90C4-12547F6B0183}"/>
+          <p:cNvPr id="25" name="">
+            <a:extLst xmlns:a="http://schemas.openxmlformats.org/drawingml/2006/main">
+              <a:ext uri="{FF2B5EF4-FFF2-40B4-BE49-F238E27FC236}">
+                <a16:creationId xmlns:a16="http://schemas.microsoft.com/office/drawing/2014/main" id="{16ADBF9C-7B41-477D-BA61-20F0C2E5613A}"/>
               </a:ext>
             </a:extLst>
           </p:cNvPr>
@@ -14042,10 +14501,10 @@
       </p:sp>
       <p:sp>
         <p:nvSpPr>
-          <p:cNvPr id="25" name="">
-            <a:extLst xmlns:a="http://schemas.openxmlformats.org/drawingml/2006/main">
-              <a:ext uri="{FF2B5EF4-FFF2-40B4-BE49-F238E27FC236}">
-                <a16:creationId xmlns:a16="http://schemas.microsoft.com/office/drawing/2014/main" id="{93BC350A-6D39-4DC1-B8F5-AE3949C52504}"/>
+          <p:cNvPr id="26" name="">
+            <a:extLst xmlns:a="http://schemas.openxmlformats.org/drawingml/2006/main">
+              <a:ext uri="{FF2B5EF4-FFF2-40B4-BE49-F238E27FC236}">
+                <a16:creationId xmlns:a16="http://schemas.microsoft.com/office/drawing/2014/main" id="{49144ADC-C870-4B47-80D8-B4C1FCA6D109}"/>
               </a:ext>
             </a:extLst>
           </p:cNvPr>
@@ -14100,10 +14559,10 @@
       </p:sp>
       <p:sp>
         <p:nvSpPr>
-          <p:cNvPr id="26" name="">
-            <a:extLst xmlns:a="http://schemas.openxmlformats.org/drawingml/2006/main">
-              <a:ext uri="{FF2B5EF4-FFF2-40B4-BE49-F238E27FC236}">
-                <a16:creationId xmlns:a16="http://schemas.microsoft.com/office/drawing/2014/main" id="{8A554E32-7431-4E91-87BA-65E058AF63A8}"/>
+          <p:cNvPr id="27" name="">
+            <a:extLst xmlns:a="http://schemas.openxmlformats.org/drawingml/2006/main">
+              <a:ext uri="{FF2B5EF4-FFF2-40B4-BE49-F238E27FC236}">
+                <a16:creationId xmlns:a16="http://schemas.microsoft.com/office/drawing/2014/main" id="{024A63AB-995D-42AE-9E61-E8A5734FE337}"/>
               </a:ext>
             </a:extLst>
           </p:cNvPr>
@@ -14243,10 +14702,10 @@
       </p:sp>
       <p:sp>
         <p:nvSpPr>
-          <p:cNvPr id="27" name="">
-            <a:extLst xmlns:a="http://schemas.openxmlformats.org/drawingml/2006/main">
-              <a:ext uri="{FF2B5EF4-FFF2-40B4-BE49-F238E27FC236}">
-                <a16:creationId xmlns:a16="http://schemas.microsoft.com/office/drawing/2014/main" id="{026A1C73-6A88-4577-A114-012C3F96A0BF}"/>
+          <p:cNvPr id="28" name="">
+            <a:extLst xmlns:a="http://schemas.openxmlformats.org/drawingml/2006/main">
+              <a:ext uri="{FF2B5EF4-FFF2-40B4-BE49-F238E27FC236}">
+                <a16:creationId xmlns:a16="http://schemas.microsoft.com/office/drawing/2014/main" id="{BAC01859-BE80-40F3-81BD-85582A299156}"/>
               </a:ext>
             </a:extLst>
           </p:cNvPr>
@@ -14278,10 +14737,10 @@
       </p:sp>
       <p:sp>
         <p:nvSpPr>
-          <p:cNvPr id="28" name="">
-            <a:extLst xmlns:a="http://schemas.openxmlformats.org/drawingml/2006/main">
-              <a:ext uri="{FF2B5EF4-FFF2-40B4-BE49-F238E27FC236}">
-                <a16:creationId xmlns:a16="http://schemas.microsoft.com/office/drawing/2014/main" id="{8041E606-0591-4DE1-A486-25F329EA9CF2}"/>
+          <p:cNvPr id="29" name="">
+            <a:extLst xmlns:a="http://schemas.openxmlformats.org/drawingml/2006/main">
+              <a:ext uri="{FF2B5EF4-FFF2-40B4-BE49-F238E27FC236}">
+                <a16:creationId xmlns:a16="http://schemas.microsoft.com/office/drawing/2014/main" id="{6FDBDCA4-8DCD-4BFE-AE2B-F30A03070B5B}"/>
               </a:ext>
             </a:extLst>
           </p:cNvPr>
@@ -14336,10 +14795,10 @@
       </p:sp>
       <p:sp>
         <p:nvSpPr>
-          <p:cNvPr id="29" name="">
-            <a:extLst xmlns:a="http://schemas.openxmlformats.org/drawingml/2006/main">
-              <a:ext uri="{FF2B5EF4-FFF2-40B4-BE49-F238E27FC236}">
-                <a16:creationId xmlns:a16="http://schemas.microsoft.com/office/drawing/2014/main" id="{54917209-4660-4852-9938-A9AB60FF612D}"/>
+          <p:cNvPr id="30" name="">
+            <a:extLst xmlns:a="http://schemas.openxmlformats.org/drawingml/2006/main">
+              <a:ext uri="{FF2B5EF4-FFF2-40B4-BE49-F238E27FC236}">
+                <a16:creationId xmlns:a16="http://schemas.microsoft.com/office/drawing/2014/main" id="{F41E8A0A-C5D2-4709-A31F-CE2C310469B1}"/>
               </a:ext>
             </a:extLst>
           </p:cNvPr>
@@ -14394,10 +14853,10 @@
       </p:sp>
       <p:sp>
         <p:nvSpPr>
-          <p:cNvPr id="30" name="">
-            <a:extLst xmlns:a="http://schemas.openxmlformats.org/drawingml/2006/main">
-              <a:ext uri="{FF2B5EF4-FFF2-40B4-BE49-F238E27FC236}">
-                <a16:creationId xmlns:a16="http://schemas.microsoft.com/office/drawing/2014/main" id="{EFF926BC-DFF7-42E8-BB85-65467AC3EB9B}"/>
+          <p:cNvPr id="31" name="">
+            <a:extLst xmlns:a="http://schemas.openxmlformats.org/drawingml/2006/main">
+              <a:ext uri="{FF2B5EF4-FFF2-40B4-BE49-F238E27FC236}">
+                <a16:creationId xmlns:a16="http://schemas.microsoft.com/office/drawing/2014/main" id="{38A718C1-195E-4E60-92F3-41F2C7BB4ACA}"/>
               </a:ext>
             </a:extLst>
           </p:cNvPr>
@@ -14457,7 +14916,7 @@
     </p:spTree>
     <p:extLst>
       <p:ext uri="{BB962C8B-B14F-4D97-AF65-F5344CB8AC3E}">
-        <p14:creationId xmlns:p14="http://schemas.microsoft.com/office/powerpoint/2010/main" val="1346982810"/>
+        <p14:creationId xmlns:p14="http://schemas.microsoft.com/office/powerpoint/2010/main" val="60178657"/>
       </p:ext>
     </p:extLst>
   </p:cSld>

</xml_diff>

<commit_message>
docs: refresh investor deck
</commit_message>
<xml_diff>
--- a/public/materials/LRWA_Seed_Deck.pptx
+++ b/public/materials/LRWA_Seed_Deck.pptx
@@ -2,20 +2,20 @@
 <file path=ppt/presentation.xml><?xml version="1.0" encoding="utf-8"?>
 <p:presentation xmlns:p="http://schemas.openxmlformats.org/presentationml/2006/main">
   <p:sldMasterIdLst>
-    <p:sldMasterId xmlns:r="http://schemas.openxmlformats.org/officeDocument/2006/relationships" id="2147483648" r:id="R78d87bf24adc439f"/>
+    <p:sldMasterId xmlns:r="http://schemas.openxmlformats.org/officeDocument/2006/relationships" id="2147483648" r:id="Rf6c49d6f4bc94110"/>
   </p:sldMasterIdLst>
   <p:notesMasterIdLst>
-    <p:notesMasterId xmlns:r="http://schemas.openxmlformats.org/officeDocument/2006/relationships" r:id="R55a4e5799406439a"/>
+    <p:notesMasterId xmlns:r="http://schemas.openxmlformats.org/officeDocument/2006/relationships" r:id="R292172a5e22e458f"/>
   </p:notesMasterIdLst>
   <p:sldIdLst>
-    <p:sldId xmlns:r="http://schemas.openxmlformats.org/officeDocument/2006/relationships" id="256" r:id="Rc5008b5ed46143cd"/>
-    <p:sldId xmlns:r="http://schemas.openxmlformats.org/officeDocument/2006/relationships" id="257" r:id="Rfcbc3e9ccb4142c4"/>
-    <p:sldId xmlns:r="http://schemas.openxmlformats.org/officeDocument/2006/relationships" id="258" r:id="R984f8158e977487b"/>
-    <p:sldId xmlns:r="http://schemas.openxmlformats.org/officeDocument/2006/relationships" id="259" r:id="R55353ca8d3df4ec7"/>
-    <p:sldId xmlns:r="http://schemas.openxmlformats.org/officeDocument/2006/relationships" id="260" r:id="Rbb5044b07394407a"/>
-    <p:sldId xmlns:r="http://schemas.openxmlformats.org/officeDocument/2006/relationships" id="261" r:id="R84c6221509ae425f"/>
-    <p:sldId xmlns:r="http://schemas.openxmlformats.org/officeDocument/2006/relationships" id="262" r:id="R431fdaa429304176"/>
-    <p:sldId xmlns:r="http://schemas.openxmlformats.org/officeDocument/2006/relationships" id="263" r:id="Ref604c7a0f0d457a"/>
+    <p:sldId xmlns:r="http://schemas.openxmlformats.org/officeDocument/2006/relationships" id="256" r:id="R0892eb5c6bb94e51"/>
+    <p:sldId xmlns:r="http://schemas.openxmlformats.org/officeDocument/2006/relationships" id="257" r:id="R01b787d52992438b"/>
+    <p:sldId xmlns:r="http://schemas.openxmlformats.org/officeDocument/2006/relationships" id="258" r:id="R680c6c2645a6470a"/>
+    <p:sldId xmlns:r="http://schemas.openxmlformats.org/officeDocument/2006/relationships" id="259" r:id="R6439be000c54466a"/>
+    <p:sldId xmlns:r="http://schemas.openxmlformats.org/officeDocument/2006/relationships" id="260" r:id="R05ca9dc5267e455c"/>
+    <p:sldId xmlns:r="http://schemas.openxmlformats.org/officeDocument/2006/relationships" id="261" r:id="R137504ffabca4d5f"/>
+    <p:sldId xmlns:r="http://schemas.openxmlformats.org/officeDocument/2006/relationships" id="262" r:id="Re6bdac126bb54b20"/>
+    <p:sldId xmlns:r="http://schemas.openxmlformats.org/officeDocument/2006/relationships" id="263" r:id="R478c6e79d549488c"/>
   </p:sldIdLst>
   <p:sldSz cx="12192000" cy="6858000"/>
   <p:notesSz cx="6858000" cy="9144000"/>
@@ -1242,7 +1242,7 @@
   </p:cSld>
   <p:clrMap bg1="lt1" tx1="dk1" bg2="lt2" tx2="dk2" accent1="accent1" accent2="accent2" accent3="accent3" accent4="accent4" accent5="accent5" accent6="accent6" hlink="hlink" folHlink="folHlink"/>
   <p:sldLayoutIdLst>
-    <p:sldLayoutId xmlns:r="http://schemas.openxmlformats.org/officeDocument/2006/relationships" id="2147483649" r:id="Rbf2d23e80f4d4b95"/>
+    <p:sldLayoutId xmlns:r="http://schemas.openxmlformats.org/officeDocument/2006/relationships" id="2147483649" r:id="R00ac81e9da9b4f7f"/>
   </p:sldLayoutIdLst>
   <p:txStyles>
     <p:titleStyle>
@@ -1797,7 +1797,7 @@
           <p:nvPr/>
         </p:nvPicPr>
         <p:blipFill>
-          <a:blip xmlns:r="http://schemas.openxmlformats.org/officeDocument/2006/relationships" xmlns:a="http://schemas.openxmlformats.org/drawingml/2006/main" r:embed="Rc13c2659b2f04a7d"/>
+          <a:blip xmlns:r="http://schemas.openxmlformats.org/officeDocument/2006/relationships" xmlns:a="http://schemas.openxmlformats.org/drawingml/2006/main" r:embed="Rfed9c9ba70f34232"/>
           <a:srcRect xmlns:a="http://schemas.openxmlformats.org/drawingml/2006/main" l="0" t="27" r="0" b="27"/>
           <a:stretch xmlns:a="http://schemas.openxmlformats.org/drawingml/2006/main">
             <a:fillRect l="0" t="0" r="0" b="0"/>
@@ -1818,7 +1818,7 @@
           <p:cNvPr id="2" name="">
             <a:extLst xmlns:a="http://schemas.openxmlformats.org/drawingml/2006/main">
               <a:ext uri="{FF2B5EF4-FFF2-40B4-BE49-F238E27FC236}">
-                <a16:creationId xmlns:a16="http://schemas.microsoft.com/office/drawing/2014/main" id="{4332B4AF-3E97-470C-A91A-B2E34DA8AA3D}"/>
+                <a16:creationId xmlns:a16="http://schemas.microsoft.com/office/drawing/2014/main" id="{8EC24BD6-C9F7-4CA8-A540-EDBA1114C28E}"/>
               </a:ext>
             </a:extLst>
           </p:cNvPr>
@@ -1868,10 +1868,10 @@
           <p:nvPr/>
         </p:nvPicPr>
         <p:blipFill>
-          <a:blip xmlns:r="http://schemas.openxmlformats.org/officeDocument/2006/relationships" xmlns:a="http://schemas.openxmlformats.org/drawingml/2006/main" r:embed="Rc253a96c3ea1495f">
+          <a:blip xmlns:r="http://schemas.openxmlformats.org/officeDocument/2006/relationships" xmlns:a="http://schemas.openxmlformats.org/drawingml/2006/main" r:embed="Raa4d49d5fde94ebd">
             <a:extLst>
               <a:ext uri="{96DAC541-7B7A-43D3-8B79-37D633B846F1}">
-                <asvg:svgBlip xmlns:asvg="http://schemas.microsoft.com/office/drawing/2016/SVG/main" r:embed="Ref280438f2064b23"/>
+                <asvg:svgBlip xmlns:asvg="http://schemas.microsoft.com/office/drawing/2016/SVG/main" r:embed="R5f7ef12c8f2142b0"/>
               </a:ext>
             </a:extLst>
           </a:blip>
@@ -1892,7 +1892,7 @@
           <p:cNvPr id="4" name="">
             <a:extLst xmlns:a="http://schemas.openxmlformats.org/drawingml/2006/main">
               <a:ext uri="{FF2B5EF4-FFF2-40B4-BE49-F238E27FC236}">
-                <a16:creationId xmlns:a16="http://schemas.microsoft.com/office/drawing/2014/main" id="{2294A36D-21E3-400D-8F9F-889DD3A386FC}"/>
+                <a16:creationId xmlns:a16="http://schemas.microsoft.com/office/drawing/2014/main" id="{2C377D2A-3F6B-4799-85AF-3DCAF06A9880}"/>
               </a:ext>
             </a:extLst>
           </p:cNvPr>
@@ -1950,7 +1950,7 @@
           <p:cNvPr id="5" name="">
             <a:extLst xmlns:a="http://schemas.openxmlformats.org/drawingml/2006/main">
               <a:ext uri="{FF2B5EF4-FFF2-40B4-BE49-F238E27FC236}">
-                <a16:creationId xmlns:a16="http://schemas.microsoft.com/office/drawing/2014/main" id="{564758E1-D6A3-4721-90D0-B409FF387082}"/>
+                <a16:creationId xmlns:a16="http://schemas.microsoft.com/office/drawing/2014/main" id="{A8B34435-3243-44CF-9343-F14054BEDF51}"/>
               </a:ext>
             </a:extLst>
           </p:cNvPr>
@@ -2012,7 +2012,7 @@
           <p:cNvPr id="6" name="">
             <a:extLst xmlns:a="http://schemas.openxmlformats.org/drawingml/2006/main">
               <a:ext uri="{FF2B5EF4-FFF2-40B4-BE49-F238E27FC236}">
-                <a16:creationId xmlns:a16="http://schemas.microsoft.com/office/drawing/2014/main" id="{3AF6BC12-2AC1-4FBD-A295-1D255A824DE2}"/>
+                <a16:creationId xmlns:a16="http://schemas.microsoft.com/office/drawing/2014/main" id="{B9D560CC-35EA-455D-A985-F167ECACD26F}"/>
               </a:ext>
             </a:extLst>
           </p:cNvPr>
@@ -2101,7 +2101,7 @@
           <p:cNvPr id="7" name="">
             <a:extLst xmlns:a="http://schemas.openxmlformats.org/drawingml/2006/main">
               <a:ext uri="{FF2B5EF4-FFF2-40B4-BE49-F238E27FC236}">
-                <a16:creationId xmlns:a16="http://schemas.microsoft.com/office/drawing/2014/main" id="{67B5A8C7-21A8-49CB-A380-B3C580285800}"/>
+                <a16:creationId xmlns:a16="http://schemas.microsoft.com/office/drawing/2014/main" id="{78201A0C-B7B0-4AF7-B603-9569F1793670}"/>
               </a:ext>
             </a:extLst>
           </p:cNvPr>
@@ -2159,7 +2159,7 @@
           <p:cNvPr id="8" name="">
             <a:extLst xmlns:a="http://schemas.openxmlformats.org/drawingml/2006/main">
               <a:ext uri="{FF2B5EF4-FFF2-40B4-BE49-F238E27FC236}">
-                <a16:creationId xmlns:a16="http://schemas.microsoft.com/office/drawing/2014/main" id="{CFA4FF81-0C67-43D6-BB1A-EED01AF949CA}"/>
+                <a16:creationId xmlns:a16="http://schemas.microsoft.com/office/drawing/2014/main" id="{12C65368-E70C-4FCE-B41D-C39EE812236D}"/>
               </a:ext>
             </a:extLst>
           </p:cNvPr>
@@ -2190,7 +2190,7 @@
           <p:cNvPr id="9" name="">
             <a:extLst xmlns:a="http://schemas.openxmlformats.org/drawingml/2006/main">
               <a:ext uri="{FF2B5EF4-FFF2-40B4-BE49-F238E27FC236}">
-                <a16:creationId xmlns:a16="http://schemas.microsoft.com/office/drawing/2014/main" id="{87E900D5-5D04-435B-84F4-4D4ABCB423CE}"/>
+                <a16:creationId xmlns:a16="http://schemas.microsoft.com/office/drawing/2014/main" id="{57C5CA9B-D632-4D69-83F5-57251B2CE14B}"/>
               </a:ext>
             </a:extLst>
           </p:cNvPr>
@@ -2248,7 +2248,7 @@
           <p:cNvPr id="10" name="">
             <a:extLst xmlns:a="http://schemas.openxmlformats.org/drawingml/2006/main">
               <a:ext uri="{FF2B5EF4-FFF2-40B4-BE49-F238E27FC236}">
-                <a16:creationId xmlns:a16="http://schemas.microsoft.com/office/drawing/2014/main" id="{D76A491D-1FFA-428B-8092-F249A1E47C5C}"/>
+                <a16:creationId xmlns:a16="http://schemas.microsoft.com/office/drawing/2014/main" id="{BC47D394-3E0A-42EE-8BCB-DCCA552A4B16}"/>
               </a:ext>
             </a:extLst>
           </p:cNvPr>
@@ -2304,7 +2304,7 @@
     </p:spTree>
     <p:extLst>
       <p:ext uri="{BB962C8B-B14F-4D97-AF65-F5344CB8AC3E}">
-        <p14:creationId xmlns:p14="http://schemas.microsoft.com/office/powerpoint/2010/main" val="1493684667"/>
+        <p14:creationId xmlns:p14="http://schemas.microsoft.com/office/powerpoint/2010/main" val="618357084"/>
       </p:ext>
     </p:extLst>
   </p:cSld>
@@ -2335,7 +2335,7 @@
           <p:cNvPr id="30" name="">
             <a:extLst xmlns:a="http://schemas.openxmlformats.org/drawingml/2006/main">
               <a:ext uri="{FF2B5EF4-FFF2-40B4-BE49-F238E27FC236}">
-                <a16:creationId xmlns:a16="http://schemas.microsoft.com/office/drawing/2014/main" id="{64CD463A-00EF-4280-B3CE-DC196C0E065B}"/>
+                <a16:creationId xmlns:a16="http://schemas.microsoft.com/office/drawing/2014/main" id="{77367070-A22D-4B28-98FC-E58FBFD1138B}"/>
               </a:ext>
             </a:extLst>
           </p:cNvPr>
@@ -2368,7 +2368,7 @@
           <p:cNvPr id="2" name="">
             <a:extLst xmlns:a="http://schemas.openxmlformats.org/drawingml/2006/main">
               <a:ext uri="{FF2B5EF4-FFF2-40B4-BE49-F238E27FC236}">
-                <a16:creationId xmlns:a16="http://schemas.microsoft.com/office/drawing/2014/main" id="{E26DA48C-8F6B-4635-9455-D6A2BE436237}"/>
+                <a16:creationId xmlns:a16="http://schemas.microsoft.com/office/drawing/2014/main" id="{A9FB4104-ADBA-49AE-A5BD-2E7A6D3F6C31}"/>
               </a:ext>
             </a:extLst>
           </p:cNvPr>
@@ -2426,7 +2426,7 @@
           <p:cNvPr id="3" name="">
             <a:extLst xmlns:a="http://schemas.openxmlformats.org/drawingml/2006/main">
               <a:ext uri="{FF2B5EF4-FFF2-40B4-BE49-F238E27FC236}">
-                <a16:creationId xmlns:a16="http://schemas.microsoft.com/office/drawing/2014/main" id="{1F9959EC-2F2E-4C29-A240-7E2DE2A2701E}"/>
+                <a16:creationId xmlns:a16="http://schemas.microsoft.com/office/drawing/2014/main" id="{FE9A1E1B-C569-44BA-A3EB-4DBCB1E8A527}"/>
               </a:ext>
             </a:extLst>
           </p:cNvPr>
@@ -2484,7 +2484,7 @@
           <p:cNvPr id="4" name="">
             <a:extLst xmlns:a="http://schemas.openxmlformats.org/drawingml/2006/main">
               <a:ext uri="{FF2B5EF4-FFF2-40B4-BE49-F238E27FC236}">
-                <a16:creationId xmlns:a16="http://schemas.microsoft.com/office/drawing/2014/main" id="{53291B57-D2D0-48D3-B9D5-6A79E4FEFA88}"/>
+                <a16:creationId xmlns:a16="http://schemas.microsoft.com/office/drawing/2014/main" id="{C8A8147E-1CB1-4F6B-8DA4-8D82BAB0A6A4}"/>
               </a:ext>
             </a:extLst>
           </p:cNvPr>
@@ -2519,10 +2519,10 @@
           <p:nvPr/>
         </p:nvPicPr>
         <p:blipFill>
-          <a:blip xmlns:r="http://schemas.openxmlformats.org/officeDocument/2006/relationships" xmlns:a="http://schemas.openxmlformats.org/drawingml/2006/main" r:embed="R365dd1a019ea4f1d">
+          <a:blip xmlns:r="http://schemas.openxmlformats.org/officeDocument/2006/relationships" xmlns:a="http://schemas.openxmlformats.org/drawingml/2006/main" r:embed="R8323816f1e77457d">
             <a:extLst>
               <a:ext uri="{96DAC541-7B7A-43D3-8B79-37D633B846F1}">
-                <asvg:svgBlip xmlns:asvg="http://schemas.microsoft.com/office/drawing/2016/SVG/main" r:embed="Rb9ad23a168414061"/>
+                <asvg:svgBlip xmlns:asvg="http://schemas.microsoft.com/office/drawing/2016/SVG/main" r:embed="Rd67b9a344bc14acf"/>
               </a:ext>
             </a:extLst>
           </a:blip>
@@ -2543,7 +2543,7 @@
           <p:cNvPr id="6" name="">
             <a:extLst xmlns:a="http://schemas.openxmlformats.org/drawingml/2006/main">
               <a:ext uri="{FF2B5EF4-FFF2-40B4-BE49-F238E27FC236}">
-                <a16:creationId xmlns:a16="http://schemas.microsoft.com/office/drawing/2014/main" id="{13832000-5BEE-4C3A-85D2-C699A2B7CAC7}"/>
+                <a16:creationId xmlns:a16="http://schemas.microsoft.com/office/drawing/2014/main" id="{ED219448-4473-483B-9CB3-B33B1BF286A8}"/>
               </a:ext>
             </a:extLst>
           </p:cNvPr>
@@ -2601,7 +2601,7 @@
           <p:cNvPr id="7" name="">
             <a:extLst xmlns:a="http://schemas.openxmlformats.org/drawingml/2006/main">
               <a:ext uri="{FF2B5EF4-FFF2-40B4-BE49-F238E27FC236}">
-                <a16:creationId xmlns:a16="http://schemas.microsoft.com/office/drawing/2014/main" id="{E716E569-3BAC-4B50-B23D-36E388248CD1}"/>
+                <a16:creationId xmlns:a16="http://schemas.microsoft.com/office/drawing/2014/main" id="{AF01824F-54ED-40F2-973E-F98D5EF35F63}"/>
               </a:ext>
             </a:extLst>
           </p:cNvPr>
@@ -2659,7 +2659,7 @@
           <p:cNvPr id="8" name="">
             <a:extLst xmlns:a="http://schemas.openxmlformats.org/drawingml/2006/main">
               <a:ext uri="{FF2B5EF4-FFF2-40B4-BE49-F238E27FC236}">
-                <a16:creationId xmlns:a16="http://schemas.microsoft.com/office/drawing/2014/main" id="{A8E5CEAC-2096-421F-A5F5-C9DA2CDF51F8}"/>
+                <a16:creationId xmlns:a16="http://schemas.microsoft.com/office/drawing/2014/main" id="{A3F6FBE1-942A-4EEF-8394-E991F0CF91EE}"/>
               </a:ext>
             </a:extLst>
           </p:cNvPr>
@@ -2748,7 +2748,7 @@
           <p:cNvPr id="9" name="">
             <a:extLst xmlns:a="http://schemas.openxmlformats.org/drawingml/2006/main">
               <a:ext uri="{FF2B5EF4-FFF2-40B4-BE49-F238E27FC236}">
-                <a16:creationId xmlns:a16="http://schemas.microsoft.com/office/drawing/2014/main" id="{45F58F9C-C10E-40FA-887B-C334AEDACC64}"/>
+                <a16:creationId xmlns:a16="http://schemas.microsoft.com/office/drawing/2014/main" id="{317D2109-C500-4A15-92B2-2E46F30D51D5}"/>
               </a:ext>
             </a:extLst>
           </p:cNvPr>
@@ -2810,7 +2810,7 @@
           <p:cNvPr id="10" name="">
             <a:extLst xmlns:a="http://schemas.openxmlformats.org/drawingml/2006/main">
               <a:ext uri="{FF2B5EF4-FFF2-40B4-BE49-F238E27FC236}">
-                <a16:creationId xmlns:a16="http://schemas.microsoft.com/office/drawing/2014/main" id="{DC745E8B-03D8-456F-A0B2-32F6D4AECA18}"/>
+                <a16:creationId xmlns:a16="http://schemas.microsoft.com/office/drawing/2014/main" id="{73AA0FBF-7803-4A78-BAE9-79B66BFEAABE}"/>
               </a:ext>
             </a:extLst>
           </p:cNvPr>
@@ -2841,7 +2841,7 @@
           <p:cNvPr id="11" name="">
             <a:extLst xmlns:a="http://schemas.openxmlformats.org/drawingml/2006/main">
               <a:ext uri="{FF2B5EF4-FFF2-40B4-BE49-F238E27FC236}">
-                <a16:creationId xmlns:a16="http://schemas.microsoft.com/office/drawing/2014/main" id="{4A49B920-00D6-40B4-9DBA-CBD5F388EBCD}"/>
+                <a16:creationId xmlns:a16="http://schemas.microsoft.com/office/drawing/2014/main" id="{2F1BE180-9069-4D22-B598-2EAF969C1630}"/>
               </a:ext>
             </a:extLst>
           </p:cNvPr>
@@ -2899,7 +2899,7 @@
           <p:cNvPr id="12" name="">
             <a:extLst xmlns:a="http://schemas.openxmlformats.org/drawingml/2006/main">
               <a:ext uri="{FF2B5EF4-FFF2-40B4-BE49-F238E27FC236}">
-                <a16:creationId xmlns:a16="http://schemas.microsoft.com/office/drawing/2014/main" id="{39802B49-1612-42EA-B338-7FF95D788024}"/>
+                <a16:creationId xmlns:a16="http://schemas.microsoft.com/office/drawing/2014/main" id="{FF3967F2-1691-40EF-A6C5-B0327FE610C0}"/>
               </a:ext>
             </a:extLst>
           </p:cNvPr>
@@ -2957,7 +2957,7 @@
           <p:cNvPr id="13" name="">
             <a:extLst xmlns:a="http://schemas.openxmlformats.org/drawingml/2006/main">
               <a:ext uri="{FF2B5EF4-FFF2-40B4-BE49-F238E27FC236}">
-                <a16:creationId xmlns:a16="http://schemas.microsoft.com/office/drawing/2014/main" id="{1FF511FE-6EDA-48C2-A01C-CBA78C091FE6}"/>
+                <a16:creationId xmlns:a16="http://schemas.microsoft.com/office/drawing/2014/main" id="{27B40B3C-A858-4320-BC06-988DE9FCDF64}"/>
               </a:ext>
             </a:extLst>
           </p:cNvPr>
@@ -3015,7 +3015,7 @@
           <p:cNvPr id="14" name="">
             <a:extLst xmlns:a="http://schemas.openxmlformats.org/drawingml/2006/main">
               <a:ext uri="{FF2B5EF4-FFF2-40B4-BE49-F238E27FC236}">
-                <a16:creationId xmlns:a16="http://schemas.microsoft.com/office/drawing/2014/main" id="{D5AA3CE8-B1B5-4143-B681-D920B8ABE898}"/>
+                <a16:creationId xmlns:a16="http://schemas.microsoft.com/office/drawing/2014/main" id="{4C51774F-EA3D-4E76-96D6-E1BFEBD4E1AD}"/>
               </a:ext>
             </a:extLst>
           </p:cNvPr>
@@ -3046,7 +3046,7 @@
           <p:cNvPr id="15" name="">
             <a:extLst xmlns:a="http://schemas.openxmlformats.org/drawingml/2006/main">
               <a:ext uri="{FF2B5EF4-FFF2-40B4-BE49-F238E27FC236}">
-                <a16:creationId xmlns:a16="http://schemas.microsoft.com/office/drawing/2014/main" id="{ED5487B9-41E9-47DB-80FC-01491E51594E}"/>
+                <a16:creationId xmlns:a16="http://schemas.microsoft.com/office/drawing/2014/main" id="{383F0A96-136C-4D5B-8E54-11199EE98363}"/>
               </a:ext>
             </a:extLst>
           </p:cNvPr>
@@ -3104,7 +3104,7 @@
           <p:cNvPr id="16" name="">
             <a:extLst xmlns:a="http://schemas.openxmlformats.org/drawingml/2006/main">
               <a:ext uri="{FF2B5EF4-FFF2-40B4-BE49-F238E27FC236}">
-                <a16:creationId xmlns:a16="http://schemas.microsoft.com/office/drawing/2014/main" id="{8C191981-2CEE-43AC-B036-71A433688C1D}"/>
+                <a16:creationId xmlns:a16="http://schemas.microsoft.com/office/drawing/2014/main" id="{E3B7B8EF-4167-44E2-B088-194E73868DFB}"/>
               </a:ext>
             </a:extLst>
           </p:cNvPr>
@@ -3162,7 +3162,7 @@
           <p:cNvPr id="17" name="">
             <a:extLst xmlns:a="http://schemas.openxmlformats.org/drawingml/2006/main">
               <a:ext uri="{FF2B5EF4-FFF2-40B4-BE49-F238E27FC236}">
-                <a16:creationId xmlns:a16="http://schemas.microsoft.com/office/drawing/2014/main" id="{E2151DFE-6959-4B12-BBDC-1047AE276FAF}"/>
+                <a16:creationId xmlns:a16="http://schemas.microsoft.com/office/drawing/2014/main" id="{E2A79CDF-C83F-4880-A1B5-61032413EF7C}"/>
               </a:ext>
             </a:extLst>
           </p:cNvPr>
@@ -3193,7 +3193,7 @@
           <p:cNvPr id="18" name="">
             <a:extLst xmlns:a="http://schemas.openxmlformats.org/drawingml/2006/main">
               <a:ext uri="{FF2B5EF4-FFF2-40B4-BE49-F238E27FC236}">
-                <a16:creationId xmlns:a16="http://schemas.microsoft.com/office/drawing/2014/main" id="{9E2CABC1-ACD7-44D4-B83C-A7F31BC11147}"/>
+                <a16:creationId xmlns:a16="http://schemas.microsoft.com/office/drawing/2014/main" id="{E240FD97-F560-4223-B06F-3DBB92776595}"/>
               </a:ext>
             </a:extLst>
           </p:cNvPr>
@@ -3251,7 +3251,7 @@
           <p:cNvPr id="19" name="">
             <a:extLst xmlns:a="http://schemas.openxmlformats.org/drawingml/2006/main">
               <a:ext uri="{FF2B5EF4-FFF2-40B4-BE49-F238E27FC236}">
-                <a16:creationId xmlns:a16="http://schemas.microsoft.com/office/drawing/2014/main" id="{87940B08-60C1-4F42-94F2-C4EAB37EEB1F}"/>
+                <a16:creationId xmlns:a16="http://schemas.microsoft.com/office/drawing/2014/main" id="{A3E4A159-3AB1-4C66-A499-B2D3787BB8D6}"/>
               </a:ext>
             </a:extLst>
           </p:cNvPr>
@@ -3309,7 +3309,7 @@
           <p:cNvPr id="20" name="">
             <a:extLst xmlns:a="http://schemas.openxmlformats.org/drawingml/2006/main">
               <a:ext uri="{FF2B5EF4-FFF2-40B4-BE49-F238E27FC236}">
-                <a16:creationId xmlns:a16="http://schemas.microsoft.com/office/drawing/2014/main" id="{9A1EF7B0-B510-4F3F-AAC3-8B1C91C148D5}"/>
+                <a16:creationId xmlns:a16="http://schemas.microsoft.com/office/drawing/2014/main" id="{F3820A69-9A95-4D74-8CD6-4603047CAD31}"/>
               </a:ext>
             </a:extLst>
           </p:cNvPr>
@@ -3340,7 +3340,7 @@
           <p:cNvPr id="21" name="">
             <a:extLst xmlns:a="http://schemas.openxmlformats.org/drawingml/2006/main">
               <a:ext uri="{FF2B5EF4-FFF2-40B4-BE49-F238E27FC236}">
-                <a16:creationId xmlns:a16="http://schemas.microsoft.com/office/drawing/2014/main" id="{0EC4C88F-3D8A-4F69-85AD-CF63A12BF9E9}"/>
+                <a16:creationId xmlns:a16="http://schemas.microsoft.com/office/drawing/2014/main" id="{228E72F9-14BD-42B1-9ECD-7CBFEB1C20FB}"/>
               </a:ext>
             </a:extLst>
           </p:cNvPr>
@@ -3398,7 +3398,7 @@
           <p:cNvPr id="22" name="">
             <a:extLst xmlns:a="http://schemas.openxmlformats.org/drawingml/2006/main">
               <a:ext uri="{FF2B5EF4-FFF2-40B4-BE49-F238E27FC236}">
-                <a16:creationId xmlns:a16="http://schemas.microsoft.com/office/drawing/2014/main" id="{67D5C60D-8E7F-456C-8E22-F0FA4BC95E2C}"/>
+                <a16:creationId xmlns:a16="http://schemas.microsoft.com/office/drawing/2014/main" id="{E4185D08-17C2-4FAA-B4B5-2FF4B2E500A6}"/>
               </a:ext>
             </a:extLst>
           </p:cNvPr>
@@ -3456,7 +3456,7 @@
           <p:cNvPr id="23" name="">
             <a:extLst xmlns:a="http://schemas.openxmlformats.org/drawingml/2006/main">
               <a:ext uri="{FF2B5EF4-FFF2-40B4-BE49-F238E27FC236}">
-                <a16:creationId xmlns:a16="http://schemas.microsoft.com/office/drawing/2014/main" id="{CCAE9A05-FFA7-453A-ABA8-49D7898DFA4F}"/>
+                <a16:creationId xmlns:a16="http://schemas.microsoft.com/office/drawing/2014/main" id="{9CF14FAE-8F68-4723-B33D-9AE1A560306F}"/>
               </a:ext>
             </a:extLst>
           </p:cNvPr>
@@ -3487,7 +3487,7 @@
           <p:cNvPr id="24" name="">
             <a:extLst xmlns:a="http://schemas.openxmlformats.org/drawingml/2006/main">
               <a:ext uri="{FF2B5EF4-FFF2-40B4-BE49-F238E27FC236}">
-                <a16:creationId xmlns:a16="http://schemas.microsoft.com/office/drawing/2014/main" id="{0AD0CB49-4294-4FF2-B016-9EFF4FDE73C1}"/>
+                <a16:creationId xmlns:a16="http://schemas.microsoft.com/office/drawing/2014/main" id="{91C4AAD3-1C89-420D-A146-4888AB8A44DE}"/>
               </a:ext>
             </a:extLst>
           </p:cNvPr>
@@ -3545,7 +3545,7 @@
           <p:cNvPr id="25" name="">
             <a:extLst xmlns:a="http://schemas.openxmlformats.org/drawingml/2006/main">
               <a:ext uri="{FF2B5EF4-FFF2-40B4-BE49-F238E27FC236}">
-                <a16:creationId xmlns:a16="http://schemas.microsoft.com/office/drawing/2014/main" id="{B27E38CB-267D-44D1-97D0-68946C17035B}"/>
+                <a16:creationId xmlns:a16="http://schemas.microsoft.com/office/drawing/2014/main" id="{6E4BF859-C1F9-4979-8977-976B477F2D75}"/>
               </a:ext>
             </a:extLst>
           </p:cNvPr>
@@ -3603,7 +3603,7 @@
           <p:cNvPr id="26" name="">
             <a:extLst xmlns:a="http://schemas.openxmlformats.org/drawingml/2006/main">
               <a:ext uri="{FF2B5EF4-FFF2-40B4-BE49-F238E27FC236}">
-                <a16:creationId xmlns:a16="http://schemas.microsoft.com/office/drawing/2014/main" id="{47C924F4-4FC6-43A1-830A-A320144CB771}"/>
+                <a16:creationId xmlns:a16="http://schemas.microsoft.com/office/drawing/2014/main" id="{71D2F627-A6FE-4FE7-946E-12333A8733D1}"/>
               </a:ext>
             </a:extLst>
           </p:cNvPr>
@@ -3634,7 +3634,7 @@
           <p:cNvPr id="27" name="">
             <a:extLst xmlns:a="http://schemas.openxmlformats.org/drawingml/2006/main">
               <a:ext uri="{FF2B5EF4-FFF2-40B4-BE49-F238E27FC236}">
-                <a16:creationId xmlns:a16="http://schemas.microsoft.com/office/drawing/2014/main" id="{A1CAE69E-EAE6-436A-BF55-69BED4F72447}"/>
+                <a16:creationId xmlns:a16="http://schemas.microsoft.com/office/drawing/2014/main" id="{64CDA739-5C89-4C62-B164-7257E30904EC}"/>
               </a:ext>
             </a:extLst>
           </p:cNvPr>
@@ -3669,7 +3669,7 @@
           <p:cNvPr id="28" name="">
             <a:extLst xmlns:a="http://schemas.openxmlformats.org/drawingml/2006/main">
               <a:ext uri="{FF2B5EF4-FFF2-40B4-BE49-F238E27FC236}">
-                <a16:creationId xmlns:a16="http://schemas.microsoft.com/office/drawing/2014/main" id="{A6AB9917-8D7B-41FE-BDA9-13D39C6240FB}"/>
+                <a16:creationId xmlns:a16="http://schemas.microsoft.com/office/drawing/2014/main" id="{882C92C1-3848-4BBB-8886-6FF6FC8DB867}"/>
               </a:ext>
             </a:extLst>
           </p:cNvPr>
@@ -3727,7 +3727,7 @@
           <p:cNvPr id="29" name="">
             <a:extLst xmlns:a="http://schemas.openxmlformats.org/drawingml/2006/main">
               <a:ext uri="{FF2B5EF4-FFF2-40B4-BE49-F238E27FC236}">
-                <a16:creationId xmlns:a16="http://schemas.microsoft.com/office/drawing/2014/main" id="{FA8A8FBA-8456-448F-AC4A-D4A619B4CD3F}"/>
+                <a16:creationId xmlns:a16="http://schemas.microsoft.com/office/drawing/2014/main" id="{CCD179A6-2650-4469-B22E-CBF78322E481}"/>
               </a:ext>
             </a:extLst>
           </p:cNvPr>
@@ -3783,7 +3783,7 @@
     </p:spTree>
     <p:extLst>
       <p:ext uri="{BB962C8B-B14F-4D97-AF65-F5344CB8AC3E}">
-        <p14:creationId xmlns:p14="http://schemas.microsoft.com/office/powerpoint/2010/main" val="1494200858"/>
+        <p14:creationId xmlns:p14="http://schemas.microsoft.com/office/powerpoint/2010/main" val="270727412"/>
       </p:ext>
     </p:extLst>
   </p:cSld>
@@ -3814,7 +3814,7 @@
           <p:cNvPr id="33" name="">
             <a:extLst xmlns:a="http://schemas.openxmlformats.org/drawingml/2006/main">
               <a:ext uri="{FF2B5EF4-FFF2-40B4-BE49-F238E27FC236}">
-                <a16:creationId xmlns:a16="http://schemas.microsoft.com/office/drawing/2014/main" id="{8DBDC765-1295-4937-9418-A50A2C4E803D}"/>
+                <a16:creationId xmlns:a16="http://schemas.microsoft.com/office/drawing/2014/main" id="{03B93F0F-AFE0-41F7-ACCD-5DE2B4FFD4B7}"/>
               </a:ext>
             </a:extLst>
           </p:cNvPr>
@@ -3847,7 +3847,7 @@
           <p:cNvPr id="2" name="">
             <a:extLst xmlns:a="http://schemas.openxmlformats.org/drawingml/2006/main">
               <a:ext uri="{FF2B5EF4-FFF2-40B4-BE49-F238E27FC236}">
-                <a16:creationId xmlns:a16="http://schemas.microsoft.com/office/drawing/2014/main" id="{D5BEAA8D-DFE3-4121-8B2C-6DF52BC7CB2F}"/>
+                <a16:creationId xmlns:a16="http://schemas.microsoft.com/office/drawing/2014/main" id="{5ABA7878-25C6-415F-9DF4-9836BD279E41}"/>
               </a:ext>
             </a:extLst>
           </p:cNvPr>
@@ -3905,7 +3905,7 @@
           <p:cNvPr id="3" name="">
             <a:extLst xmlns:a="http://schemas.openxmlformats.org/drawingml/2006/main">
               <a:ext uri="{FF2B5EF4-FFF2-40B4-BE49-F238E27FC236}">
-                <a16:creationId xmlns:a16="http://schemas.microsoft.com/office/drawing/2014/main" id="{DF70D327-4322-4399-8A84-1F5636D98841}"/>
+                <a16:creationId xmlns:a16="http://schemas.microsoft.com/office/drawing/2014/main" id="{518648F0-3F40-43F5-961D-693B5174EEC2}"/>
               </a:ext>
             </a:extLst>
           </p:cNvPr>
@@ -3963,7 +3963,7 @@
           <p:cNvPr id="4" name="">
             <a:extLst xmlns:a="http://schemas.openxmlformats.org/drawingml/2006/main">
               <a:ext uri="{FF2B5EF4-FFF2-40B4-BE49-F238E27FC236}">
-                <a16:creationId xmlns:a16="http://schemas.microsoft.com/office/drawing/2014/main" id="{142979B1-B64D-4E68-A590-A5E1C630E8A9}"/>
+                <a16:creationId xmlns:a16="http://schemas.microsoft.com/office/drawing/2014/main" id="{D625C46D-AC8B-4466-82B3-E970F6687372}"/>
               </a:ext>
             </a:extLst>
           </p:cNvPr>
@@ -3998,10 +3998,10 @@
           <p:nvPr/>
         </p:nvPicPr>
         <p:blipFill>
-          <a:blip xmlns:r="http://schemas.openxmlformats.org/officeDocument/2006/relationships" xmlns:a="http://schemas.openxmlformats.org/drawingml/2006/main" r:embed="R6384576d466b4cd8">
+          <a:blip xmlns:r="http://schemas.openxmlformats.org/officeDocument/2006/relationships" xmlns:a="http://schemas.openxmlformats.org/drawingml/2006/main" r:embed="Rb0be71a2eda2444f">
             <a:extLst>
               <a:ext uri="{96DAC541-7B7A-43D3-8B79-37D633B846F1}">
-                <asvg:svgBlip xmlns:asvg="http://schemas.microsoft.com/office/drawing/2016/SVG/main" r:embed="Rc6ae1d8c14bc4fe7"/>
+                <asvg:svgBlip xmlns:asvg="http://schemas.microsoft.com/office/drawing/2016/SVG/main" r:embed="R5afe09c5857d4dfd"/>
               </a:ext>
             </a:extLst>
           </a:blip>
@@ -4022,7 +4022,7 @@
           <p:cNvPr id="6" name="">
             <a:extLst xmlns:a="http://schemas.openxmlformats.org/drawingml/2006/main">
               <a:ext uri="{FF2B5EF4-FFF2-40B4-BE49-F238E27FC236}">
-                <a16:creationId xmlns:a16="http://schemas.microsoft.com/office/drawing/2014/main" id="{ED3DE9CF-D089-4AD1-A9B1-32CF7BB4CBAC}"/>
+                <a16:creationId xmlns:a16="http://schemas.microsoft.com/office/drawing/2014/main" id="{B96DAC61-F9DE-454B-B3E9-32E2BF8AC128}"/>
               </a:ext>
             </a:extLst>
           </p:cNvPr>
@@ -4080,7 +4080,7 @@
           <p:cNvPr id="7" name="">
             <a:extLst xmlns:a="http://schemas.openxmlformats.org/drawingml/2006/main">
               <a:ext uri="{FF2B5EF4-FFF2-40B4-BE49-F238E27FC236}">
-                <a16:creationId xmlns:a16="http://schemas.microsoft.com/office/drawing/2014/main" id="{168D0A55-6E3B-49D0-981D-BD643D4A82DD}"/>
+                <a16:creationId xmlns:a16="http://schemas.microsoft.com/office/drawing/2014/main" id="{94C8C42D-8D59-4FF3-8CE6-3B7817C8C4BA}"/>
               </a:ext>
             </a:extLst>
           </p:cNvPr>
@@ -4138,7 +4138,7 @@
           <p:cNvPr id="8" name="">
             <a:extLst xmlns:a="http://schemas.openxmlformats.org/drawingml/2006/main">
               <a:ext uri="{FF2B5EF4-FFF2-40B4-BE49-F238E27FC236}">
-                <a16:creationId xmlns:a16="http://schemas.microsoft.com/office/drawing/2014/main" id="{F5AF53C4-F6DD-4535-B477-BE27DBF1663D}"/>
+                <a16:creationId xmlns:a16="http://schemas.microsoft.com/office/drawing/2014/main" id="{D43D7E22-B8DB-44E9-A1C3-41DE57611E2C}"/>
               </a:ext>
             </a:extLst>
           </p:cNvPr>
@@ -4200,7 +4200,7 @@
           <p:cNvPr id="9" name="">
             <a:extLst xmlns:a="http://schemas.openxmlformats.org/drawingml/2006/main">
               <a:ext uri="{FF2B5EF4-FFF2-40B4-BE49-F238E27FC236}">
-                <a16:creationId xmlns:a16="http://schemas.microsoft.com/office/drawing/2014/main" id="{6E496C76-041F-49D2-97B8-26C5788A83FD}"/>
+                <a16:creationId xmlns:a16="http://schemas.microsoft.com/office/drawing/2014/main" id="{0EFBFEDE-22B5-42FE-9FDF-B2F330FA7696}"/>
               </a:ext>
             </a:extLst>
           </p:cNvPr>
@@ -4258,7 +4258,7 @@
           <p:cNvPr id="10" name="mission-plan-shot-frame">
             <a:extLst xmlns:a="http://schemas.openxmlformats.org/drawingml/2006/main">
               <a:ext uri="{FF2B5EF4-FFF2-40B4-BE49-F238E27FC236}">
-                <a16:creationId xmlns:a16="http://schemas.microsoft.com/office/drawing/2014/main" id="{5126DF97-4246-423C-9294-7DDFC03D403F}"/>
+                <a16:creationId xmlns:a16="http://schemas.microsoft.com/office/drawing/2014/main" id="{BDBB458D-9DA3-4623-9843-7DE59E86AD10}"/>
               </a:ext>
             </a:extLst>
           </p:cNvPr>
@@ -4303,7 +4303,7 @@
           <p:nvPr/>
         </p:nvPicPr>
         <p:blipFill>
-          <a:blip xmlns:r="http://schemas.openxmlformats.org/officeDocument/2006/relationships" xmlns:a="http://schemas.openxmlformats.org/drawingml/2006/main" r:embed="Rc3cf0df55066453f"/>
+          <a:blip xmlns:r="http://schemas.openxmlformats.org/officeDocument/2006/relationships" xmlns:a="http://schemas.openxmlformats.org/drawingml/2006/main" r:embed="R6e0e607aa045419e"/>
           <a:srcRect xmlns:a="http://schemas.openxmlformats.org/drawingml/2006/main" l="0" t="112" r="0" b="112"/>
           <a:stretch xmlns:a="http://schemas.openxmlformats.org/drawingml/2006/main">
             <a:fillRect l="0" t="0" r="0" b="0"/>
@@ -4326,7 +4326,7 @@
           <p:cNvPr id="12" name="live-mission-shot-frame">
             <a:extLst xmlns:a="http://schemas.openxmlformats.org/drawingml/2006/main">
               <a:ext uri="{FF2B5EF4-FFF2-40B4-BE49-F238E27FC236}">
-                <a16:creationId xmlns:a16="http://schemas.microsoft.com/office/drawing/2014/main" id="{A79D9C4D-B69F-462D-ABA4-B8A6B8DE3AB3}"/>
+                <a16:creationId xmlns:a16="http://schemas.microsoft.com/office/drawing/2014/main" id="{EE2AE817-70BF-4989-B9C3-7403A5814EB3}"/>
               </a:ext>
             </a:extLst>
           </p:cNvPr>
@@ -4371,7 +4371,7 @@
           <p:nvPr/>
         </p:nvPicPr>
         <p:blipFill>
-          <a:blip xmlns:r="http://schemas.openxmlformats.org/officeDocument/2006/relationships" xmlns:a="http://schemas.openxmlformats.org/drawingml/2006/main" r:embed="Rd8a57a2621314e69"/>
+          <a:blip xmlns:r="http://schemas.openxmlformats.org/officeDocument/2006/relationships" xmlns:a="http://schemas.openxmlformats.org/drawingml/2006/main" r:embed="Rabe536bbaee44aa6"/>
           <a:srcRect xmlns:a="http://schemas.openxmlformats.org/drawingml/2006/main" l="0" t="112" r="0" b="112"/>
           <a:stretch xmlns:a="http://schemas.openxmlformats.org/drawingml/2006/main">
             <a:fillRect l="0" t="0" r="0" b="0"/>
@@ -4394,7 +4394,7 @@
           <p:cNvPr id="14" name="findings-shot-frame">
             <a:extLst xmlns:a="http://schemas.openxmlformats.org/drawingml/2006/main">
               <a:ext uri="{FF2B5EF4-FFF2-40B4-BE49-F238E27FC236}">
-                <a16:creationId xmlns:a16="http://schemas.microsoft.com/office/drawing/2014/main" id="{5E72BB51-0EFF-4FD9-A92A-3499EE072584}"/>
+                <a16:creationId xmlns:a16="http://schemas.microsoft.com/office/drawing/2014/main" id="{49297BD0-8876-4055-A624-9DF9E0A396D7}"/>
               </a:ext>
             </a:extLst>
           </p:cNvPr>
@@ -4439,7 +4439,7 @@
           <p:nvPr/>
         </p:nvPicPr>
         <p:blipFill>
-          <a:blip xmlns:r="http://schemas.openxmlformats.org/officeDocument/2006/relationships" xmlns:a="http://schemas.openxmlformats.org/drawingml/2006/main" r:embed="R4c5dcdf757184e17"/>
+          <a:blip xmlns:r="http://schemas.openxmlformats.org/officeDocument/2006/relationships" xmlns:a="http://schemas.openxmlformats.org/drawingml/2006/main" r:embed="R4796c2a9c5d54c3f"/>
           <a:srcRect xmlns:a="http://schemas.openxmlformats.org/drawingml/2006/main" l="0" t="112" r="0" b="112"/>
           <a:stretch xmlns:a="http://schemas.openxmlformats.org/drawingml/2006/main">
             <a:fillRect l="0" t="0" r="0" b="0"/>
@@ -4462,7 +4462,7 @@
           <p:cNvPr id="16" name="">
             <a:extLst xmlns:a="http://schemas.openxmlformats.org/drawingml/2006/main">
               <a:ext uri="{FF2B5EF4-FFF2-40B4-BE49-F238E27FC236}">
-                <a16:creationId xmlns:a16="http://schemas.microsoft.com/office/drawing/2014/main" id="{3F99453A-4EA1-45E6-B16F-ADFADC005356}"/>
+                <a16:creationId xmlns:a16="http://schemas.microsoft.com/office/drawing/2014/main" id="{4DF0DD47-9999-41E5-BD01-89A49087E5B4}"/>
               </a:ext>
             </a:extLst>
           </p:cNvPr>
@@ -4520,7 +4520,7 @@
           <p:cNvPr id="17" name="">
             <a:extLst xmlns:a="http://schemas.openxmlformats.org/drawingml/2006/main">
               <a:ext uri="{FF2B5EF4-FFF2-40B4-BE49-F238E27FC236}">
-                <a16:creationId xmlns:a16="http://schemas.microsoft.com/office/drawing/2014/main" id="{A36EE0F0-8BA6-42AC-9435-6C89CDDCF09F}"/>
+                <a16:creationId xmlns:a16="http://schemas.microsoft.com/office/drawing/2014/main" id="{65610E2D-5657-4CC6-97E6-668A674D3EDE}"/>
               </a:ext>
             </a:extLst>
           </p:cNvPr>
@@ -4578,7 +4578,7 @@
           <p:cNvPr id="18" name="">
             <a:extLst xmlns:a="http://schemas.openxmlformats.org/drawingml/2006/main">
               <a:ext uri="{FF2B5EF4-FFF2-40B4-BE49-F238E27FC236}">
-                <a16:creationId xmlns:a16="http://schemas.microsoft.com/office/drawing/2014/main" id="{7D04635E-F865-4793-B937-F2B343A535AA}"/>
+                <a16:creationId xmlns:a16="http://schemas.microsoft.com/office/drawing/2014/main" id="{8DFEC875-0D31-4B69-8D6E-105B0322701A}"/>
               </a:ext>
             </a:extLst>
           </p:cNvPr>
@@ -4636,7 +4636,7 @@
           <p:cNvPr id="19" name="">
             <a:extLst xmlns:a="http://schemas.openxmlformats.org/drawingml/2006/main">
               <a:ext uri="{FF2B5EF4-FFF2-40B4-BE49-F238E27FC236}">
-                <a16:creationId xmlns:a16="http://schemas.microsoft.com/office/drawing/2014/main" id="{3073BE6B-EA2E-4771-ABDB-E7534BAEF584}"/>
+                <a16:creationId xmlns:a16="http://schemas.microsoft.com/office/drawing/2014/main" id="{82A85FB8-E494-42BA-BAA1-296484509A97}"/>
               </a:ext>
             </a:extLst>
           </p:cNvPr>
@@ -4694,7 +4694,7 @@
           <p:cNvPr id="20" name="">
             <a:extLst xmlns:a="http://schemas.openxmlformats.org/drawingml/2006/main">
               <a:ext uri="{FF2B5EF4-FFF2-40B4-BE49-F238E27FC236}">
-                <a16:creationId xmlns:a16="http://schemas.microsoft.com/office/drawing/2014/main" id="{41552733-661D-4BF6-BC9D-F660BA1D2C94}"/>
+                <a16:creationId xmlns:a16="http://schemas.microsoft.com/office/drawing/2014/main" id="{BF74B38D-38DE-4203-9C22-43958A569D57}"/>
               </a:ext>
             </a:extLst>
           </p:cNvPr>
@@ -4752,7 +4752,7 @@
           <p:cNvPr id="21" name="">
             <a:extLst xmlns:a="http://schemas.openxmlformats.org/drawingml/2006/main">
               <a:ext uri="{FF2B5EF4-FFF2-40B4-BE49-F238E27FC236}">
-                <a16:creationId xmlns:a16="http://schemas.microsoft.com/office/drawing/2014/main" id="{EA1E7971-11D6-481B-BF02-32685D9D60FD}"/>
+                <a16:creationId xmlns:a16="http://schemas.microsoft.com/office/drawing/2014/main" id="{B316EA98-2439-441F-ABD7-9A4C98FC2419}"/>
               </a:ext>
             </a:extLst>
           </p:cNvPr>
@@ -4783,7 +4783,7 @@
           <p:cNvPr id="22" name="">
             <a:extLst xmlns:a="http://schemas.openxmlformats.org/drawingml/2006/main">
               <a:ext uri="{FF2B5EF4-FFF2-40B4-BE49-F238E27FC236}">
-                <a16:creationId xmlns:a16="http://schemas.microsoft.com/office/drawing/2014/main" id="{DEEF7A17-B513-4597-9B30-B4251438DC6C}"/>
+                <a16:creationId xmlns:a16="http://schemas.microsoft.com/office/drawing/2014/main" id="{87608DF9-9DE1-421F-8DC8-61D21D851757}"/>
               </a:ext>
             </a:extLst>
           </p:cNvPr>
@@ -4841,7 +4841,7 @@
           <p:cNvPr id="23" name="">
             <a:extLst xmlns:a="http://schemas.openxmlformats.org/drawingml/2006/main">
               <a:ext uri="{FF2B5EF4-FFF2-40B4-BE49-F238E27FC236}">
-                <a16:creationId xmlns:a16="http://schemas.microsoft.com/office/drawing/2014/main" id="{13ACCB97-739F-4403-AE49-1BA921070B7A}"/>
+                <a16:creationId xmlns:a16="http://schemas.microsoft.com/office/drawing/2014/main" id="{E523A982-38EE-41B4-9780-5637B5EDC529}"/>
               </a:ext>
             </a:extLst>
           </p:cNvPr>
@@ -4899,7 +4899,7 @@
           <p:cNvPr id="24" name="">
             <a:extLst xmlns:a="http://schemas.openxmlformats.org/drawingml/2006/main">
               <a:ext uri="{FF2B5EF4-FFF2-40B4-BE49-F238E27FC236}">
-                <a16:creationId xmlns:a16="http://schemas.microsoft.com/office/drawing/2014/main" id="{E203E7C1-202A-4758-95B4-F51E78B0610E}"/>
+                <a16:creationId xmlns:a16="http://schemas.microsoft.com/office/drawing/2014/main" id="{6CCDC0C8-DBD7-4F9D-AFFB-116309B72AE8}"/>
               </a:ext>
             </a:extLst>
           </p:cNvPr>
@@ -4957,7 +4957,7 @@
           <p:cNvPr id="25" name="">
             <a:extLst xmlns:a="http://schemas.openxmlformats.org/drawingml/2006/main">
               <a:ext uri="{FF2B5EF4-FFF2-40B4-BE49-F238E27FC236}">
-                <a16:creationId xmlns:a16="http://schemas.microsoft.com/office/drawing/2014/main" id="{C4E68BB7-B889-4FBD-BBE1-68057AEBC4A6}"/>
+                <a16:creationId xmlns:a16="http://schemas.microsoft.com/office/drawing/2014/main" id="{9625BED3-5666-4E18-BA93-273A97F7126A}"/>
               </a:ext>
             </a:extLst>
           </p:cNvPr>
@@ -5015,7 +5015,7 @@
           <p:cNvPr id="26" name="">
             <a:extLst xmlns:a="http://schemas.openxmlformats.org/drawingml/2006/main">
               <a:ext uri="{FF2B5EF4-FFF2-40B4-BE49-F238E27FC236}">
-                <a16:creationId xmlns:a16="http://schemas.microsoft.com/office/drawing/2014/main" id="{0A42760A-1E14-4812-A2A1-2EF250D40A97}"/>
+                <a16:creationId xmlns:a16="http://schemas.microsoft.com/office/drawing/2014/main" id="{6BC3ACD2-6E92-4F06-8379-299A86CBA059}"/>
               </a:ext>
             </a:extLst>
           </p:cNvPr>
@@ -5027,7 +5027,7 @@
         <p:spPr>
           <a:xfrm xmlns:a="http://schemas.openxmlformats.org/drawingml/2006/main" rot="0">
             <a:off x="7086600" y="5610225"/>
-            <a:ext cx="2381250" cy="180975"/>
+            <a:ext cx="2381250" cy="323850"/>
           </a:xfrm>
           <a:prstGeom xmlns:a="http://schemas.openxmlformats.org/drawingml/2006/main" prst="rect">
             <a:avLst/>
@@ -5045,6 +5045,10 @@
           <a:lstStyle xmlns:a="http://schemas.openxmlformats.org/drawingml/2006/main"/>
           <a:p xmlns:a="http://schemas.openxmlformats.org/drawingml/2006/main">
             <a:pPr algn="l">
+              <a:lnSpc>
+                <a:spcPct val="100000"/>
+              </a:lnSpc>
+              <a:buNone/>
               <a:defRPr sz="975" b="0">
                 <a:solidFill>
                   <a:srgbClr val="A6A3A0"/>
@@ -5063,7 +5067,34 @@
                 <a:ea typeface="Arial"/>
                 <a:cs typeface="Arial"/>
               </a:rPr>
-              <a:t>42.3% gap  |  heuristic score 0.88</a:t>
+              <a:t>42.3% gap</a:t>
+            </a:r>
+          </a:p>
+          <a:p xmlns:a="http://schemas.openxmlformats.org/drawingml/2006/main">
+            <a:pPr algn="l">
+              <a:lnSpc>
+                <a:spcPct val="100000"/>
+              </a:lnSpc>
+              <a:buNone/>
+              <a:defRPr sz="975" b="0">
+                <a:solidFill>
+                  <a:srgbClr val="A6A3A0"/>
+                </a:solidFill>
+                <a:latin typeface="Arial"/>
+                <a:ea typeface="Arial"/>
+                <a:cs typeface="Arial"/>
+              </a:defRPr>
+            </a:pPr>
+            <a:r>
+              <a:rPr sz="975" b="0">
+                <a:solidFill>
+                  <a:srgbClr val="A6A3A0"/>
+                </a:solidFill>
+                <a:latin typeface="Arial"/>
+                <a:ea typeface="Arial"/>
+                <a:cs typeface="Arial"/>
+              </a:rPr>
+              <a:t>Heuristic policy score 0.88</a:t>
             </a:r>
           </a:p>
         </p:txBody>
@@ -5073,7 +5104,7 @@
           <p:cNvPr id="27" name="">
             <a:extLst xmlns:a="http://schemas.openxmlformats.org/drawingml/2006/main">
               <a:ext uri="{FF2B5EF4-FFF2-40B4-BE49-F238E27FC236}">
-                <a16:creationId xmlns:a16="http://schemas.microsoft.com/office/drawing/2014/main" id="{669F723F-66EE-462A-8F5B-A5D010473D0F}"/>
+                <a16:creationId xmlns:a16="http://schemas.microsoft.com/office/drawing/2014/main" id="{563BF943-A625-409E-935F-F7B7797F781A}"/>
               </a:ext>
             </a:extLst>
           </p:cNvPr>
@@ -5131,7 +5162,7 @@
           <p:cNvPr id="28" name="">
             <a:extLst xmlns:a="http://schemas.openxmlformats.org/drawingml/2006/main">
               <a:ext uri="{FF2B5EF4-FFF2-40B4-BE49-F238E27FC236}">
-                <a16:creationId xmlns:a16="http://schemas.microsoft.com/office/drawing/2014/main" id="{271BB254-4757-45EC-B1FC-D06D57588380}"/>
+                <a16:creationId xmlns:a16="http://schemas.microsoft.com/office/drawing/2014/main" id="{076F6BDF-91E6-4DF1-9208-6BFAC89A375A}"/>
               </a:ext>
             </a:extLst>
           </p:cNvPr>
@@ -5189,7 +5220,7 @@
           <p:cNvPr id="29" name="">
             <a:extLst xmlns:a="http://schemas.openxmlformats.org/drawingml/2006/main">
               <a:ext uri="{FF2B5EF4-FFF2-40B4-BE49-F238E27FC236}">
-                <a16:creationId xmlns:a16="http://schemas.microsoft.com/office/drawing/2014/main" id="{FE40AFBB-311E-4E08-9823-E559417DD056}"/>
+                <a16:creationId xmlns:a16="http://schemas.microsoft.com/office/drawing/2014/main" id="{308F4B31-F4B2-4C9A-93F2-9DB662ED038B}"/>
               </a:ext>
             </a:extLst>
           </p:cNvPr>
@@ -5237,7 +5268,7 @@
                 <a:ea typeface="Courier New"/>
                 <a:cs typeface="Courier New"/>
               </a:rPr>
-              <a:t>FIXED REPLAY BAND</a:t>
+              <a:t>FIXED REPLAY SCENARIO BAND</a:t>
             </a:r>
           </a:p>
         </p:txBody>
@@ -5247,7 +5278,7 @@
           <p:cNvPr id="30" name="">
             <a:extLst xmlns:a="http://schemas.openxmlformats.org/drawingml/2006/main">
               <a:ext uri="{FF2B5EF4-FFF2-40B4-BE49-F238E27FC236}">
-                <a16:creationId xmlns:a16="http://schemas.microsoft.com/office/drawing/2014/main" id="{98BD59CC-8337-4E9D-ABF1-23FA60D008B7}"/>
+                <a16:creationId xmlns:a16="http://schemas.microsoft.com/office/drawing/2014/main" id="{8C6D4865-4C2D-4E66-94D4-34A2724DF13C}"/>
               </a:ext>
             </a:extLst>
           </p:cNvPr>
@@ -5305,7 +5336,7 @@
           <p:cNvPr id="31" name="">
             <a:extLst xmlns:a="http://schemas.openxmlformats.org/drawingml/2006/main">
               <a:ext uri="{FF2B5EF4-FFF2-40B4-BE49-F238E27FC236}">
-                <a16:creationId xmlns:a16="http://schemas.microsoft.com/office/drawing/2014/main" id="{EC02D924-0BCB-450E-A0F5-28E1A02B7A08}"/>
+                <a16:creationId xmlns:a16="http://schemas.microsoft.com/office/drawing/2014/main" id="{B5099E1B-03F8-4932-8F76-6BC4032279AF}"/>
               </a:ext>
             </a:extLst>
           </p:cNvPr>
@@ -5317,7 +5348,7 @@
         <p:spPr>
           <a:xfrm xmlns:a="http://schemas.openxmlformats.org/drawingml/2006/main" rot="0">
             <a:off x="9639300" y="5610225"/>
-            <a:ext cx="1943100" cy="180975"/>
+            <a:ext cx="1943100" cy="323850"/>
           </a:xfrm>
           <a:prstGeom xmlns:a="http://schemas.openxmlformats.org/drawingml/2006/main" prst="rect">
             <a:avLst/>
@@ -5335,6 +5366,10 @@
           <a:lstStyle xmlns:a="http://schemas.openxmlformats.org/drawingml/2006/main"/>
           <a:p xmlns:a="http://schemas.openxmlformats.org/drawingml/2006/main">
             <a:pPr algn="l">
+              <a:lnSpc>
+                <a:spcPct val="100000"/>
+              </a:lnSpc>
+              <a:buNone/>
               <a:defRPr sz="975" b="0">
                 <a:solidFill>
                   <a:srgbClr val="A6A3A0"/>
@@ -5353,7 +5388,34 @@
                 <a:ea typeface="Arial"/>
                 <a:cs typeface="Arial"/>
               </a:rPr>
-              <a:t>27.9% gap  |  heuristic score 0.82</a:t>
+              <a:t>27.9% gap</a:t>
+            </a:r>
+          </a:p>
+          <a:p xmlns:a="http://schemas.openxmlformats.org/drawingml/2006/main">
+            <a:pPr algn="l">
+              <a:lnSpc>
+                <a:spcPct val="100000"/>
+              </a:lnSpc>
+              <a:buNone/>
+              <a:defRPr sz="975" b="0">
+                <a:solidFill>
+                  <a:srgbClr val="A6A3A0"/>
+                </a:solidFill>
+                <a:latin typeface="Arial"/>
+                <a:ea typeface="Arial"/>
+                <a:cs typeface="Arial"/>
+              </a:defRPr>
+            </a:pPr>
+            <a:r>
+              <a:rPr sz="975" b="0">
+                <a:solidFill>
+                  <a:srgbClr val="A6A3A0"/>
+                </a:solidFill>
+                <a:latin typeface="Arial"/>
+                <a:ea typeface="Arial"/>
+                <a:cs typeface="Arial"/>
+              </a:rPr>
+              <a:t>Heuristic policy score 0.82</a:t>
             </a:r>
           </a:p>
         </p:txBody>
@@ -5363,19 +5425,19 @@
           <p:cNvPr id="32" name="">
             <a:extLst xmlns:a="http://schemas.openxmlformats.org/drawingml/2006/main">
               <a:ext uri="{FF2B5EF4-FFF2-40B4-BE49-F238E27FC236}">
-                <a16:creationId xmlns:a16="http://schemas.microsoft.com/office/drawing/2014/main" id="{3CF45079-47FC-4A9A-BE77-F5F0F4575A3B}"/>
-              </a:ext>
-            </a:extLst>
-          </p:cNvPr>
-          <p:cNvSpPr>
-            <a:spLocks xmlns:a="http://schemas.openxmlformats.org/drawingml/2006/main" noGrp="1"/>
-          </p:cNvSpPr>
-          <p:nvPr/>
-        </p:nvSpPr>
-        <p:spPr>
-          <a:xfrm xmlns:a="http://schemas.openxmlformats.org/drawingml/2006/main" rot="0">
-            <a:off x="7086600" y="5953125"/>
-            <a:ext cx="4495800" cy="190500"/>
+                <a16:creationId xmlns:a16="http://schemas.microsoft.com/office/drawing/2014/main" id="{D6987B8A-ADDE-4BDE-9D48-917E901D9277}"/>
+              </a:ext>
+            </a:extLst>
+          </p:cNvPr>
+          <p:cNvSpPr>
+            <a:spLocks xmlns:a="http://schemas.openxmlformats.org/drawingml/2006/main" noGrp="1"/>
+          </p:cNvSpPr>
+          <p:nvPr/>
+        </p:nvSpPr>
+        <p:spPr>
+          <a:xfrm xmlns:a="http://schemas.openxmlformats.org/drawingml/2006/main" rot="0">
+            <a:off x="7086600" y="6029325"/>
+            <a:ext cx="4495800" cy="323850"/>
           </a:xfrm>
           <a:prstGeom xmlns:a="http://schemas.openxmlformats.org/drawingml/2006/main" prst="rect">
             <a:avLst/>
@@ -5411,7 +5473,30 @@
                 <a:ea typeface="Courier New"/>
                 <a:cs typeface="Courier New"/>
               </a:rPr>
-              <a:t>PLANNED QUOTA 1,024  |  5 LOGICAL CATEGORIES  |  5 AGGREGATE RECEIPTS</a:t>
+              <a:t>PLANNED AGGREGATE PROBE QUOTA: 1,024</a:t>
+            </a:r>
+          </a:p>
+          <a:p xmlns:a="http://schemas.openxmlformats.org/drawingml/2006/main">
+            <a:pPr algn="r">
+              <a:defRPr sz="825" b="1">
+                <a:solidFill>
+                  <a:srgbClr val="F3C45E"/>
+                </a:solidFill>
+                <a:latin typeface="Courier New"/>
+                <a:ea typeface="Courier New"/>
+                <a:cs typeface="Courier New"/>
+              </a:defRPr>
+            </a:pPr>
+            <a:r>
+              <a:rPr sz="825" b="1">
+                <a:solidFill>
+                  <a:srgbClr val="F3C45E"/>
+                </a:solidFill>
+                <a:latin typeface="Courier New"/>
+                <a:ea typeface="Courier New"/>
+                <a:cs typeface="Courier New"/>
+              </a:rPr>
+              <a:t>ACTUAL OUTPUT: 5 RECEIPTS / 5 LOGICAL CATEGORIES</a:t>
             </a:r>
           </a:p>
         </p:txBody>
@@ -5419,7 +5504,7 @@
     </p:spTree>
     <p:extLst>
       <p:ext uri="{BB962C8B-B14F-4D97-AF65-F5344CB8AC3E}">
-        <p14:creationId xmlns:p14="http://schemas.microsoft.com/office/powerpoint/2010/main" val="202202135"/>
+        <p14:creationId xmlns:p14="http://schemas.microsoft.com/office/powerpoint/2010/main" val="2041692057"/>
       </p:ext>
     </p:extLst>
   </p:cSld>
@@ -5450,7 +5535,7 @@
           <p:cNvPr id="58" name="">
             <a:extLst xmlns:a="http://schemas.openxmlformats.org/drawingml/2006/main">
               <a:ext uri="{FF2B5EF4-FFF2-40B4-BE49-F238E27FC236}">
-                <a16:creationId xmlns:a16="http://schemas.microsoft.com/office/drawing/2014/main" id="{2AA0F2AA-0B88-4D25-8B01-060149849D7B}"/>
+                <a16:creationId xmlns:a16="http://schemas.microsoft.com/office/drawing/2014/main" id="{1A435749-1435-4F90-B849-58EE282E7B58}"/>
               </a:ext>
             </a:extLst>
           </p:cNvPr>
@@ -5483,7 +5568,7 @@
           <p:cNvPr id="2" name="">
             <a:extLst xmlns:a="http://schemas.openxmlformats.org/drawingml/2006/main">
               <a:ext uri="{FF2B5EF4-FFF2-40B4-BE49-F238E27FC236}">
-                <a16:creationId xmlns:a16="http://schemas.microsoft.com/office/drawing/2014/main" id="{23CFB91A-8049-4A3B-B449-31ACA36FCBC3}"/>
+                <a16:creationId xmlns:a16="http://schemas.microsoft.com/office/drawing/2014/main" id="{0EA2A6D7-FE81-4E17-97B5-D9ED5CD7F053}"/>
               </a:ext>
             </a:extLst>
           </p:cNvPr>
@@ -5541,7 +5626,7 @@
           <p:cNvPr id="3" name="">
             <a:extLst xmlns:a="http://schemas.openxmlformats.org/drawingml/2006/main">
               <a:ext uri="{FF2B5EF4-FFF2-40B4-BE49-F238E27FC236}">
-                <a16:creationId xmlns:a16="http://schemas.microsoft.com/office/drawing/2014/main" id="{AE3837B7-8C7B-4A26-BAFC-974A7F48B3AE}"/>
+                <a16:creationId xmlns:a16="http://schemas.microsoft.com/office/drawing/2014/main" id="{A39EB560-CF3E-4E85-B330-1E5097EEBD1F}"/>
               </a:ext>
             </a:extLst>
           </p:cNvPr>
@@ -5599,7 +5684,7 @@
           <p:cNvPr id="4" name="">
             <a:extLst xmlns:a="http://schemas.openxmlformats.org/drawingml/2006/main">
               <a:ext uri="{FF2B5EF4-FFF2-40B4-BE49-F238E27FC236}">
-                <a16:creationId xmlns:a16="http://schemas.microsoft.com/office/drawing/2014/main" id="{A839038E-1A07-4D38-8B0D-E20B8559C248}"/>
+                <a16:creationId xmlns:a16="http://schemas.microsoft.com/office/drawing/2014/main" id="{D9DDD676-69B1-4910-A194-480B9D464AEA}"/>
               </a:ext>
             </a:extLst>
           </p:cNvPr>
@@ -5634,10 +5719,10 @@
           <p:nvPr/>
         </p:nvPicPr>
         <p:blipFill>
-          <a:blip xmlns:r="http://schemas.openxmlformats.org/officeDocument/2006/relationships" xmlns:a="http://schemas.openxmlformats.org/drawingml/2006/main" r:embed="R60845cec1e064fd7">
+          <a:blip xmlns:r="http://schemas.openxmlformats.org/officeDocument/2006/relationships" xmlns:a="http://schemas.openxmlformats.org/drawingml/2006/main" r:embed="R330bc37159984b99">
             <a:extLst>
               <a:ext uri="{96DAC541-7B7A-43D3-8B79-37D633B846F1}">
-                <asvg:svgBlip xmlns:asvg="http://schemas.microsoft.com/office/drawing/2016/SVG/main" r:embed="R1a6918ac3b5a4d02"/>
+                <asvg:svgBlip xmlns:asvg="http://schemas.microsoft.com/office/drawing/2016/SVG/main" r:embed="Rbe5f5fefa50b495e"/>
               </a:ext>
             </a:extLst>
           </a:blip>
@@ -5658,7 +5743,7 @@
           <p:cNvPr id="6" name="">
             <a:extLst xmlns:a="http://schemas.openxmlformats.org/drawingml/2006/main">
               <a:ext uri="{FF2B5EF4-FFF2-40B4-BE49-F238E27FC236}">
-                <a16:creationId xmlns:a16="http://schemas.microsoft.com/office/drawing/2014/main" id="{6E0D8F94-3743-4BC6-913F-A1DC0FA8971D}"/>
+                <a16:creationId xmlns:a16="http://schemas.microsoft.com/office/drawing/2014/main" id="{378C01E8-4CC6-4ABD-9364-07CAEACB9878}"/>
               </a:ext>
             </a:extLst>
           </p:cNvPr>
@@ -5716,7 +5801,7 @@
           <p:cNvPr id="7" name="">
             <a:extLst xmlns:a="http://schemas.openxmlformats.org/drawingml/2006/main">
               <a:ext uri="{FF2B5EF4-FFF2-40B4-BE49-F238E27FC236}">
-                <a16:creationId xmlns:a16="http://schemas.microsoft.com/office/drawing/2014/main" id="{4643127C-0DDD-4743-8907-6238C37C5DCD}"/>
+                <a16:creationId xmlns:a16="http://schemas.microsoft.com/office/drawing/2014/main" id="{51699D52-ED81-40A9-846F-4D74F0DF342C}"/>
               </a:ext>
             </a:extLst>
           </p:cNvPr>
@@ -5774,7 +5859,7 @@
           <p:cNvPr id="8" name="">
             <a:extLst xmlns:a="http://schemas.openxmlformats.org/drawingml/2006/main">
               <a:ext uri="{FF2B5EF4-FFF2-40B4-BE49-F238E27FC236}">
-                <a16:creationId xmlns:a16="http://schemas.microsoft.com/office/drawing/2014/main" id="{08CE3E67-3D4A-4C08-B81D-0B0E4C5326AD}"/>
+                <a16:creationId xmlns:a16="http://schemas.microsoft.com/office/drawing/2014/main" id="{FE295514-8E1B-4363-9CEB-6EC1B33DF47A}"/>
               </a:ext>
             </a:extLst>
           </p:cNvPr>
@@ -5836,7 +5921,7 @@
           <p:cNvPr id="9" name="">
             <a:extLst xmlns:a="http://schemas.openxmlformats.org/drawingml/2006/main">
               <a:ext uri="{FF2B5EF4-FFF2-40B4-BE49-F238E27FC236}">
-                <a16:creationId xmlns:a16="http://schemas.microsoft.com/office/drawing/2014/main" id="{C5A7F13D-4205-478E-A307-567C29EE53E0}"/>
+                <a16:creationId xmlns:a16="http://schemas.microsoft.com/office/drawing/2014/main" id="{D7BE61EA-B5D7-4A1B-9B15-CD25BC4FEB9F}"/>
               </a:ext>
             </a:extLst>
           </p:cNvPr>
@@ -5898,7 +5983,7 @@
           <p:cNvPr id="10" name="">
             <a:extLst xmlns:a="http://schemas.openxmlformats.org/drawingml/2006/main">
               <a:ext uri="{FF2B5EF4-FFF2-40B4-BE49-F238E27FC236}">
-                <a16:creationId xmlns:a16="http://schemas.microsoft.com/office/drawing/2014/main" id="{494BEDDC-09BE-472C-8DE2-E9A01029D5B9}"/>
+                <a16:creationId xmlns:a16="http://schemas.microsoft.com/office/drawing/2014/main" id="{EA2422A7-B01D-4D9F-826F-3B219DE59327}"/>
               </a:ext>
             </a:extLst>
           </p:cNvPr>
@@ -5929,7 +6014,7 @@
           <p:cNvPr id="11" name="">
             <a:extLst xmlns:a="http://schemas.openxmlformats.org/drawingml/2006/main">
               <a:ext uri="{FF2B5EF4-FFF2-40B4-BE49-F238E27FC236}">
-                <a16:creationId xmlns:a16="http://schemas.microsoft.com/office/drawing/2014/main" id="{FCC86091-8E96-428D-AE8D-96236253C9FC}"/>
+                <a16:creationId xmlns:a16="http://schemas.microsoft.com/office/drawing/2014/main" id="{B61FD790-9043-4141-8CB7-212FB5FD60CA}"/>
               </a:ext>
             </a:extLst>
           </p:cNvPr>
@@ -5960,7 +6045,7 @@
           <p:cNvPr id="12" name="">
             <a:extLst xmlns:a="http://schemas.openxmlformats.org/drawingml/2006/main">
               <a:ext uri="{FF2B5EF4-FFF2-40B4-BE49-F238E27FC236}">
-                <a16:creationId xmlns:a16="http://schemas.microsoft.com/office/drawing/2014/main" id="{4BC24F5A-C61F-4495-A5F4-F2C66C566077}"/>
+                <a16:creationId xmlns:a16="http://schemas.microsoft.com/office/drawing/2014/main" id="{681F89CD-99F6-40A7-9075-AB7009C86C65}"/>
               </a:ext>
             </a:extLst>
           </p:cNvPr>
@@ -5991,7 +6076,7 @@
           <p:cNvPr id="13" name="">
             <a:extLst xmlns:a="http://schemas.openxmlformats.org/drawingml/2006/main">
               <a:ext uri="{FF2B5EF4-FFF2-40B4-BE49-F238E27FC236}">
-                <a16:creationId xmlns:a16="http://schemas.microsoft.com/office/drawing/2014/main" id="{1CE5F4FF-F7D0-4BB2-BEF6-B72A118745E2}"/>
+                <a16:creationId xmlns:a16="http://schemas.microsoft.com/office/drawing/2014/main" id="{3F973CC7-BD17-4C13-A77F-A6BC46A75464}"/>
               </a:ext>
             </a:extLst>
           </p:cNvPr>
@@ -6022,7 +6107,7 @@
           <p:cNvPr id="14" name="">
             <a:extLst xmlns:a="http://schemas.openxmlformats.org/drawingml/2006/main">
               <a:ext uri="{FF2B5EF4-FFF2-40B4-BE49-F238E27FC236}">
-                <a16:creationId xmlns:a16="http://schemas.microsoft.com/office/drawing/2014/main" id="{B009B1A1-A1FE-4A21-A101-7DEF4FF1185A}"/>
+                <a16:creationId xmlns:a16="http://schemas.microsoft.com/office/drawing/2014/main" id="{A4C68469-E25D-404A-9488-91A56A7B9C38}"/>
               </a:ext>
             </a:extLst>
           </p:cNvPr>
@@ -6053,7 +6138,7 @@
           <p:cNvPr id="15" name="">
             <a:extLst xmlns:a="http://schemas.openxmlformats.org/drawingml/2006/main">
               <a:ext uri="{FF2B5EF4-FFF2-40B4-BE49-F238E27FC236}">
-                <a16:creationId xmlns:a16="http://schemas.microsoft.com/office/drawing/2014/main" id="{2A278626-F011-4BD1-BE54-BED2655CD2EA}"/>
+                <a16:creationId xmlns:a16="http://schemas.microsoft.com/office/drawing/2014/main" id="{8ACF856D-0D89-43A5-9B05-85382B6D32B5}"/>
               </a:ext>
             </a:extLst>
           </p:cNvPr>
@@ -6084,7 +6169,7 @@
           <p:cNvPr id="16" name="">
             <a:extLst xmlns:a="http://schemas.openxmlformats.org/drawingml/2006/main">
               <a:ext uri="{FF2B5EF4-FFF2-40B4-BE49-F238E27FC236}">
-                <a16:creationId xmlns:a16="http://schemas.microsoft.com/office/drawing/2014/main" id="{6B2BD70C-7170-4432-9A2B-FF3CCC51A35E}"/>
+                <a16:creationId xmlns:a16="http://schemas.microsoft.com/office/drawing/2014/main" id="{D4B041A0-6047-4AFA-919A-A426DD6FC96F}"/>
               </a:ext>
             </a:extLst>
           </p:cNvPr>
@@ -6115,7 +6200,7 @@
           <p:cNvPr id="17" name="">
             <a:extLst xmlns:a="http://schemas.openxmlformats.org/drawingml/2006/main">
               <a:ext uri="{FF2B5EF4-FFF2-40B4-BE49-F238E27FC236}">
-                <a16:creationId xmlns:a16="http://schemas.microsoft.com/office/drawing/2014/main" id="{EF8557AE-6D08-4340-A54A-1E81B6710129}"/>
+                <a16:creationId xmlns:a16="http://schemas.microsoft.com/office/drawing/2014/main" id="{07E5380B-85B2-4451-B05E-184507429011}"/>
               </a:ext>
             </a:extLst>
           </p:cNvPr>
@@ -6146,7 +6231,7 @@
           <p:cNvPr id="18" name="">
             <a:extLst xmlns:a="http://schemas.openxmlformats.org/drawingml/2006/main">
               <a:ext uri="{FF2B5EF4-FFF2-40B4-BE49-F238E27FC236}">
-                <a16:creationId xmlns:a16="http://schemas.microsoft.com/office/drawing/2014/main" id="{75B08014-41AA-48BE-A344-643BE6B0E1C6}"/>
+                <a16:creationId xmlns:a16="http://schemas.microsoft.com/office/drawing/2014/main" id="{48174864-2ED9-43A0-B197-6EED9AF503FE}"/>
               </a:ext>
             </a:extLst>
           </p:cNvPr>
@@ -6181,7 +6266,7 @@
           <p:cNvPr id="19" name="">
             <a:extLst xmlns:a="http://schemas.openxmlformats.org/drawingml/2006/main">
               <a:ext uri="{FF2B5EF4-FFF2-40B4-BE49-F238E27FC236}">
-                <a16:creationId xmlns:a16="http://schemas.microsoft.com/office/drawing/2014/main" id="{B0E48B32-30C4-467B-B745-47869084C081}"/>
+                <a16:creationId xmlns:a16="http://schemas.microsoft.com/office/drawing/2014/main" id="{1C20B181-1AD6-4D26-96B6-E0436FBEC1BD}"/>
               </a:ext>
             </a:extLst>
           </p:cNvPr>
@@ -6239,7 +6324,7 @@
           <p:cNvPr id="20" name="">
             <a:extLst xmlns:a="http://schemas.openxmlformats.org/drawingml/2006/main">
               <a:ext uri="{FF2B5EF4-FFF2-40B4-BE49-F238E27FC236}">
-                <a16:creationId xmlns:a16="http://schemas.microsoft.com/office/drawing/2014/main" id="{06F4734C-6131-4368-B80D-90EC26A6B574}"/>
+                <a16:creationId xmlns:a16="http://schemas.microsoft.com/office/drawing/2014/main" id="{0E894ED9-0D3C-47ED-9DC1-6DF2BB590708}"/>
               </a:ext>
             </a:extLst>
           </p:cNvPr>
@@ -6297,7 +6382,7 @@
           <p:cNvPr id="21" name="">
             <a:extLst xmlns:a="http://schemas.openxmlformats.org/drawingml/2006/main">
               <a:ext uri="{FF2B5EF4-FFF2-40B4-BE49-F238E27FC236}">
-                <a16:creationId xmlns:a16="http://schemas.microsoft.com/office/drawing/2014/main" id="{EA7B473B-B7F4-4301-B93B-BDDCFCBD383B}"/>
+                <a16:creationId xmlns:a16="http://schemas.microsoft.com/office/drawing/2014/main" id="{366D283F-9450-4B4A-AA87-4F1CEF550958}"/>
               </a:ext>
             </a:extLst>
           </p:cNvPr>
@@ -6332,7 +6417,7 @@
           <p:cNvPr id="22" name="">
             <a:extLst xmlns:a="http://schemas.openxmlformats.org/drawingml/2006/main">
               <a:ext uri="{FF2B5EF4-FFF2-40B4-BE49-F238E27FC236}">
-                <a16:creationId xmlns:a16="http://schemas.microsoft.com/office/drawing/2014/main" id="{ABA0B7B5-CA7C-49A9-863C-66DCA46359E0}"/>
+                <a16:creationId xmlns:a16="http://schemas.microsoft.com/office/drawing/2014/main" id="{F5DF19AD-A9E9-4216-A62B-6B997FFD6590}"/>
               </a:ext>
             </a:extLst>
           </p:cNvPr>
@@ -6390,7 +6475,7 @@
           <p:cNvPr id="23" name="">
             <a:extLst xmlns:a="http://schemas.openxmlformats.org/drawingml/2006/main">
               <a:ext uri="{FF2B5EF4-FFF2-40B4-BE49-F238E27FC236}">
-                <a16:creationId xmlns:a16="http://schemas.microsoft.com/office/drawing/2014/main" id="{084032AC-6EB4-4829-8EA5-5B54E0954030}"/>
+                <a16:creationId xmlns:a16="http://schemas.microsoft.com/office/drawing/2014/main" id="{7CEDFB60-5985-4D69-B409-8482651BEAC4}"/>
               </a:ext>
             </a:extLst>
           </p:cNvPr>
@@ -6448,7 +6533,7 @@
           <p:cNvPr id="24" name="">
             <a:extLst xmlns:a="http://schemas.openxmlformats.org/drawingml/2006/main">
               <a:ext uri="{FF2B5EF4-FFF2-40B4-BE49-F238E27FC236}">
-                <a16:creationId xmlns:a16="http://schemas.microsoft.com/office/drawing/2014/main" id="{ED8BB02D-DE15-4E3A-BB86-06E3CD923C5D}"/>
+                <a16:creationId xmlns:a16="http://schemas.microsoft.com/office/drawing/2014/main" id="{BC91CA49-EA37-4727-83C1-84A9A46BA35C}"/>
               </a:ext>
             </a:extLst>
           </p:cNvPr>
@@ -6483,7 +6568,7 @@
           <p:cNvPr id="25" name="">
             <a:extLst xmlns:a="http://schemas.openxmlformats.org/drawingml/2006/main">
               <a:ext uri="{FF2B5EF4-FFF2-40B4-BE49-F238E27FC236}">
-                <a16:creationId xmlns:a16="http://schemas.microsoft.com/office/drawing/2014/main" id="{1E995E87-6AB4-4400-9C02-C4B303D1A269}"/>
+                <a16:creationId xmlns:a16="http://schemas.microsoft.com/office/drawing/2014/main" id="{1BA2205A-53F6-4E17-B330-7B8E686AC212}"/>
               </a:ext>
             </a:extLst>
           </p:cNvPr>
@@ -6541,7 +6626,7 @@
           <p:cNvPr id="26" name="">
             <a:extLst xmlns:a="http://schemas.openxmlformats.org/drawingml/2006/main">
               <a:ext uri="{FF2B5EF4-FFF2-40B4-BE49-F238E27FC236}">
-                <a16:creationId xmlns:a16="http://schemas.microsoft.com/office/drawing/2014/main" id="{892961D1-EC18-4BF9-AF40-F28D26F2F970}"/>
+                <a16:creationId xmlns:a16="http://schemas.microsoft.com/office/drawing/2014/main" id="{77D0593C-DB97-4CFD-ABA0-BD2BAD2D2985}"/>
               </a:ext>
             </a:extLst>
           </p:cNvPr>
@@ -6599,7 +6684,7 @@
           <p:cNvPr id="27" name="">
             <a:extLst xmlns:a="http://schemas.openxmlformats.org/drawingml/2006/main">
               <a:ext uri="{FF2B5EF4-FFF2-40B4-BE49-F238E27FC236}">
-                <a16:creationId xmlns:a16="http://schemas.microsoft.com/office/drawing/2014/main" id="{3169772A-01B4-4F81-B216-6F16BF0673ED}"/>
+                <a16:creationId xmlns:a16="http://schemas.microsoft.com/office/drawing/2014/main" id="{15D7F52A-CC0C-46B2-8DEC-BF75537A7947}"/>
               </a:ext>
             </a:extLst>
           </p:cNvPr>
@@ -6634,7 +6719,7 @@
           <p:cNvPr id="28" name="">
             <a:extLst xmlns:a="http://schemas.openxmlformats.org/drawingml/2006/main">
               <a:ext uri="{FF2B5EF4-FFF2-40B4-BE49-F238E27FC236}">
-                <a16:creationId xmlns:a16="http://schemas.microsoft.com/office/drawing/2014/main" id="{3B4AF8D0-402C-4AA6-8E46-F5036A8D8DCC}"/>
+                <a16:creationId xmlns:a16="http://schemas.microsoft.com/office/drawing/2014/main" id="{D367C548-866E-498D-8E37-A9A1954C8489}"/>
               </a:ext>
             </a:extLst>
           </p:cNvPr>
@@ -6692,7 +6777,7 @@
           <p:cNvPr id="29" name="">
             <a:extLst xmlns:a="http://schemas.openxmlformats.org/drawingml/2006/main">
               <a:ext uri="{FF2B5EF4-FFF2-40B4-BE49-F238E27FC236}">
-                <a16:creationId xmlns:a16="http://schemas.microsoft.com/office/drawing/2014/main" id="{366C20D6-58F9-4B79-A09B-B5CDDCCD96E0}"/>
+                <a16:creationId xmlns:a16="http://schemas.microsoft.com/office/drawing/2014/main" id="{DA6BEFA5-B3F1-4D4D-B0C5-CA821FD7904B}"/>
               </a:ext>
             </a:extLst>
           </p:cNvPr>
@@ -6750,7 +6835,7 @@
           <p:cNvPr id="30" name="">
             <a:extLst xmlns:a="http://schemas.openxmlformats.org/drawingml/2006/main">
               <a:ext uri="{FF2B5EF4-FFF2-40B4-BE49-F238E27FC236}">
-                <a16:creationId xmlns:a16="http://schemas.microsoft.com/office/drawing/2014/main" id="{B4B84EEA-A488-45AF-A92A-D10B47981065}"/>
+                <a16:creationId xmlns:a16="http://schemas.microsoft.com/office/drawing/2014/main" id="{546626F8-75E6-4E61-B4DD-82E08A8530BA}"/>
               </a:ext>
             </a:extLst>
           </p:cNvPr>
@@ -6785,7 +6870,7 @@
           <p:cNvPr id="31" name="">
             <a:extLst xmlns:a="http://schemas.openxmlformats.org/drawingml/2006/main">
               <a:ext uri="{FF2B5EF4-FFF2-40B4-BE49-F238E27FC236}">
-                <a16:creationId xmlns:a16="http://schemas.microsoft.com/office/drawing/2014/main" id="{93C31C8D-6C25-4E87-9343-3B3DFD95A8FB}"/>
+                <a16:creationId xmlns:a16="http://schemas.microsoft.com/office/drawing/2014/main" id="{0E376173-F971-4532-84F0-B28DEEBBDE86}"/>
               </a:ext>
             </a:extLst>
           </p:cNvPr>
@@ -6843,7 +6928,7 @@
           <p:cNvPr id="32" name="">
             <a:extLst xmlns:a="http://schemas.openxmlformats.org/drawingml/2006/main">
               <a:ext uri="{FF2B5EF4-FFF2-40B4-BE49-F238E27FC236}">
-                <a16:creationId xmlns:a16="http://schemas.microsoft.com/office/drawing/2014/main" id="{2CE92721-1B7E-4650-83BC-A594C09D74F8}"/>
+                <a16:creationId xmlns:a16="http://schemas.microsoft.com/office/drawing/2014/main" id="{988C7518-F6A6-4F43-BEC0-5DD9B5C05F5C}"/>
               </a:ext>
             </a:extLst>
           </p:cNvPr>
@@ -6901,7 +6986,7 @@
           <p:cNvPr id="33" name="">
             <a:extLst xmlns:a="http://schemas.openxmlformats.org/drawingml/2006/main">
               <a:ext uri="{FF2B5EF4-FFF2-40B4-BE49-F238E27FC236}">
-                <a16:creationId xmlns:a16="http://schemas.microsoft.com/office/drawing/2014/main" id="{4CD4A50D-032B-4B61-BB69-603D15CED44D}"/>
+                <a16:creationId xmlns:a16="http://schemas.microsoft.com/office/drawing/2014/main" id="{534B94A4-5E46-4DDF-A381-B4515FCD1E0F}"/>
               </a:ext>
             </a:extLst>
           </p:cNvPr>
@@ -6936,7 +7021,7 @@
           <p:cNvPr id="34" name="">
             <a:extLst xmlns:a="http://schemas.openxmlformats.org/drawingml/2006/main">
               <a:ext uri="{FF2B5EF4-FFF2-40B4-BE49-F238E27FC236}">
-                <a16:creationId xmlns:a16="http://schemas.microsoft.com/office/drawing/2014/main" id="{6FAAFFA1-7A4B-4C08-B872-F58C023F1E66}"/>
+                <a16:creationId xmlns:a16="http://schemas.microsoft.com/office/drawing/2014/main" id="{28DF4DA2-D87C-4887-80DC-1B1F624C0E2D}"/>
               </a:ext>
             </a:extLst>
           </p:cNvPr>
@@ -6994,7 +7079,7 @@
           <p:cNvPr id="35" name="">
             <a:extLst xmlns:a="http://schemas.openxmlformats.org/drawingml/2006/main">
               <a:ext uri="{FF2B5EF4-FFF2-40B4-BE49-F238E27FC236}">
-                <a16:creationId xmlns:a16="http://schemas.microsoft.com/office/drawing/2014/main" id="{5AC62FD1-A9F5-467D-A6B1-8C3CBCA71BE1}"/>
+                <a16:creationId xmlns:a16="http://schemas.microsoft.com/office/drawing/2014/main" id="{1721FD24-E5B4-4AD1-A92C-9E37ABE6BE93}"/>
               </a:ext>
             </a:extLst>
           </p:cNvPr>
@@ -7052,7 +7137,7 @@
           <p:cNvPr id="36" name="">
             <a:extLst xmlns:a="http://schemas.openxmlformats.org/drawingml/2006/main">
               <a:ext uri="{FF2B5EF4-FFF2-40B4-BE49-F238E27FC236}">
-                <a16:creationId xmlns:a16="http://schemas.microsoft.com/office/drawing/2014/main" id="{BF99E93E-5BD4-4C67-97A9-5B2C010F483B}"/>
+                <a16:creationId xmlns:a16="http://schemas.microsoft.com/office/drawing/2014/main" id="{925AA163-8158-4248-A169-37E393591E6D}"/>
               </a:ext>
             </a:extLst>
           </p:cNvPr>
@@ -7087,7 +7172,7 @@
           <p:cNvPr id="37" name="">
             <a:extLst xmlns:a="http://schemas.openxmlformats.org/drawingml/2006/main">
               <a:ext uri="{FF2B5EF4-FFF2-40B4-BE49-F238E27FC236}">
-                <a16:creationId xmlns:a16="http://schemas.microsoft.com/office/drawing/2014/main" id="{84E9D1D4-9A8C-4C1D-A86F-7547B0DC4BA8}"/>
+                <a16:creationId xmlns:a16="http://schemas.microsoft.com/office/drawing/2014/main" id="{3E7C5FC8-D776-4188-9789-ECB0BEB09979}"/>
               </a:ext>
             </a:extLst>
           </p:cNvPr>
@@ -7145,7 +7230,7 @@
           <p:cNvPr id="38" name="">
             <a:extLst xmlns:a="http://schemas.openxmlformats.org/drawingml/2006/main">
               <a:ext uri="{FF2B5EF4-FFF2-40B4-BE49-F238E27FC236}">
-                <a16:creationId xmlns:a16="http://schemas.microsoft.com/office/drawing/2014/main" id="{D7A87E01-0EAB-4F4C-A250-2AC2CA0A07DD}"/>
+                <a16:creationId xmlns:a16="http://schemas.microsoft.com/office/drawing/2014/main" id="{E02A533D-8409-4929-BA16-7BB764DDF5D9}"/>
               </a:ext>
             </a:extLst>
           </p:cNvPr>
@@ -7203,7 +7288,7 @@
           <p:cNvPr id="39" name="">
             <a:extLst xmlns:a="http://schemas.openxmlformats.org/drawingml/2006/main">
               <a:ext uri="{FF2B5EF4-FFF2-40B4-BE49-F238E27FC236}">
-                <a16:creationId xmlns:a16="http://schemas.microsoft.com/office/drawing/2014/main" id="{4393A14B-A80F-4052-9F0A-8701B43D2F4A}"/>
+                <a16:creationId xmlns:a16="http://schemas.microsoft.com/office/drawing/2014/main" id="{ABA738CF-A64F-4307-8A6E-102CF0A0F79F}"/>
               </a:ext>
             </a:extLst>
           </p:cNvPr>
@@ -7238,7 +7323,7 @@
           <p:cNvPr id="40" name="">
             <a:extLst xmlns:a="http://schemas.openxmlformats.org/drawingml/2006/main">
               <a:ext uri="{FF2B5EF4-FFF2-40B4-BE49-F238E27FC236}">
-                <a16:creationId xmlns:a16="http://schemas.microsoft.com/office/drawing/2014/main" id="{F795F274-D97B-48DB-918A-1BBFBA8A507B}"/>
+                <a16:creationId xmlns:a16="http://schemas.microsoft.com/office/drawing/2014/main" id="{FC7C9488-393F-4017-B4D5-AA7900A050DB}"/>
               </a:ext>
             </a:extLst>
           </p:cNvPr>
@@ -7296,7 +7381,7 @@
           <p:cNvPr id="41" name="">
             <a:extLst xmlns:a="http://schemas.openxmlformats.org/drawingml/2006/main">
               <a:ext uri="{FF2B5EF4-FFF2-40B4-BE49-F238E27FC236}">
-                <a16:creationId xmlns:a16="http://schemas.microsoft.com/office/drawing/2014/main" id="{7FEEAA10-3F37-486C-95E8-0DEC996AD9E6}"/>
+                <a16:creationId xmlns:a16="http://schemas.microsoft.com/office/drawing/2014/main" id="{96D69587-FF08-4A4B-951A-0E93311D5E83}"/>
               </a:ext>
             </a:extLst>
           </p:cNvPr>
@@ -7354,7 +7439,7 @@
           <p:cNvPr id="42" name="">
             <a:extLst xmlns:a="http://schemas.openxmlformats.org/drawingml/2006/main">
               <a:ext uri="{FF2B5EF4-FFF2-40B4-BE49-F238E27FC236}">
-                <a16:creationId xmlns:a16="http://schemas.microsoft.com/office/drawing/2014/main" id="{37E0609F-73CA-4361-8DB4-02A9D44BD6E6}"/>
+                <a16:creationId xmlns:a16="http://schemas.microsoft.com/office/drawing/2014/main" id="{5108D78A-45A7-43C8-9F6F-1F6346EB9596}"/>
               </a:ext>
             </a:extLst>
           </p:cNvPr>
@@ -7412,7 +7497,7 @@
           <p:cNvPr id="43" name="">
             <a:extLst xmlns:a="http://schemas.openxmlformats.org/drawingml/2006/main">
               <a:ext uri="{FF2B5EF4-FFF2-40B4-BE49-F238E27FC236}">
-                <a16:creationId xmlns:a16="http://schemas.microsoft.com/office/drawing/2014/main" id="{F06043F4-DD0F-4161-80B0-AC2ABBA4F313}"/>
+                <a16:creationId xmlns:a16="http://schemas.microsoft.com/office/drawing/2014/main" id="{DB20DF18-3A62-460A-9ED3-FE927E00D7C8}"/>
               </a:ext>
             </a:extLst>
           </p:cNvPr>
@@ -7443,7 +7528,7 @@
           <p:cNvPr id="44" name="">
             <a:extLst xmlns:a="http://schemas.openxmlformats.org/drawingml/2006/main">
               <a:ext uri="{FF2B5EF4-FFF2-40B4-BE49-F238E27FC236}">
-                <a16:creationId xmlns:a16="http://schemas.microsoft.com/office/drawing/2014/main" id="{C2BC3E57-39C3-4F9B-82B5-C07E0DC589C1}"/>
+                <a16:creationId xmlns:a16="http://schemas.microsoft.com/office/drawing/2014/main" id="{235DB8E3-D168-48EB-8F8A-DAEB0F409111}"/>
               </a:ext>
             </a:extLst>
           </p:cNvPr>
@@ -7501,7 +7586,7 @@
           <p:cNvPr id="45" name="">
             <a:extLst xmlns:a="http://schemas.openxmlformats.org/drawingml/2006/main">
               <a:ext uri="{FF2B5EF4-FFF2-40B4-BE49-F238E27FC236}">
-                <a16:creationId xmlns:a16="http://schemas.microsoft.com/office/drawing/2014/main" id="{F86E03C1-9975-46E1-B72A-1967F99025AD}"/>
+                <a16:creationId xmlns:a16="http://schemas.microsoft.com/office/drawing/2014/main" id="{94DC24DF-8374-47AC-A9D1-0CA13FDF0440}"/>
               </a:ext>
             </a:extLst>
           </p:cNvPr>
@@ -7532,7 +7617,7 @@
           <p:cNvPr id="46" name="">
             <a:extLst xmlns:a="http://schemas.openxmlformats.org/drawingml/2006/main">
               <a:ext uri="{FF2B5EF4-FFF2-40B4-BE49-F238E27FC236}">
-                <a16:creationId xmlns:a16="http://schemas.microsoft.com/office/drawing/2014/main" id="{2DB626C0-C74E-424D-8CFB-281671F902D7}"/>
+                <a16:creationId xmlns:a16="http://schemas.microsoft.com/office/drawing/2014/main" id="{98B96397-13A8-484E-9BF9-A9189FAD3401}"/>
               </a:ext>
             </a:extLst>
           </p:cNvPr>
@@ -7590,7 +7675,7 @@
           <p:cNvPr id="47" name="">
             <a:extLst xmlns:a="http://schemas.openxmlformats.org/drawingml/2006/main">
               <a:ext uri="{FF2B5EF4-FFF2-40B4-BE49-F238E27FC236}">
-                <a16:creationId xmlns:a16="http://schemas.microsoft.com/office/drawing/2014/main" id="{55E68136-DB13-41D7-9012-69DADB2D991E}"/>
+                <a16:creationId xmlns:a16="http://schemas.microsoft.com/office/drawing/2014/main" id="{2740D62A-967A-48B3-8A1D-BF82BEF8A7B1}"/>
               </a:ext>
             </a:extLst>
           </p:cNvPr>
@@ -7621,7 +7706,7 @@
           <p:cNvPr id="48" name="">
             <a:extLst xmlns:a="http://schemas.openxmlformats.org/drawingml/2006/main">
               <a:ext uri="{FF2B5EF4-FFF2-40B4-BE49-F238E27FC236}">
-                <a16:creationId xmlns:a16="http://schemas.microsoft.com/office/drawing/2014/main" id="{C1C94E1A-07DD-45C5-B155-1A3F5391B8C2}"/>
+                <a16:creationId xmlns:a16="http://schemas.microsoft.com/office/drawing/2014/main" id="{C63ECB49-C13C-4B0C-AD47-4072AD1C649F}"/>
               </a:ext>
             </a:extLst>
           </p:cNvPr>
@@ -7679,7 +7764,7 @@
           <p:cNvPr id="49" name="">
             <a:extLst xmlns:a="http://schemas.openxmlformats.org/drawingml/2006/main">
               <a:ext uri="{FF2B5EF4-FFF2-40B4-BE49-F238E27FC236}">
-                <a16:creationId xmlns:a16="http://schemas.microsoft.com/office/drawing/2014/main" id="{E222BD4E-35A0-47DF-9934-76B1E4056661}"/>
+                <a16:creationId xmlns:a16="http://schemas.microsoft.com/office/drawing/2014/main" id="{8826B63B-51F2-4E0F-98BB-D5C27B198BC1}"/>
               </a:ext>
             </a:extLst>
           </p:cNvPr>
@@ -7710,7 +7795,7 @@
           <p:cNvPr id="50" name="">
             <a:extLst xmlns:a="http://schemas.openxmlformats.org/drawingml/2006/main">
               <a:ext uri="{FF2B5EF4-FFF2-40B4-BE49-F238E27FC236}">
-                <a16:creationId xmlns:a16="http://schemas.microsoft.com/office/drawing/2014/main" id="{4610ECE2-0305-4717-B131-CAD3D641937B}"/>
+                <a16:creationId xmlns:a16="http://schemas.microsoft.com/office/drawing/2014/main" id="{15630A22-ABAB-463E-AD6C-D07D23634F59}"/>
               </a:ext>
             </a:extLst>
           </p:cNvPr>
@@ -7768,7 +7853,7 @@
           <p:cNvPr id="51" name="">
             <a:extLst xmlns:a="http://schemas.openxmlformats.org/drawingml/2006/main">
               <a:ext uri="{FF2B5EF4-FFF2-40B4-BE49-F238E27FC236}">
-                <a16:creationId xmlns:a16="http://schemas.microsoft.com/office/drawing/2014/main" id="{7404A199-2E90-4B8B-9609-2BBFED627E33}"/>
+                <a16:creationId xmlns:a16="http://schemas.microsoft.com/office/drawing/2014/main" id="{DE1CBE49-A73E-4AFC-8DAB-84BA31DC209F}"/>
               </a:ext>
             </a:extLst>
           </p:cNvPr>
@@ -7799,7 +7884,7 @@
           <p:cNvPr id="52" name="">
             <a:extLst xmlns:a="http://schemas.openxmlformats.org/drawingml/2006/main">
               <a:ext uri="{FF2B5EF4-FFF2-40B4-BE49-F238E27FC236}">
-                <a16:creationId xmlns:a16="http://schemas.microsoft.com/office/drawing/2014/main" id="{EBB8A346-DCAC-4E43-A3BD-27201F2464FA}"/>
+                <a16:creationId xmlns:a16="http://schemas.microsoft.com/office/drawing/2014/main" id="{6DFC4353-6F8A-4E4F-8A12-AAE17D5FFC1C}"/>
               </a:ext>
             </a:extLst>
           </p:cNvPr>
@@ -7857,7 +7942,7 @@
           <p:cNvPr id="53" name="replay-shot-frame">
             <a:extLst xmlns:a="http://schemas.openxmlformats.org/drawingml/2006/main">
               <a:ext uri="{FF2B5EF4-FFF2-40B4-BE49-F238E27FC236}">
-                <a16:creationId xmlns:a16="http://schemas.microsoft.com/office/drawing/2014/main" id="{D5487C67-895C-497F-983C-87064A8C5114}"/>
+                <a16:creationId xmlns:a16="http://schemas.microsoft.com/office/drawing/2014/main" id="{CFB09304-BD02-4D00-AC8C-6D3BFFA219D2}"/>
               </a:ext>
             </a:extLst>
           </p:cNvPr>
@@ -7902,7 +7987,7 @@
           <p:nvPr/>
         </p:nvPicPr>
         <p:blipFill>
-          <a:blip xmlns:r="http://schemas.openxmlformats.org/officeDocument/2006/relationships" xmlns:a="http://schemas.openxmlformats.org/drawingml/2006/main" r:embed="Ra751d907f8ad422e"/>
+          <a:blip xmlns:r="http://schemas.openxmlformats.org/officeDocument/2006/relationships" xmlns:a="http://schemas.openxmlformats.org/drawingml/2006/main" r:embed="R1ae509f8b95c4063"/>
           <a:srcRect xmlns:a="http://schemas.openxmlformats.org/drawingml/2006/main" l="46" t="0" r="46" b="0"/>
           <a:stretch xmlns:a="http://schemas.openxmlformats.org/drawingml/2006/main">
             <a:fillRect l="0" t="0" r="0" b="0"/>
@@ -7925,7 +8010,7 @@
           <p:cNvPr id="55" name="">
             <a:extLst xmlns:a="http://schemas.openxmlformats.org/drawingml/2006/main">
               <a:ext uri="{FF2B5EF4-FFF2-40B4-BE49-F238E27FC236}">
-                <a16:creationId xmlns:a16="http://schemas.microsoft.com/office/drawing/2014/main" id="{4E7B4F99-34B2-4FC9-9211-646B2E9823C1}"/>
+                <a16:creationId xmlns:a16="http://schemas.microsoft.com/office/drawing/2014/main" id="{DC3CF779-B906-4FF3-B87B-746F53FE602B}"/>
               </a:ext>
             </a:extLst>
           </p:cNvPr>
@@ -7983,7 +8068,7 @@
           <p:cNvPr id="56" name="">
             <a:extLst xmlns:a="http://schemas.openxmlformats.org/drawingml/2006/main">
               <a:ext uri="{FF2B5EF4-FFF2-40B4-BE49-F238E27FC236}">
-                <a16:creationId xmlns:a16="http://schemas.microsoft.com/office/drawing/2014/main" id="{F7E5D3FB-8A23-459B-A464-2A95D9A3A97F}"/>
+                <a16:creationId xmlns:a16="http://schemas.microsoft.com/office/drawing/2014/main" id="{C2FB2251-6958-4192-A1E5-3B657F8AC036}"/>
               </a:ext>
             </a:extLst>
           </p:cNvPr>
@@ -8045,7 +8130,7 @@
           <p:cNvPr id="57" name="">
             <a:extLst xmlns:a="http://schemas.openxmlformats.org/drawingml/2006/main">
               <a:ext uri="{FF2B5EF4-FFF2-40B4-BE49-F238E27FC236}">
-                <a16:creationId xmlns:a16="http://schemas.microsoft.com/office/drawing/2014/main" id="{794AE6B0-1923-49E2-A99F-44C695F44ECE}"/>
+                <a16:creationId xmlns:a16="http://schemas.microsoft.com/office/drawing/2014/main" id="{CC33FEE3-F9D4-4594-B8F5-8B75EE56D6A5}"/>
               </a:ext>
             </a:extLst>
           </p:cNvPr>
@@ -8101,7 +8186,7 @@
     </p:spTree>
     <p:extLst>
       <p:ext uri="{BB962C8B-B14F-4D97-AF65-F5344CB8AC3E}">
-        <p14:creationId xmlns:p14="http://schemas.microsoft.com/office/powerpoint/2010/main" val="488294287"/>
+        <p14:creationId xmlns:p14="http://schemas.microsoft.com/office/powerpoint/2010/main" val="629310359"/>
       </p:ext>
     </p:extLst>
   </p:cSld>
@@ -8132,7 +8217,7 @@
           <p:cNvPr id="31" name="">
             <a:extLst xmlns:a="http://schemas.openxmlformats.org/drawingml/2006/main">
               <a:ext uri="{FF2B5EF4-FFF2-40B4-BE49-F238E27FC236}">
-                <a16:creationId xmlns:a16="http://schemas.microsoft.com/office/drawing/2014/main" id="{B5EFF40D-5A3A-40E1-8BEC-8374682CA078}"/>
+                <a16:creationId xmlns:a16="http://schemas.microsoft.com/office/drawing/2014/main" id="{949DFB8B-2D98-4640-9CC9-95849333591C}"/>
               </a:ext>
             </a:extLst>
           </p:cNvPr>
@@ -8165,7 +8250,7 @@
           <p:cNvPr id="2" name="">
             <a:extLst xmlns:a="http://schemas.openxmlformats.org/drawingml/2006/main">
               <a:ext uri="{FF2B5EF4-FFF2-40B4-BE49-F238E27FC236}">
-                <a16:creationId xmlns:a16="http://schemas.microsoft.com/office/drawing/2014/main" id="{7282AF3E-B0D9-4A0D-8EA5-F8BDCC756F58}"/>
+                <a16:creationId xmlns:a16="http://schemas.microsoft.com/office/drawing/2014/main" id="{70853D8D-1838-458E-B26D-2E2500F02798}"/>
               </a:ext>
             </a:extLst>
           </p:cNvPr>
@@ -8223,7 +8308,7 @@
           <p:cNvPr id="3" name="">
             <a:extLst xmlns:a="http://schemas.openxmlformats.org/drawingml/2006/main">
               <a:ext uri="{FF2B5EF4-FFF2-40B4-BE49-F238E27FC236}">
-                <a16:creationId xmlns:a16="http://schemas.microsoft.com/office/drawing/2014/main" id="{482997E8-3706-4D12-B6ED-F6E5E455B0B4}"/>
+                <a16:creationId xmlns:a16="http://schemas.microsoft.com/office/drawing/2014/main" id="{45221329-ADE0-479A-B17C-E9FAED9D6C9E}"/>
               </a:ext>
             </a:extLst>
           </p:cNvPr>
@@ -8281,7 +8366,7 @@
           <p:cNvPr id="4" name="">
             <a:extLst xmlns:a="http://schemas.openxmlformats.org/drawingml/2006/main">
               <a:ext uri="{FF2B5EF4-FFF2-40B4-BE49-F238E27FC236}">
-                <a16:creationId xmlns:a16="http://schemas.microsoft.com/office/drawing/2014/main" id="{A49827C6-73B7-4C1A-B2F1-7EC2747ACB8D}"/>
+                <a16:creationId xmlns:a16="http://schemas.microsoft.com/office/drawing/2014/main" id="{4DACFA35-6439-47EF-8F0A-0CB876A62902}"/>
               </a:ext>
             </a:extLst>
           </p:cNvPr>
@@ -8316,10 +8401,10 @@
           <p:nvPr/>
         </p:nvPicPr>
         <p:blipFill>
-          <a:blip xmlns:r="http://schemas.openxmlformats.org/officeDocument/2006/relationships" xmlns:a="http://schemas.openxmlformats.org/drawingml/2006/main" r:embed="R1b4b78b2ae924a7c">
+          <a:blip xmlns:r="http://schemas.openxmlformats.org/officeDocument/2006/relationships" xmlns:a="http://schemas.openxmlformats.org/drawingml/2006/main" r:embed="R0e727cd658b54207">
             <a:extLst>
               <a:ext uri="{96DAC541-7B7A-43D3-8B79-37D633B846F1}">
-                <asvg:svgBlip xmlns:asvg="http://schemas.microsoft.com/office/drawing/2016/SVG/main" r:embed="R53daed5d1d1d4d91"/>
+                <asvg:svgBlip xmlns:asvg="http://schemas.microsoft.com/office/drawing/2016/SVG/main" r:embed="R2fd3fe12836c472e"/>
               </a:ext>
             </a:extLst>
           </a:blip>
@@ -8340,7 +8425,7 @@
           <p:cNvPr id="6" name="">
             <a:extLst xmlns:a="http://schemas.openxmlformats.org/drawingml/2006/main">
               <a:ext uri="{FF2B5EF4-FFF2-40B4-BE49-F238E27FC236}">
-                <a16:creationId xmlns:a16="http://schemas.microsoft.com/office/drawing/2014/main" id="{9D019CA9-D4E7-497E-A67E-496C41F79B63}"/>
+                <a16:creationId xmlns:a16="http://schemas.microsoft.com/office/drawing/2014/main" id="{6651F722-6255-47F0-B60A-90F64F172B9F}"/>
               </a:ext>
             </a:extLst>
           </p:cNvPr>
@@ -8398,7 +8483,7 @@
           <p:cNvPr id="7" name="">
             <a:extLst xmlns:a="http://schemas.openxmlformats.org/drawingml/2006/main">
               <a:ext uri="{FF2B5EF4-FFF2-40B4-BE49-F238E27FC236}">
-                <a16:creationId xmlns:a16="http://schemas.microsoft.com/office/drawing/2014/main" id="{BBF2F6A5-7C91-4EEA-A07F-0C5A7ACBA7FE}"/>
+                <a16:creationId xmlns:a16="http://schemas.microsoft.com/office/drawing/2014/main" id="{7C4B2EBF-22E8-45AF-A461-A1BFD27A90B7}"/>
               </a:ext>
             </a:extLst>
           </p:cNvPr>
@@ -8456,7 +8541,7 @@
           <p:cNvPr id="8" name="">
             <a:extLst xmlns:a="http://schemas.openxmlformats.org/drawingml/2006/main">
               <a:ext uri="{FF2B5EF4-FFF2-40B4-BE49-F238E27FC236}">
-                <a16:creationId xmlns:a16="http://schemas.microsoft.com/office/drawing/2014/main" id="{8DDD1033-A39D-4AB4-A9F2-982C38DF6A31}"/>
+                <a16:creationId xmlns:a16="http://schemas.microsoft.com/office/drawing/2014/main" id="{5A85964D-DF88-41A5-9E3A-64A31B2A48F5}"/>
               </a:ext>
             </a:extLst>
           </p:cNvPr>
@@ -8518,7 +8603,7 @@
           <p:cNvPr id="9" name="">
             <a:extLst xmlns:a="http://schemas.openxmlformats.org/drawingml/2006/main">
               <a:ext uri="{FF2B5EF4-FFF2-40B4-BE49-F238E27FC236}">
-                <a16:creationId xmlns:a16="http://schemas.microsoft.com/office/drawing/2014/main" id="{CB4160F9-B72E-4C4D-91B9-1DBD0B69015B}"/>
+                <a16:creationId xmlns:a16="http://schemas.microsoft.com/office/drawing/2014/main" id="{C03552FD-6AEB-4D7B-8E96-6EFCD1746135}"/>
               </a:ext>
             </a:extLst>
           </p:cNvPr>
@@ -8576,7 +8661,7 @@
           <p:cNvPr id="10" name="">
             <a:extLst xmlns:a="http://schemas.openxmlformats.org/drawingml/2006/main">
               <a:ext uri="{FF2B5EF4-FFF2-40B4-BE49-F238E27FC236}">
-                <a16:creationId xmlns:a16="http://schemas.microsoft.com/office/drawing/2014/main" id="{07F28D12-23EC-4852-BBE1-1D3B9F392DAC}"/>
+                <a16:creationId xmlns:a16="http://schemas.microsoft.com/office/drawing/2014/main" id="{B4AAA78E-5A65-41D4-9ADF-5A9EFE78CBDA}"/>
               </a:ext>
             </a:extLst>
           </p:cNvPr>
@@ -8607,7 +8692,7 @@
           <p:cNvPr id="11" name="">
             <a:extLst xmlns:a="http://schemas.openxmlformats.org/drawingml/2006/main">
               <a:ext uri="{FF2B5EF4-FFF2-40B4-BE49-F238E27FC236}">
-                <a16:creationId xmlns:a16="http://schemas.microsoft.com/office/drawing/2014/main" id="{529A3E7A-5F6C-487B-BD32-0187FAADD892}"/>
+                <a16:creationId xmlns:a16="http://schemas.microsoft.com/office/drawing/2014/main" id="{382BD885-2388-4074-B326-81D30B290F55}"/>
               </a:ext>
             </a:extLst>
           </p:cNvPr>
@@ -8640,7 +8725,7 @@
           <p:cNvPr id="12" name="">
             <a:extLst xmlns:a="http://schemas.openxmlformats.org/drawingml/2006/main">
               <a:ext uri="{FF2B5EF4-FFF2-40B4-BE49-F238E27FC236}">
-                <a16:creationId xmlns:a16="http://schemas.microsoft.com/office/drawing/2014/main" id="{ADF1BF88-0CB6-4AC5-A6C0-DDD907835F75}"/>
+                <a16:creationId xmlns:a16="http://schemas.microsoft.com/office/drawing/2014/main" id="{629995D3-7FE4-44F9-A193-F3DB0801E97B}"/>
               </a:ext>
             </a:extLst>
           </p:cNvPr>
@@ -8698,7 +8783,7 @@
           <p:cNvPr id="13" name="">
             <a:extLst xmlns:a="http://schemas.openxmlformats.org/drawingml/2006/main">
               <a:ext uri="{FF2B5EF4-FFF2-40B4-BE49-F238E27FC236}">
-                <a16:creationId xmlns:a16="http://schemas.microsoft.com/office/drawing/2014/main" id="{3E95993B-BA91-495A-BDE0-E02478AE39CF}"/>
+                <a16:creationId xmlns:a16="http://schemas.microsoft.com/office/drawing/2014/main" id="{D1503566-2715-41BC-937C-6AC92809C5E5}"/>
               </a:ext>
             </a:extLst>
           </p:cNvPr>
@@ -8756,7 +8841,7 @@
           <p:cNvPr id="14" name="">
             <a:extLst xmlns:a="http://schemas.openxmlformats.org/drawingml/2006/main">
               <a:ext uri="{FF2B5EF4-FFF2-40B4-BE49-F238E27FC236}">
-                <a16:creationId xmlns:a16="http://schemas.microsoft.com/office/drawing/2014/main" id="{E2FC45D6-D24B-4C5C-9547-8E6AE83A415E}"/>
+                <a16:creationId xmlns:a16="http://schemas.microsoft.com/office/drawing/2014/main" id="{939ABD3F-84FA-4AB4-A2AC-A8A9777E57A3}"/>
               </a:ext>
             </a:extLst>
           </p:cNvPr>
@@ -8814,7 +8899,7 @@
           <p:cNvPr id="15" name="">
             <a:extLst xmlns:a="http://schemas.openxmlformats.org/drawingml/2006/main">
               <a:ext uri="{FF2B5EF4-FFF2-40B4-BE49-F238E27FC236}">
-                <a16:creationId xmlns:a16="http://schemas.microsoft.com/office/drawing/2014/main" id="{5AEEF901-E9AE-4CFE-991B-1F2D954029C3}"/>
+                <a16:creationId xmlns:a16="http://schemas.microsoft.com/office/drawing/2014/main" id="{51245AC4-5AA2-4EDE-B833-F95CB47ADA0C}"/>
               </a:ext>
             </a:extLst>
           </p:cNvPr>
@@ -8847,7 +8932,7 @@
           <p:cNvPr id="16" name="">
             <a:extLst xmlns:a="http://schemas.openxmlformats.org/drawingml/2006/main">
               <a:ext uri="{FF2B5EF4-FFF2-40B4-BE49-F238E27FC236}">
-                <a16:creationId xmlns:a16="http://schemas.microsoft.com/office/drawing/2014/main" id="{AAB110E7-0E9C-4A11-82D6-9B803B9624A3}"/>
+                <a16:creationId xmlns:a16="http://schemas.microsoft.com/office/drawing/2014/main" id="{D65D5B28-484F-41DE-ABC3-CC33AF7ECAAC}"/>
               </a:ext>
             </a:extLst>
           </p:cNvPr>
@@ -8905,7 +8990,7 @@
           <p:cNvPr id="17" name="">
             <a:extLst xmlns:a="http://schemas.openxmlformats.org/drawingml/2006/main">
               <a:ext uri="{FF2B5EF4-FFF2-40B4-BE49-F238E27FC236}">
-                <a16:creationId xmlns:a16="http://schemas.microsoft.com/office/drawing/2014/main" id="{09AEE580-E682-48B0-98AD-EF40EF037BAC}"/>
+                <a16:creationId xmlns:a16="http://schemas.microsoft.com/office/drawing/2014/main" id="{FC57177D-5089-4219-A48F-D02C0FFC47AD}"/>
               </a:ext>
             </a:extLst>
           </p:cNvPr>
@@ -8963,7 +9048,7 @@
           <p:cNvPr id="18" name="">
             <a:extLst xmlns:a="http://schemas.openxmlformats.org/drawingml/2006/main">
               <a:ext uri="{FF2B5EF4-FFF2-40B4-BE49-F238E27FC236}">
-                <a16:creationId xmlns:a16="http://schemas.microsoft.com/office/drawing/2014/main" id="{A4A3EAA9-C9DD-4106-B8B1-54089C86196B}"/>
+                <a16:creationId xmlns:a16="http://schemas.microsoft.com/office/drawing/2014/main" id="{61E2A90C-118D-40A0-8135-E48DAD2EC9C3}"/>
               </a:ext>
             </a:extLst>
           </p:cNvPr>
@@ -9021,7 +9106,7 @@
           <p:cNvPr id="19" name="">
             <a:extLst xmlns:a="http://schemas.openxmlformats.org/drawingml/2006/main">
               <a:ext uri="{FF2B5EF4-FFF2-40B4-BE49-F238E27FC236}">
-                <a16:creationId xmlns:a16="http://schemas.microsoft.com/office/drawing/2014/main" id="{E23BF6B2-1A47-4078-8140-BA015F80F877}"/>
+                <a16:creationId xmlns:a16="http://schemas.microsoft.com/office/drawing/2014/main" id="{D0513210-2BD7-4737-BC9C-2101CD212797}"/>
               </a:ext>
             </a:extLst>
           </p:cNvPr>
@@ -9054,7 +9139,7 @@
           <p:cNvPr id="20" name="">
             <a:extLst xmlns:a="http://schemas.openxmlformats.org/drawingml/2006/main">
               <a:ext uri="{FF2B5EF4-FFF2-40B4-BE49-F238E27FC236}">
-                <a16:creationId xmlns:a16="http://schemas.microsoft.com/office/drawing/2014/main" id="{BDE5C8BD-A72D-4171-8C14-31DDF9F8CD85}"/>
+                <a16:creationId xmlns:a16="http://schemas.microsoft.com/office/drawing/2014/main" id="{A70BFED2-8893-4C75-86CF-3A0B98AC78AD}"/>
               </a:ext>
             </a:extLst>
           </p:cNvPr>
@@ -9112,7 +9197,7 @@
           <p:cNvPr id="21" name="">
             <a:extLst xmlns:a="http://schemas.openxmlformats.org/drawingml/2006/main">
               <a:ext uri="{FF2B5EF4-FFF2-40B4-BE49-F238E27FC236}">
-                <a16:creationId xmlns:a16="http://schemas.microsoft.com/office/drawing/2014/main" id="{24F31647-22C2-433A-8300-7E10316CB34C}"/>
+                <a16:creationId xmlns:a16="http://schemas.microsoft.com/office/drawing/2014/main" id="{48F8A8F5-E1E8-45DA-9493-62CDE0D36A4B}"/>
               </a:ext>
             </a:extLst>
           </p:cNvPr>
@@ -9170,7 +9255,7 @@
           <p:cNvPr id="22" name="">
             <a:extLst xmlns:a="http://schemas.openxmlformats.org/drawingml/2006/main">
               <a:ext uri="{FF2B5EF4-FFF2-40B4-BE49-F238E27FC236}">
-                <a16:creationId xmlns:a16="http://schemas.microsoft.com/office/drawing/2014/main" id="{B702C6E8-76B4-448A-9BB6-EC95000967EC}"/>
+                <a16:creationId xmlns:a16="http://schemas.microsoft.com/office/drawing/2014/main" id="{655581B0-45BF-4BB7-803D-C38DFA409B0A}"/>
               </a:ext>
             </a:extLst>
           </p:cNvPr>
@@ -9228,7 +9313,7 @@
           <p:cNvPr id="23" name="">
             <a:extLst xmlns:a="http://schemas.openxmlformats.org/drawingml/2006/main">
               <a:ext uri="{FF2B5EF4-FFF2-40B4-BE49-F238E27FC236}">
-                <a16:creationId xmlns:a16="http://schemas.microsoft.com/office/drawing/2014/main" id="{C79CF974-124B-48A9-9FE8-DAC34E370A33}"/>
+                <a16:creationId xmlns:a16="http://schemas.microsoft.com/office/drawing/2014/main" id="{D8C538FD-7D73-4492-88ED-B8B3E2892DBC}"/>
               </a:ext>
             </a:extLst>
           </p:cNvPr>
@@ -9261,7 +9346,7 @@
           <p:cNvPr id="24" name="">
             <a:extLst xmlns:a="http://schemas.openxmlformats.org/drawingml/2006/main">
               <a:ext uri="{FF2B5EF4-FFF2-40B4-BE49-F238E27FC236}">
-                <a16:creationId xmlns:a16="http://schemas.microsoft.com/office/drawing/2014/main" id="{C1BF475D-7B11-4C85-BC71-7F3DC7F6023B}"/>
+                <a16:creationId xmlns:a16="http://schemas.microsoft.com/office/drawing/2014/main" id="{2676AA53-D5B4-4056-A5BD-E8C2FE26FEE7}"/>
               </a:ext>
             </a:extLst>
           </p:cNvPr>
@@ -9319,7 +9404,7 @@
           <p:cNvPr id="25" name="">
             <a:extLst xmlns:a="http://schemas.openxmlformats.org/drawingml/2006/main">
               <a:ext uri="{FF2B5EF4-FFF2-40B4-BE49-F238E27FC236}">
-                <a16:creationId xmlns:a16="http://schemas.microsoft.com/office/drawing/2014/main" id="{31F89086-1ECC-4A5E-8DD6-2F1B1312AFF2}"/>
+                <a16:creationId xmlns:a16="http://schemas.microsoft.com/office/drawing/2014/main" id="{CF80B474-097D-42D9-9312-8849AEBCEB52}"/>
               </a:ext>
             </a:extLst>
           </p:cNvPr>
@@ -9377,7 +9462,7 @@
           <p:cNvPr id="26" name="">
             <a:extLst xmlns:a="http://schemas.openxmlformats.org/drawingml/2006/main">
               <a:ext uri="{FF2B5EF4-FFF2-40B4-BE49-F238E27FC236}">
-                <a16:creationId xmlns:a16="http://schemas.microsoft.com/office/drawing/2014/main" id="{8CAFA2A2-BB3E-4426-862F-57F3E3484348}"/>
+                <a16:creationId xmlns:a16="http://schemas.microsoft.com/office/drawing/2014/main" id="{55CCF9D1-33DC-40F0-BC76-BF22328BD28E}"/>
               </a:ext>
             </a:extLst>
           </p:cNvPr>
@@ -9435,7 +9520,7 @@
           <p:cNvPr id="27" name="action-queue-shot-frame">
             <a:extLst xmlns:a="http://schemas.openxmlformats.org/drawingml/2006/main">
               <a:ext uri="{FF2B5EF4-FFF2-40B4-BE49-F238E27FC236}">
-                <a16:creationId xmlns:a16="http://schemas.microsoft.com/office/drawing/2014/main" id="{B8EA4A7E-38EA-44DD-8C9E-F603C5255DF5}"/>
+                <a16:creationId xmlns:a16="http://schemas.microsoft.com/office/drawing/2014/main" id="{E9BC5D2B-DE75-4410-B284-BA148400C2B5}"/>
               </a:ext>
             </a:extLst>
           </p:cNvPr>
@@ -9480,7 +9565,7 @@
           <p:nvPr/>
         </p:nvPicPr>
         <p:blipFill>
-          <a:blip xmlns:r="http://schemas.openxmlformats.org/officeDocument/2006/relationships" xmlns:a="http://schemas.openxmlformats.org/drawingml/2006/main" r:embed="R727ef6d6d28d453d"/>
+          <a:blip xmlns:r="http://schemas.openxmlformats.org/officeDocument/2006/relationships" xmlns:a="http://schemas.openxmlformats.org/drawingml/2006/main" r:embed="Rd8376ee45cb94ece"/>
           <a:srcRect xmlns:a="http://schemas.openxmlformats.org/drawingml/2006/main" l="33" t="0" r="33" b="0"/>
           <a:stretch xmlns:a="http://schemas.openxmlformats.org/drawingml/2006/main">
             <a:fillRect l="0" t="0" r="0" b="0"/>
@@ -9503,7 +9588,7 @@
           <p:cNvPr id="29" name="">
             <a:extLst xmlns:a="http://schemas.openxmlformats.org/drawingml/2006/main">
               <a:ext uri="{FF2B5EF4-FFF2-40B4-BE49-F238E27FC236}">
-                <a16:creationId xmlns:a16="http://schemas.microsoft.com/office/drawing/2014/main" id="{6165417F-55C8-4315-8127-AFBDC837428C}"/>
+                <a16:creationId xmlns:a16="http://schemas.microsoft.com/office/drawing/2014/main" id="{835F600A-DFA9-4A67-BB77-758899059D97}"/>
               </a:ext>
             </a:extLst>
           </p:cNvPr>
@@ -9561,7 +9646,7 @@
           <p:cNvPr id="30" name="">
             <a:extLst xmlns:a="http://schemas.openxmlformats.org/drawingml/2006/main">
               <a:ext uri="{FF2B5EF4-FFF2-40B4-BE49-F238E27FC236}">
-                <a16:creationId xmlns:a16="http://schemas.microsoft.com/office/drawing/2014/main" id="{E2794E91-A224-44CF-BF68-C0A4EFD026AC}"/>
+                <a16:creationId xmlns:a16="http://schemas.microsoft.com/office/drawing/2014/main" id="{1E7B7CB6-6D50-4358-80F5-27C76DE70062}"/>
               </a:ext>
             </a:extLst>
           </p:cNvPr>
@@ -9617,7 +9702,7 @@
     </p:spTree>
     <p:extLst>
       <p:ext uri="{BB962C8B-B14F-4D97-AF65-F5344CB8AC3E}">
-        <p14:creationId xmlns:p14="http://schemas.microsoft.com/office/powerpoint/2010/main" val="585381479"/>
+        <p14:creationId xmlns:p14="http://schemas.microsoft.com/office/powerpoint/2010/main" val="308439708"/>
       </p:ext>
     </p:extLst>
   </p:cSld>
@@ -9648,7 +9733,7 @@
           <p:cNvPr id="34" name="">
             <a:extLst xmlns:a="http://schemas.openxmlformats.org/drawingml/2006/main">
               <a:ext uri="{FF2B5EF4-FFF2-40B4-BE49-F238E27FC236}">
-                <a16:creationId xmlns:a16="http://schemas.microsoft.com/office/drawing/2014/main" id="{72C9A87E-F10C-4D65-A119-334B7D49F636}"/>
+                <a16:creationId xmlns:a16="http://schemas.microsoft.com/office/drawing/2014/main" id="{B57DD452-C947-406D-86F4-A25B02571A1D}"/>
               </a:ext>
             </a:extLst>
           </p:cNvPr>
@@ -9681,7 +9766,7 @@
           <p:cNvPr id="2" name="">
             <a:extLst xmlns:a="http://schemas.openxmlformats.org/drawingml/2006/main">
               <a:ext uri="{FF2B5EF4-FFF2-40B4-BE49-F238E27FC236}">
-                <a16:creationId xmlns:a16="http://schemas.microsoft.com/office/drawing/2014/main" id="{7FDC1D58-3CD9-458F-82E9-38BAF0D06BE9}"/>
+                <a16:creationId xmlns:a16="http://schemas.microsoft.com/office/drawing/2014/main" id="{EB9883A7-FE95-42EB-AB36-F2FD47309B54}"/>
               </a:ext>
             </a:extLst>
           </p:cNvPr>
@@ -9739,7 +9824,7 @@
           <p:cNvPr id="3" name="">
             <a:extLst xmlns:a="http://schemas.openxmlformats.org/drawingml/2006/main">
               <a:ext uri="{FF2B5EF4-FFF2-40B4-BE49-F238E27FC236}">
-                <a16:creationId xmlns:a16="http://schemas.microsoft.com/office/drawing/2014/main" id="{55BDEBB3-323E-4C10-BDF5-8D073A3D1304}"/>
+                <a16:creationId xmlns:a16="http://schemas.microsoft.com/office/drawing/2014/main" id="{13203BF0-3E60-4521-9D15-01816CD5359D}"/>
               </a:ext>
             </a:extLst>
           </p:cNvPr>
@@ -9797,7 +9882,7 @@
           <p:cNvPr id="4" name="">
             <a:extLst xmlns:a="http://schemas.openxmlformats.org/drawingml/2006/main">
               <a:ext uri="{FF2B5EF4-FFF2-40B4-BE49-F238E27FC236}">
-                <a16:creationId xmlns:a16="http://schemas.microsoft.com/office/drawing/2014/main" id="{247B6235-1650-446F-90C9-3A77EF1C956A}"/>
+                <a16:creationId xmlns:a16="http://schemas.microsoft.com/office/drawing/2014/main" id="{73A5C577-56F7-4D78-B0FE-68255AD7C181}"/>
               </a:ext>
             </a:extLst>
           </p:cNvPr>
@@ -9832,10 +9917,10 @@
           <p:nvPr/>
         </p:nvPicPr>
         <p:blipFill>
-          <a:blip xmlns:r="http://schemas.openxmlformats.org/officeDocument/2006/relationships" xmlns:a="http://schemas.openxmlformats.org/drawingml/2006/main" r:embed="Reb98867d40b04f94">
+          <a:blip xmlns:r="http://schemas.openxmlformats.org/officeDocument/2006/relationships" xmlns:a="http://schemas.openxmlformats.org/drawingml/2006/main" r:embed="R9ef94b2dcb26465c">
             <a:extLst>
               <a:ext uri="{96DAC541-7B7A-43D3-8B79-37D633B846F1}">
-                <asvg:svgBlip xmlns:asvg="http://schemas.microsoft.com/office/drawing/2016/SVG/main" r:embed="Rf0be59faed2e467e"/>
+                <asvg:svgBlip xmlns:asvg="http://schemas.microsoft.com/office/drawing/2016/SVG/main" r:embed="R09508e2701bd4030"/>
               </a:ext>
             </a:extLst>
           </a:blip>
@@ -9856,7 +9941,7 @@
           <p:cNvPr id="6" name="">
             <a:extLst xmlns:a="http://schemas.openxmlformats.org/drawingml/2006/main">
               <a:ext uri="{FF2B5EF4-FFF2-40B4-BE49-F238E27FC236}">
-                <a16:creationId xmlns:a16="http://schemas.microsoft.com/office/drawing/2014/main" id="{CACA81FE-74F8-47B4-8E76-9F97447C212D}"/>
+                <a16:creationId xmlns:a16="http://schemas.microsoft.com/office/drawing/2014/main" id="{04FAA04A-D07A-48F7-8D2A-AA75B066A367}"/>
               </a:ext>
             </a:extLst>
           </p:cNvPr>
@@ -9914,7 +9999,7 @@
           <p:cNvPr id="7" name="">
             <a:extLst xmlns:a="http://schemas.openxmlformats.org/drawingml/2006/main">
               <a:ext uri="{FF2B5EF4-FFF2-40B4-BE49-F238E27FC236}">
-                <a16:creationId xmlns:a16="http://schemas.microsoft.com/office/drawing/2014/main" id="{DE111D55-9915-4D83-911C-7D0A3792A17A}"/>
+                <a16:creationId xmlns:a16="http://schemas.microsoft.com/office/drawing/2014/main" id="{889283A1-D0CB-4B75-A156-46CD93B914E4}"/>
               </a:ext>
             </a:extLst>
           </p:cNvPr>
@@ -9972,7 +10057,7 @@
           <p:cNvPr id="8" name="">
             <a:extLst xmlns:a="http://schemas.openxmlformats.org/drawingml/2006/main">
               <a:ext uri="{FF2B5EF4-FFF2-40B4-BE49-F238E27FC236}">
-                <a16:creationId xmlns:a16="http://schemas.microsoft.com/office/drawing/2014/main" id="{23CF7380-50A6-4863-8FA6-8406FC199EC7}"/>
+                <a16:creationId xmlns:a16="http://schemas.microsoft.com/office/drawing/2014/main" id="{15A1A36F-E8E4-4643-81EB-775595B289DB}"/>
               </a:ext>
             </a:extLst>
           </p:cNvPr>
@@ -10034,7 +10119,7 @@
           <p:cNvPr id="9" name="">
             <a:extLst xmlns:a="http://schemas.openxmlformats.org/drawingml/2006/main">
               <a:ext uri="{FF2B5EF4-FFF2-40B4-BE49-F238E27FC236}">
-                <a16:creationId xmlns:a16="http://schemas.microsoft.com/office/drawing/2014/main" id="{A2A37E7D-F0EE-4AA2-9241-E1B1894333E1}"/>
+                <a16:creationId xmlns:a16="http://schemas.microsoft.com/office/drawing/2014/main" id="{BF6DD27F-F69D-4096-B645-2D98D80DC86B}"/>
               </a:ext>
             </a:extLst>
           </p:cNvPr>
@@ -10096,7 +10181,7 @@
           <p:cNvPr id="10" name="">
             <a:extLst xmlns:a="http://schemas.openxmlformats.org/drawingml/2006/main">
               <a:ext uri="{FF2B5EF4-FFF2-40B4-BE49-F238E27FC236}">
-                <a16:creationId xmlns:a16="http://schemas.microsoft.com/office/drawing/2014/main" id="{B7716398-1995-4A44-8EE8-43F86567BECF}"/>
+                <a16:creationId xmlns:a16="http://schemas.microsoft.com/office/drawing/2014/main" id="{5AFA0A07-72E7-4FFB-8A93-98C608D263CF}"/>
               </a:ext>
             </a:extLst>
           </p:cNvPr>
@@ -10154,7 +10239,7 @@
           <p:cNvPr id="11" name="">
             <a:extLst xmlns:a="http://schemas.openxmlformats.org/drawingml/2006/main">
               <a:ext uri="{FF2B5EF4-FFF2-40B4-BE49-F238E27FC236}">
-                <a16:creationId xmlns:a16="http://schemas.microsoft.com/office/drawing/2014/main" id="{13B74C2D-D171-4A77-93A2-EAA8982FADE2}"/>
+                <a16:creationId xmlns:a16="http://schemas.microsoft.com/office/drawing/2014/main" id="{52A07173-8B10-46AF-A58B-CA644371B6DF}"/>
               </a:ext>
             </a:extLst>
           </p:cNvPr>
@@ -10212,7 +10297,7 @@
           <p:cNvPr id="12" name="">
             <a:extLst xmlns:a="http://schemas.openxmlformats.org/drawingml/2006/main">
               <a:ext uri="{FF2B5EF4-FFF2-40B4-BE49-F238E27FC236}">
-                <a16:creationId xmlns:a16="http://schemas.microsoft.com/office/drawing/2014/main" id="{0FB94E3C-74D6-4D5C-AE49-3EE9C1AA2108}"/>
+                <a16:creationId xmlns:a16="http://schemas.microsoft.com/office/drawing/2014/main" id="{3157AF99-FA21-47AB-A562-59A380DE6327}"/>
               </a:ext>
             </a:extLst>
           </p:cNvPr>
@@ -10274,7 +10359,7 @@
           <p:cNvPr id="13" name="">
             <a:extLst xmlns:a="http://schemas.openxmlformats.org/drawingml/2006/main">
               <a:ext uri="{FF2B5EF4-FFF2-40B4-BE49-F238E27FC236}">
-                <a16:creationId xmlns:a16="http://schemas.microsoft.com/office/drawing/2014/main" id="{DBE27312-3542-4F24-886D-08DC7E31E979}"/>
+                <a16:creationId xmlns:a16="http://schemas.microsoft.com/office/drawing/2014/main" id="{E752770E-3AA0-4717-A28C-D132191040F8}"/>
               </a:ext>
             </a:extLst>
           </p:cNvPr>
@@ -10332,7 +10417,7 @@
           <p:cNvPr id="14" name="">
             <a:extLst xmlns:a="http://schemas.openxmlformats.org/drawingml/2006/main">
               <a:ext uri="{FF2B5EF4-FFF2-40B4-BE49-F238E27FC236}">
-                <a16:creationId xmlns:a16="http://schemas.microsoft.com/office/drawing/2014/main" id="{262D70AC-FB5D-433A-8488-9C396F2F488F}"/>
+                <a16:creationId xmlns:a16="http://schemas.microsoft.com/office/drawing/2014/main" id="{DCAC7BF5-793E-4B4A-B239-766EF3E38841}"/>
               </a:ext>
             </a:extLst>
           </p:cNvPr>
@@ -10394,7 +10479,7 @@
           <p:cNvPr id="15" name="">
             <a:extLst xmlns:a="http://schemas.openxmlformats.org/drawingml/2006/main">
               <a:ext uri="{FF2B5EF4-FFF2-40B4-BE49-F238E27FC236}">
-                <a16:creationId xmlns:a16="http://schemas.microsoft.com/office/drawing/2014/main" id="{1B97D740-A6E9-4710-ADA1-F3761AADFF03}"/>
+                <a16:creationId xmlns:a16="http://schemas.microsoft.com/office/drawing/2014/main" id="{CB47F56F-43AB-4DD0-A3EF-4E36E977A553}"/>
               </a:ext>
             </a:extLst>
           </p:cNvPr>
@@ -10452,7 +10537,7 @@
           <p:cNvPr id="16" name="">
             <a:extLst xmlns:a="http://schemas.openxmlformats.org/drawingml/2006/main">
               <a:ext uri="{FF2B5EF4-FFF2-40B4-BE49-F238E27FC236}">
-                <a16:creationId xmlns:a16="http://schemas.microsoft.com/office/drawing/2014/main" id="{5178B79D-6EFF-4611-A580-A922916E4E94}"/>
+                <a16:creationId xmlns:a16="http://schemas.microsoft.com/office/drawing/2014/main" id="{C9F3F97D-3318-40DB-8C8E-9975090E6D75}"/>
               </a:ext>
             </a:extLst>
           </p:cNvPr>
@@ -10514,7 +10599,7 @@
           <p:cNvPr id="17" name="">
             <a:extLst xmlns:a="http://schemas.openxmlformats.org/drawingml/2006/main">
               <a:ext uri="{FF2B5EF4-FFF2-40B4-BE49-F238E27FC236}">
-                <a16:creationId xmlns:a16="http://schemas.microsoft.com/office/drawing/2014/main" id="{5FE28563-0181-4571-A714-5F8C8530CE9E}"/>
+                <a16:creationId xmlns:a16="http://schemas.microsoft.com/office/drawing/2014/main" id="{32383B46-22E3-4478-9CD4-74334A312C0D}"/>
               </a:ext>
             </a:extLst>
           </p:cNvPr>
@@ -10545,7 +10630,7 @@
           <p:cNvPr id="18" name="">
             <a:extLst xmlns:a="http://schemas.openxmlformats.org/drawingml/2006/main">
               <a:ext uri="{FF2B5EF4-FFF2-40B4-BE49-F238E27FC236}">
-                <a16:creationId xmlns:a16="http://schemas.microsoft.com/office/drawing/2014/main" id="{77A7F590-616B-4372-B1D5-A0BA9852597C}"/>
+                <a16:creationId xmlns:a16="http://schemas.microsoft.com/office/drawing/2014/main" id="{9FF3BF14-222F-4B7C-B515-5A0AC012FD6F}"/>
               </a:ext>
             </a:extLst>
           </p:cNvPr>
@@ -10603,7 +10688,7 @@
           <p:cNvPr id="19" name="">
             <a:extLst xmlns:a="http://schemas.openxmlformats.org/drawingml/2006/main">
               <a:ext uri="{FF2B5EF4-FFF2-40B4-BE49-F238E27FC236}">
-                <a16:creationId xmlns:a16="http://schemas.microsoft.com/office/drawing/2014/main" id="{D709FA31-DB26-4AE6-83E8-BD4E244DDED1}"/>
+                <a16:creationId xmlns:a16="http://schemas.microsoft.com/office/drawing/2014/main" id="{DCD4732E-8854-49F4-9D25-96B7C3CF3B36}"/>
               </a:ext>
             </a:extLst>
           </p:cNvPr>
@@ -10661,7 +10746,7 @@
           <p:cNvPr id="20" name="">
             <a:extLst xmlns:a="http://schemas.openxmlformats.org/drawingml/2006/main">
               <a:ext uri="{FF2B5EF4-FFF2-40B4-BE49-F238E27FC236}">
-                <a16:creationId xmlns:a16="http://schemas.microsoft.com/office/drawing/2014/main" id="{83F29988-0D1F-4EE3-9391-6E4CA3C5E8C2}"/>
+                <a16:creationId xmlns:a16="http://schemas.microsoft.com/office/drawing/2014/main" id="{6F7FED53-0BBB-4359-A4FC-07BDF9B4EA76}"/>
               </a:ext>
             </a:extLst>
           </p:cNvPr>
@@ -10719,7 +10804,7 @@
           <p:cNvPr id="21" name="">
             <a:extLst xmlns:a="http://schemas.openxmlformats.org/drawingml/2006/main">
               <a:ext uri="{FF2B5EF4-FFF2-40B4-BE49-F238E27FC236}">
-                <a16:creationId xmlns:a16="http://schemas.microsoft.com/office/drawing/2014/main" id="{D1D2240E-41D3-4CDD-AD8F-412F05DF88C6}"/>
+                <a16:creationId xmlns:a16="http://schemas.microsoft.com/office/drawing/2014/main" id="{50C99A7F-0357-47DB-A952-A2B02889B663}"/>
               </a:ext>
             </a:extLst>
           </p:cNvPr>
@@ -10750,7 +10835,7 @@
           <p:cNvPr id="22" name="">
             <a:extLst xmlns:a="http://schemas.openxmlformats.org/drawingml/2006/main">
               <a:ext uri="{FF2B5EF4-FFF2-40B4-BE49-F238E27FC236}">
-                <a16:creationId xmlns:a16="http://schemas.microsoft.com/office/drawing/2014/main" id="{28773471-B9AE-4C52-A682-0DA27854DB57}"/>
+                <a16:creationId xmlns:a16="http://schemas.microsoft.com/office/drawing/2014/main" id="{D8CAB0A4-861E-4C92-9101-5CB6A9223866}"/>
               </a:ext>
             </a:extLst>
           </p:cNvPr>
@@ -10808,7 +10893,7 @@
           <p:cNvPr id="23" name="">
             <a:extLst xmlns:a="http://schemas.openxmlformats.org/drawingml/2006/main">
               <a:ext uri="{FF2B5EF4-FFF2-40B4-BE49-F238E27FC236}">
-                <a16:creationId xmlns:a16="http://schemas.microsoft.com/office/drawing/2014/main" id="{42281C29-5685-4F8E-A161-19EF83663380}"/>
+                <a16:creationId xmlns:a16="http://schemas.microsoft.com/office/drawing/2014/main" id="{B6DDBBDA-A49B-454B-8C2E-60E35A1EA3BC}"/>
               </a:ext>
             </a:extLst>
           </p:cNvPr>
@@ -10866,7 +10951,7 @@
           <p:cNvPr id="24" name="">
             <a:extLst xmlns:a="http://schemas.openxmlformats.org/drawingml/2006/main">
               <a:ext uri="{FF2B5EF4-FFF2-40B4-BE49-F238E27FC236}">
-                <a16:creationId xmlns:a16="http://schemas.microsoft.com/office/drawing/2014/main" id="{6D2B30DC-CC39-4F78-BFF1-97E7A0E0869C}"/>
+                <a16:creationId xmlns:a16="http://schemas.microsoft.com/office/drawing/2014/main" id="{2608041F-91A8-4ADB-B993-580EDC0ED86A}"/>
               </a:ext>
             </a:extLst>
           </p:cNvPr>
@@ -10897,7 +10982,7 @@
           <p:cNvPr id="25" name="">
             <a:extLst xmlns:a="http://schemas.openxmlformats.org/drawingml/2006/main">
               <a:ext uri="{FF2B5EF4-FFF2-40B4-BE49-F238E27FC236}">
-                <a16:creationId xmlns:a16="http://schemas.microsoft.com/office/drawing/2014/main" id="{3E55E05D-E338-46B8-8274-3730F10A15B1}"/>
+                <a16:creationId xmlns:a16="http://schemas.microsoft.com/office/drawing/2014/main" id="{71F2EEEF-B193-4A23-8608-C2D981678CAA}"/>
               </a:ext>
             </a:extLst>
           </p:cNvPr>
@@ -10955,7 +11040,7 @@
           <p:cNvPr id="26" name="">
             <a:extLst xmlns:a="http://schemas.openxmlformats.org/drawingml/2006/main">
               <a:ext uri="{FF2B5EF4-FFF2-40B4-BE49-F238E27FC236}">
-                <a16:creationId xmlns:a16="http://schemas.microsoft.com/office/drawing/2014/main" id="{1D716EC1-3786-4AB2-9712-E76505C4EAE5}"/>
+                <a16:creationId xmlns:a16="http://schemas.microsoft.com/office/drawing/2014/main" id="{A264ED34-A087-4A00-AEC4-9BD8DB9F56F5}"/>
               </a:ext>
             </a:extLst>
           </p:cNvPr>
@@ -11013,7 +11098,7 @@
           <p:cNvPr id="27" name="">
             <a:extLst xmlns:a="http://schemas.openxmlformats.org/drawingml/2006/main">
               <a:ext uri="{FF2B5EF4-FFF2-40B4-BE49-F238E27FC236}">
-                <a16:creationId xmlns:a16="http://schemas.microsoft.com/office/drawing/2014/main" id="{A8A09D58-D220-44FE-B838-A9A1AE904BD7}"/>
+                <a16:creationId xmlns:a16="http://schemas.microsoft.com/office/drawing/2014/main" id="{75E44C15-AB80-4EE4-9663-EC2F914DCBCE}"/>
               </a:ext>
             </a:extLst>
           </p:cNvPr>
@@ -11044,7 +11129,7 @@
           <p:cNvPr id="28" name="">
             <a:extLst xmlns:a="http://schemas.openxmlformats.org/drawingml/2006/main">
               <a:ext uri="{FF2B5EF4-FFF2-40B4-BE49-F238E27FC236}">
-                <a16:creationId xmlns:a16="http://schemas.microsoft.com/office/drawing/2014/main" id="{5C7F90D7-5ED2-45A8-B7B9-DC8C84700D74}"/>
+                <a16:creationId xmlns:a16="http://schemas.microsoft.com/office/drawing/2014/main" id="{B037D4A4-1AD4-4736-885A-B9A3232B3079}"/>
               </a:ext>
             </a:extLst>
           </p:cNvPr>
@@ -11102,7 +11187,7 @@
           <p:cNvPr id="29" name="">
             <a:extLst xmlns:a="http://schemas.openxmlformats.org/drawingml/2006/main">
               <a:ext uri="{FF2B5EF4-FFF2-40B4-BE49-F238E27FC236}">
-                <a16:creationId xmlns:a16="http://schemas.microsoft.com/office/drawing/2014/main" id="{AED83E7A-D5BD-4C22-87A9-7D346BB50B78}"/>
+                <a16:creationId xmlns:a16="http://schemas.microsoft.com/office/drawing/2014/main" id="{DA313895-2E4A-4CE2-93A7-2B9239F2A951}"/>
               </a:ext>
             </a:extLst>
           </p:cNvPr>
@@ -11160,7 +11245,7 @@
           <p:cNvPr id="30" name="">
             <a:extLst xmlns:a="http://schemas.openxmlformats.org/drawingml/2006/main">
               <a:ext uri="{FF2B5EF4-FFF2-40B4-BE49-F238E27FC236}">
-                <a16:creationId xmlns:a16="http://schemas.microsoft.com/office/drawing/2014/main" id="{BAAC4396-7952-495C-A1A7-6A5CDACBACE1}"/>
+                <a16:creationId xmlns:a16="http://schemas.microsoft.com/office/drawing/2014/main" id="{CBB84777-4E89-4943-96FF-B02BD9069D2E}"/>
               </a:ext>
             </a:extLst>
           </p:cNvPr>
@@ -11191,7 +11276,7 @@
           <p:cNvPr id="31" name="">
             <a:extLst xmlns:a="http://schemas.openxmlformats.org/drawingml/2006/main">
               <a:ext uri="{FF2B5EF4-FFF2-40B4-BE49-F238E27FC236}">
-                <a16:creationId xmlns:a16="http://schemas.microsoft.com/office/drawing/2014/main" id="{E7CF6709-1BFF-4A81-AAD0-C7F74481F833}"/>
+                <a16:creationId xmlns:a16="http://schemas.microsoft.com/office/drawing/2014/main" id="{DCE24188-77AB-4E04-9EE4-1AFA4FEAADC4}"/>
               </a:ext>
             </a:extLst>
           </p:cNvPr>
@@ -11226,7 +11311,7 @@
           <p:cNvPr id="32" name="">
             <a:extLst xmlns:a="http://schemas.openxmlformats.org/drawingml/2006/main">
               <a:ext uri="{FF2B5EF4-FFF2-40B4-BE49-F238E27FC236}">
-                <a16:creationId xmlns:a16="http://schemas.microsoft.com/office/drawing/2014/main" id="{978D36D6-BE91-4E1F-94B3-EDFC66A6DC08}"/>
+                <a16:creationId xmlns:a16="http://schemas.microsoft.com/office/drawing/2014/main" id="{26B4AF40-0DB6-4974-8846-2D35E1A82A29}"/>
               </a:ext>
             </a:extLst>
           </p:cNvPr>
@@ -11284,7 +11369,7 @@
           <p:cNvPr id="33" name="">
             <a:extLst xmlns:a="http://schemas.openxmlformats.org/drawingml/2006/main">
               <a:ext uri="{FF2B5EF4-FFF2-40B4-BE49-F238E27FC236}">
-                <a16:creationId xmlns:a16="http://schemas.microsoft.com/office/drawing/2014/main" id="{434D0E10-D4CA-4DD5-BA8A-22F3311314FC}"/>
+                <a16:creationId xmlns:a16="http://schemas.microsoft.com/office/drawing/2014/main" id="{B5393B6F-09D6-43C9-AC12-047411342CBB}"/>
               </a:ext>
             </a:extLst>
           </p:cNvPr>
@@ -11340,7 +11425,7 @@
     </p:spTree>
     <p:extLst>
       <p:ext uri="{BB962C8B-B14F-4D97-AF65-F5344CB8AC3E}">
-        <p14:creationId xmlns:p14="http://schemas.microsoft.com/office/powerpoint/2010/main" val="1669156536"/>
+        <p14:creationId xmlns:p14="http://schemas.microsoft.com/office/powerpoint/2010/main" val="1033349908"/>
       </p:ext>
     </p:extLst>
   </p:cSld>
@@ -11371,7 +11456,7 @@
           <p:cNvPr id="35" name="">
             <a:extLst xmlns:a="http://schemas.openxmlformats.org/drawingml/2006/main">
               <a:ext uri="{FF2B5EF4-FFF2-40B4-BE49-F238E27FC236}">
-                <a16:creationId xmlns:a16="http://schemas.microsoft.com/office/drawing/2014/main" id="{2FE25834-F772-46DF-A2DB-4AFD2D9EB42F}"/>
+                <a16:creationId xmlns:a16="http://schemas.microsoft.com/office/drawing/2014/main" id="{43D21ED1-4432-4282-8657-4848E4370382}"/>
               </a:ext>
             </a:extLst>
           </p:cNvPr>
@@ -11404,7 +11489,7 @@
           <p:cNvPr id="2" name="">
             <a:extLst xmlns:a="http://schemas.openxmlformats.org/drawingml/2006/main">
               <a:ext uri="{FF2B5EF4-FFF2-40B4-BE49-F238E27FC236}">
-                <a16:creationId xmlns:a16="http://schemas.microsoft.com/office/drawing/2014/main" id="{2A29C29C-12EE-4550-9A7E-9319EA5599FC}"/>
+                <a16:creationId xmlns:a16="http://schemas.microsoft.com/office/drawing/2014/main" id="{987F3A70-209A-4AE9-A5D4-A31972998B70}"/>
               </a:ext>
             </a:extLst>
           </p:cNvPr>
@@ -11462,7 +11547,7 @@
           <p:cNvPr id="3" name="">
             <a:extLst xmlns:a="http://schemas.openxmlformats.org/drawingml/2006/main">
               <a:ext uri="{FF2B5EF4-FFF2-40B4-BE49-F238E27FC236}">
-                <a16:creationId xmlns:a16="http://schemas.microsoft.com/office/drawing/2014/main" id="{704B0E42-6659-48B9-B577-AD707EAB6E15}"/>
+                <a16:creationId xmlns:a16="http://schemas.microsoft.com/office/drawing/2014/main" id="{4E7453AC-62E0-4B49-AFE7-9B160EDC179D}"/>
               </a:ext>
             </a:extLst>
           </p:cNvPr>
@@ -11520,7 +11605,7 @@
           <p:cNvPr id="4" name="">
             <a:extLst xmlns:a="http://schemas.openxmlformats.org/drawingml/2006/main">
               <a:ext uri="{FF2B5EF4-FFF2-40B4-BE49-F238E27FC236}">
-                <a16:creationId xmlns:a16="http://schemas.microsoft.com/office/drawing/2014/main" id="{312D3797-6E5C-42E8-819E-64239E22C296}"/>
+                <a16:creationId xmlns:a16="http://schemas.microsoft.com/office/drawing/2014/main" id="{4748C9EE-7941-4FE9-B277-DA70166D74D0}"/>
               </a:ext>
             </a:extLst>
           </p:cNvPr>
@@ -11555,10 +11640,10 @@
           <p:nvPr/>
         </p:nvPicPr>
         <p:blipFill>
-          <a:blip xmlns:r="http://schemas.openxmlformats.org/officeDocument/2006/relationships" xmlns:a="http://schemas.openxmlformats.org/drawingml/2006/main" r:embed="Re91169c4810d4b1d">
+          <a:blip xmlns:r="http://schemas.openxmlformats.org/officeDocument/2006/relationships" xmlns:a="http://schemas.openxmlformats.org/drawingml/2006/main" r:embed="R85a041005de441b4">
             <a:extLst>
               <a:ext uri="{96DAC541-7B7A-43D3-8B79-37D633B846F1}">
-                <asvg:svgBlip xmlns:asvg="http://schemas.microsoft.com/office/drawing/2016/SVG/main" r:embed="R272dc6684a1a41df"/>
+                <asvg:svgBlip xmlns:asvg="http://schemas.microsoft.com/office/drawing/2016/SVG/main" r:embed="Rb133f72790164373"/>
               </a:ext>
             </a:extLst>
           </a:blip>
@@ -11579,7 +11664,7 @@
           <p:cNvPr id="6" name="">
             <a:extLst xmlns:a="http://schemas.openxmlformats.org/drawingml/2006/main">
               <a:ext uri="{FF2B5EF4-FFF2-40B4-BE49-F238E27FC236}">
-                <a16:creationId xmlns:a16="http://schemas.microsoft.com/office/drawing/2014/main" id="{8EBBF4B5-5026-4CD2-94B9-5EF3CD78A8FF}"/>
+                <a16:creationId xmlns:a16="http://schemas.microsoft.com/office/drawing/2014/main" id="{97D1FA2A-4D91-4BA8-9167-DAE5FB4E0AA6}"/>
               </a:ext>
             </a:extLst>
           </p:cNvPr>
@@ -11637,7 +11722,7 @@
           <p:cNvPr id="7" name="">
             <a:extLst xmlns:a="http://schemas.openxmlformats.org/drawingml/2006/main">
               <a:ext uri="{FF2B5EF4-FFF2-40B4-BE49-F238E27FC236}">
-                <a16:creationId xmlns:a16="http://schemas.microsoft.com/office/drawing/2014/main" id="{AC829477-469D-4E08-A54A-C74C6E680900}"/>
+                <a16:creationId xmlns:a16="http://schemas.microsoft.com/office/drawing/2014/main" id="{BDA6BE30-80D0-4326-AB5C-7EDDF43CC4E1}"/>
               </a:ext>
             </a:extLst>
           </p:cNvPr>
@@ -11695,7 +11780,7 @@
           <p:cNvPr id="8" name="">
             <a:extLst xmlns:a="http://schemas.openxmlformats.org/drawingml/2006/main">
               <a:ext uri="{FF2B5EF4-FFF2-40B4-BE49-F238E27FC236}">
-                <a16:creationId xmlns:a16="http://schemas.microsoft.com/office/drawing/2014/main" id="{5A3CABFC-295D-40DC-B285-CDFA27CD22FC}"/>
+                <a16:creationId xmlns:a16="http://schemas.microsoft.com/office/drawing/2014/main" id="{FD4A69CC-AFC9-48DC-A6A7-DB4E580C74F8}"/>
               </a:ext>
             </a:extLst>
           </p:cNvPr>
@@ -11757,7 +11842,7 @@
           <p:cNvPr id="9" name="">
             <a:extLst xmlns:a="http://schemas.openxmlformats.org/drawingml/2006/main">
               <a:ext uri="{FF2B5EF4-FFF2-40B4-BE49-F238E27FC236}">
-                <a16:creationId xmlns:a16="http://schemas.microsoft.com/office/drawing/2014/main" id="{2FDDB06C-C064-40BB-A79A-A71ADB646924}"/>
+                <a16:creationId xmlns:a16="http://schemas.microsoft.com/office/drawing/2014/main" id="{CEF23AF5-505F-4839-9202-C715A7E0EF29}"/>
               </a:ext>
             </a:extLst>
           </p:cNvPr>
@@ -11815,7 +11900,7 @@
           <p:cNvPr id="10" name="">
             <a:extLst xmlns:a="http://schemas.openxmlformats.org/drawingml/2006/main">
               <a:ext uri="{FF2B5EF4-FFF2-40B4-BE49-F238E27FC236}">
-                <a16:creationId xmlns:a16="http://schemas.microsoft.com/office/drawing/2014/main" id="{60B2700E-B968-4848-8D1B-514D2D6C3E07}"/>
+                <a16:creationId xmlns:a16="http://schemas.microsoft.com/office/drawing/2014/main" id="{2455E094-B6B1-43EA-A1B3-45430C0F56D9}"/>
               </a:ext>
             </a:extLst>
           </p:cNvPr>
@@ -11846,7 +11931,7 @@
           <p:cNvPr id="11" name="">
             <a:extLst xmlns:a="http://schemas.openxmlformats.org/drawingml/2006/main">
               <a:ext uri="{FF2B5EF4-FFF2-40B4-BE49-F238E27FC236}">
-                <a16:creationId xmlns:a16="http://schemas.microsoft.com/office/drawing/2014/main" id="{493EF6A4-D39D-4758-AC0D-64B2E869528F}"/>
+                <a16:creationId xmlns:a16="http://schemas.microsoft.com/office/drawing/2014/main" id="{38DE0A5A-3B30-483D-A93B-3828CECE8189}"/>
               </a:ext>
             </a:extLst>
           </p:cNvPr>
@@ -11877,7 +11962,7 @@
           <p:cNvPr id="12" name="">
             <a:extLst xmlns:a="http://schemas.openxmlformats.org/drawingml/2006/main">
               <a:ext uri="{FF2B5EF4-FFF2-40B4-BE49-F238E27FC236}">
-                <a16:creationId xmlns:a16="http://schemas.microsoft.com/office/drawing/2014/main" id="{20AC9C75-84C4-4A1A-814A-91D5B5D69455}"/>
+                <a16:creationId xmlns:a16="http://schemas.microsoft.com/office/drawing/2014/main" id="{7898CC8D-A479-45AD-BAD2-3A5EE1987AF9}"/>
               </a:ext>
             </a:extLst>
           </p:cNvPr>
@@ -11908,7 +11993,7 @@
           <p:cNvPr id="13" name="">
             <a:extLst xmlns:a="http://schemas.openxmlformats.org/drawingml/2006/main">
               <a:ext uri="{FF2B5EF4-FFF2-40B4-BE49-F238E27FC236}">
-                <a16:creationId xmlns:a16="http://schemas.microsoft.com/office/drawing/2014/main" id="{B15A7892-1CB8-4BE2-AC11-B8888B1F4BEC}"/>
+                <a16:creationId xmlns:a16="http://schemas.microsoft.com/office/drawing/2014/main" id="{CA6FEBB7-E070-407D-AE4A-D2DA5B9E4EB4}"/>
               </a:ext>
             </a:extLst>
           </p:cNvPr>
@@ -11966,7 +12051,7 @@
           <p:cNvPr id="14" name="">
             <a:extLst xmlns:a="http://schemas.openxmlformats.org/drawingml/2006/main">
               <a:ext uri="{FF2B5EF4-FFF2-40B4-BE49-F238E27FC236}">
-                <a16:creationId xmlns:a16="http://schemas.microsoft.com/office/drawing/2014/main" id="{6FAC9A9F-DB6C-42C2-AACC-3F24503A5654}"/>
+                <a16:creationId xmlns:a16="http://schemas.microsoft.com/office/drawing/2014/main" id="{9DB8711F-BEC9-4BB8-A9D5-CB0AA939DE9D}"/>
               </a:ext>
             </a:extLst>
           </p:cNvPr>
@@ -12028,7 +12113,7 @@
           <p:cNvPr id="15" name="">
             <a:extLst xmlns:a="http://schemas.openxmlformats.org/drawingml/2006/main">
               <a:ext uri="{FF2B5EF4-FFF2-40B4-BE49-F238E27FC236}">
-                <a16:creationId xmlns:a16="http://schemas.microsoft.com/office/drawing/2014/main" id="{EAD7E55B-C434-400D-B9F6-8AEC6F7BA71E}"/>
+                <a16:creationId xmlns:a16="http://schemas.microsoft.com/office/drawing/2014/main" id="{288B20DB-FA0A-4D5F-8705-B10026AC73AA}"/>
               </a:ext>
             </a:extLst>
           </p:cNvPr>
@@ -12059,7 +12144,7 @@
           <p:cNvPr id="16" name="">
             <a:extLst xmlns:a="http://schemas.openxmlformats.org/drawingml/2006/main">
               <a:ext uri="{FF2B5EF4-FFF2-40B4-BE49-F238E27FC236}">
-                <a16:creationId xmlns:a16="http://schemas.microsoft.com/office/drawing/2014/main" id="{130DF629-5D93-4226-BA34-32E062B8CDC3}"/>
+                <a16:creationId xmlns:a16="http://schemas.microsoft.com/office/drawing/2014/main" id="{CDFB983D-272F-432D-A552-80289AEF3C4D}"/>
               </a:ext>
             </a:extLst>
           </p:cNvPr>
@@ -12148,7 +12233,7 @@
           <p:cNvPr id="17" name="">
             <a:extLst xmlns:a="http://schemas.openxmlformats.org/drawingml/2006/main">
               <a:ext uri="{FF2B5EF4-FFF2-40B4-BE49-F238E27FC236}">
-                <a16:creationId xmlns:a16="http://schemas.microsoft.com/office/drawing/2014/main" id="{61B0BED6-534F-45D3-B581-A0163BBD64C0}"/>
+                <a16:creationId xmlns:a16="http://schemas.microsoft.com/office/drawing/2014/main" id="{69658146-517A-442B-87D7-5D7A35F4F5EB}"/>
               </a:ext>
             </a:extLst>
           </p:cNvPr>
@@ -12206,7 +12291,7 @@
           <p:cNvPr id="18" name="">
             <a:extLst xmlns:a="http://schemas.openxmlformats.org/drawingml/2006/main">
               <a:ext uri="{FF2B5EF4-FFF2-40B4-BE49-F238E27FC236}">
-                <a16:creationId xmlns:a16="http://schemas.microsoft.com/office/drawing/2014/main" id="{6BD1ADA5-969F-4B4F-B4B4-1140845F53CC}"/>
+                <a16:creationId xmlns:a16="http://schemas.microsoft.com/office/drawing/2014/main" id="{0C1A5332-B2A9-48D3-9609-CA3C584A215D}"/>
               </a:ext>
             </a:extLst>
           </p:cNvPr>
@@ -12268,7 +12353,7 @@
           <p:cNvPr id="19" name="">
             <a:extLst xmlns:a="http://schemas.openxmlformats.org/drawingml/2006/main">
               <a:ext uri="{FF2B5EF4-FFF2-40B4-BE49-F238E27FC236}">
-                <a16:creationId xmlns:a16="http://schemas.microsoft.com/office/drawing/2014/main" id="{E9594453-46DB-423F-8C3B-9B898413FD28}"/>
+                <a16:creationId xmlns:a16="http://schemas.microsoft.com/office/drawing/2014/main" id="{B863D380-30C2-488C-9473-464102EB9BD7}"/>
               </a:ext>
             </a:extLst>
           </p:cNvPr>
@@ -12299,7 +12384,7 @@
           <p:cNvPr id="20" name="">
             <a:extLst xmlns:a="http://schemas.openxmlformats.org/drawingml/2006/main">
               <a:ext uri="{FF2B5EF4-FFF2-40B4-BE49-F238E27FC236}">
-                <a16:creationId xmlns:a16="http://schemas.microsoft.com/office/drawing/2014/main" id="{EEDC58C1-8408-4D9C-B089-E4C33C9E46C3}"/>
+                <a16:creationId xmlns:a16="http://schemas.microsoft.com/office/drawing/2014/main" id="{5E352C3B-5015-4F3C-BDD0-1F10EA614974}"/>
               </a:ext>
             </a:extLst>
           </p:cNvPr>
@@ -12388,7 +12473,7 @@
           <p:cNvPr id="21" name="">
             <a:extLst xmlns:a="http://schemas.openxmlformats.org/drawingml/2006/main">
               <a:ext uri="{FF2B5EF4-FFF2-40B4-BE49-F238E27FC236}">
-                <a16:creationId xmlns:a16="http://schemas.microsoft.com/office/drawing/2014/main" id="{617000DC-9C4A-4A31-9346-9C1532CBB389}"/>
+                <a16:creationId xmlns:a16="http://schemas.microsoft.com/office/drawing/2014/main" id="{3575E96D-3201-4FF2-A242-2C18344682E2}"/>
               </a:ext>
             </a:extLst>
           </p:cNvPr>
@@ -12446,7 +12531,7 @@
           <p:cNvPr id="22" name="">
             <a:extLst xmlns:a="http://schemas.openxmlformats.org/drawingml/2006/main">
               <a:ext uri="{FF2B5EF4-FFF2-40B4-BE49-F238E27FC236}">
-                <a16:creationId xmlns:a16="http://schemas.microsoft.com/office/drawing/2014/main" id="{0E6A547B-C885-4A83-8B69-776932364DCB}"/>
+                <a16:creationId xmlns:a16="http://schemas.microsoft.com/office/drawing/2014/main" id="{8063CCC4-7DD2-4566-B5B9-024AE98FC391}"/>
               </a:ext>
             </a:extLst>
           </p:cNvPr>
@@ -12508,7 +12593,7 @@
           <p:cNvPr id="23" name="">
             <a:extLst xmlns:a="http://schemas.openxmlformats.org/drawingml/2006/main">
               <a:ext uri="{FF2B5EF4-FFF2-40B4-BE49-F238E27FC236}">
-                <a16:creationId xmlns:a16="http://schemas.microsoft.com/office/drawing/2014/main" id="{957E6342-80A3-41D1-B08D-FEC089360E5B}"/>
+                <a16:creationId xmlns:a16="http://schemas.microsoft.com/office/drawing/2014/main" id="{8A4D18A4-6684-4D47-B8E5-3BA6B892B3BE}"/>
               </a:ext>
             </a:extLst>
           </p:cNvPr>
@@ -12539,7 +12624,7 @@
           <p:cNvPr id="24" name="">
             <a:extLst xmlns:a="http://schemas.openxmlformats.org/drawingml/2006/main">
               <a:ext uri="{FF2B5EF4-FFF2-40B4-BE49-F238E27FC236}">
-                <a16:creationId xmlns:a16="http://schemas.microsoft.com/office/drawing/2014/main" id="{1AC7C1F6-435F-491B-B267-8895A6E685C1}"/>
+                <a16:creationId xmlns:a16="http://schemas.microsoft.com/office/drawing/2014/main" id="{38DA6A97-22CE-4E17-B210-00A65C846EEE}"/>
               </a:ext>
             </a:extLst>
           </p:cNvPr>
@@ -12628,7 +12713,7 @@
           <p:cNvPr id="25" name="">
             <a:extLst xmlns:a="http://schemas.openxmlformats.org/drawingml/2006/main">
               <a:ext uri="{FF2B5EF4-FFF2-40B4-BE49-F238E27FC236}">
-                <a16:creationId xmlns:a16="http://schemas.microsoft.com/office/drawing/2014/main" id="{02EC10A7-B61D-47B2-9EEB-7B50F77B1672}"/>
+                <a16:creationId xmlns:a16="http://schemas.microsoft.com/office/drawing/2014/main" id="{21BA4752-4C16-4AD0-AC9C-C6BD161B7C7C}"/>
               </a:ext>
             </a:extLst>
           </p:cNvPr>
@@ -12686,7 +12771,7 @@
           <p:cNvPr id="26" name="">
             <a:extLst xmlns:a="http://schemas.openxmlformats.org/drawingml/2006/main">
               <a:ext uri="{FF2B5EF4-FFF2-40B4-BE49-F238E27FC236}">
-                <a16:creationId xmlns:a16="http://schemas.microsoft.com/office/drawing/2014/main" id="{064F95E1-F485-4779-B31F-AEF19A339F5D}"/>
+                <a16:creationId xmlns:a16="http://schemas.microsoft.com/office/drawing/2014/main" id="{37D8EDA5-E791-4B25-A87B-F2270E042CFC}"/>
               </a:ext>
             </a:extLst>
           </p:cNvPr>
@@ -12748,7 +12833,7 @@
           <p:cNvPr id="27" name="">
             <a:extLst xmlns:a="http://schemas.openxmlformats.org/drawingml/2006/main">
               <a:ext uri="{FF2B5EF4-FFF2-40B4-BE49-F238E27FC236}">
-                <a16:creationId xmlns:a16="http://schemas.microsoft.com/office/drawing/2014/main" id="{E0D4E39B-D02C-42D8-9727-0806E78583E0}"/>
+                <a16:creationId xmlns:a16="http://schemas.microsoft.com/office/drawing/2014/main" id="{833A35C8-AFE0-47EE-A85D-AD897A44A129}"/>
               </a:ext>
             </a:extLst>
           </p:cNvPr>
@@ -12779,7 +12864,7 @@
           <p:cNvPr id="28" name="">
             <a:extLst xmlns:a="http://schemas.openxmlformats.org/drawingml/2006/main">
               <a:ext uri="{FF2B5EF4-FFF2-40B4-BE49-F238E27FC236}">
-                <a16:creationId xmlns:a16="http://schemas.microsoft.com/office/drawing/2014/main" id="{E643E110-75B7-4991-B95A-26F6928CD24B}"/>
+                <a16:creationId xmlns:a16="http://schemas.microsoft.com/office/drawing/2014/main" id="{8A36A26A-A5D3-44EE-901D-23F3312CB9F6}"/>
               </a:ext>
             </a:extLst>
           </p:cNvPr>
@@ -12868,7 +12953,7 @@
           <p:cNvPr id="29" name="">
             <a:extLst xmlns:a="http://schemas.openxmlformats.org/drawingml/2006/main">
               <a:ext uri="{FF2B5EF4-FFF2-40B4-BE49-F238E27FC236}">
-                <a16:creationId xmlns:a16="http://schemas.microsoft.com/office/drawing/2014/main" id="{792553B9-1BC1-4BF2-AE4F-A7B01255EDC1}"/>
+                <a16:creationId xmlns:a16="http://schemas.microsoft.com/office/drawing/2014/main" id="{96624476-9D26-4401-98C7-2CB6733BA0A3}"/>
               </a:ext>
             </a:extLst>
           </p:cNvPr>
@@ -12926,7 +13011,7 @@
           <p:cNvPr id="30" name="">
             <a:extLst xmlns:a="http://schemas.openxmlformats.org/drawingml/2006/main">
               <a:ext uri="{FF2B5EF4-FFF2-40B4-BE49-F238E27FC236}">
-                <a16:creationId xmlns:a16="http://schemas.microsoft.com/office/drawing/2014/main" id="{D2B771C2-EF93-42B5-8FF9-3CF643DD897C}"/>
+                <a16:creationId xmlns:a16="http://schemas.microsoft.com/office/drawing/2014/main" id="{023AB1E5-6629-475A-BFD2-41FD508191A8}"/>
               </a:ext>
             </a:extLst>
           </p:cNvPr>
@@ -12988,7 +13073,7 @@
           <p:cNvPr id="31" name="">
             <a:extLst xmlns:a="http://schemas.openxmlformats.org/drawingml/2006/main">
               <a:ext uri="{FF2B5EF4-FFF2-40B4-BE49-F238E27FC236}">
-                <a16:creationId xmlns:a16="http://schemas.microsoft.com/office/drawing/2014/main" id="{B4CF6CED-B2EF-4806-89DD-3F138F810FE5}"/>
+                <a16:creationId xmlns:a16="http://schemas.microsoft.com/office/drawing/2014/main" id="{19163CA7-8AAF-44DE-8466-673D3D6362C3}"/>
               </a:ext>
             </a:extLst>
           </p:cNvPr>
@@ -13046,7 +13131,7 @@
           <p:cNvPr id="32" name="mobile-plan-shot-frame">
             <a:extLst xmlns:a="http://schemas.openxmlformats.org/drawingml/2006/main">
               <a:ext uri="{FF2B5EF4-FFF2-40B4-BE49-F238E27FC236}">
-                <a16:creationId xmlns:a16="http://schemas.microsoft.com/office/drawing/2014/main" id="{8D87455D-C656-42B8-8DAF-92BA156BBAB8}"/>
+                <a16:creationId xmlns:a16="http://schemas.microsoft.com/office/drawing/2014/main" id="{09D161CE-1C66-4CA4-9AFA-F5FB138835BE}"/>
               </a:ext>
             </a:extLst>
           </p:cNvPr>
@@ -13091,7 +13176,7 @@
           <p:nvPr/>
         </p:nvPicPr>
         <p:blipFill>
-          <a:blip xmlns:r="http://schemas.openxmlformats.org/officeDocument/2006/relationships" xmlns:a="http://schemas.openxmlformats.org/drawingml/2006/main" r:embed="R73dab8b451e34842"/>
+          <a:blip xmlns:r="http://schemas.openxmlformats.org/officeDocument/2006/relationships" xmlns:a="http://schemas.openxmlformats.org/drawingml/2006/main" r:embed="R9518fc6a3a624ab9"/>
           <a:srcRect xmlns:a="http://schemas.openxmlformats.org/drawingml/2006/main" l="59" t="0" r="59" b="0"/>
           <a:stretch xmlns:a="http://schemas.openxmlformats.org/drawingml/2006/main">
             <a:fillRect l="0" t="0" r="0" b="0"/>
@@ -13114,7 +13199,7 @@
           <p:cNvPr id="34" name="">
             <a:extLst xmlns:a="http://schemas.openxmlformats.org/drawingml/2006/main">
               <a:ext uri="{FF2B5EF4-FFF2-40B4-BE49-F238E27FC236}">
-                <a16:creationId xmlns:a16="http://schemas.microsoft.com/office/drawing/2014/main" id="{7253B942-C019-48B7-BF96-F780D3E3F82F}"/>
+                <a16:creationId xmlns:a16="http://schemas.microsoft.com/office/drawing/2014/main" id="{BF63469A-BFBE-4F5D-AE8F-F6FC677E0AD0}"/>
               </a:ext>
             </a:extLst>
           </p:cNvPr>
@@ -13170,7 +13255,7 @@
     </p:spTree>
     <p:extLst>
       <p:ext uri="{BB962C8B-B14F-4D97-AF65-F5344CB8AC3E}">
-        <p14:creationId xmlns:p14="http://schemas.microsoft.com/office/powerpoint/2010/main" val="269301411"/>
+        <p14:creationId xmlns:p14="http://schemas.microsoft.com/office/powerpoint/2010/main" val="758381829"/>
       </p:ext>
     </p:extLst>
   </p:cSld>
@@ -13201,7 +13286,7 @@
           <p:cNvPr id="32" name="">
             <a:extLst xmlns:a="http://schemas.openxmlformats.org/drawingml/2006/main">
               <a:ext uri="{FF2B5EF4-FFF2-40B4-BE49-F238E27FC236}">
-                <a16:creationId xmlns:a16="http://schemas.microsoft.com/office/drawing/2014/main" id="{EFC3FA8F-8C7F-475B-AD4B-4AB35E3B7B22}"/>
+                <a16:creationId xmlns:a16="http://schemas.microsoft.com/office/drawing/2014/main" id="{CF5016B8-E488-4488-9CB7-ED6B6C5D5F47}"/>
               </a:ext>
             </a:extLst>
           </p:cNvPr>
@@ -13234,7 +13319,7 @@
           <p:cNvPr id="2" name="">
             <a:extLst xmlns:a="http://schemas.openxmlformats.org/drawingml/2006/main">
               <a:ext uri="{FF2B5EF4-FFF2-40B4-BE49-F238E27FC236}">
-                <a16:creationId xmlns:a16="http://schemas.microsoft.com/office/drawing/2014/main" id="{431DF014-5A05-4F88-80C9-6F66B22B0F5D}"/>
+                <a16:creationId xmlns:a16="http://schemas.microsoft.com/office/drawing/2014/main" id="{7865FD40-E469-4AE4-BE6A-1AF5B1FA1608}"/>
               </a:ext>
             </a:extLst>
           </p:cNvPr>
@@ -13292,7 +13377,7 @@
           <p:cNvPr id="3" name="">
             <a:extLst xmlns:a="http://schemas.openxmlformats.org/drawingml/2006/main">
               <a:ext uri="{FF2B5EF4-FFF2-40B4-BE49-F238E27FC236}">
-                <a16:creationId xmlns:a16="http://schemas.microsoft.com/office/drawing/2014/main" id="{AD0B13B6-6FF3-45B7-91D1-3A0090350A90}"/>
+                <a16:creationId xmlns:a16="http://schemas.microsoft.com/office/drawing/2014/main" id="{D681D986-501A-44FA-854D-00409755EF55}"/>
               </a:ext>
             </a:extLst>
           </p:cNvPr>
@@ -13350,7 +13435,7 @@
           <p:cNvPr id="4" name="">
             <a:extLst xmlns:a="http://schemas.openxmlformats.org/drawingml/2006/main">
               <a:ext uri="{FF2B5EF4-FFF2-40B4-BE49-F238E27FC236}">
-                <a16:creationId xmlns:a16="http://schemas.microsoft.com/office/drawing/2014/main" id="{3A0AD1D6-925C-47F9-9E98-DABD97C31C9B}"/>
+                <a16:creationId xmlns:a16="http://schemas.microsoft.com/office/drawing/2014/main" id="{A6493240-34E0-4179-8EAF-FDE95D7CC665}"/>
               </a:ext>
             </a:extLst>
           </p:cNvPr>
@@ -13385,10 +13470,10 @@
           <p:nvPr/>
         </p:nvPicPr>
         <p:blipFill>
-          <a:blip xmlns:r="http://schemas.openxmlformats.org/officeDocument/2006/relationships" xmlns:a="http://schemas.openxmlformats.org/drawingml/2006/main" r:embed="R1052d474535e4a0e">
+          <a:blip xmlns:r="http://schemas.openxmlformats.org/officeDocument/2006/relationships" xmlns:a="http://schemas.openxmlformats.org/drawingml/2006/main" r:embed="R9e7a5ac9051a429c">
             <a:extLst>
               <a:ext uri="{96DAC541-7B7A-43D3-8B79-37D633B846F1}">
-                <asvg:svgBlip xmlns:asvg="http://schemas.microsoft.com/office/drawing/2016/SVG/main" r:embed="R306f0309abca48b8"/>
+                <asvg:svgBlip xmlns:asvg="http://schemas.microsoft.com/office/drawing/2016/SVG/main" r:embed="R2ff964514e6745a9"/>
               </a:ext>
             </a:extLst>
           </a:blip>
@@ -13409,7 +13494,7 @@
           <p:cNvPr id="6" name="">
             <a:extLst xmlns:a="http://schemas.openxmlformats.org/drawingml/2006/main">
               <a:ext uri="{FF2B5EF4-FFF2-40B4-BE49-F238E27FC236}">
-                <a16:creationId xmlns:a16="http://schemas.microsoft.com/office/drawing/2014/main" id="{3DA138D0-D2FB-4E2F-9B4A-9308E6538D69}"/>
+                <a16:creationId xmlns:a16="http://schemas.microsoft.com/office/drawing/2014/main" id="{F2C97915-2421-4BE9-8E42-A27A1FEEC4E9}"/>
               </a:ext>
             </a:extLst>
           </p:cNvPr>
@@ -13467,7 +13552,7 @@
           <p:cNvPr id="7" name="">
             <a:extLst xmlns:a="http://schemas.openxmlformats.org/drawingml/2006/main">
               <a:ext uri="{FF2B5EF4-FFF2-40B4-BE49-F238E27FC236}">
-                <a16:creationId xmlns:a16="http://schemas.microsoft.com/office/drawing/2014/main" id="{888113F4-62DB-4207-B8FF-2FC222E787D6}"/>
+                <a16:creationId xmlns:a16="http://schemas.microsoft.com/office/drawing/2014/main" id="{3B065AD5-2BDA-45ED-BF0F-D3E8660D9326}"/>
               </a:ext>
             </a:extLst>
           </p:cNvPr>
@@ -13525,7 +13610,7 @@
           <p:cNvPr id="8" name="">
             <a:extLst xmlns:a="http://schemas.openxmlformats.org/drawingml/2006/main">
               <a:ext uri="{FF2B5EF4-FFF2-40B4-BE49-F238E27FC236}">
-                <a16:creationId xmlns:a16="http://schemas.microsoft.com/office/drawing/2014/main" id="{ECCD785E-C7B3-4214-A163-DC47849457A9}"/>
+                <a16:creationId xmlns:a16="http://schemas.microsoft.com/office/drawing/2014/main" id="{70EE1904-FE54-4CF9-BE04-FCDF79FD81F9}"/>
               </a:ext>
             </a:extLst>
           </p:cNvPr>
@@ -13587,7 +13672,7 @@
           <p:cNvPr id="9" name="">
             <a:extLst xmlns:a="http://schemas.openxmlformats.org/drawingml/2006/main">
               <a:ext uri="{FF2B5EF4-FFF2-40B4-BE49-F238E27FC236}">
-                <a16:creationId xmlns:a16="http://schemas.microsoft.com/office/drawing/2014/main" id="{74468D56-5642-4754-BACE-C414A0C641FA}"/>
+                <a16:creationId xmlns:a16="http://schemas.microsoft.com/office/drawing/2014/main" id="{23B6D44C-78EA-429A-B85F-8D289C7B3408}"/>
               </a:ext>
             </a:extLst>
           </p:cNvPr>
@@ -13645,7 +13730,7 @@
           <p:cNvPr id="10" name="">
             <a:extLst xmlns:a="http://schemas.openxmlformats.org/drawingml/2006/main">
               <a:ext uri="{FF2B5EF4-FFF2-40B4-BE49-F238E27FC236}">
-                <a16:creationId xmlns:a16="http://schemas.microsoft.com/office/drawing/2014/main" id="{DBFA81E9-DB10-4091-A2EA-6F8F11F0A1E8}"/>
+                <a16:creationId xmlns:a16="http://schemas.microsoft.com/office/drawing/2014/main" id="{D5D50837-83D7-4C33-91B7-DB91D9B81D02}"/>
               </a:ext>
             </a:extLst>
           </p:cNvPr>
@@ -13676,7 +13761,7 @@
           <p:cNvPr id="11" name="">
             <a:extLst xmlns:a="http://schemas.openxmlformats.org/drawingml/2006/main">
               <a:ext uri="{FF2B5EF4-FFF2-40B4-BE49-F238E27FC236}">
-                <a16:creationId xmlns:a16="http://schemas.microsoft.com/office/drawing/2014/main" id="{AA4F0493-39C7-4C31-9A13-6CCFEDFE1423}"/>
+                <a16:creationId xmlns:a16="http://schemas.microsoft.com/office/drawing/2014/main" id="{E854ACC6-A8D7-4DAE-BCB5-5E2B22E45C94}"/>
               </a:ext>
             </a:extLst>
           </p:cNvPr>
@@ -13709,7 +13794,7 @@
           <p:cNvPr id="12" name="">
             <a:extLst xmlns:a="http://schemas.openxmlformats.org/drawingml/2006/main">
               <a:ext uri="{FF2B5EF4-FFF2-40B4-BE49-F238E27FC236}">
-                <a16:creationId xmlns:a16="http://schemas.microsoft.com/office/drawing/2014/main" id="{56E17EB4-3941-409D-821F-49B999AB3462}"/>
+                <a16:creationId xmlns:a16="http://schemas.microsoft.com/office/drawing/2014/main" id="{0581FF39-89E2-418E-9CF4-D4157A6C2CE8}"/>
               </a:ext>
             </a:extLst>
           </p:cNvPr>
@@ -13767,7 +13852,7 @@
           <p:cNvPr id="13" name="">
             <a:extLst xmlns:a="http://schemas.openxmlformats.org/drawingml/2006/main">
               <a:ext uri="{FF2B5EF4-FFF2-40B4-BE49-F238E27FC236}">
-                <a16:creationId xmlns:a16="http://schemas.microsoft.com/office/drawing/2014/main" id="{846252E3-C6B9-46CD-AF6A-6AB5FDEDF28E}"/>
+                <a16:creationId xmlns:a16="http://schemas.microsoft.com/office/drawing/2014/main" id="{C960A159-0B10-4CB2-8500-F0970E692F23}"/>
               </a:ext>
             </a:extLst>
           </p:cNvPr>
@@ -13825,7 +13910,7 @@
           <p:cNvPr id="14" name="">
             <a:extLst xmlns:a="http://schemas.openxmlformats.org/drawingml/2006/main">
               <a:ext uri="{FF2B5EF4-FFF2-40B4-BE49-F238E27FC236}">
-                <a16:creationId xmlns:a16="http://schemas.microsoft.com/office/drawing/2014/main" id="{D721742A-DBAF-475A-88F9-790DCF5A24D6}"/>
+                <a16:creationId xmlns:a16="http://schemas.microsoft.com/office/drawing/2014/main" id="{103118CE-DF78-4ADE-9B12-0922EE34A437}"/>
               </a:ext>
             </a:extLst>
           </p:cNvPr>
@@ -13858,7 +13943,7 @@
           <p:cNvPr id="15" name="">
             <a:extLst xmlns:a="http://schemas.openxmlformats.org/drawingml/2006/main">
               <a:ext uri="{FF2B5EF4-FFF2-40B4-BE49-F238E27FC236}">
-                <a16:creationId xmlns:a16="http://schemas.microsoft.com/office/drawing/2014/main" id="{93252838-0B5B-4E88-BBDD-922D2A582C94}"/>
+                <a16:creationId xmlns:a16="http://schemas.microsoft.com/office/drawing/2014/main" id="{4EA3FD22-886B-4649-864D-9BD4A6130F70}"/>
               </a:ext>
             </a:extLst>
           </p:cNvPr>
@@ -13916,7 +14001,7 @@
           <p:cNvPr id="16" name="">
             <a:extLst xmlns:a="http://schemas.openxmlformats.org/drawingml/2006/main">
               <a:ext uri="{FF2B5EF4-FFF2-40B4-BE49-F238E27FC236}">
-                <a16:creationId xmlns:a16="http://schemas.microsoft.com/office/drawing/2014/main" id="{B1E79A80-D508-454C-B9F1-7F4509A8697A}"/>
+                <a16:creationId xmlns:a16="http://schemas.microsoft.com/office/drawing/2014/main" id="{BA8E1140-C3D6-4A49-B966-70FF7686E002}"/>
               </a:ext>
             </a:extLst>
           </p:cNvPr>
@@ -13974,7 +14059,7 @@
           <p:cNvPr id="17" name="">
             <a:extLst xmlns:a="http://schemas.openxmlformats.org/drawingml/2006/main">
               <a:ext uri="{FF2B5EF4-FFF2-40B4-BE49-F238E27FC236}">
-                <a16:creationId xmlns:a16="http://schemas.microsoft.com/office/drawing/2014/main" id="{03CDBCFF-3AC2-46D1-A21B-B8BDE1E6F2A3}"/>
+                <a16:creationId xmlns:a16="http://schemas.microsoft.com/office/drawing/2014/main" id="{C99D430D-ED17-4926-9611-00CAA81FD6BF}"/>
               </a:ext>
             </a:extLst>
           </p:cNvPr>
@@ -14007,7 +14092,7 @@
           <p:cNvPr id="18" name="">
             <a:extLst xmlns:a="http://schemas.openxmlformats.org/drawingml/2006/main">
               <a:ext uri="{FF2B5EF4-FFF2-40B4-BE49-F238E27FC236}">
-                <a16:creationId xmlns:a16="http://schemas.microsoft.com/office/drawing/2014/main" id="{7144E4DC-C654-4C02-876C-206A17F074DD}"/>
+                <a16:creationId xmlns:a16="http://schemas.microsoft.com/office/drawing/2014/main" id="{9BD13BDC-5975-408C-9B35-64217C10355D}"/>
               </a:ext>
             </a:extLst>
           </p:cNvPr>
@@ -14065,7 +14150,7 @@
           <p:cNvPr id="19" name="">
             <a:extLst xmlns:a="http://schemas.openxmlformats.org/drawingml/2006/main">
               <a:ext uri="{FF2B5EF4-FFF2-40B4-BE49-F238E27FC236}">
-                <a16:creationId xmlns:a16="http://schemas.microsoft.com/office/drawing/2014/main" id="{37DB81F5-614E-4156-8DB2-964A790DD8DE}"/>
+                <a16:creationId xmlns:a16="http://schemas.microsoft.com/office/drawing/2014/main" id="{7FC91256-3063-4A14-A4A0-EE4E41BBBDFD}"/>
               </a:ext>
             </a:extLst>
           </p:cNvPr>
@@ -14123,7 +14208,7 @@
           <p:cNvPr id="20" name="">
             <a:extLst xmlns:a="http://schemas.openxmlformats.org/drawingml/2006/main">
               <a:ext uri="{FF2B5EF4-FFF2-40B4-BE49-F238E27FC236}">
-                <a16:creationId xmlns:a16="http://schemas.microsoft.com/office/drawing/2014/main" id="{68B089F8-FF9E-4185-ACE8-20F620B32783}"/>
+                <a16:creationId xmlns:a16="http://schemas.microsoft.com/office/drawing/2014/main" id="{5BCF483E-C97A-48BB-80E8-1BF9B1FE2218}"/>
               </a:ext>
             </a:extLst>
           </p:cNvPr>
@@ -14156,7 +14241,7 @@
           <p:cNvPr id="21" name="">
             <a:extLst xmlns:a="http://schemas.openxmlformats.org/drawingml/2006/main">
               <a:ext uri="{FF2B5EF4-FFF2-40B4-BE49-F238E27FC236}">
-                <a16:creationId xmlns:a16="http://schemas.microsoft.com/office/drawing/2014/main" id="{BBC638C2-AC24-4E9F-AAAF-AD1CFE56655B}"/>
+                <a16:creationId xmlns:a16="http://schemas.microsoft.com/office/drawing/2014/main" id="{AB66F379-5A46-4BFF-8300-C88CD09227A2}"/>
               </a:ext>
             </a:extLst>
           </p:cNvPr>
@@ -14214,7 +14299,7 @@
           <p:cNvPr id="22" name="">
             <a:extLst xmlns:a="http://schemas.openxmlformats.org/drawingml/2006/main">
               <a:ext uri="{FF2B5EF4-FFF2-40B4-BE49-F238E27FC236}">
-                <a16:creationId xmlns:a16="http://schemas.microsoft.com/office/drawing/2014/main" id="{DE0B3DBC-2FE9-4DA7-BEEA-BA4682BAC1C7}"/>
+                <a16:creationId xmlns:a16="http://schemas.microsoft.com/office/drawing/2014/main" id="{8758B0B9-2B65-44EB-9AFC-3EF5A65E6A94}"/>
               </a:ext>
             </a:extLst>
           </p:cNvPr>
@@ -14272,7 +14357,7 @@
           <p:cNvPr id="23" name="">
             <a:extLst xmlns:a="http://schemas.openxmlformats.org/drawingml/2006/main">
               <a:ext uri="{FF2B5EF4-FFF2-40B4-BE49-F238E27FC236}">
-                <a16:creationId xmlns:a16="http://schemas.microsoft.com/office/drawing/2014/main" id="{CDC5FD2B-D55A-42DD-833E-5DDDAC25E099}"/>
+                <a16:creationId xmlns:a16="http://schemas.microsoft.com/office/drawing/2014/main" id="{17DF8AE3-B4A7-404A-B082-9E16D71B627B}"/>
               </a:ext>
             </a:extLst>
           </p:cNvPr>
@@ -14330,7 +14415,7 @@
           <p:cNvPr id="24" name="">
             <a:extLst xmlns:a="http://schemas.openxmlformats.org/drawingml/2006/main">
               <a:ext uri="{FF2B5EF4-FFF2-40B4-BE49-F238E27FC236}">
-                <a16:creationId xmlns:a16="http://schemas.microsoft.com/office/drawing/2014/main" id="{586B2F34-F294-4933-AA81-D944E5C1FE2D}"/>
+                <a16:creationId xmlns:a16="http://schemas.microsoft.com/office/drawing/2014/main" id="{67AF3DC7-AC9F-4246-B028-A7115B22CF34}"/>
               </a:ext>
             </a:extLst>
           </p:cNvPr>
@@ -14409,7 +14494,7 @@
                 <a:ea typeface="Arial"/>
                 <a:cs typeface="Arial"/>
               </a:rPr>
-              <a:t>•  Planned 1,024-unit aggregate quota; 5 receipts</a:t>
+              <a:t>•  Planned aggregate probe quota: 1,024; actual: 5 receipts</a:t>
             </a:r>
           </a:p>
           <a:p xmlns:a="http://schemas.openxmlformats.org/drawingml/2006/main">
@@ -14473,7 +14558,7 @@
           <p:cNvPr id="25" name="">
             <a:extLst xmlns:a="http://schemas.openxmlformats.org/drawingml/2006/main">
               <a:ext uri="{FF2B5EF4-FFF2-40B4-BE49-F238E27FC236}">
-                <a16:creationId xmlns:a16="http://schemas.microsoft.com/office/drawing/2014/main" id="{16ADBF9C-7B41-477D-BA61-20F0C2E5613A}"/>
+                <a16:creationId xmlns:a16="http://schemas.microsoft.com/office/drawing/2014/main" id="{A17405EF-ABAB-4189-AF0F-7C42641CF016}"/>
               </a:ext>
             </a:extLst>
           </p:cNvPr>
@@ -14504,7 +14589,7 @@
           <p:cNvPr id="26" name="">
             <a:extLst xmlns:a="http://schemas.openxmlformats.org/drawingml/2006/main">
               <a:ext uri="{FF2B5EF4-FFF2-40B4-BE49-F238E27FC236}">
-                <a16:creationId xmlns:a16="http://schemas.microsoft.com/office/drawing/2014/main" id="{49144ADC-C870-4B47-80D8-B4C1FCA6D109}"/>
+                <a16:creationId xmlns:a16="http://schemas.microsoft.com/office/drawing/2014/main" id="{DD4418BA-FFA4-47E0-A39F-A607AB3CBB21}"/>
               </a:ext>
             </a:extLst>
           </p:cNvPr>
@@ -14562,7 +14647,7 @@
           <p:cNvPr id="27" name="">
             <a:extLst xmlns:a="http://schemas.openxmlformats.org/drawingml/2006/main">
               <a:ext uri="{FF2B5EF4-FFF2-40B4-BE49-F238E27FC236}">
-                <a16:creationId xmlns:a16="http://schemas.microsoft.com/office/drawing/2014/main" id="{024A63AB-995D-42AE-9E61-E8A5734FE337}"/>
+                <a16:creationId xmlns:a16="http://schemas.microsoft.com/office/drawing/2014/main" id="{34CB3FBE-F0E6-4484-AD34-47BF5519087D}"/>
               </a:ext>
             </a:extLst>
           </p:cNvPr>
@@ -14705,7 +14790,7 @@
           <p:cNvPr id="28" name="">
             <a:extLst xmlns:a="http://schemas.openxmlformats.org/drawingml/2006/main">
               <a:ext uri="{FF2B5EF4-FFF2-40B4-BE49-F238E27FC236}">
-                <a16:creationId xmlns:a16="http://schemas.microsoft.com/office/drawing/2014/main" id="{BAC01859-BE80-40F3-81BD-85582A299156}"/>
+                <a16:creationId xmlns:a16="http://schemas.microsoft.com/office/drawing/2014/main" id="{53E0F188-E6B2-4354-A0E5-B48735A3F53E}"/>
               </a:ext>
             </a:extLst>
           </p:cNvPr>
@@ -14740,7 +14825,7 @@
           <p:cNvPr id="29" name="">
             <a:extLst xmlns:a="http://schemas.openxmlformats.org/drawingml/2006/main">
               <a:ext uri="{FF2B5EF4-FFF2-40B4-BE49-F238E27FC236}">
-                <a16:creationId xmlns:a16="http://schemas.microsoft.com/office/drawing/2014/main" id="{6FDBDCA4-8DCD-4BFE-AE2B-F30A03070B5B}"/>
+                <a16:creationId xmlns:a16="http://schemas.microsoft.com/office/drawing/2014/main" id="{15F5F280-9359-4996-B471-BAFB6EF77CED}"/>
               </a:ext>
             </a:extLst>
           </p:cNvPr>
@@ -14798,7 +14883,7 @@
           <p:cNvPr id="30" name="">
             <a:extLst xmlns:a="http://schemas.openxmlformats.org/drawingml/2006/main">
               <a:ext uri="{FF2B5EF4-FFF2-40B4-BE49-F238E27FC236}">
-                <a16:creationId xmlns:a16="http://schemas.microsoft.com/office/drawing/2014/main" id="{F41E8A0A-C5D2-4709-A31F-CE2C310469B1}"/>
+                <a16:creationId xmlns:a16="http://schemas.microsoft.com/office/drawing/2014/main" id="{C3D39847-86FB-4BA4-B785-D2B95BC7A3C4}"/>
               </a:ext>
             </a:extLst>
           </p:cNvPr>
@@ -14856,7 +14941,7 @@
           <p:cNvPr id="31" name="">
             <a:extLst xmlns:a="http://schemas.openxmlformats.org/drawingml/2006/main">
               <a:ext uri="{FF2B5EF4-FFF2-40B4-BE49-F238E27FC236}">
-                <a16:creationId xmlns:a16="http://schemas.microsoft.com/office/drawing/2014/main" id="{38A718C1-195E-4E60-92F3-41F2C7BB4ACA}"/>
+                <a16:creationId xmlns:a16="http://schemas.microsoft.com/office/drawing/2014/main" id="{9F3EE6EA-79FD-4D67-823B-F5E48D541E7C}"/>
               </a:ext>
             </a:extLst>
           </p:cNvPr>
@@ -14916,7 +15001,7 @@
     </p:spTree>
     <p:extLst>
       <p:ext uri="{BB962C8B-B14F-4D97-AF65-F5344CB8AC3E}">
-        <p14:creationId xmlns:p14="http://schemas.microsoft.com/office/powerpoint/2010/main" val="60178657"/>
+        <p14:creationId xmlns:p14="http://schemas.microsoft.com/office/powerpoint/2010/main" val="716931443"/>
       </p:ext>
     </p:extLst>
   </p:cSld>

</xml_diff>

<commit_message>
feat: ship truthful evidence operations workflow
</commit_message>
<xml_diff>
--- a/public/materials/LRWA_Seed_Deck.pptx
+++ b/public/materials/LRWA_Seed_Deck.pptx
@@ -2,20 +2,20 @@
 <file path=ppt/presentation.xml><?xml version="1.0" encoding="utf-8"?>
 <p:presentation xmlns:p="http://schemas.openxmlformats.org/presentationml/2006/main">
   <p:sldMasterIdLst>
-    <p:sldMasterId xmlns:r="http://schemas.openxmlformats.org/officeDocument/2006/relationships" id="2147483648" r:id="Rf6c49d6f4bc94110"/>
+    <p:sldMasterId xmlns:r="http://schemas.openxmlformats.org/officeDocument/2006/relationships" id="2147483648" r:id="R22b569cfb3e440d4"/>
   </p:sldMasterIdLst>
   <p:notesMasterIdLst>
-    <p:notesMasterId xmlns:r="http://schemas.openxmlformats.org/officeDocument/2006/relationships" r:id="R292172a5e22e458f"/>
+    <p:notesMasterId xmlns:r="http://schemas.openxmlformats.org/officeDocument/2006/relationships" r:id="Rc200874a69864f9e"/>
   </p:notesMasterIdLst>
   <p:sldIdLst>
-    <p:sldId xmlns:r="http://schemas.openxmlformats.org/officeDocument/2006/relationships" id="256" r:id="R0892eb5c6bb94e51"/>
-    <p:sldId xmlns:r="http://schemas.openxmlformats.org/officeDocument/2006/relationships" id="257" r:id="R01b787d52992438b"/>
-    <p:sldId xmlns:r="http://schemas.openxmlformats.org/officeDocument/2006/relationships" id="258" r:id="R680c6c2645a6470a"/>
-    <p:sldId xmlns:r="http://schemas.openxmlformats.org/officeDocument/2006/relationships" id="259" r:id="R6439be000c54466a"/>
-    <p:sldId xmlns:r="http://schemas.openxmlformats.org/officeDocument/2006/relationships" id="260" r:id="R05ca9dc5267e455c"/>
-    <p:sldId xmlns:r="http://schemas.openxmlformats.org/officeDocument/2006/relationships" id="261" r:id="R137504ffabca4d5f"/>
-    <p:sldId xmlns:r="http://schemas.openxmlformats.org/officeDocument/2006/relationships" id="262" r:id="Re6bdac126bb54b20"/>
-    <p:sldId xmlns:r="http://schemas.openxmlformats.org/officeDocument/2006/relationships" id="263" r:id="R478c6e79d549488c"/>
+    <p:sldId xmlns:r="http://schemas.openxmlformats.org/officeDocument/2006/relationships" id="256" r:id="R93eb77c23f8e4b11"/>
+    <p:sldId xmlns:r="http://schemas.openxmlformats.org/officeDocument/2006/relationships" id="257" r:id="R367336ce85764bc5"/>
+    <p:sldId xmlns:r="http://schemas.openxmlformats.org/officeDocument/2006/relationships" id="258" r:id="R5738d316f92543ab"/>
+    <p:sldId xmlns:r="http://schemas.openxmlformats.org/officeDocument/2006/relationships" id="259" r:id="R59d6ace0cec74f6c"/>
+    <p:sldId xmlns:r="http://schemas.openxmlformats.org/officeDocument/2006/relationships" id="260" r:id="R3a5c1c19881d4390"/>
+    <p:sldId xmlns:r="http://schemas.openxmlformats.org/officeDocument/2006/relationships" id="261" r:id="Rfeb7df68dad043ae"/>
+    <p:sldId xmlns:r="http://schemas.openxmlformats.org/officeDocument/2006/relationships" id="262" r:id="Rd0897975c79f40f8"/>
+    <p:sldId xmlns:r="http://schemas.openxmlformats.org/officeDocument/2006/relationships" id="263" r:id="R6b2aeff5b3f44cba"/>
   </p:sldIdLst>
   <p:sldSz cx="12192000" cy="6858000"/>
   <p:notesSz cx="6858000" cy="9144000"/>
@@ -449,7 +449,7 @@
           <a:lstStyle xmlns:a="http://schemas.openxmlformats.org/drawingml/2006/main"/>
           <a:p xmlns:a="http://schemas.openxmlformats.org/drawingml/2006/main">
             <a:r>
-              <a:t>Every investment starts with a story and a set of numbers. LRWA is built for the moment when a decision maker asks whether the reality outside the data room supports that story. We turn a commercial claim into a governed verification mission executed by a coordinated fleet of agents.</a:t>
+              <a:t>LRWA starts from a narrow rule: an AI plan is not evidence. The product turns one material commercial claim into four bounded role missions, then keeps preparation, external contact, receipts, integrity, and review as separate states.</a:t>
             </a:r>
           </a:p>
           <a:p xmlns:a="http://schemas.openxmlformats.org/drawingml/2006/main">
@@ -464,22 +464,22 @@
           </a:p>
           <a:p xmlns:a="http://schemas.openxmlformats.org/drawingml/2006/main">
             <a:r>
-              <a:t>- Internal brand asset: lrwa-agent-web/public/og.png</a:t>
-            </a:r>
-          </a:p>
-          <a:p xmlns:a="http://schemas.openxmlformats.org/drawingml/2006/main">
-            <a:r>
-              <a:t>- Product positioning: outputs/PITCH_DECK_OUTLINE.md</a:t>
+              <a:t>- Current product: lrwa-agent-web source repository.</a:t>
+            </a:r>
+          </a:p>
+          <a:p xmlns:a="http://schemas.openxmlformats.org/drawingml/2006/main">
+            <a:r>
+              <a:t>- Current evidence API: lrwa-agent/src/evidence-operations.</a:t>
+            </a:r>
+          </a:p>
+          <a:p xmlns:a="http://schemas.openxmlformats.org/drawingml/2006/main">
+            <a:r>
+              <a:t>- User-provided LRWA brand asset: favicon.svg.</a:t>
             </a:r>
           </a:p>
           <a:p xmlns:a="http://schemas.openxmlformats.org/drawingml/2006/main">
             <a:r>
               <a:t>- Founder and financing details intentionally omitted from this public deck.</a:t>
-            </a:r>
-          </a:p>
-          <a:p xmlns:a="http://schemas.openxmlformats.org/drawingml/2006/main">
-            <a:r>
-              <a:t>- User-provided LRWA brand asset: favicon.svg</a:t>
             </a:r>
           </a:p>
         </p:txBody>
@@ -549,7 +549,7 @@
           <a:lstStyle xmlns:a="http://schemas.openxmlformats.org/drawingml/2006/main"/>
           <a:p xmlns:a="http://schemas.openxmlformats.org/drawingml/2006/main">
             <a:r>
-              <a:t>A financial model can test whether numbers are internally consistent. It cannot establish whether stores are operating, customers are buying, suppliers are replenishing, or field behavior matches management's narrative. Teams assemble those outside signals manually under deal pressure, and the reasoning is difficult to rerun when a new question appears.</a:t>
+              <a:t>Financial statements and supplied documents can be checked for consistency, but they are not independent proof of real-world operations. LRWA is designed to make the missing external receipt visible instead of filling that gap with generated prose.</a:t>
             </a:r>
           </a:p>
           <a:p xmlns:a="http://schemas.openxmlformats.org/drawingml/2006/main">
@@ -564,17 +564,17 @@
           </a:p>
           <a:p xmlns:a="http://schemas.openxmlformats.org/drawingml/2006/main">
             <a:r>
-              <a:t>- Problem framing and claim discipline: outputs/PITCH_DECK_OUTLINE.md</a:t>
-            </a:r>
-          </a:p>
-          <a:p xmlns:a="http://schemas.openxmlformats.org/drawingml/2006/main">
-            <a:r>
-              <a:t>- No market-size, time-saved, or cost-saved statistics are asserted.</a:t>
-            </a:r>
-          </a:p>
-          <a:p xmlns:a="http://schemas.openxmlformats.org/drawingml/2006/main">
-            <a:r>
-              <a:t>- User-provided LRWA brand asset: favicon.svg</a:t>
+              <a:t>- Problem framing: outputs/PITCH_DECK_OUTLINE.md.</a:t>
+            </a:r>
+          </a:p>
+          <a:p xmlns:a="http://schemas.openxmlformats.org/drawingml/2006/main">
+            <a:r>
+              <a:t>- No market-size, time-saved, customer, or traction statistic is asserted.</a:t>
+            </a:r>
+          </a:p>
+          <a:p xmlns:a="http://schemas.openxmlformats.org/drawingml/2006/main">
+            <a:r>
+              <a:t>- User-provided LRWA brand asset: favicon.svg.</a:t>
             </a:r>
           </a:p>
         </p:txBody>
@@ -644,7 +644,7 @@
           <a:lstStyle xmlns:a="http://schemas.openxmlformats.org/drawingml/2006/main"/>
           <a:p xmlns:a="http://schemas.openxmlformats.org/drawingml/2006/main">
             <a:r>
-              <a:t>LRWA compiles four declared operating metrics into a planned aggregate quota of 1,024 parameterized probes across five logical evidence categories. The current synthetic demo produces five aggregate evidence receipts, one per category; it does not persist 1,024 raw observations, and the categories' statistical independence has not been established. The initial fixed scenario band is ¥1.72m to ¥2.14m with a heuristic policy score of 0.88. A separate unauthenticated UI/API interaction gate applies the preconfigured 20% corporate-order counterfactual; it is not identity-verified compliance approval. The fixed replay band is ¥2.12m to ¥2.72m with a heuristic policy score of 0.82. The result remains unsupported after the gap narrows from 42.3% to 27.9%.</a:t>
+              <a:t>The shipped prototype demonstrates only truthful state transitions. A claim receives four role strategies. Copying a strategy marks it prepared, not sent. A user must confirm an authorized external contact, and only a user-submitted receipt enters the evidence room. With no receipt, the conclusion remains locked.</a:t>
             </a:r>
           </a:p>
           <a:p xmlns:a="http://schemas.openxmlformats.org/drawingml/2006/main">
@@ -659,22 +659,22 @@
           </a:p>
           <a:p xmlns:a="http://schemas.openxmlformats.org/drawingml/2006/main">
             <a:r>
-              <a:t>- Canonical metrics: outputs/PITCH_DECK_OUTLINE.md</a:t>
-            </a:r>
-          </a:p>
-          <a:p xmlns:a="http://schemas.openxmlformats.org/drawingml/2006/main">
-            <a:r>
-              <a:t>- Working product screenshots: lrwa-agent-video/public/screens/plan.png, live-final.png, findings.png</a:t>
-            </a:r>
-          </a:p>
-          <a:p xmlns:a="http://schemas.openxmlformats.org/drawingml/2006/main">
-            <a:r>
-              <a:t>- All displayed Morrow Coffee data is synthetic and illustrative.</a:t>
-            </a:r>
-          </a:p>
-          <a:p xmlns:a="http://schemas.openxmlformats.org/drawingml/2006/main">
-            <a:r>
-              <a:t>- User-provided LRWA brand asset: favicon.svg</a:t>
+              <a:t>- Screenshots: lrwa-agent-video/public/screens/evidence-plan.jpg, evidence-workbench.jpg, evidence-gate.jpg.</a:t>
+            </a:r>
+          </a:p>
+          <a:p xmlns:a="http://schemas.openxmlformats.org/drawingml/2006/main">
+            <a:r>
+              <a:t>- Frontend state model: lrwa-agent-web/lib/investigation.ts.</a:t>
+            </a:r>
+          </a:p>
+          <a:p xmlns:a="http://schemas.openxmlformats.org/drawingml/2006/main">
+            <a:r>
+              <a:t>- No external Meituan or Google connector is represented as configured.</a:t>
+            </a:r>
+          </a:p>
+          <a:p xmlns:a="http://schemas.openxmlformats.org/drawingml/2006/main">
+            <a:r>
+              <a:t>- User-provided LRWA brand asset: favicon.svg.</a:t>
             </a:r>
           </a:p>
         </p:txBody>
@@ -744,7 +744,7 @@
           <a:lstStyle xmlns:a="http://schemas.openxmlformats.org/drawingml/2006/main"/>
           <a:p xmlns:a="http://schemas.openxmlformats.org/drawingml/2006/main">
             <a:r>
-              <a:t>The model is not the moat. The current demo maps a business claim into a declared aggregate sampling quota and preserves methodology and content hashes across five aggregate receipts. Five logical evidence categories feed the deterministic fixture; their statistical independence has not been established. The Skeptic presents a preconfigured missing-channel counterfactual, and a separate unauthenticated UI/API interaction starts the deterministic replay. Identity-verified approval remains a production requirement.</a:t>
+              <a:t>DeepSeek is optional and may draft role questions only when the user opts in. It cannot create evidence or claim that contact happened. The API records user-confirmed contact and hashes submitted receipt content with SHA-256. Evidence absence is preserved as a decision state.</a:t>
             </a:r>
           </a:p>
           <a:p xmlns:a="http://schemas.openxmlformats.org/drawingml/2006/main">
@@ -759,22 +759,22 @@
           </a:p>
           <a:p xmlns:a="http://schemas.openxmlformats.org/drawingml/2006/main">
             <a:r>
-              <a:t>- System description and five evidence categories: outputs/PITCH_DECK_OUTLINE.md</a:t>
-            </a:r>
-          </a:p>
-          <a:p xmlns:a="http://schemas.openxmlformats.org/drawingml/2006/main">
-            <a:r>
-              <a:t>- Replay screenshot: lrwa-agent-video/public/screens/replay.png</a:t>
-            </a:r>
-          </a:p>
-          <a:p xmlns:a="http://schemas.openxmlformats.org/drawingml/2006/main">
-            <a:r>
-              <a:t>- Backend behavior and audit events: lrwa-agent source repository.</a:t>
-            </a:r>
-          </a:p>
-          <a:p xmlns:a="http://schemas.openxmlformats.org/drawingml/2006/main">
-            <a:r>
-              <a:t>- User-provided LRWA brand asset: favicon.svg</a:t>
+              <a:t>- Evidence operations implementation: lrwa-agent/src/evidence-operations.</a:t>
+            </a:r>
+          </a:p>
+          <a:p xmlns:a="http://schemas.openxmlformats.org/drawingml/2006/main">
+            <a:r>
+              <a:t>- Screenshot: lrwa-agent-video/public/screens/evidence-actions.jpg.</a:t>
+            </a:r>
+          </a:p>
+          <a:p xmlns:a="http://schemas.openxmlformats.org/drawingml/2006/main">
+            <a:r>
+              <a:t>- Current storage is volatile in-memory and is not presented as production durability.</a:t>
+            </a:r>
+          </a:p>
+          <a:p xmlns:a="http://schemas.openxmlformats.org/drawingml/2006/main">
+            <a:r>
+              <a:t>- User-provided LRWA brand asset: favicon.svg.</a:t>
             </a:r>
           </a:p>
         </p:txBody>
@@ -844,7 +844,7 @@
           <a:lstStyle xmlns:a="http://schemas.openxmlformats.org/drawingml/2006/main"/>
           <a:p xmlns:a="http://schemas.openxmlformats.org/drawingml/2006/main">
             <a:r>
-              <a:t>The first wedge is not a universal market-intelligence platform. It is one material operating claim in one deal, starting with location-based or omnichannel businesses. A fund can be the buyer for the first mission and the distribution channel into portfolio companies. This creates repeated questions and a path to recurring workflows without claiming customers or revenue before they exist.</a:t>
+              <a:t>The first commercial wedge is one material claim in one investment or commercial-diligence decision. The design-partner fund, paid mission, repeatable workflow, and vertical library are go-to-market targets, not current traction.</a:t>
             </a:r>
           </a:p>
           <a:p xmlns:a="http://schemas.openxmlformats.org/drawingml/2006/main">
@@ -859,22 +859,22 @@
           </a:p>
           <a:p xmlns:a="http://schemas.openxmlformats.org/drawingml/2006/main">
             <a:r>
-              <a:t>- Initial wedge and target milestones: outputs/PITCH_DECK_OUTLINE.md</a:t>
-            </a:r>
-          </a:p>
-          <a:p xmlns:a="http://schemas.openxmlformats.org/drawingml/2006/main">
-            <a:r>
-              <a:t>- Action queue screenshot: lrwa-agent-video/public/screens/actions.png</a:t>
-            </a:r>
-          </a:p>
-          <a:p xmlns:a="http://schemas.openxmlformats.org/drawingml/2006/main">
-            <a:r>
-              <a:t>- Design partner, paid mission, and portfolio expansion are go-to-market targets, not current traction.</a:t>
-            </a:r>
-          </a:p>
-          <a:p xmlns:a="http://schemas.openxmlformats.org/drawingml/2006/main">
-            <a:r>
-              <a:t>- User-provided LRWA brand asset: favicon.svg</a:t>
+              <a:t>- Wedge and milestone labels: outputs/PITCH_DECK_OUTLINE.md.</a:t>
+            </a:r>
+          </a:p>
+          <a:p xmlns:a="http://schemas.openxmlformats.org/drawingml/2006/main">
+            <a:r>
+              <a:t>- Screenshot: lrwa-agent-video/public/screens/evidence-actions.jpg.</a:t>
+            </a:r>
+          </a:p>
+          <a:p xmlns:a="http://schemas.openxmlformats.org/drawingml/2006/main">
+            <a:r>
+              <a:t>- No customer, revenue, or renewal claim is asserted.</a:t>
+            </a:r>
+          </a:p>
+          <a:p xmlns:a="http://schemas.openxmlformats.org/drawingml/2006/main">
+            <a:r>
+              <a:t>- User-provided LRWA brand asset: favicon.svg.</a:t>
             </a:r>
           </a:p>
         </p:txBody>
@@ -944,7 +944,7 @@
           <a:lstStyle xmlns:a="http://schemas.openxmlformats.org/drawingml/2006/main"/>
           <a:p xmlns:a="http://schemas.openxmlformats.org/drawingml/2006/main">
             <a:r>
-              <a:t>LRWA sits between a material claim and the next decision. Its unit of work is a verification mission with a declared policy, evidence lineage, counterevidence search, and a rerunnable result. Commercial verification infrastructure remains a positioning hypothesis until customers repeat the language.</a:t>
+              <a:t>Most research products return a document, report, interview, or dataset. LRWA's positioning hypothesis is a verification mission: a claim, bounded roles, explicit action states, inspectable receipts, integrity metadata, and a human decision gate.</a:t>
             </a:r>
           </a:p>
           <a:p xmlns:a="http://schemas.openxmlformats.org/drawingml/2006/main">
@@ -959,22 +959,22 @@
           </a:p>
           <a:p xmlns:a="http://schemas.openxmlformats.org/drawingml/2006/main">
             <a:r>
-              <a:t>- Category framing and claim discipline: outputs/PITCH_DECK_OUTLINE.md</a:t>
-            </a:r>
-          </a:p>
-          <a:p xmlns:a="http://schemas.openxmlformats.org/drawingml/2006/main">
-            <a:r>
-              <a:t>- Current LRWA workflow capability: lrwa-agent and lrwa-agent-web source repositories.</a:t>
-            </a:r>
-          </a:p>
-          <a:p xmlns:a="http://schemas.openxmlformats.org/drawingml/2006/main">
-            <a:r>
-              <a:t>- No competitor exclusivity or market-size claim is asserted.</a:t>
-            </a:r>
-          </a:p>
-          <a:p xmlns:a="http://schemas.openxmlformats.org/drawingml/2006/main">
-            <a:r>
-              <a:t>- User-provided LRWA brand asset: favicon.svg</a:t>
+              <a:t>- Category framing: outputs/PITCH_DECK_OUTLINE.md.</a:t>
+            </a:r>
+          </a:p>
+          <a:p xmlns:a="http://schemas.openxmlformats.org/drawingml/2006/main">
+            <a:r>
+              <a:t>- Current LRWA workflow: lrwa-agent and lrwa-agent-web source repositories.</a:t>
+            </a:r>
+          </a:p>
+          <a:p xmlns:a="http://schemas.openxmlformats.org/drawingml/2006/main">
+            <a:r>
+              <a:t>- This is a positioning hypothesis, not an exclusivity or market-share claim.</a:t>
+            </a:r>
+          </a:p>
+          <a:p xmlns:a="http://schemas.openxmlformats.org/drawingml/2006/main">
+            <a:r>
+              <a:t>- User-provided LRWA brand asset: favicon.svg.</a:t>
             </a:r>
           </a:p>
         </p:txBody>
@@ -1044,7 +1044,7 @@
           <a:lstStyle xmlns:a="http://schemas.openxmlformats.org/drawingml/2006/main"/>
           <a:p xmlns:a="http://schemas.openxmlformats.org/drawingml/2006/main">
             <a:r>
-              <a:t>We begin with a high-value business-to-business mission where the buyer has a clear decision and an explicit budget. Repeated missions can become a portfolio subscription. Licensed data and authorized connectors increase coverage. The same claim-to-mission engine can later support a merchant deciding where to open, but that is an expansion path, not the initial product.</a:t>
+              <a:t>Institutional diligence is the initial wedge. Team subscriptions, licensed sources, authorized connectors, and merchant location decisions are expansion hypotheses. The current prototype does not claim direct platform access.</a:t>
             </a:r>
           </a:p>
           <a:p xmlns:a="http://schemas.openxmlformats.org/drawingml/2006/main">
@@ -1059,22 +1059,22 @@
           </a:p>
           <a:p xmlns:a="http://schemas.openxmlformats.org/drawingml/2006/main">
             <a:r>
-              <a:t>- Business-model and expansion hypotheses: outputs/PITCH_DECK_OUTLINE.md</a:t>
-            </a:r>
-          </a:p>
-          <a:p xmlns:a="http://schemas.openxmlformats.org/drawingml/2006/main">
-            <a:r>
-              <a:t>- Responsive product screenshot: lrwa-agent-video/public/screens/mobile-plan.png</a:t>
-            </a:r>
-          </a:p>
-          <a:p xmlns:a="http://schemas.openxmlformats.org/drawingml/2006/main">
-            <a:r>
-              <a:t>- No pricing, recurring revenue, or customer renewal claim is asserted.</a:t>
-            </a:r>
-          </a:p>
-          <a:p xmlns:a="http://schemas.openxmlformats.org/drawingml/2006/main">
-            <a:r>
-              <a:t>- User-provided LRWA brand asset: favicon.svg</a:t>
+              <a:t>- Expansion hypotheses: outputs/PITCH_DECK_OUTLINE.md.</a:t>
+            </a:r>
+          </a:p>
+          <a:p xmlns:a="http://schemas.openxmlformats.org/drawingml/2006/main">
+            <a:r>
+              <a:t>- Screenshot: lrwa-agent-video/public/screens/evidence-home.jpg.</a:t>
+            </a:r>
+          </a:p>
+          <a:p xmlns:a="http://schemas.openxmlformats.org/drawingml/2006/main">
+            <a:r>
+              <a:t>- No pricing, recurring revenue, platform partnership, or customer renewal claim is asserted.</a:t>
+            </a:r>
+          </a:p>
+          <a:p xmlns:a="http://schemas.openxmlformats.org/drawingml/2006/main">
+            <a:r>
+              <a:t>- User-provided LRWA brand asset: favicon.svg.</a:t>
             </a:r>
           </a:p>
         </p:txBody>
@@ -1144,7 +1144,7 @@
           <a:lstStyle xmlns:a="http://schemas.openxmlformats.org/drawingml/2006/main"/>
           <a:p xmlns:a="http://schemas.openxmlformats.org/drawingml/2006/main">
             <a:r>
-              <a:t>We are not asking investors to underwrite a universal intelligence platform today. The seed proof is narrower: can LRWA find a material contradiction, show the evidence path, and direct a better next diligence action in one vertical? The round funds product, authorized data access, pilot delivery, and compliance. Exact terms and founder identity are intentionally reserved for private diligence.</a:t>
+              <a:t>What exists today is a local web prototype, a NestJS evidence-operations API, four role routes, explicit prepared/contact/receipt states, manual receipt intake, server-side SHA-256 hashing, and a conclusion gate that stays locked when evidence is empty. Design partners, a paid authorized pilot, durable storage, authentication, and a licensed connector remain targets.</a:t>
             </a:r>
           </a:p>
           <a:p xmlns:a="http://schemas.openxmlformats.org/drawingml/2006/main">
@@ -1159,22 +1159,22 @@
           </a:p>
           <a:p xmlns:a="http://schemas.openxmlformats.org/drawingml/2006/main">
             <a:r>
-              <a:t>- Current demo capabilities and target proof points: outputs/PITCH_DECK_OUTLINE.md</a:t>
-            </a:r>
-          </a:p>
-          <a:p xmlns:a="http://schemas.openxmlformats.org/drawingml/2006/main">
-            <a:r>
-              <a:t>- Canonical synthetic case metrics: outputs/OPENARENA_SUBMISSION.md</a:t>
-            </a:r>
-          </a:p>
-          <a:p xmlns:a="http://schemas.openxmlformats.org/drawingml/2006/main">
-            <a:r>
-              <a:t>- Design partners, paid pilot, and connector are target milestones, not current traction.</a:t>
-            </a:r>
-          </a:p>
-          <a:p xmlns:a="http://schemas.openxmlformats.org/drawingml/2006/main">
-            <a:r>
-              <a:t>- User-provided LRWA brand asset: favicon.svg</a:t>
+              <a:t>- Current implementation: lrwa-agent-web and lrwa-agent source repositories.</a:t>
+            </a:r>
+          </a:p>
+          <a:p xmlns:a="http://schemas.openxmlformats.org/drawingml/2006/main">
+            <a:r>
+              <a:t>- Current proof plan: outputs/PITCH_DECK_OUTLINE.md.</a:t>
+            </a:r>
+          </a:p>
+          <a:p xmlns:a="http://schemas.openxmlformats.org/drawingml/2006/main">
+            <a:r>
+              <a:t>- Future milestones are labeled targets and are not current traction.</a:t>
+            </a:r>
+          </a:p>
+          <a:p xmlns:a="http://schemas.openxmlformats.org/drawingml/2006/main">
+            <a:r>
+              <a:t>- User-provided LRWA brand asset: favicon.svg.</a:t>
             </a:r>
           </a:p>
         </p:txBody>
@@ -1242,7 +1242,7 @@
   </p:cSld>
   <p:clrMap bg1="lt1" tx1="dk1" bg2="lt2" tx2="dk2" accent1="accent1" accent2="accent2" accent3="accent3" accent4="accent4" accent5="accent5" accent6="accent6" hlink="hlink" folHlink="folHlink"/>
   <p:sldLayoutIdLst>
-    <p:sldLayoutId xmlns:r="http://schemas.openxmlformats.org/officeDocument/2006/relationships" id="2147483649" r:id="R00ac81e9da9b4f7f"/>
+    <p:sldLayoutId xmlns:r="http://schemas.openxmlformats.org/officeDocument/2006/relationships" id="2147483649" r:id="Rb81a22adfb064295"/>
   </p:sldLayoutIdLst>
   <p:txStyles>
     <p:titleStyle>
@@ -1790,14 +1790,14 @@
       </p:grpSpPr>
       <p:pic>
         <p:nvPicPr>
-          <p:cNvPr id="11" name=""/>
+          <p:cNvPr id="13" name=""/>
           <p:cNvPicPr>
             <a:picLocks xmlns:a="http://schemas.openxmlformats.org/drawingml/2006/main" noChangeAspect="1"/>
           </p:cNvPicPr>
           <p:nvPr/>
         </p:nvPicPr>
         <p:blipFill>
-          <a:blip xmlns:r="http://schemas.openxmlformats.org/officeDocument/2006/relationships" xmlns:a="http://schemas.openxmlformats.org/drawingml/2006/main" r:embed="Rfed9c9ba70f34232"/>
+          <a:blip xmlns:r="http://schemas.openxmlformats.org/officeDocument/2006/relationships" xmlns:a="http://schemas.openxmlformats.org/drawingml/2006/main" r:embed="Rbcdd2ae7e0f946f0"/>
           <a:srcRect xmlns:a="http://schemas.openxmlformats.org/drawingml/2006/main" l="0" t="27" r="0" b="27"/>
           <a:stretch xmlns:a="http://schemas.openxmlformats.org/drawingml/2006/main">
             <a:fillRect l="0" t="0" r="0" b="0"/>
@@ -1861,17 +1861,17 @@
       </p:sp>
       <p:pic>
         <p:nvPicPr>
-          <p:cNvPr id="13" name=""/>
+          <p:cNvPr id="15" name=""/>
           <p:cNvPicPr>
             <a:picLocks xmlns:a="http://schemas.openxmlformats.org/drawingml/2006/main" noChangeAspect="1"/>
           </p:cNvPicPr>
           <p:nvPr/>
         </p:nvPicPr>
         <p:blipFill>
-          <a:blip xmlns:r="http://schemas.openxmlformats.org/officeDocument/2006/relationships" xmlns:a="http://schemas.openxmlformats.org/drawingml/2006/main" r:embed="Raa4d49d5fde94ebd">
+          <a:blip xmlns:r="http://schemas.openxmlformats.org/officeDocument/2006/relationships" xmlns:a="http://schemas.openxmlformats.org/drawingml/2006/main" r:embed="R4227bc84422049f9">
             <a:extLst>
               <a:ext uri="{96DAC541-7B7A-43D3-8B79-37D633B846F1}">
-                <asvg:svgBlip xmlns:asvg="http://schemas.microsoft.com/office/drawing/2016/SVG/main" r:embed="R5f7ef12c8f2142b0"/>
+                <asvg:svgBlip xmlns:asvg="http://schemas.microsoft.com/office/drawing/2016/SVG/main" r:embed="R215ce5f5784d4222"/>
               </a:ext>
             </a:extLst>
           </a:blip>
@@ -1922,6 +1922,7 @@
           <a:lstStyle xmlns:a="http://schemas.openxmlformats.org/drawingml/2006/main"/>
           <a:p xmlns:a="http://schemas.openxmlformats.org/drawingml/2006/main">
             <a:pPr algn="l">
+              <a:buNone/>
               <a:defRPr sz="1050" b="1">
                 <a:solidFill>
                   <a:srgbClr val="FF5B22"/>
@@ -2037,7 +2038,7 @@
         </p:spPr>
         <p:txBody>
           <a:bodyPr xmlns:a="http://schemas.openxmlformats.org/drawingml/2006/main" wrap="square" lIns="0" tIns="0" rIns="0" bIns="0" anchor="t">
-            <a:normAutofit fontScale="100000"/>
+            <a:normAutofit fontScale="87380"/>
           </a:bodyPr>
           <a:lstStyle xmlns:a="http://schemas.openxmlformats.org/drawingml/2006/main"/>
           <a:p xmlns:a="http://schemas.openxmlformats.org/drawingml/2006/main">
@@ -2064,7 +2065,7 @@
                 <a:ea typeface="Arial"/>
                 <a:cs typeface="Arial"/>
               </a:rPr>
-              <a:t>Test the world behind</a:t>
+              <a:t>Evidence before answers.</a:t>
             </a:r>
           </a:p>
           <a:p xmlns:a="http://schemas.openxmlformats.org/drawingml/2006/main">
@@ -2091,7 +2092,7 @@
                 <a:ea typeface="Arial"/>
                 <a:cs typeface="Arial"/>
               </a:rPr>
-              <a:t>the spreadsheet.</a:t>
+              <a:t>No receipt, no conclusion.</a:t>
             </a:r>
           </a:p>
         </p:txBody>
@@ -2131,6 +2132,7 @@
           <a:lstStyle xmlns:a="http://schemas.openxmlformats.org/drawingml/2006/main"/>
           <a:p xmlns:a="http://schemas.openxmlformats.org/drawingml/2006/main">
             <a:pPr algn="l">
+              <a:buNone/>
               <a:defRPr sz="1875" b="0">
                 <a:solidFill>
                   <a:srgbClr val="A6A3A0"/>
@@ -2149,7 +2151,7 @@
                 <a:ea typeface="Arial"/>
                 <a:cs typeface="Arial"/>
               </a:rPr>
-              <a:t>Multi-agent commercial verification</a:t>
+              <a:t>Four roles. Exact receipts. Human review.</a:t>
             </a:r>
           </a:p>
         </p:txBody>
@@ -2220,6 +2222,7 @@
           <a:lstStyle xmlns:a="http://schemas.openxmlformats.org/drawingml/2006/main"/>
           <a:p xmlns:a="http://schemas.openxmlformats.org/drawingml/2006/main">
             <a:pPr algn="l">
+              <a:buNone/>
               <a:defRPr sz="1125" b="1">
                 <a:solidFill>
                   <a:srgbClr val="FF8A55"/>
@@ -2278,6 +2281,7 @@
           <a:lstStyle xmlns:a="http://schemas.openxmlformats.org/drawingml/2006/main"/>
           <a:p xmlns:a="http://schemas.openxmlformats.org/drawingml/2006/main">
             <a:pPr algn="l">
+              <a:buNone/>
               <a:defRPr sz="1200" b="0">
                 <a:solidFill>
                   <a:srgbClr val="6F6D6B"/>
@@ -2398,6 +2402,7 @@
           <a:lstStyle xmlns:a="http://schemas.openxmlformats.org/drawingml/2006/main"/>
           <a:p xmlns:a="http://schemas.openxmlformats.org/drawingml/2006/main">
             <a:pPr algn="l">
+              <a:buNone/>
               <a:defRPr sz="1050" b="1">
                 <a:solidFill>
                   <a:srgbClr val="FF5B22"/>
@@ -2456,6 +2461,7 @@
           <a:lstStyle xmlns:a="http://schemas.openxmlformats.org/drawingml/2006/main"/>
           <a:p xmlns:a="http://schemas.openxmlformats.org/drawingml/2006/main">
             <a:pPr algn="r">
+              <a:buNone/>
               <a:defRPr sz="975" b="0">
                 <a:solidFill>
                   <a:srgbClr val="6F6D6B"/>
@@ -2512,17 +2518,17 @@
       </p:sp>
       <p:pic>
         <p:nvPicPr>
-          <p:cNvPr id="34" name=""/>
+          <p:cNvPr id="36" name=""/>
           <p:cNvPicPr>
             <a:picLocks xmlns:a="http://schemas.openxmlformats.org/drawingml/2006/main" noChangeAspect="1"/>
           </p:cNvPicPr>
           <p:nvPr/>
         </p:nvPicPr>
         <p:blipFill>
-          <a:blip xmlns:r="http://schemas.openxmlformats.org/officeDocument/2006/relationships" xmlns:a="http://schemas.openxmlformats.org/drawingml/2006/main" r:embed="R8323816f1e77457d">
+          <a:blip xmlns:r="http://schemas.openxmlformats.org/officeDocument/2006/relationships" xmlns:a="http://schemas.openxmlformats.org/drawingml/2006/main" r:embed="R4ed2f6917dc143a8">
             <a:extLst>
               <a:ext uri="{96DAC541-7B7A-43D3-8B79-37D633B846F1}">
-                <asvg:svgBlip xmlns:asvg="http://schemas.microsoft.com/office/drawing/2016/SVG/main" r:embed="Rd67b9a344bc14acf"/>
+                <asvg:svgBlip xmlns:asvg="http://schemas.microsoft.com/office/drawing/2016/SVG/main" r:embed="R5b9db7f4a6cd413d"/>
               </a:ext>
             </a:extLst>
           </a:blip>
@@ -2573,6 +2579,7 @@
           <a:lstStyle xmlns:a="http://schemas.openxmlformats.org/drawingml/2006/main"/>
           <a:p xmlns:a="http://schemas.openxmlformats.org/drawingml/2006/main">
             <a:pPr algn="l">
+              <a:buNone/>
               <a:defRPr sz="750" b="1">
                 <a:solidFill>
                   <a:srgbClr val="6F6D6B"/>
@@ -2631,6 +2638,7 @@
           <a:lstStyle xmlns:a="http://schemas.openxmlformats.org/drawingml/2006/main"/>
           <a:p xmlns:a="http://schemas.openxmlformats.org/drawingml/2006/main">
             <a:pPr algn="r">
+              <a:buNone/>
               <a:defRPr sz="750" b="1">
                 <a:solidFill>
                   <a:srgbClr val="6F6D6B"/>
@@ -2773,7 +2781,7 @@
         </p:spPr>
         <p:txBody>
           <a:bodyPr xmlns:a="http://schemas.openxmlformats.org/drawingml/2006/main" wrap="square" lIns="0" tIns="0" rIns="0" bIns="0" anchor="t">
-            <a:normAutofit fontScale="93275"/>
+            <a:normAutofit fontScale="100000"/>
           </a:bodyPr>
           <a:lstStyle xmlns:a="http://schemas.openxmlformats.org/drawingml/2006/main"/>
           <a:p xmlns:a="http://schemas.openxmlformats.org/drawingml/2006/main">
@@ -2800,7 +2808,7 @@
                 <a:ea typeface="Arial"/>
                 <a:cs typeface="Arial"/>
               </a:rPr>
-              <a:t>A model can test internal consistency. It cannot independently establish whether operations match the narrative.</a:t>
+              <a:t>AI can test internal consistency. It cannot turn a supplied narrative into independent evidence.</a:t>
             </a:r>
           </a:p>
         </p:txBody>
@@ -2871,6 +2879,7 @@
           <a:lstStyle xmlns:a="http://schemas.openxmlformats.org/drawingml/2006/main"/>
           <a:p xmlns:a="http://schemas.openxmlformats.org/drawingml/2006/main">
             <a:pPr algn="l">
+              <a:buNone/>
               <a:defRPr sz="1050" b="1">
                 <a:solidFill>
                   <a:srgbClr val="FF5B22"/>
@@ -2929,6 +2938,7 @@
           <a:lstStyle xmlns:a="http://schemas.openxmlformats.org/drawingml/2006/main"/>
           <a:p xmlns:a="http://schemas.openxmlformats.org/drawingml/2006/main">
             <a:pPr algn="l">
+              <a:buNone/>
               <a:defRPr sz="1350" b="1">
                 <a:solidFill>
                   <a:srgbClr val="6F6D6B"/>
@@ -2987,6 +2997,7 @@
           <a:lstStyle xmlns:a="http://schemas.openxmlformats.org/drawingml/2006/main"/>
           <a:p xmlns:a="http://schemas.openxmlformats.org/drawingml/2006/main">
             <a:pPr algn="l">
+              <a:buNone/>
               <a:defRPr sz="1800" b="0">
                 <a:solidFill>
                   <a:srgbClr val="A6A3A0"/>
@@ -3076,6 +3087,7 @@
           <a:lstStyle xmlns:a="http://schemas.openxmlformats.org/drawingml/2006/main"/>
           <a:p xmlns:a="http://schemas.openxmlformats.org/drawingml/2006/main">
             <a:pPr algn="l">
+              <a:buNone/>
               <a:defRPr sz="1350" b="1">
                 <a:solidFill>
                   <a:srgbClr val="6F6D6B"/>
@@ -3134,6 +3146,7 @@
           <a:lstStyle xmlns:a="http://schemas.openxmlformats.org/drawingml/2006/main"/>
           <a:p xmlns:a="http://schemas.openxmlformats.org/drawingml/2006/main">
             <a:pPr algn="l">
+              <a:buNone/>
               <a:defRPr sz="1800" b="0">
                 <a:solidFill>
                   <a:srgbClr val="A6A3A0"/>
@@ -3223,6 +3236,7 @@
           <a:lstStyle xmlns:a="http://schemas.openxmlformats.org/drawingml/2006/main"/>
           <a:p xmlns:a="http://schemas.openxmlformats.org/drawingml/2006/main">
             <a:pPr algn="l">
+              <a:buNone/>
               <a:defRPr sz="1350" b="1">
                 <a:solidFill>
                   <a:srgbClr val="6F6D6B"/>
@@ -3281,6 +3295,7 @@
           <a:lstStyle xmlns:a="http://schemas.openxmlformats.org/drawingml/2006/main"/>
           <a:p xmlns:a="http://schemas.openxmlformats.org/drawingml/2006/main">
             <a:pPr algn="l">
+              <a:buNone/>
               <a:defRPr sz="1800" b="0">
                 <a:solidFill>
                   <a:srgbClr val="A6A3A0"/>
@@ -3370,6 +3385,7 @@
           <a:lstStyle xmlns:a="http://schemas.openxmlformats.org/drawingml/2006/main"/>
           <a:p xmlns:a="http://schemas.openxmlformats.org/drawingml/2006/main">
             <a:pPr algn="l">
+              <a:buNone/>
               <a:defRPr sz="1350" b="1">
                 <a:solidFill>
                   <a:srgbClr val="6F6D6B"/>
@@ -3428,6 +3444,7 @@
           <a:lstStyle xmlns:a="http://schemas.openxmlformats.org/drawingml/2006/main"/>
           <a:p xmlns:a="http://schemas.openxmlformats.org/drawingml/2006/main">
             <a:pPr algn="l">
+              <a:buNone/>
               <a:defRPr sz="1800" b="0">
                 <a:solidFill>
                   <a:srgbClr val="A6A3A0"/>
@@ -3446,7 +3463,7 @@
                 <a:ea typeface="Arial"/>
                 <a:cs typeface="Arial"/>
               </a:rPr>
-              <a:t>One-off fieldwork</a:t>
+              <a:t>Authorized field contact</a:t>
             </a:r>
           </a:p>
         </p:txBody>
@@ -3517,6 +3534,7 @@
           <a:lstStyle xmlns:a="http://schemas.openxmlformats.org/drawingml/2006/main"/>
           <a:p xmlns:a="http://schemas.openxmlformats.org/drawingml/2006/main">
             <a:pPr algn="l">
+              <a:buNone/>
               <a:defRPr sz="1350" b="1">
                 <a:solidFill>
                   <a:srgbClr val="FF5B22"/>
@@ -3575,6 +3593,7 @@
           <a:lstStyle xmlns:a="http://schemas.openxmlformats.org/drawingml/2006/main"/>
           <a:p xmlns:a="http://schemas.openxmlformats.org/drawingml/2006/main">
             <a:pPr algn="l">
+              <a:buNone/>
               <a:defRPr sz="1800" b="1">
                 <a:solidFill>
                   <a:srgbClr val="F4F3EF"/>
@@ -3699,6 +3718,7 @@
           <a:lstStyle xmlns:a="http://schemas.openxmlformats.org/drawingml/2006/main"/>
           <a:p xmlns:a="http://schemas.openxmlformats.org/drawingml/2006/main">
             <a:pPr algn="l">
+              <a:buNone/>
               <a:defRPr sz="975" b="1">
                 <a:solidFill>
                   <a:srgbClr val="FF6A62"/>
@@ -3757,6 +3777,7 @@
           <a:lstStyle xmlns:a="http://schemas.openxmlformats.org/drawingml/2006/main"/>
           <a:p xmlns:a="http://schemas.openxmlformats.org/drawingml/2006/main">
             <a:pPr algn="l">
+              <a:buNone/>
               <a:defRPr sz="2250" b="1">
                 <a:solidFill>
                   <a:srgbClr val="F4F3EF"/>
@@ -3775,7 +3796,7 @@
                 <a:ea typeface="Arial"/>
                 <a:cs typeface="Arial"/>
               </a:rPr>
-              <a:t>Do outside signals support the same claim?</a:t>
+              <a:t>Which claim still lacks an inspectable receipt?</a:t>
             </a:r>
           </a:p>
         </p:txBody>
@@ -3877,6 +3898,7 @@
           <a:lstStyle xmlns:a="http://schemas.openxmlformats.org/drawingml/2006/main"/>
           <a:p xmlns:a="http://schemas.openxmlformats.org/drawingml/2006/main">
             <a:pPr algn="l">
+              <a:buNone/>
               <a:defRPr sz="1050" b="1">
                 <a:solidFill>
                   <a:srgbClr val="FF5B22"/>
@@ -3935,6 +3957,7 @@
           <a:lstStyle xmlns:a="http://schemas.openxmlformats.org/drawingml/2006/main"/>
           <a:p xmlns:a="http://schemas.openxmlformats.org/drawingml/2006/main">
             <a:pPr algn="r">
+              <a:buNone/>
               <a:defRPr sz="975" b="0">
                 <a:solidFill>
                   <a:srgbClr val="6F6D6B"/>
@@ -3991,17 +4014,17 @@
       </p:sp>
       <p:pic>
         <p:nvPicPr>
-          <p:cNvPr id="37" name=""/>
+          <p:cNvPr id="42" name=""/>
           <p:cNvPicPr>
             <a:picLocks xmlns:a="http://schemas.openxmlformats.org/drawingml/2006/main" noChangeAspect="1"/>
           </p:cNvPicPr>
           <p:nvPr/>
         </p:nvPicPr>
         <p:blipFill>
-          <a:blip xmlns:r="http://schemas.openxmlformats.org/officeDocument/2006/relationships" xmlns:a="http://schemas.openxmlformats.org/drawingml/2006/main" r:embed="Rb0be71a2eda2444f">
+          <a:blip xmlns:r="http://schemas.openxmlformats.org/officeDocument/2006/relationships" xmlns:a="http://schemas.openxmlformats.org/drawingml/2006/main" r:embed="R5a55a688fb79431a">
             <a:extLst>
               <a:ext uri="{96DAC541-7B7A-43D3-8B79-37D633B846F1}">
-                <asvg:svgBlip xmlns:asvg="http://schemas.microsoft.com/office/drawing/2016/SVG/main" r:embed="R5afe09c5857d4dfd"/>
+                <asvg:svgBlip xmlns:asvg="http://schemas.microsoft.com/office/drawing/2016/SVG/main" r:embed="R15dd6311dd8e4224"/>
               </a:ext>
             </a:extLst>
           </a:blip>
@@ -4052,6 +4075,7 @@
           <a:lstStyle xmlns:a="http://schemas.openxmlformats.org/drawingml/2006/main"/>
           <a:p xmlns:a="http://schemas.openxmlformats.org/drawingml/2006/main">
             <a:pPr algn="l">
+              <a:buNone/>
               <a:defRPr sz="750" b="1">
                 <a:solidFill>
                   <a:srgbClr val="6F6D6B"/>
@@ -4110,6 +4134,7 @@
           <a:lstStyle xmlns:a="http://schemas.openxmlformats.org/drawingml/2006/main"/>
           <a:p xmlns:a="http://schemas.openxmlformats.org/drawingml/2006/main">
             <a:pPr algn="r">
+              <a:buNone/>
               <a:defRPr sz="750" b="1">
                 <a:solidFill>
                   <a:srgbClr val="6F6D6B"/>
@@ -4230,6 +4255,7 @@
           <a:lstStyle xmlns:a="http://schemas.openxmlformats.org/drawingml/2006/main"/>
           <a:p xmlns:a="http://schemas.openxmlformats.org/drawingml/2006/main">
             <a:pPr algn="r">
+              <a:buNone/>
               <a:defRPr sz="975" b="1">
                 <a:solidFill>
                   <a:srgbClr val="F3C45E"/>
@@ -4248,7 +4274,7 @@
                 <a:ea typeface="Courier New"/>
                 <a:cs typeface="Courier New"/>
               </a:rPr>
-              <a:t>SYNTHETIC MORROW COFFEE CASE</a:t>
+              <a:t>CURRENT PROTOTYPE · CONNECTORS OFF</a:t>
             </a:r>
           </a:p>
         </p:txBody>
@@ -4296,28 +4322,26 @@
       </p:sp>
       <p:pic>
         <p:nvPicPr>
-          <p:cNvPr id="43" name=""/>
+          <p:cNvPr id="48" name=""/>
           <p:cNvPicPr>
             <a:picLocks xmlns:a="http://schemas.openxmlformats.org/drawingml/2006/main" noChangeAspect="1"/>
           </p:cNvPicPr>
           <p:nvPr/>
         </p:nvPicPr>
         <p:blipFill>
-          <a:blip xmlns:r="http://schemas.openxmlformats.org/officeDocument/2006/relationships" xmlns:a="http://schemas.openxmlformats.org/drawingml/2006/main" r:embed="R6e0e607aa045419e"/>
+          <a:blip xmlns:r="http://schemas.openxmlformats.org/officeDocument/2006/relationships" xmlns:a="http://schemas.openxmlformats.org/drawingml/2006/main" r:embed="R5de16ecba73b473c"/>
           <a:srcRect xmlns:a="http://schemas.openxmlformats.org/drawingml/2006/main" l="0" t="112" r="0" b="112"/>
           <a:stretch xmlns:a="http://schemas.openxmlformats.org/drawingml/2006/main">
             <a:fillRect l="0" t="0" r="0" b="0"/>
           </a:stretch>
         </p:blipFill>
         <p:spPr>
-          <a:xfrm xmlns:a="http://schemas.openxmlformats.org/drawingml/2006/main">
+          <a:xfrm xmlns:a="http://schemas.openxmlformats.org/drawingml/2006/main" flipH="0" flipV="0">
             <a:off x="609600" y="1657350"/>
             <a:ext cx="3390900" cy="2114550"/>
           </a:xfrm>
           <a:prstGeom xmlns:a="http://schemas.openxmlformats.org/drawingml/2006/main" prst="roundRect">
-            <a:avLst>
-              <a:gd name="adj" fmla="val 5405"/>
-            </a:avLst>
+            <a:avLst/>
           </a:prstGeom>
         </p:spPr>
       </p:pic>
@@ -4364,28 +4388,26 @@
       </p:sp>
       <p:pic>
         <p:nvPicPr>
-          <p:cNvPr id="45" name=""/>
+          <p:cNvPr id="50" name=""/>
           <p:cNvPicPr>
             <a:picLocks xmlns:a="http://schemas.openxmlformats.org/drawingml/2006/main" noChangeAspect="1"/>
           </p:cNvPicPr>
           <p:nvPr/>
         </p:nvPicPr>
         <p:blipFill>
-          <a:blip xmlns:r="http://schemas.openxmlformats.org/officeDocument/2006/relationships" xmlns:a="http://schemas.openxmlformats.org/drawingml/2006/main" r:embed="Rabe536bbaee44aa6"/>
+          <a:blip xmlns:r="http://schemas.openxmlformats.org/officeDocument/2006/relationships" xmlns:a="http://schemas.openxmlformats.org/drawingml/2006/main" r:embed="R678deafa400e44e5"/>
           <a:srcRect xmlns:a="http://schemas.openxmlformats.org/drawingml/2006/main" l="0" t="112" r="0" b="112"/>
           <a:stretch xmlns:a="http://schemas.openxmlformats.org/drawingml/2006/main">
             <a:fillRect l="0" t="0" r="0" b="0"/>
           </a:stretch>
         </p:blipFill>
         <p:spPr>
-          <a:xfrm xmlns:a="http://schemas.openxmlformats.org/drawingml/2006/main">
+          <a:xfrm xmlns:a="http://schemas.openxmlformats.org/drawingml/2006/main" flipH="0" flipV="0">
             <a:off x="4400550" y="1657350"/>
             <a:ext cx="3390900" cy="2114550"/>
           </a:xfrm>
           <a:prstGeom xmlns:a="http://schemas.openxmlformats.org/drawingml/2006/main" prst="roundRect">
-            <a:avLst>
-              <a:gd name="adj" fmla="val 5405"/>
-            </a:avLst>
+            <a:avLst/>
           </a:prstGeom>
         </p:spPr>
       </p:pic>
@@ -4432,28 +4454,26 @@
       </p:sp>
       <p:pic>
         <p:nvPicPr>
-          <p:cNvPr id="47" name=""/>
+          <p:cNvPr id="52" name=""/>
           <p:cNvPicPr>
             <a:picLocks xmlns:a="http://schemas.openxmlformats.org/drawingml/2006/main" noChangeAspect="1"/>
           </p:cNvPicPr>
           <p:nvPr/>
         </p:nvPicPr>
         <p:blipFill>
-          <a:blip xmlns:r="http://schemas.openxmlformats.org/officeDocument/2006/relationships" xmlns:a="http://schemas.openxmlformats.org/drawingml/2006/main" r:embed="R4796c2a9c5d54c3f"/>
+          <a:blip xmlns:r="http://schemas.openxmlformats.org/officeDocument/2006/relationships" xmlns:a="http://schemas.openxmlformats.org/drawingml/2006/main" r:embed="R5a55a688fb79431a"/>
           <a:srcRect xmlns:a="http://schemas.openxmlformats.org/drawingml/2006/main" l="0" t="112" r="0" b="112"/>
           <a:stretch xmlns:a="http://schemas.openxmlformats.org/drawingml/2006/main">
             <a:fillRect l="0" t="0" r="0" b="0"/>
           </a:stretch>
         </p:blipFill>
         <p:spPr>
-          <a:xfrm xmlns:a="http://schemas.openxmlformats.org/drawingml/2006/main">
+          <a:xfrm xmlns:a="http://schemas.openxmlformats.org/drawingml/2006/main" flipH="0" flipV="0">
             <a:off x="8191500" y="1657350"/>
             <a:ext cx="3390900" cy="2114550"/>
           </a:xfrm>
           <a:prstGeom xmlns:a="http://schemas.openxmlformats.org/drawingml/2006/main" prst="roundRect">
-            <a:avLst>
-              <a:gd name="adj" fmla="val 5405"/>
-            </a:avLst>
+            <a:avLst/>
           </a:prstGeom>
         </p:spPr>
       </p:pic>
@@ -4492,6 +4512,7 @@
           <a:lstStyle xmlns:a="http://schemas.openxmlformats.org/drawingml/2006/main"/>
           <a:p xmlns:a="http://schemas.openxmlformats.org/drawingml/2006/main">
             <a:pPr algn="l">
+              <a:buNone/>
               <a:defRPr sz="975" b="1">
                 <a:solidFill>
                   <a:srgbClr val="6F6D6B"/>
@@ -4510,7 +4531,7 @@
                 <a:ea typeface="Courier New"/>
                 <a:cs typeface="Courier New"/>
               </a:rPr>
-              <a:t>01  PLAN + DEMO GATE</a:t>
+              <a:t>01  CLAIM → ROLE PLAN</a:t>
             </a:r>
           </a:p>
         </p:txBody>
@@ -4550,6 +4571,7 @@
           <a:lstStyle xmlns:a="http://schemas.openxmlformats.org/drawingml/2006/main"/>
           <a:p xmlns:a="http://schemas.openxmlformats.org/drawingml/2006/main">
             <a:pPr algn="l">
+              <a:buNone/>
               <a:defRPr sz="975" b="1">
                 <a:solidFill>
                   <a:srgbClr val="FF5B22"/>
@@ -4568,7 +4590,7 @@
                 <a:ea typeface="Courier New"/>
                 <a:cs typeface="Courier New"/>
               </a:rPr>
-              <a:t>02  OBSERVE + CHALLENGE</a:t>
+              <a:t>02  PREPARED ≠ SENT</a:t>
             </a:r>
           </a:p>
         </p:txBody>
@@ -4608,6 +4630,7 @@
           <a:lstStyle xmlns:a="http://schemas.openxmlformats.org/drawingml/2006/main"/>
           <a:p xmlns:a="http://schemas.openxmlformats.org/drawingml/2006/main">
             <a:pPr algn="l">
+              <a:buNone/>
               <a:defRPr sz="975" b="1">
                 <a:solidFill>
                   <a:srgbClr val="6F6D6B"/>
@@ -4626,7 +4649,7 @@
                 <a:ea typeface="Courier New"/>
                 <a:cs typeface="Courier New"/>
               </a:rPr>
-              <a:t>03  INSPECT + ACT</a:t>
+              <a:t>03  EMPTY GATE STAYS LOCKED</a:t>
             </a:r>
           </a:p>
         </p:txBody>
@@ -4661,11 +4684,12 @@
         </p:spPr>
         <p:txBody>
           <a:bodyPr xmlns:a="http://schemas.openxmlformats.org/drawingml/2006/main" wrap="square" lIns="0" tIns="0" rIns="0" bIns="0" anchor="t">
-            <a:normAutofit fontScale="100000"/>
+            <a:normAutofit fontScale="98879"/>
           </a:bodyPr>
           <a:lstStyle xmlns:a="http://schemas.openxmlformats.org/drawingml/2006/main"/>
           <a:p xmlns:a="http://schemas.openxmlformats.org/drawingml/2006/main">
             <a:pPr algn="l">
+              <a:buNone/>
               <a:defRPr sz="1275" b="1">
                 <a:solidFill>
                   <a:srgbClr val="F4F3EF"/>
@@ -4684,7 +4708,7 @@
                 <a:ea typeface="Courier New"/>
                 <a:cs typeface="Courier New"/>
               </a:rPr>
-              <a:t>CLAIM  →  PROBE  →  CHALLENGE  →  DEMO GATE  →  DECIDE</a:t>
+              <a:t>CLAIM  →  PLAN  →  PREPARE  →  CONFIRM  →  RECEIPT  →  REVIEW</a:t>
             </a:r>
           </a:p>
         </p:txBody>
@@ -4724,6 +4748,7 @@
           <a:lstStyle xmlns:a="http://schemas.openxmlformats.org/drawingml/2006/main"/>
           <a:p xmlns:a="http://schemas.openxmlformats.org/drawingml/2006/main">
             <a:pPr algn="l">
+              <a:buNone/>
               <a:defRPr sz="1800" b="0">
                 <a:solidFill>
                   <a:srgbClr val="A6A3A0"/>
@@ -4742,7 +4767,7 @@
                 <a:ea typeface="Arial"/>
                 <a:cs typeface="Arial"/>
               </a:rPr>
-              <a:t>A repeatable decision workflow, not another report.</a:t>
+              <a:t>A staged evidence workflow, not a generated report.</a:t>
             </a:r>
           </a:p>
         </p:txBody>
@@ -4813,6 +4838,7 @@
           <a:lstStyle xmlns:a="http://schemas.openxmlformats.org/drawingml/2006/main"/>
           <a:p xmlns:a="http://schemas.openxmlformats.org/drawingml/2006/main">
             <a:pPr algn="l">
+              <a:buNone/>
               <a:defRPr sz="975" b="1">
                 <a:solidFill>
                   <a:srgbClr val="6F6D6B"/>
@@ -4831,7 +4857,7 @@
                 <a:ea typeface="Courier New"/>
                 <a:cs typeface="Courier New"/>
               </a:rPr>
-              <a:t>INITIAL SCENARIO</a:t>
+              <a:t>CURRENT STATE</a:t>
             </a:r>
           </a:p>
         </p:txBody>
@@ -4871,6 +4897,7 @@
           <a:lstStyle xmlns:a="http://schemas.openxmlformats.org/drawingml/2006/main"/>
           <a:p xmlns:a="http://schemas.openxmlformats.org/drawingml/2006/main">
             <a:pPr algn="l">
+              <a:buNone/>
               <a:defRPr sz="3150" b="1">
                 <a:solidFill>
                   <a:srgbClr val="FF5B22"/>
@@ -4889,7 +4916,7 @@
                 <a:ea typeface="Arial"/>
                 <a:cs typeface="Arial"/>
               </a:rPr>
-              <a:t>¥1.92m</a:t>
+              <a:t>PLAN</a:t>
             </a:r>
           </a:p>
         </p:txBody>
@@ -4929,6 +4956,7 @@
           <a:lstStyle xmlns:a="http://schemas.openxmlformats.org/drawingml/2006/main"/>
           <a:p xmlns:a="http://schemas.openxmlformats.org/drawingml/2006/main">
             <a:pPr algn="l">
+              <a:buNone/>
               <a:defRPr sz="825" b="1">
                 <a:solidFill>
                   <a:srgbClr val="6F6D6B"/>
@@ -4947,7 +4975,7 @@
                 <a:ea typeface="Courier New"/>
                 <a:cs typeface="Courier New"/>
               </a:rPr>
-              <a:t>FIXED SCENARIO BAND</a:t>
+              <a:t>DRAFT QUESTIONS</a:t>
             </a:r>
           </a:p>
         </p:txBody>
@@ -4987,6 +5015,7 @@
           <a:lstStyle xmlns:a="http://schemas.openxmlformats.org/drawingml/2006/main"/>
           <a:p xmlns:a="http://schemas.openxmlformats.org/drawingml/2006/main">
             <a:pPr algn="l">
+              <a:buNone/>
               <a:defRPr sz="1200" b="0">
                 <a:solidFill>
                   <a:srgbClr val="F4F3EF"/>
@@ -5005,7 +5034,7 @@
                 <a:ea typeface="Arial"/>
                 <a:cs typeface="Arial"/>
               </a:rPr>
-              <a:t>¥1.72m to ¥2.14m</a:t>
+              <a:t>No receipt yet</a:t>
             </a:r>
           </a:p>
         </p:txBody>
@@ -5067,7 +5096,7 @@
                 <a:ea typeface="Arial"/>
                 <a:cs typeface="Arial"/>
               </a:rPr>
-              <a:t>42.3% gap</a:t>
+              <a:t>No claim confirmed</a:t>
             </a:r>
           </a:p>
           <a:p xmlns:a="http://schemas.openxmlformats.org/drawingml/2006/main">
@@ -5094,7 +5123,7 @@
                 <a:ea typeface="Arial"/>
                 <a:cs typeface="Arial"/>
               </a:rPr>
-              <a:t>Heuristic policy score 0.88</a:t>
+              <a:t>No metric inferred</a:t>
             </a:r>
           </a:p>
         </p:txBody>
@@ -5134,6 +5163,7 @@
           <a:lstStyle xmlns:a="http://schemas.openxmlformats.org/drawingml/2006/main"/>
           <a:p xmlns:a="http://schemas.openxmlformats.org/drawingml/2006/main">
             <a:pPr algn="l">
+              <a:buNone/>
               <a:defRPr sz="975" b="1">
                 <a:solidFill>
                   <a:srgbClr val="6F6D6B"/>
@@ -5152,7 +5182,7 @@
                 <a:ea typeface="Courier New"/>
                 <a:cs typeface="Courier New"/>
               </a:rPr>
-              <a:t>REPLAY</a:t>
+              <a:t>GATE</a:t>
             </a:r>
           </a:p>
         </p:txBody>
@@ -5192,6 +5222,7 @@
           <a:lstStyle xmlns:a="http://schemas.openxmlformats.org/drawingml/2006/main"/>
           <a:p xmlns:a="http://schemas.openxmlformats.org/drawingml/2006/main">
             <a:pPr algn="l">
+              <a:buNone/>
               <a:defRPr sz="3150" b="1">
                 <a:solidFill>
                   <a:srgbClr val="F4F3EF"/>
@@ -5210,7 +5241,7 @@
                 <a:ea typeface="Arial"/>
                 <a:cs typeface="Arial"/>
               </a:rPr>
-              <a:t>¥2.40m</a:t>
+              <a:t>LOCKED</a:t>
             </a:r>
           </a:p>
         </p:txBody>
@@ -5250,6 +5281,7 @@
           <a:lstStyle xmlns:a="http://schemas.openxmlformats.org/drawingml/2006/main"/>
           <a:p xmlns:a="http://schemas.openxmlformats.org/drawingml/2006/main">
             <a:pPr algn="l">
+              <a:buNone/>
               <a:defRPr sz="825" b="1">
                 <a:solidFill>
                   <a:srgbClr val="6F6D6B"/>
@@ -5268,7 +5300,7 @@
                 <a:ea typeface="Courier New"/>
                 <a:cs typeface="Courier New"/>
               </a:rPr>
-              <a:t>FIXED REPLAY SCENARIO BAND</a:t>
+              <a:t>UNLOCK CONDITION</a:t>
             </a:r>
           </a:p>
         </p:txBody>
@@ -5308,6 +5340,7 @@
           <a:lstStyle xmlns:a="http://schemas.openxmlformats.org/drawingml/2006/main"/>
           <a:p xmlns:a="http://schemas.openxmlformats.org/drawingml/2006/main">
             <a:pPr algn="l">
+              <a:buNone/>
               <a:defRPr sz="1200" b="0">
                 <a:solidFill>
                   <a:srgbClr val="F4F3EF"/>
@@ -5326,7 +5359,7 @@
                 <a:ea typeface="Arial"/>
                 <a:cs typeface="Arial"/>
               </a:rPr>
-              <a:t>¥2.12m to ¥2.72m</a:t>
+              <a:t>User-submitted receipt</a:t>
             </a:r>
           </a:p>
         </p:txBody>
@@ -5388,7 +5421,7 @@
                 <a:ea typeface="Arial"/>
                 <a:cs typeface="Arial"/>
               </a:rPr>
-              <a:t>27.9% gap</a:t>
+              <a:t>Server hash + review</a:t>
             </a:r>
           </a:p>
           <a:p xmlns:a="http://schemas.openxmlformats.org/drawingml/2006/main">
@@ -5415,7 +5448,7 @@
                 <a:ea typeface="Arial"/>
                 <a:cs typeface="Arial"/>
               </a:rPr>
-              <a:t>Heuristic policy score 0.82</a:t>
+              <a:t>before any conclusion</a:t>
             </a:r>
           </a:p>
         </p:txBody>
@@ -5455,6 +5488,7 @@
           <a:lstStyle xmlns:a="http://schemas.openxmlformats.org/drawingml/2006/main"/>
           <a:p xmlns:a="http://schemas.openxmlformats.org/drawingml/2006/main">
             <a:pPr algn="r">
+              <a:buNone/>
               <a:defRPr sz="825" b="1">
                 <a:solidFill>
                   <a:srgbClr val="F3C45E"/>
@@ -5473,11 +5507,12 @@
                 <a:ea typeface="Courier New"/>
                 <a:cs typeface="Courier New"/>
               </a:rPr>
-              <a:t>PLANNED AGGREGATE PROBE QUOTA: 1,024</a:t>
+              <a:t>DISPLAYED STATE: PREPARED, NOT SENT</a:t>
             </a:r>
           </a:p>
           <a:p xmlns:a="http://schemas.openxmlformats.org/drawingml/2006/main">
             <a:pPr algn="r">
+              <a:buNone/>
               <a:defRPr sz="825" b="1">
                 <a:solidFill>
                   <a:srgbClr val="F3C45E"/>
@@ -5496,7 +5531,7 @@
                 <a:ea typeface="Courier New"/>
                 <a:cs typeface="Courier New"/>
               </a:rPr>
-              <a:t>ACTUAL OUTPUT: 5 RECEIPTS / 5 LOGICAL CATEGORIES</a:t>
+              <a:t>EVIDENCE ROOM: EMPTY / CONCLUSION LOCKED</a:t>
             </a:r>
           </a:p>
         </p:txBody>
@@ -5598,6 +5633,7 @@
           <a:lstStyle xmlns:a="http://schemas.openxmlformats.org/drawingml/2006/main"/>
           <a:p xmlns:a="http://schemas.openxmlformats.org/drawingml/2006/main">
             <a:pPr algn="l">
+              <a:buNone/>
               <a:defRPr sz="1050" b="1">
                 <a:solidFill>
                   <a:srgbClr val="FF5B22"/>
@@ -5656,6 +5692,7 @@
           <a:lstStyle xmlns:a="http://schemas.openxmlformats.org/drawingml/2006/main"/>
           <a:p xmlns:a="http://schemas.openxmlformats.org/drawingml/2006/main">
             <a:pPr algn="r">
+              <a:buNone/>
               <a:defRPr sz="975" b="0">
                 <a:solidFill>
                   <a:srgbClr val="6F6D6B"/>
@@ -5712,17 +5749,17 @@
       </p:sp>
       <p:pic>
         <p:nvPicPr>
-          <p:cNvPr id="62" name=""/>
+          <p:cNvPr id="65" name=""/>
           <p:cNvPicPr>
             <a:picLocks xmlns:a="http://schemas.openxmlformats.org/drawingml/2006/main" noChangeAspect="1"/>
           </p:cNvPicPr>
           <p:nvPr/>
         </p:nvPicPr>
         <p:blipFill>
-          <a:blip xmlns:r="http://schemas.openxmlformats.org/officeDocument/2006/relationships" xmlns:a="http://schemas.openxmlformats.org/drawingml/2006/main" r:embed="R330bc37159984b99">
+          <a:blip xmlns:r="http://schemas.openxmlformats.org/officeDocument/2006/relationships" xmlns:a="http://schemas.openxmlformats.org/drawingml/2006/main" r:embed="Re8ad3ef22a264998">
             <a:extLst>
               <a:ext uri="{96DAC541-7B7A-43D3-8B79-37D633B846F1}">
-                <asvg:svgBlip xmlns:asvg="http://schemas.microsoft.com/office/drawing/2016/SVG/main" r:embed="Rbe5f5fefa50b495e"/>
+                <asvg:svgBlip xmlns:asvg="http://schemas.microsoft.com/office/drawing/2016/SVG/main" r:embed="R47c5f8f4c51a4dc5"/>
               </a:ext>
             </a:extLst>
           </a:blip>
@@ -5773,6 +5810,7 @@
           <a:lstStyle xmlns:a="http://schemas.openxmlformats.org/drawingml/2006/main"/>
           <a:p xmlns:a="http://schemas.openxmlformats.org/drawingml/2006/main">
             <a:pPr algn="l">
+              <a:buNone/>
               <a:defRPr sz="750" b="1">
                 <a:solidFill>
                   <a:srgbClr val="6F6D6B"/>
@@ -5831,6 +5869,7 @@
           <a:lstStyle xmlns:a="http://schemas.openxmlformats.org/drawingml/2006/main"/>
           <a:p xmlns:a="http://schemas.openxmlformats.org/drawingml/2006/main">
             <a:pPr algn="r">
+              <a:buNone/>
               <a:defRPr sz="750" b="1">
                 <a:solidFill>
                   <a:srgbClr val="6F6D6B"/>
@@ -5911,7 +5950,7 @@
                 <a:ea typeface="Arial"/>
                 <a:cs typeface="Arial"/>
               </a:rPr>
-              <a:t>The moat is the governed loop, not the model.</a:t>
+              <a:t>The moat is the truth-state loop, not the model.</a:t>
             </a:r>
           </a:p>
         </p:txBody>
@@ -5973,7 +6012,7 @@
                 <a:ea typeface="Arial"/>
                 <a:cs typeface="Arial"/>
               </a:rPr>
-              <a:t>Claim-to-observable mappings and mission outcomes compound today; future source calibration and authorized connectors extend the loop.</a:t>
+              <a:t>AI may draft questions. Only user-confirmed contact and submitted receipts can move a claim toward review.</a:t>
             </a:r>
           </a:p>
         </p:txBody>
@@ -6296,6 +6335,7 @@
           <a:lstStyle xmlns:a="http://schemas.openxmlformats.org/drawingml/2006/main"/>
           <a:p xmlns:a="http://schemas.openxmlformats.org/drawingml/2006/main">
             <a:pPr algn="ctr">
+              <a:buNone/>
               <a:defRPr sz="1125" b="1">
                 <a:solidFill>
                   <a:srgbClr val="F4F3EF"/>
@@ -6354,6 +6394,7 @@
           <a:lstStyle xmlns:a="http://schemas.openxmlformats.org/drawingml/2006/main"/>
           <a:p xmlns:a="http://schemas.openxmlformats.org/drawingml/2006/main">
             <a:pPr algn="ctr">
+              <a:buNone/>
               <a:defRPr sz="1125" b="0">
                 <a:solidFill>
                   <a:srgbClr val="A6A3A0"/>
@@ -6372,7 +6413,7 @@
                 <a:ea typeface="Arial"/>
                 <a:cs typeface="Arial"/>
               </a:rPr>
-              <a:t>Compile</a:t>
+              <a:t>Bound</a:t>
             </a:r>
           </a:p>
         </p:txBody>
@@ -6447,6 +6488,7 @@
           <a:lstStyle xmlns:a="http://schemas.openxmlformats.org/drawingml/2006/main"/>
           <a:p xmlns:a="http://schemas.openxmlformats.org/drawingml/2006/main">
             <a:pPr algn="ctr">
+              <a:buNone/>
               <a:defRPr sz="1125" b="1">
                 <a:solidFill>
                   <a:srgbClr val="F4F3EF"/>
@@ -6505,6 +6547,7 @@
           <a:lstStyle xmlns:a="http://schemas.openxmlformats.org/drawingml/2006/main"/>
           <a:p xmlns:a="http://schemas.openxmlformats.org/drawingml/2006/main">
             <a:pPr algn="ctr">
+              <a:buNone/>
               <a:defRPr sz="1125" b="0">
                 <a:solidFill>
                   <a:srgbClr val="A6A3A0"/>
@@ -6523,7 +6566,7 @@
                 <a:ea typeface="Arial"/>
                 <a:cs typeface="Arial"/>
               </a:rPr>
-              <a:t>Bound</a:t>
+              <a:t>Draft</a:t>
             </a:r>
           </a:p>
         </p:txBody>
@@ -6598,6 +6641,7 @@
           <a:lstStyle xmlns:a="http://schemas.openxmlformats.org/drawingml/2006/main"/>
           <a:p xmlns:a="http://schemas.openxmlformats.org/drawingml/2006/main">
             <a:pPr algn="ctr">
+              <a:buNone/>
               <a:defRPr sz="1125" b="1">
                 <a:solidFill>
                   <a:srgbClr val="F4F3EF"/>
@@ -6616,7 +6660,7 @@
                 <a:ea typeface="Courier New"/>
                 <a:cs typeface="Courier New"/>
               </a:rPr>
-              <a:t>OBSERVE</a:t>
+              <a:t>PREPARE</a:t>
             </a:r>
           </a:p>
         </p:txBody>
@@ -6656,6 +6700,7 @@
           <a:lstStyle xmlns:a="http://schemas.openxmlformats.org/drawingml/2006/main"/>
           <a:p xmlns:a="http://schemas.openxmlformats.org/drawingml/2006/main">
             <a:pPr algn="ctr">
+              <a:buNone/>
               <a:defRPr sz="1125" b="0">
                 <a:solidFill>
                   <a:srgbClr val="A6A3A0"/>
@@ -6674,7 +6719,7 @@
                 <a:ea typeface="Arial"/>
                 <a:cs typeface="Arial"/>
               </a:rPr>
-              <a:t>Probe</a:t>
+              <a:t>Stage</a:t>
             </a:r>
           </a:p>
         </p:txBody>
@@ -6749,6 +6794,7 @@
           <a:lstStyle xmlns:a="http://schemas.openxmlformats.org/drawingml/2006/main"/>
           <a:p xmlns:a="http://schemas.openxmlformats.org/drawingml/2006/main">
             <a:pPr algn="ctr">
+              <a:buNone/>
               <a:defRPr sz="1125" b="1">
                 <a:solidFill>
                   <a:srgbClr val="FF5B22"/>
@@ -6767,7 +6813,7 @@
                 <a:ea typeface="Courier New"/>
                 <a:cs typeface="Courier New"/>
               </a:rPr>
-              <a:t>CHALLENGE</a:t>
+              <a:t>CONTACT</a:t>
             </a:r>
           </a:p>
         </p:txBody>
@@ -6807,6 +6853,7 @@
           <a:lstStyle xmlns:a="http://schemas.openxmlformats.org/drawingml/2006/main"/>
           <a:p xmlns:a="http://schemas.openxmlformats.org/drawingml/2006/main">
             <a:pPr algn="ctr">
+              <a:buNone/>
               <a:defRPr sz="1125" b="0">
                 <a:solidFill>
                   <a:srgbClr val="A6A3A0"/>
@@ -6825,7 +6872,7 @@
                 <a:ea typeface="Arial"/>
                 <a:cs typeface="Arial"/>
               </a:rPr>
-              <a:t>Falsify</a:t>
+              <a:t>Confirm</a:t>
             </a:r>
           </a:p>
         </p:txBody>
@@ -6900,6 +6947,7 @@
           <a:lstStyle xmlns:a="http://schemas.openxmlformats.org/drawingml/2006/main"/>
           <a:p xmlns:a="http://schemas.openxmlformats.org/drawingml/2006/main">
             <a:pPr algn="ctr">
+              <a:buNone/>
               <a:defRPr sz="1125" b="1">
                 <a:solidFill>
                   <a:srgbClr val="F4F3EF"/>
@@ -6918,7 +6966,7 @@
                 <a:ea typeface="Courier New"/>
                 <a:cs typeface="Courier New"/>
               </a:rPr>
-              <a:t>DECIDE</a:t>
+              <a:t>NEXT</a:t>
             </a:r>
           </a:p>
         </p:txBody>
@@ -6958,6 +7006,7 @@
           <a:lstStyle xmlns:a="http://schemas.openxmlformats.org/drawingml/2006/main"/>
           <a:p xmlns:a="http://schemas.openxmlformats.org/drawingml/2006/main">
             <a:pPr algn="ctr">
+              <a:buNone/>
               <a:defRPr sz="1125" b="0">
                 <a:solidFill>
                   <a:srgbClr val="A6A3A0"/>
@@ -7051,6 +7100,7 @@
           <a:lstStyle xmlns:a="http://schemas.openxmlformats.org/drawingml/2006/main"/>
           <a:p xmlns:a="http://schemas.openxmlformats.org/drawingml/2006/main">
             <a:pPr algn="ctr">
+              <a:buNone/>
               <a:defRPr sz="1125" b="1">
                 <a:solidFill>
                   <a:srgbClr val="F4F3EF"/>
@@ -7069,7 +7119,7 @@
                 <a:ea typeface="Courier New"/>
                 <a:cs typeface="Courier New"/>
               </a:rPr>
-              <a:t>AUDIT</a:t>
+              <a:t>REVIEW</a:t>
             </a:r>
           </a:p>
         </p:txBody>
@@ -7109,6 +7159,7 @@
           <a:lstStyle xmlns:a="http://schemas.openxmlformats.org/drawingml/2006/main"/>
           <a:p xmlns:a="http://schemas.openxmlformats.org/drawingml/2006/main">
             <a:pPr algn="ctr">
+              <a:buNone/>
               <a:defRPr sz="1125" b="0">
                 <a:solidFill>
                   <a:srgbClr val="A6A3A0"/>
@@ -7127,7 +7178,7 @@
                 <a:ea typeface="Arial"/>
                 <a:cs typeface="Arial"/>
               </a:rPr>
-              <a:t>Verify</a:t>
+              <a:t>Inspect</a:t>
             </a:r>
           </a:p>
         </p:txBody>
@@ -7202,6 +7253,7 @@
           <a:lstStyle xmlns:a="http://schemas.openxmlformats.org/drawingml/2006/main"/>
           <a:p xmlns:a="http://schemas.openxmlformats.org/drawingml/2006/main">
             <a:pPr algn="ctr">
+              <a:buNone/>
               <a:defRPr sz="1125" b="1">
                 <a:solidFill>
                   <a:srgbClr val="F4F3EF"/>
@@ -7220,7 +7272,7 @@
                 <a:ea typeface="Courier New"/>
                 <a:cs typeface="Courier New"/>
               </a:rPr>
-              <a:t>REPLAY</a:t>
+              <a:t>HASH</a:t>
             </a:r>
           </a:p>
         </p:txBody>
@@ -7260,6 +7312,7 @@
           <a:lstStyle xmlns:a="http://schemas.openxmlformats.org/drawingml/2006/main"/>
           <a:p xmlns:a="http://schemas.openxmlformats.org/drawingml/2006/main">
             <a:pPr algn="ctr">
+              <a:buNone/>
               <a:defRPr sz="1125" b="0">
                 <a:solidFill>
                   <a:srgbClr val="A6A3A0"/>
@@ -7278,7 +7331,7 @@
                 <a:ea typeface="Arial"/>
                 <a:cs typeface="Arial"/>
               </a:rPr>
-              <a:t>Recompute</a:t>
+              <a:t>Seal</a:t>
             </a:r>
           </a:p>
         </p:txBody>
@@ -7353,6 +7406,7 @@
           <a:lstStyle xmlns:a="http://schemas.openxmlformats.org/drawingml/2006/main"/>
           <a:p xmlns:a="http://schemas.openxmlformats.org/drawingml/2006/main">
             <a:pPr algn="ctr">
+              <a:buNone/>
               <a:defRPr sz="1125" b="1">
                 <a:solidFill>
                   <a:srgbClr val="FF5B22"/>
@@ -7371,7 +7425,7 @@
                 <a:ea typeface="Courier New"/>
                 <a:cs typeface="Courier New"/>
               </a:rPr>
-              <a:t>DEMO GATE</a:t>
+              <a:t>RECEIPT</a:t>
             </a:r>
           </a:p>
         </p:txBody>
@@ -7411,6 +7465,7 @@
           <a:lstStyle xmlns:a="http://schemas.openxmlformats.org/drawingml/2006/main"/>
           <a:p xmlns:a="http://schemas.openxmlformats.org/drawingml/2006/main">
             <a:pPr algn="ctr">
+              <a:buNone/>
               <a:defRPr sz="1125" b="0">
                 <a:solidFill>
                   <a:srgbClr val="A6A3A0"/>
@@ -7429,7 +7484,7 @@
                 <a:ea typeface="Arial"/>
                 <a:cs typeface="Arial"/>
               </a:rPr>
-              <a:t>Trigger</a:t>
+              <a:t>Submit</a:t>
             </a:r>
           </a:p>
         </p:txBody>
@@ -7469,6 +7524,7 @@
           <a:lstStyle xmlns:a="http://schemas.openxmlformats.org/drawingml/2006/main"/>
           <a:p xmlns:a="http://schemas.openxmlformats.org/drawingml/2006/main">
             <a:pPr algn="l">
+              <a:buNone/>
               <a:defRPr sz="975" b="1">
                 <a:solidFill>
                   <a:srgbClr val="6F6D6B"/>
@@ -7487,7 +7543,7 @@
                 <a:ea typeface="Courier New"/>
                 <a:cs typeface="Courier New"/>
               </a:rPr>
-              <a:t>FIVE LOGICAL EVIDENCE CATEGORIES</a:t>
+              <a:t>FOUR BOUNDED ROLE ROUTES</a:t>
             </a:r>
           </a:p>
         </p:txBody>
@@ -7558,6 +7614,7 @@
           <a:lstStyle xmlns:a="http://schemas.openxmlformats.org/drawingml/2006/main"/>
           <a:p xmlns:a="http://schemas.openxmlformats.org/drawingml/2006/main">
             <a:pPr algn="l">
+              <a:buNone/>
               <a:defRPr sz="900" b="1">
                 <a:solidFill>
                   <a:srgbClr val="F4F3EF"/>
@@ -7576,7 +7633,7 @@
                 <a:ea typeface="Courier New"/>
                 <a:cs typeface="Courier New"/>
               </a:rPr>
-              <a:t>STORE OBSERVATION</a:t>
+              <a:t>BUYER</a:t>
             </a:r>
           </a:p>
         </p:txBody>
@@ -7647,6 +7704,7 @@
           <a:lstStyle xmlns:a="http://schemas.openxmlformats.org/drawingml/2006/main"/>
           <a:p xmlns:a="http://schemas.openxmlformats.org/drawingml/2006/main">
             <a:pPr algn="l">
+              <a:buNone/>
               <a:defRPr sz="900" b="1">
                 <a:solidFill>
                   <a:srgbClr val="F4F3EF"/>
@@ -7665,7 +7723,7 @@
                 <a:ea typeface="Courier New"/>
                 <a:cs typeface="Courier New"/>
               </a:rPr>
-              <a:t>SYNTHETIC CONSUMER</a:t>
+              <a:t>SUPPLIER</a:t>
             </a:r>
           </a:p>
         </p:txBody>
@@ -7736,6 +7794,7 @@
           <a:lstStyle xmlns:a="http://schemas.openxmlformats.org/drawingml/2006/main"/>
           <a:p xmlns:a="http://schemas.openxmlformats.org/drawingml/2006/main">
             <a:pPr algn="l">
+              <a:buNone/>
               <a:defRPr sz="900" b="1">
                 <a:solidFill>
                   <a:srgbClr val="A6A3A0"/>
@@ -7754,7 +7813,7 @@
                 <a:ea typeface="Courier New"/>
                 <a:cs typeface="Courier New"/>
               </a:rPr>
-              <a:t>DIGITAL FOOTPRINT</a:t>
+              <a:t>PEER / COMPETITOR</a:t>
             </a:r>
           </a:p>
         </p:txBody>
@@ -7825,6 +7884,7 @@
           <a:lstStyle xmlns:a="http://schemas.openxmlformats.org/drawingml/2006/main"/>
           <a:p xmlns:a="http://schemas.openxmlformats.org/drawingml/2006/main">
             <a:pPr algn="l">
+              <a:buNone/>
               <a:defRPr sz="900" b="1">
                 <a:solidFill>
                   <a:srgbClr val="A6A3A0"/>
@@ -7843,7 +7903,7 @@
                 <a:ea typeface="Courier New"/>
                 <a:cs typeface="Courier New"/>
               </a:rPr>
-              <a:t>LABOR</a:t>
+              <a:t>SKEPTIC</a:t>
             </a:r>
           </a:p>
         </p:txBody>
@@ -7914,6 +7974,7 @@
           <a:lstStyle xmlns:a="http://schemas.openxmlformats.org/drawingml/2006/main"/>
           <a:p xmlns:a="http://schemas.openxmlformats.org/drawingml/2006/main">
             <a:pPr algn="l">
+              <a:buNone/>
               <a:defRPr sz="900" b="1">
                 <a:solidFill>
                   <a:srgbClr val="A6A3A0"/>
@@ -7932,7 +7993,7 @@
                 <a:ea typeface="Courier New"/>
                 <a:cs typeface="Courier New"/>
               </a:rPr>
-              <a:t>SUPPLY CHAIN</a:t>
+              <a:t>MISSINGNESS AS SIGNAL</a:t>
             </a:r>
           </a:p>
         </p:txBody>
@@ -7980,28 +8041,26 @@
       </p:sp>
       <p:pic>
         <p:nvPicPr>
-          <p:cNvPr id="111" name=""/>
+          <p:cNvPr id="114" name=""/>
           <p:cNvPicPr>
             <a:picLocks xmlns:a="http://schemas.openxmlformats.org/drawingml/2006/main" noChangeAspect="1"/>
           </p:cNvPicPr>
           <p:nvPr/>
         </p:nvPicPr>
         <p:blipFill>
-          <a:blip xmlns:r="http://schemas.openxmlformats.org/officeDocument/2006/relationships" xmlns:a="http://schemas.openxmlformats.org/drawingml/2006/main" r:embed="R1ae509f8b95c4063"/>
+          <a:blip xmlns:r="http://schemas.openxmlformats.org/officeDocument/2006/relationships" xmlns:a="http://schemas.openxmlformats.org/drawingml/2006/main" r:embed="Re8ad3ef22a264998"/>
           <a:srcRect xmlns:a="http://schemas.openxmlformats.org/drawingml/2006/main" l="46" t="0" r="46" b="0"/>
           <a:stretch xmlns:a="http://schemas.openxmlformats.org/drawingml/2006/main">
             <a:fillRect l="0" t="0" r="0" b="0"/>
           </a:stretch>
         </p:blipFill>
         <p:spPr>
-          <a:xfrm xmlns:a="http://schemas.openxmlformats.org/drawingml/2006/main">
+          <a:xfrm xmlns:a="http://schemas.openxmlformats.org/drawingml/2006/main" flipH="0" flipV="0">
             <a:off x="7486650" y="1771650"/>
             <a:ext cx="4095750" cy="2562225"/>
           </a:xfrm>
           <a:prstGeom xmlns:a="http://schemas.openxmlformats.org/drawingml/2006/main" prst="roundRect">
-            <a:avLst>
-              <a:gd name="adj" fmla="val 4461"/>
-            </a:avLst>
+            <a:avLst/>
           </a:prstGeom>
         </p:spPr>
       </p:pic>
@@ -8040,6 +8099,7 @@
           <a:lstStyle xmlns:a="http://schemas.openxmlformats.org/drawingml/2006/main"/>
           <a:p xmlns:a="http://schemas.openxmlformats.org/drawingml/2006/main">
             <a:pPr algn="l">
+              <a:buNone/>
               <a:defRPr sz="975" b="1">
                 <a:solidFill>
                   <a:srgbClr val="FF5B22"/>
@@ -8058,7 +8118,7 @@
                 <a:ea typeface="Courier New"/>
                 <a:cs typeface="Courier New"/>
               </a:rPr>
-              <a:t>THE CONTROLLED TRANSITION</a:t>
+              <a:t>THE HONEST TRANSITION</a:t>
             </a:r>
           </a:p>
         </p:txBody>
@@ -8120,7 +8180,7 @@
                 <a:ea typeface="Arial"/>
                 <a:cs typeface="Arial"/>
               </a:rPr>
-              <a:t>The Skeptic proposes an alternative. A separate demo interaction starts the deterministic replay.</a:t>
+              <a:t>Copying a strategy only marks it prepared. The user must confirm a real authorized contact.</a:t>
             </a:r>
           </a:p>
         </p:txBody>
@@ -8160,6 +8220,7 @@
           <a:lstStyle xmlns:a="http://schemas.openxmlformats.org/drawingml/2006/main"/>
           <a:p xmlns:a="http://schemas.openxmlformats.org/drawingml/2006/main">
             <a:pPr algn="l">
+              <a:buNone/>
               <a:defRPr sz="1200" b="0">
                 <a:solidFill>
                   <a:srgbClr val="A6A3A0"/>
@@ -8178,7 +8239,7 @@
                 <a:ea typeface="Arial"/>
                 <a:cs typeface="Arial"/>
               </a:rPr>
-              <a:t>Provenance + content hashes remain attached to each of the five aggregate receipts.</a:t>
+              <a:t>A submitted receipt receives a server-side SHA-256 hash; empty evidence keeps the gate locked.</a:t>
             </a:r>
           </a:p>
         </p:txBody>
@@ -8280,6 +8341,7 @@
           <a:lstStyle xmlns:a="http://schemas.openxmlformats.org/drawingml/2006/main"/>
           <a:p xmlns:a="http://schemas.openxmlformats.org/drawingml/2006/main">
             <a:pPr algn="l">
+              <a:buNone/>
               <a:defRPr sz="1050" b="1">
                 <a:solidFill>
                   <a:srgbClr val="FF5B22"/>
@@ -8338,6 +8400,7 @@
           <a:lstStyle xmlns:a="http://schemas.openxmlformats.org/drawingml/2006/main"/>
           <a:p xmlns:a="http://schemas.openxmlformats.org/drawingml/2006/main">
             <a:pPr algn="r">
+              <a:buNone/>
               <a:defRPr sz="975" b="0">
                 <a:solidFill>
                   <a:srgbClr val="6F6D6B"/>
@@ -8394,17 +8457,17 @@
       </p:sp>
       <p:pic>
         <p:nvPicPr>
-          <p:cNvPr id="35" name=""/>
+          <p:cNvPr id="38" name=""/>
           <p:cNvPicPr>
             <a:picLocks xmlns:a="http://schemas.openxmlformats.org/drawingml/2006/main" noChangeAspect="1"/>
           </p:cNvPicPr>
           <p:nvPr/>
         </p:nvPicPr>
         <p:blipFill>
-          <a:blip xmlns:r="http://schemas.openxmlformats.org/officeDocument/2006/relationships" xmlns:a="http://schemas.openxmlformats.org/drawingml/2006/main" r:embed="R0e727cd658b54207">
+          <a:blip xmlns:r="http://schemas.openxmlformats.org/officeDocument/2006/relationships" xmlns:a="http://schemas.openxmlformats.org/drawingml/2006/main" r:embed="R07f48a4a649744ed">
             <a:extLst>
               <a:ext uri="{96DAC541-7B7A-43D3-8B79-37D633B846F1}">
-                <asvg:svgBlip xmlns:asvg="http://schemas.microsoft.com/office/drawing/2016/SVG/main" r:embed="R2fd3fe12836c472e"/>
+                <asvg:svgBlip xmlns:asvg="http://schemas.microsoft.com/office/drawing/2016/SVG/main" r:embed="Rf0fc815a2ebd4be1"/>
               </a:ext>
             </a:extLst>
           </a:blip>
@@ -8455,6 +8518,7 @@
           <a:lstStyle xmlns:a="http://schemas.openxmlformats.org/drawingml/2006/main"/>
           <a:p xmlns:a="http://schemas.openxmlformats.org/drawingml/2006/main">
             <a:pPr algn="l">
+              <a:buNone/>
               <a:defRPr sz="750" b="1">
                 <a:solidFill>
                   <a:srgbClr val="6F6D6B"/>
@@ -8513,6 +8577,7 @@
           <a:lstStyle xmlns:a="http://schemas.openxmlformats.org/drawingml/2006/main"/>
           <a:p xmlns:a="http://schemas.openxmlformats.org/drawingml/2006/main">
             <a:pPr algn="r">
+              <a:buNone/>
               <a:defRPr sz="750" b="1">
                 <a:solidFill>
                   <a:srgbClr val="6F6D6B"/>
@@ -8633,6 +8698,7 @@
           <a:lstStyle xmlns:a="http://schemas.openxmlformats.org/drawingml/2006/main"/>
           <a:p xmlns:a="http://schemas.openxmlformats.org/drawingml/2006/main">
             <a:pPr algn="l">
+              <a:buNone/>
               <a:defRPr sz="1650" b="0">
                 <a:solidFill>
                   <a:srgbClr val="A6A3A0"/>
@@ -8755,6 +8821,7 @@
           <a:lstStyle xmlns:a="http://schemas.openxmlformats.org/drawingml/2006/main"/>
           <a:p xmlns:a="http://schemas.openxmlformats.org/drawingml/2006/main">
             <a:pPr algn="l">
+              <a:buNone/>
               <a:defRPr sz="1050" b="1">
                 <a:solidFill>
                   <a:srgbClr val="FF5B22"/>
@@ -8813,6 +8880,7 @@
           <a:lstStyle xmlns:a="http://schemas.openxmlformats.org/drawingml/2006/main"/>
           <a:p xmlns:a="http://schemas.openxmlformats.org/drawingml/2006/main">
             <a:pPr algn="l">
+              <a:buNone/>
               <a:defRPr sz="1800" b="1">
                 <a:solidFill>
                   <a:srgbClr val="F4F3EF"/>
@@ -8831,7 +8899,7 @@
                 <a:ea typeface="Arial"/>
                 <a:cs typeface="Arial"/>
               </a:rPr>
-              <a:t>1 design-partner fund</a:t>
+              <a:t>Target: design-partner fund</a:t>
             </a:r>
           </a:p>
         </p:txBody>
@@ -8871,6 +8939,7 @@
           <a:lstStyle xmlns:a="http://schemas.openxmlformats.org/drawingml/2006/main"/>
           <a:p xmlns:a="http://schemas.openxmlformats.org/drawingml/2006/main">
             <a:pPr algn="l">
+              <a:buNone/>
               <a:defRPr sz="1275" b="0">
                 <a:solidFill>
                   <a:srgbClr val="A6A3A0"/>
@@ -8962,6 +9031,7 @@
           <a:lstStyle xmlns:a="http://schemas.openxmlformats.org/drawingml/2006/main"/>
           <a:p xmlns:a="http://schemas.openxmlformats.org/drawingml/2006/main">
             <a:pPr algn="l">
+              <a:buNone/>
               <a:defRPr sz="1050" b="1">
                 <a:solidFill>
                   <a:srgbClr val="6F6D6B"/>
@@ -9020,6 +9090,7 @@
           <a:lstStyle xmlns:a="http://schemas.openxmlformats.org/drawingml/2006/main"/>
           <a:p xmlns:a="http://schemas.openxmlformats.org/drawingml/2006/main">
             <a:pPr algn="l">
+              <a:buNone/>
               <a:defRPr sz="1800" b="1">
                 <a:solidFill>
                   <a:srgbClr val="F4F3EF"/>
@@ -9038,7 +9109,7 @@
                 <a:ea typeface="Arial"/>
                 <a:cs typeface="Arial"/>
               </a:rPr>
-              <a:t>Repeated deal missions</a:t>
+              <a:t>Target: authorized mission</a:t>
             </a:r>
           </a:p>
         </p:txBody>
@@ -9078,6 +9149,7 @@
           <a:lstStyle xmlns:a="http://schemas.openxmlformats.org/drawingml/2006/main"/>
           <a:p xmlns:a="http://schemas.openxmlformats.org/drawingml/2006/main">
             <a:pPr algn="l">
+              <a:buNone/>
               <a:defRPr sz="1275" b="0">
                 <a:solidFill>
                   <a:srgbClr val="A6A3A0"/>
@@ -9096,7 +9168,7 @@
                 <a:ea typeface="Arial"/>
                 <a:cs typeface="Arial"/>
               </a:rPr>
-              <a:t>Paid, scoped verification work</a:t>
+              <a:t>Paid, scoped verification target</a:t>
             </a:r>
           </a:p>
         </p:txBody>
@@ -9169,6 +9241,7 @@
           <a:lstStyle xmlns:a="http://schemas.openxmlformats.org/drawingml/2006/main"/>
           <a:p xmlns:a="http://schemas.openxmlformats.org/drawingml/2006/main">
             <a:pPr algn="l">
+              <a:buNone/>
               <a:defRPr sz="1050" b="1">
                 <a:solidFill>
                   <a:srgbClr val="6F6D6B"/>
@@ -9227,6 +9300,7 @@
           <a:lstStyle xmlns:a="http://schemas.openxmlformats.org/drawingml/2006/main"/>
           <a:p xmlns:a="http://schemas.openxmlformats.org/drawingml/2006/main">
             <a:pPr algn="l">
+              <a:buNone/>
               <a:defRPr sz="1800" b="1">
                 <a:solidFill>
                   <a:srgbClr val="F4F3EF"/>
@@ -9245,7 +9319,7 @@
                 <a:ea typeface="Arial"/>
                 <a:cs typeface="Arial"/>
               </a:rPr>
-              <a:t>Portfolio workflows</a:t>
+              <a:t>Target: team workflow</a:t>
             </a:r>
           </a:p>
         </p:txBody>
@@ -9285,6 +9359,7 @@
           <a:lstStyle xmlns:a="http://schemas.openxmlformats.org/drawingml/2006/main"/>
           <a:p xmlns:a="http://schemas.openxmlformats.org/drawingml/2006/main">
             <a:pPr algn="l">
+              <a:buNone/>
               <a:defRPr sz="1275" b="0">
                 <a:solidFill>
                   <a:srgbClr val="A6A3A0"/>
@@ -9303,7 +9378,7 @@
                 <a:ea typeface="Arial"/>
                 <a:cs typeface="Arial"/>
               </a:rPr>
-              <a:t>Reusable questions and monitoring</a:t>
+              <a:t>Reusable questions and evidence history</a:t>
             </a:r>
           </a:p>
         </p:txBody>
@@ -9376,6 +9451,7 @@
           <a:lstStyle xmlns:a="http://schemas.openxmlformats.org/drawingml/2006/main"/>
           <a:p xmlns:a="http://schemas.openxmlformats.org/drawingml/2006/main">
             <a:pPr algn="l">
+              <a:buNone/>
               <a:defRPr sz="1050" b="1">
                 <a:solidFill>
                   <a:srgbClr val="6F6D6B"/>
@@ -9434,6 +9510,7 @@
           <a:lstStyle xmlns:a="http://schemas.openxmlformats.org/drawingml/2006/main"/>
           <a:p xmlns:a="http://schemas.openxmlformats.org/drawingml/2006/main">
             <a:pPr algn="l">
+              <a:buNone/>
               <a:defRPr sz="1800" b="1">
                 <a:solidFill>
                   <a:srgbClr val="F4F3EF"/>
@@ -9452,7 +9529,7 @@
                 <a:ea typeface="Arial"/>
                 <a:cs typeface="Arial"/>
               </a:rPr>
-              <a:t>Vertical mission library</a:t>
+              <a:t>Target: mission library</a:t>
             </a:r>
           </a:p>
         </p:txBody>
@@ -9492,6 +9569,7 @@
           <a:lstStyle xmlns:a="http://schemas.openxmlformats.org/drawingml/2006/main"/>
           <a:p xmlns:a="http://schemas.openxmlformats.org/drawingml/2006/main">
             <a:pPr algn="l">
+              <a:buNone/>
               <a:defRPr sz="1275" b="0">
                 <a:solidFill>
                   <a:srgbClr val="A6A3A0"/>
@@ -9558,28 +9636,26 @@
       </p:sp>
       <p:pic>
         <p:nvPicPr>
-          <p:cNvPr id="58" name=""/>
+          <p:cNvPr id="61" name=""/>
           <p:cNvPicPr>
             <a:picLocks xmlns:a="http://schemas.openxmlformats.org/drawingml/2006/main" noChangeAspect="1"/>
           </p:cNvPicPr>
           <p:nvPr/>
         </p:nvPicPr>
         <p:blipFill>
-          <a:blip xmlns:r="http://schemas.openxmlformats.org/officeDocument/2006/relationships" xmlns:a="http://schemas.openxmlformats.org/drawingml/2006/main" r:embed="Rd8376ee45cb94ece"/>
+          <a:blip xmlns:r="http://schemas.openxmlformats.org/officeDocument/2006/relationships" xmlns:a="http://schemas.openxmlformats.org/drawingml/2006/main" r:embed="R07f48a4a649744ed"/>
           <a:srcRect xmlns:a="http://schemas.openxmlformats.org/drawingml/2006/main" l="33" t="0" r="33" b="0"/>
           <a:stretch xmlns:a="http://schemas.openxmlformats.org/drawingml/2006/main">
             <a:fillRect l="0" t="0" r="0" b="0"/>
           </a:stretch>
         </p:blipFill>
         <p:spPr>
-          <a:xfrm xmlns:a="http://schemas.openxmlformats.org/drawingml/2006/main">
+          <a:xfrm xmlns:a="http://schemas.openxmlformats.org/drawingml/2006/main" flipH="0" flipV="0">
             <a:off x="5810250" y="1847850"/>
             <a:ext cx="5772150" cy="3609975"/>
           </a:xfrm>
           <a:prstGeom xmlns:a="http://schemas.openxmlformats.org/drawingml/2006/main" prst="roundRect">
-            <a:avLst>
-              <a:gd name="adj" fmla="val 3166"/>
-            </a:avLst>
+            <a:avLst/>
           </a:prstGeom>
         </p:spPr>
       </p:pic>
@@ -9618,6 +9694,7 @@
           <a:lstStyle xmlns:a="http://schemas.openxmlformats.org/drawingml/2006/main"/>
           <a:p xmlns:a="http://schemas.openxmlformats.org/drawingml/2006/main">
             <a:pPr algn="l">
+              <a:buNone/>
               <a:defRPr sz="975" b="1">
                 <a:solidFill>
                   <a:srgbClr val="FF5B22"/>
@@ -9636,7 +9713,7 @@
                 <a:ea typeface="Courier New"/>
                 <a:cs typeface="Courier New"/>
               </a:rPr>
-              <a:t>THE PURCHASE IS A DECISION WORKFLOW</a:t>
+              <a:t>THE WEDGE IS A DECISION WORKFLOW</a:t>
             </a:r>
           </a:p>
         </p:txBody>
@@ -9676,6 +9753,7 @@
           <a:lstStyle xmlns:a="http://schemas.openxmlformats.org/drawingml/2006/main"/>
           <a:p xmlns:a="http://schemas.openxmlformats.org/drawingml/2006/main">
             <a:pPr algn="r">
+              <a:buNone/>
               <a:defRPr sz="1650" b="1">
                 <a:solidFill>
                   <a:srgbClr val="F4F3EF"/>
@@ -9694,7 +9772,7 @@
                 <a:ea typeface="Arial"/>
                 <a:cs typeface="Arial"/>
               </a:rPr>
-              <a:t>VC access is distribution, not the entire market.</a:t>
+              <a:t>VC access is the first distribution channel.</a:t>
             </a:r>
           </a:p>
         </p:txBody>
@@ -9796,6 +9874,7 @@
           <a:lstStyle xmlns:a="http://schemas.openxmlformats.org/drawingml/2006/main"/>
           <a:p xmlns:a="http://schemas.openxmlformats.org/drawingml/2006/main">
             <a:pPr algn="l">
+              <a:buNone/>
               <a:defRPr sz="1050" b="1">
                 <a:solidFill>
                   <a:srgbClr val="FF5B22"/>
@@ -9854,6 +9933,7 @@
           <a:lstStyle xmlns:a="http://schemas.openxmlformats.org/drawingml/2006/main"/>
           <a:p xmlns:a="http://schemas.openxmlformats.org/drawingml/2006/main">
             <a:pPr algn="r">
+              <a:buNone/>
               <a:defRPr sz="975" b="0">
                 <a:solidFill>
                   <a:srgbClr val="6F6D6B"/>
@@ -9910,17 +9990,17 @@
       </p:sp>
       <p:pic>
         <p:nvPicPr>
-          <p:cNvPr id="38" name=""/>
+          <p:cNvPr id="40" name=""/>
           <p:cNvPicPr>
             <a:picLocks xmlns:a="http://schemas.openxmlformats.org/drawingml/2006/main" noChangeAspect="1"/>
           </p:cNvPicPr>
           <p:nvPr/>
         </p:nvPicPr>
         <p:blipFill>
-          <a:blip xmlns:r="http://schemas.openxmlformats.org/officeDocument/2006/relationships" xmlns:a="http://schemas.openxmlformats.org/drawingml/2006/main" r:embed="R9ef94b2dcb26465c">
+          <a:blip xmlns:r="http://schemas.openxmlformats.org/officeDocument/2006/relationships" xmlns:a="http://schemas.openxmlformats.org/drawingml/2006/main" r:embed="Rdf2073bd20f24668">
             <a:extLst>
               <a:ext uri="{96DAC541-7B7A-43D3-8B79-37D633B846F1}">
-                <asvg:svgBlip xmlns:asvg="http://schemas.microsoft.com/office/drawing/2016/SVG/main" r:embed="R09508e2701bd4030"/>
+                <asvg:svgBlip xmlns:asvg="http://schemas.microsoft.com/office/drawing/2016/SVG/main" r:embed="R9c14e86effdc4dfa"/>
               </a:ext>
             </a:extLst>
           </a:blip>
@@ -9971,6 +10051,7 @@
           <a:lstStyle xmlns:a="http://schemas.openxmlformats.org/drawingml/2006/main"/>
           <a:p xmlns:a="http://schemas.openxmlformats.org/drawingml/2006/main">
             <a:pPr algn="l">
+              <a:buNone/>
               <a:defRPr sz="750" b="1">
                 <a:solidFill>
                   <a:srgbClr val="6F6D6B"/>
@@ -10029,6 +10110,7 @@
           <a:lstStyle xmlns:a="http://schemas.openxmlformats.org/drawingml/2006/main"/>
           <a:p xmlns:a="http://schemas.openxmlformats.org/drawingml/2006/main">
             <a:pPr algn="r">
+              <a:buNone/>
               <a:defRPr sz="750" b="1">
                 <a:solidFill>
                   <a:srgbClr val="6F6D6B"/>
@@ -10211,6 +10293,7 @@
           <a:lstStyle xmlns:a="http://schemas.openxmlformats.org/drawingml/2006/main"/>
           <a:p xmlns:a="http://schemas.openxmlformats.org/drawingml/2006/main">
             <a:pPr algn="l">
+              <a:buNone/>
               <a:defRPr sz="1050" b="1">
                 <a:solidFill>
                   <a:srgbClr val="FF5B22"/>
@@ -10269,6 +10352,7 @@
           <a:lstStyle xmlns:a="http://schemas.openxmlformats.org/drawingml/2006/main"/>
           <a:p xmlns:a="http://schemas.openxmlformats.org/drawingml/2006/main">
             <a:pPr algn="l">
+              <a:buNone/>
               <a:defRPr sz="1200" b="1">
                 <a:solidFill>
                   <a:srgbClr val="6F6D6B"/>
@@ -10349,7 +10433,7 @@
                 <a:ea typeface="Arial"/>
                 <a:cs typeface="Arial"/>
               </a:rPr>
-              <a:t>Agents execute multi-step research</a:t>
+              <a:t>AI can draft multi-stage role strategies</a:t>
             </a:r>
           </a:p>
         </p:txBody>
@@ -10389,6 +10473,7 @@
           <a:lstStyle xmlns:a="http://schemas.openxmlformats.org/drawingml/2006/main"/>
           <a:p xmlns:a="http://schemas.openxmlformats.org/drawingml/2006/main">
             <a:pPr algn="l">
+              <a:buNone/>
               <a:defRPr sz="1200" b="1">
                 <a:solidFill>
                   <a:srgbClr val="6F6D6B"/>
@@ -10442,7 +10527,7 @@
         </p:spPr>
         <p:txBody>
           <a:bodyPr xmlns:a="http://schemas.openxmlformats.org/drawingml/2006/main" wrap="square" lIns="0" tIns="0" rIns="0" bIns="0" anchor="t">
-            <a:normAutofit fontScale="89576"/>
+            <a:normAutofit fontScale="92476"/>
           </a:bodyPr>
           <a:lstStyle xmlns:a="http://schemas.openxmlformats.org/drawingml/2006/main"/>
           <a:p xmlns:a="http://schemas.openxmlformats.org/drawingml/2006/main">
@@ -10469,7 +10554,7 @@
                 <a:ea typeface="Arial"/>
                 <a:cs typeface="Arial"/>
               </a:rPr>
-              <a:t>Commercial operations leave queryable signals</a:t>
+              <a:t>Claims can be mapped to inspectable receipts</a:t>
             </a:r>
           </a:p>
         </p:txBody>
@@ -10509,6 +10594,7 @@
           <a:lstStyle xmlns:a="http://schemas.openxmlformats.org/drawingml/2006/main"/>
           <a:p xmlns:a="http://schemas.openxmlformats.org/drawingml/2006/main">
             <a:pPr algn="l">
+              <a:buNone/>
               <a:defRPr sz="1200" b="1">
                 <a:solidFill>
                   <a:srgbClr val="6F6D6B"/>
@@ -10562,7 +10648,7 @@
         </p:spPr>
         <p:txBody>
           <a:bodyPr xmlns:a="http://schemas.openxmlformats.org/drawingml/2006/main" wrap="square" lIns="0" tIns="0" rIns="0" bIns="0" anchor="t">
-            <a:normAutofit fontScale="86676"/>
+            <a:normAutofit fontScale="84424"/>
           </a:bodyPr>
           <a:lstStyle xmlns:a="http://schemas.openxmlformats.org/drawingml/2006/main"/>
           <a:p xmlns:a="http://schemas.openxmlformats.org/drawingml/2006/main">
@@ -10589,7 +10675,7 @@
                 <a:ea typeface="Arial"/>
                 <a:cs typeface="Arial"/>
               </a:rPr>
-              <a:t>Buyers need provenance, permission, and replay</a:t>
+              <a:t>Buyers need permission, provenance, and missingness</a:t>
             </a:r>
           </a:p>
         </p:txBody>
@@ -10660,6 +10746,7 @@
           <a:lstStyle xmlns:a="http://schemas.openxmlformats.org/drawingml/2006/main"/>
           <a:p xmlns:a="http://schemas.openxmlformats.org/drawingml/2006/main">
             <a:pPr algn="l">
+              <a:buNone/>
               <a:defRPr sz="1050" b="1">
                 <a:solidFill>
                   <a:srgbClr val="FF5B22"/>
@@ -10718,6 +10805,7 @@
           <a:lstStyle xmlns:a="http://schemas.openxmlformats.org/drawingml/2006/main"/>
           <a:p xmlns:a="http://schemas.openxmlformats.org/drawingml/2006/main">
             <a:pPr algn="l">
+              <a:buNone/>
               <a:defRPr sz="1050" b="1">
                 <a:solidFill>
                   <a:srgbClr val="6F6D6B"/>
@@ -10776,6 +10864,7 @@
           <a:lstStyle xmlns:a="http://schemas.openxmlformats.org/drawingml/2006/main"/>
           <a:p xmlns:a="http://schemas.openxmlformats.org/drawingml/2006/main">
             <a:pPr algn="r">
+              <a:buNone/>
               <a:defRPr sz="1725" b="0">
                 <a:solidFill>
                   <a:srgbClr val="A6A3A0"/>
@@ -10865,6 +10954,7 @@
           <a:lstStyle xmlns:a="http://schemas.openxmlformats.org/drawingml/2006/main"/>
           <a:p xmlns:a="http://schemas.openxmlformats.org/drawingml/2006/main">
             <a:pPr algn="l">
+              <a:buNone/>
               <a:defRPr sz="1050" b="1">
                 <a:solidFill>
                   <a:srgbClr val="6F6D6B"/>
@@ -10883,7 +10973,7 @@
                 <a:ea typeface="Courier New"/>
                 <a:cs typeface="Courier New"/>
               </a:rPr>
-              <a:t>EXPERT NETWORKS</a:t>
+              <a:t>RESEARCH AGENTS</a:t>
             </a:r>
           </a:p>
         </p:txBody>
@@ -10923,6 +11013,7 @@
           <a:lstStyle xmlns:a="http://schemas.openxmlformats.org/drawingml/2006/main"/>
           <a:p xmlns:a="http://schemas.openxmlformats.org/drawingml/2006/main">
             <a:pPr algn="r">
+              <a:buNone/>
               <a:defRPr sz="1725" b="0">
                 <a:solidFill>
                   <a:srgbClr val="A6A3A0"/>
@@ -10941,7 +11032,7 @@
                 <a:ea typeface="Arial"/>
                 <a:cs typeface="Arial"/>
               </a:rPr>
-              <a:t>Interview</a:t>
+              <a:t>Report</a:t>
             </a:r>
           </a:p>
         </p:txBody>
@@ -11012,6 +11103,7 @@
           <a:lstStyle xmlns:a="http://schemas.openxmlformats.org/drawingml/2006/main"/>
           <a:p xmlns:a="http://schemas.openxmlformats.org/drawingml/2006/main">
             <a:pPr algn="l">
+              <a:buNone/>
               <a:defRPr sz="1050" b="1">
                 <a:solidFill>
                   <a:srgbClr val="6F6D6B"/>
@@ -11070,6 +11162,7 @@
           <a:lstStyle xmlns:a="http://schemas.openxmlformats.org/drawingml/2006/main"/>
           <a:p xmlns:a="http://schemas.openxmlformats.org/drawingml/2006/main">
             <a:pPr algn="r">
+              <a:buNone/>
               <a:defRPr sz="1725" b="0">
                 <a:solidFill>
                   <a:srgbClr val="A6A3A0"/>
@@ -11159,6 +11252,7 @@
           <a:lstStyle xmlns:a="http://schemas.openxmlformats.org/drawingml/2006/main"/>
           <a:p xmlns:a="http://schemas.openxmlformats.org/drawingml/2006/main">
             <a:pPr algn="l">
+              <a:buNone/>
               <a:defRPr sz="1050" b="1">
                 <a:solidFill>
                   <a:srgbClr val="FF5B22"/>
@@ -11217,6 +11311,7 @@
           <a:lstStyle xmlns:a="http://schemas.openxmlformats.org/drawingml/2006/main"/>
           <a:p xmlns:a="http://schemas.openxmlformats.org/drawingml/2006/main">
             <a:pPr algn="r">
+              <a:buNone/>
               <a:defRPr sz="1725" b="1">
                 <a:solidFill>
                   <a:srgbClr val="F4F3EF"/>
@@ -11341,6 +11436,7 @@
           <a:lstStyle xmlns:a="http://schemas.openxmlformats.org/drawingml/2006/main"/>
           <a:p xmlns:a="http://schemas.openxmlformats.org/drawingml/2006/main">
             <a:pPr algn="l">
+              <a:buNone/>
               <a:defRPr sz="975" b="1">
                 <a:solidFill>
                   <a:srgbClr val="FF5B22"/>
@@ -11399,6 +11495,7 @@
           <a:lstStyle xmlns:a="http://schemas.openxmlformats.org/drawingml/2006/main"/>
           <a:p xmlns:a="http://schemas.openxmlformats.org/drawingml/2006/main">
             <a:pPr algn="r">
+              <a:buNone/>
               <a:defRPr sz="2250" b="1">
                 <a:solidFill>
                   <a:srgbClr val="F4F3EF"/>
@@ -11519,6 +11616,7 @@
           <a:lstStyle xmlns:a="http://schemas.openxmlformats.org/drawingml/2006/main"/>
           <a:p xmlns:a="http://schemas.openxmlformats.org/drawingml/2006/main">
             <a:pPr algn="l">
+              <a:buNone/>
               <a:defRPr sz="1050" b="1">
                 <a:solidFill>
                   <a:srgbClr val="FF5B22"/>
@@ -11577,6 +11675,7 @@
           <a:lstStyle xmlns:a="http://schemas.openxmlformats.org/drawingml/2006/main"/>
           <a:p xmlns:a="http://schemas.openxmlformats.org/drawingml/2006/main">
             <a:pPr algn="r">
+              <a:buNone/>
               <a:defRPr sz="975" b="0">
                 <a:solidFill>
                   <a:srgbClr val="6F6D6B"/>
@@ -11633,17 +11732,17 @@
       </p:sp>
       <p:pic>
         <p:nvPicPr>
-          <p:cNvPr id="39" name=""/>
+          <p:cNvPr id="42" name=""/>
           <p:cNvPicPr>
             <a:picLocks xmlns:a="http://schemas.openxmlformats.org/drawingml/2006/main" noChangeAspect="1"/>
           </p:cNvPicPr>
           <p:nvPr/>
         </p:nvPicPr>
         <p:blipFill>
-          <a:blip xmlns:r="http://schemas.openxmlformats.org/officeDocument/2006/relationships" xmlns:a="http://schemas.openxmlformats.org/drawingml/2006/main" r:embed="R85a041005de441b4">
+          <a:blip xmlns:r="http://schemas.openxmlformats.org/officeDocument/2006/relationships" xmlns:a="http://schemas.openxmlformats.org/drawingml/2006/main" r:embed="Rf916374bc1024246">
             <a:extLst>
               <a:ext uri="{96DAC541-7B7A-43D3-8B79-37D633B846F1}">
-                <asvg:svgBlip xmlns:asvg="http://schemas.microsoft.com/office/drawing/2016/SVG/main" r:embed="Rb133f72790164373"/>
+                <asvg:svgBlip xmlns:asvg="http://schemas.microsoft.com/office/drawing/2016/SVG/main" r:embed="R78f14e78715b4092"/>
               </a:ext>
             </a:extLst>
           </a:blip>
@@ -11694,6 +11793,7 @@
           <a:lstStyle xmlns:a="http://schemas.openxmlformats.org/drawingml/2006/main"/>
           <a:p xmlns:a="http://schemas.openxmlformats.org/drawingml/2006/main">
             <a:pPr algn="l">
+              <a:buNone/>
               <a:defRPr sz="750" b="1">
                 <a:solidFill>
                   <a:srgbClr val="6F6D6B"/>
@@ -11752,6 +11852,7 @@
           <a:lstStyle xmlns:a="http://schemas.openxmlformats.org/drawingml/2006/main"/>
           <a:p xmlns:a="http://schemas.openxmlformats.org/drawingml/2006/main">
             <a:pPr algn="r">
+              <a:buNone/>
               <a:defRPr sz="750" b="1">
                 <a:solidFill>
                   <a:srgbClr val="6F6D6B"/>
@@ -11872,6 +11973,7 @@
           <a:lstStyle xmlns:a="http://schemas.openxmlformats.org/drawingml/2006/main"/>
           <a:p xmlns:a="http://schemas.openxmlformats.org/drawingml/2006/main">
             <a:pPr algn="l">
+              <a:buNone/>
               <a:defRPr sz="1650" b="0">
                 <a:solidFill>
                   <a:srgbClr val="A6A3A0"/>
@@ -12023,6 +12125,7 @@
           <a:lstStyle xmlns:a="http://schemas.openxmlformats.org/drawingml/2006/main"/>
           <a:p xmlns:a="http://schemas.openxmlformats.org/drawingml/2006/main">
             <a:pPr algn="l">
+              <a:buNone/>
               <a:defRPr sz="1275" b="1">
                 <a:solidFill>
                   <a:srgbClr val="FF5B22"/>
@@ -12263,6 +12366,7 @@
           <a:lstStyle xmlns:a="http://schemas.openxmlformats.org/drawingml/2006/main"/>
           <a:p xmlns:a="http://schemas.openxmlformats.org/drawingml/2006/main">
             <a:pPr algn="l">
+              <a:buNone/>
               <a:defRPr sz="1275" b="1">
                 <a:solidFill>
                   <a:srgbClr val="FF5B22"/>
@@ -12343,7 +12447,7 @@
                 <a:ea typeface="Courier New"/>
                 <a:cs typeface="Courier New"/>
               </a:rPr>
-              <a:t>PORTFOLIO SUBSCRIPTION</a:t>
+              <a:t>TEAM SUBSCRIPTION</a:t>
             </a:r>
           </a:p>
         </p:txBody>
@@ -12409,7 +12513,7 @@
         </p:spPr>
         <p:txBody>
           <a:bodyPr xmlns:a="http://schemas.openxmlformats.org/drawingml/2006/main" wrap="square" lIns="0" tIns="0" rIns="0" bIns="0" anchor="t">
-            <a:normAutofit fontScale="96976"/>
+            <a:normAutofit fontScale="100000"/>
           </a:bodyPr>
           <a:lstStyle xmlns:a="http://schemas.openxmlformats.org/drawingml/2006/main"/>
           <a:p xmlns:a="http://schemas.openxmlformats.org/drawingml/2006/main">
@@ -12463,7 +12567,7 @@
                 <a:ea typeface="Arial"/>
                 <a:cs typeface="Arial"/>
               </a:rPr>
-              <a:t>Longitudinal monitoring</a:t>
+              <a:t>Evidence history</a:t>
             </a:r>
           </a:p>
         </p:txBody>
@@ -12503,6 +12607,7 @@
           <a:lstStyle xmlns:a="http://schemas.openxmlformats.org/drawingml/2006/main"/>
           <a:p xmlns:a="http://schemas.openxmlformats.org/drawingml/2006/main">
             <a:pPr algn="l">
+              <a:buNone/>
               <a:defRPr sz="1275" b="1">
                 <a:solidFill>
                   <a:srgbClr val="6F6D6B"/>
@@ -12743,6 +12848,7 @@
           <a:lstStyle xmlns:a="http://schemas.openxmlformats.org/drawingml/2006/main"/>
           <a:p xmlns:a="http://schemas.openxmlformats.org/drawingml/2006/main">
             <a:pPr algn="l">
+              <a:buNone/>
               <a:defRPr sz="1275" b="1">
                 <a:solidFill>
                   <a:srgbClr val="6F6D6B"/>
@@ -12823,7 +12929,7 @@
                 <a:ea typeface="Courier New"/>
                 <a:cs typeface="Courier New"/>
               </a:rPr>
-              <a:t>SELF-SERVICE</a:t>
+              <a:t>LOCATION DECISIONS</a:t>
             </a:r>
           </a:p>
         </p:txBody>
@@ -12983,6 +13089,7 @@
           <a:lstStyle xmlns:a="http://schemas.openxmlformats.org/drawingml/2006/main"/>
           <a:p xmlns:a="http://schemas.openxmlformats.org/drawingml/2006/main">
             <a:pPr algn="l">
+              <a:buNone/>
               <a:defRPr sz="975" b="1">
                 <a:solidFill>
                   <a:srgbClr val="FF5B22"/>
@@ -13103,6 +13210,7 @@
           <a:lstStyle xmlns:a="http://schemas.openxmlformats.org/drawingml/2006/main"/>
           <a:p xmlns:a="http://schemas.openxmlformats.org/drawingml/2006/main">
             <a:pPr algn="l">
+              <a:buNone/>
               <a:defRPr sz="1200" b="0">
                 <a:solidFill>
                   <a:srgbClr val="6F6D6B"/>
@@ -13169,28 +13277,25 @@
       </p:sp>
       <p:pic>
         <p:nvPicPr>
-          <p:cNvPr id="67" name=""/>
+          <p:cNvPr id="70" name=""/>
           <p:cNvPicPr>
             <a:picLocks xmlns:a="http://schemas.openxmlformats.org/drawingml/2006/main" noChangeAspect="1"/>
           </p:cNvPicPr>
           <p:nvPr/>
         </p:nvPicPr>
         <p:blipFill>
-          <a:blip xmlns:r="http://schemas.openxmlformats.org/officeDocument/2006/relationships" xmlns:a="http://schemas.openxmlformats.org/drawingml/2006/main" r:embed="R9518fc6a3a624ab9"/>
-          <a:srcRect xmlns:a="http://schemas.openxmlformats.org/drawingml/2006/main" l="59" t="0" r="59" b="0"/>
+          <a:blip xmlns:r="http://schemas.openxmlformats.org/officeDocument/2006/relationships" xmlns:a="http://schemas.openxmlformats.org/drawingml/2006/main" r:embed="Rffebb65fca7d4468"/>
           <a:stretch xmlns:a="http://schemas.openxmlformats.org/drawingml/2006/main">
             <a:fillRect l="0" t="0" r="0" b="0"/>
           </a:stretch>
         </p:blipFill>
         <p:spPr>
-          <a:xfrm xmlns:a="http://schemas.openxmlformats.org/drawingml/2006/main">
+          <a:xfrm xmlns:a="http://schemas.openxmlformats.org/drawingml/2006/main" flipH="0" flipV="0">
             <a:off x="9820275" y="2028825"/>
             <a:ext cx="1657350" cy="3590925"/>
           </a:xfrm>
           <a:prstGeom xmlns:a="http://schemas.openxmlformats.org/drawingml/2006/main" prst="roundRect">
-            <a:avLst>
-              <a:gd name="adj" fmla="val 10345"/>
-            </a:avLst>
+            <a:avLst/>
           </a:prstGeom>
         </p:spPr>
       </p:pic>
@@ -13229,6 +13334,7 @@
           <a:lstStyle xmlns:a="http://schemas.openxmlformats.org/drawingml/2006/main"/>
           <a:p xmlns:a="http://schemas.openxmlformats.org/drawingml/2006/main">
             <a:pPr algn="r">
+              <a:buNone/>
               <a:defRPr sz="975" b="1">
                 <a:solidFill>
                   <a:srgbClr val="FF5B22"/>
@@ -13247,7 +13353,7 @@
                 <a:ea typeface="Courier New"/>
                 <a:cs typeface="Courier New"/>
               </a:rPr>
-              <a:t>SHOULD I OPEN HERE?</a:t>
+              <a:t>WHERE SHOULD I VERIFY NEXT?</a:t>
             </a:r>
           </a:p>
         </p:txBody>
@@ -13349,6 +13455,7 @@
           <a:lstStyle xmlns:a="http://schemas.openxmlformats.org/drawingml/2006/main"/>
           <a:p xmlns:a="http://schemas.openxmlformats.org/drawingml/2006/main">
             <a:pPr algn="l">
+              <a:buNone/>
               <a:defRPr sz="1050" b="1">
                 <a:solidFill>
                   <a:srgbClr val="FF5B22"/>
@@ -13407,6 +13514,7 @@
           <a:lstStyle xmlns:a="http://schemas.openxmlformats.org/drawingml/2006/main"/>
           <a:p xmlns:a="http://schemas.openxmlformats.org/drawingml/2006/main">
             <a:pPr algn="r">
+              <a:buNone/>
               <a:defRPr sz="975" b="0">
                 <a:solidFill>
                   <a:srgbClr val="6F6D6B"/>
@@ -13463,17 +13571,17 @@
       </p:sp>
       <p:pic>
         <p:nvPicPr>
-          <p:cNvPr id="36" name=""/>
+          <p:cNvPr id="38" name=""/>
           <p:cNvPicPr>
             <a:picLocks xmlns:a="http://schemas.openxmlformats.org/drawingml/2006/main" noChangeAspect="1"/>
           </p:cNvPicPr>
           <p:nvPr/>
         </p:nvPicPr>
         <p:blipFill>
-          <a:blip xmlns:r="http://schemas.openxmlformats.org/officeDocument/2006/relationships" xmlns:a="http://schemas.openxmlformats.org/drawingml/2006/main" r:embed="R9e7a5ac9051a429c">
+          <a:blip xmlns:r="http://schemas.openxmlformats.org/officeDocument/2006/relationships" xmlns:a="http://schemas.openxmlformats.org/drawingml/2006/main" r:embed="Rc4886e056f7642ce">
             <a:extLst>
               <a:ext uri="{96DAC541-7B7A-43D3-8B79-37D633B846F1}">
-                <asvg:svgBlip xmlns:asvg="http://schemas.microsoft.com/office/drawing/2016/SVG/main" r:embed="R2ff964514e6745a9"/>
+                <asvg:svgBlip xmlns:asvg="http://schemas.microsoft.com/office/drawing/2016/SVG/main" r:embed="R2c2a939ad5db42a6"/>
               </a:ext>
             </a:extLst>
           </a:blip>
@@ -13524,6 +13632,7 @@
           <a:lstStyle xmlns:a="http://schemas.openxmlformats.org/drawingml/2006/main"/>
           <a:p xmlns:a="http://schemas.openxmlformats.org/drawingml/2006/main">
             <a:pPr algn="l">
+              <a:buNone/>
               <a:defRPr sz="750" b="1">
                 <a:solidFill>
                   <a:srgbClr val="6F6D6B"/>
@@ -13582,6 +13691,7 @@
           <a:lstStyle xmlns:a="http://schemas.openxmlformats.org/drawingml/2006/main"/>
           <a:p xmlns:a="http://schemas.openxmlformats.org/drawingml/2006/main">
             <a:pPr algn="r">
+              <a:buNone/>
               <a:defRPr sz="750" b="1">
                 <a:solidFill>
                   <a:srgbClr val="6F6D6B"/>
@@ -13697,11 +13807,12 @@
         </p:spPr>
         <p:txBody>
           <a:bodyPr xmlns:a="http://schemas.openxmlformats.org/drawingml/2006/main" wrap="square" lIns="0" tIns="0" rIns="0" bIns="0" anchor="t">
-            <a:normAutofit fontScale="100000"/>
+            <a:normAutofit fontScale="98893"/>
           </a:bodyPr>
           <a:lstStyle xmlns:a="http://schemas.openxmlformats.org/drawingml/2006/main"/>
           <a:p xmlns:a="http://schemas.openxmlformats.org/drawingml/2006/main">
             <a:pPr algn="l">
+              <a:buNone/>
               <a:defRPr sz="1650" b="0">
                 <a:solidFill>
                   <a:srgbClr val="A6A3A0"/>
@@ -13720,7 +13831,7 @@
                 <a:ea typeface="Arial"/>
                 <a:cs typeface="Arial"/>
               </a:rPr>
-              <a:t>The next round of evidence is commercial, not theatrical.</a:t>
+              <a:t>The next evidence must come from authorized real work, not a staged result.</a:t>
             </a:r>
           </a:p>
         </p:txBody>
@@ -13824,6 +13935,7 @@
           <a:lstStyle xmlns:a="http://schemas.openxmlformats.org/drawingml/2006/main"/>
           <a:p xmlns:a="http://schemas.openxmlformats.org/drawingml/2006/main">
             <a:pPr algn="l">
+              <a:buNone/>
               <a:defRPr sz="1050" b="1">
                 <a:solidFill>
                   <a:srgbClr val="FF5B22"/>
@@ -13882,6 +13994,7 @@
           <a:lstStyle xmlns:a="http://schemas.openxmlformats.org/drawingml/2006/main"/>
           <a:p xmlns:a="http://schemas.openxmlformats.org/drawingml/2006/main">
             <a:pPr algn="l">
+              <a:buNone/>
               <a:defRPr sz="900" b="1">
                 <a:solidFill>
                   <a:srgbClr val="FF5B22"/>
@@ -13973,6 +14086,7 @@
           <a:lstStyle xmlns:a="http://schemas.openxmlformats.org/drawingml/2006/main"/>
           <a:p xmlns:a="http://schemas.openxmlformats.org/drawingml/2006/main">
             <a:pPr algn="ctr">
+              <a:buNone/>
               <a:defRPr sz="1050" b="1">
                 <a:solidFill>
                   <a:srgbClr val="F4F3EF"/>
@@ -14031,6 +14145,7 @@
           <a:lstStyle xmlns:a="http://schemas.openxmlformats.org/drawingml/2006/main"/>
           <a:p xmlns:a="http://schemas.openxmlformats.org/drawingml/2006/main">
             <a:pPr algn="ctr">
+              <a:buNone/>
               <a:defRPr sz="900" b="1">
                 <a:solidFill>
                   <a:srgbClr val="6F6D6B"/>
@@ -14122,6 +14237,7 @@
           <a:lstStyle xmlns:a="http://schemas.openxmlformats.org/drawingml/2006/main"/>
           <a:p xmlns:a="http://schemas.openxmlformats.org/drawingml/2006/main">
             <a:pPr algn="ctr">
+              <a:buNone/>
               <a:defRPr sz="1050" b="1">
                 <a:solidFill>
                   <a:srgbClr val="F4F3EF"/>
@@ -14180,6 +14296,7 @@
           <a:lstStyle xmlns:a="http://schemas.openxmlformats.org/drawingml/2006/main"/>
           <a:p xmlns:a="http://schemas.openxmlformats.org/drawingml/2006/main">
             <a:pPr algn="ctr">
+              <a:buNone/>
               <a:defRPr sz="900" b="1">
                 <a:solidFill>
                   <a:srgbClr val="6F6D6B"/>
@@ -14271,6 +14388,7 @@
           <a:lstStyle xmlns:a="http://schemas.openxmlformats.org/drawingml/2006/main"/>
           <a:p xmlns:a="http://schemas.openxmlformats.org/drawingml/2006/main">
             <a:pPr algn="r">
+              <a:buNone/>
               <a:defRPr sz="1050" b="1">
                 <a:solidFill>
                   <a:srgbClr val="F4F3EF"/>
@@ -14329,6 +14447,7 @@
           <a:lstStyle xmlns:a="http://schemas.openxmlformats.org/drawingml/2006/main"/>
           <a:p xmlns:a="http://schemas.openxmlformats.org/drawingml/2006/main">
             <a:pPr algn="r">
+              <a:buNone/>
               <a:defRPr sz="900" b="1">
                 <a:solidFill>
                   <a:srgbClr val="6F6D6B"/>
@@ -14387,6 +14506,7 @@
           <a:lstStyle xmlns:a="http://schemas.openxmlformats.org/drawingml/2006/main"/>
           <a:p xmlns:a="http://schemas.openxmlformats.org/drawingml/2006/main">
             <a:pPr algn="l">
+              <a:buNone/>
               <a:defRPr sz="1050" b="1">
                 <a:solidFill>
                   <a:srgbClr val="FF5B22"/>
@@ -14467,7 +14587,7 @@
                 <a:ea typeface="Arial"/>
                 <a:cs typeface="Arial"/>
               </a:rPr>
-              <a:t>•  Reproducible synthetic Morrow Coffee mission</a:t>
+              <a:t>•  Running web + NestJS prototype</a:t>
             </a:r>
           </a:p>
           <a:p xmlns:a="http://schemas.openxmlformats.org/drawingml/2006/main">
@@ -14494,7 +14614,7 @@
                 <a:ea typeface="Arial"/>
                 <a:cs typeface="Arial"/>
               </a:rPr>
-              <a:t>•  Planned aggregate probe quota: 1,024; actual: 5 receipts</a:t>
+              <a:t>•  Four role routes with staged states</a:t>
             </a:r>
           </a:p>
           <a:p xmlns:a="http://schemas.openxmlformats.org/drawingml/2006/main">
@@ -14521,7 +14641,7 @@
                 <a:ea typeface="Arial"/>
                 <a:cs typeface="Arial"/>
               </a:rPr>
-              <a:t>•  Skeptic replay behind a demo interaction gate</a:t>
+              <a:t>•  Manual receipt intake + SHA-256</a:t>
             </a:r>
           </a:p>
           <a:p xmlns:a="http://schemas.openxmlformats.org/drawingml/2006/main">
@@ -14548,7 +14668,7 @@
                 <a:ea typeface="Arial"/>
                 <a:cs typeface="Arial"/>
               </a:rPr>
-              <a:t>•  Prioritized evidence action queue</a:t>
+              <a:t>•  Empty evidence locks conclusions</a:t>
             </a:r>
           </a:p>
         </p:txBody>
@@ -14619,6 +14739,7 @@
           <a:lstStyle xmlns:a="http://schemas.openxmlformats.org/drawingml/2006/main"/>
           <a:p xmlns:a="http://schemas.openxmlformats.org/drawingml/2006/main">
             <a:pPr algn="l">
+              <a:buNone/>
               <a:defRPr sz="1050" b="1">
                 <a:solidFill>
                   <a:srgbClr val="FF5B22"/>
@@ -14699,7 +14820,7 @@
                 <a:ea typeface="Arial"/>
                 <a:cs typeface="Arial"/>
               </a:rPr>
-              <a:t>•  Reproducible synthetic benchmark</a:t>
+              <a:t>•  3 design partners</a:t>
             </a:r>
           </a:p>
           <a:p xmlns:a="http://schemas.openxmlformats.org/drawingml/2006/main">
@@ -14726,7 +14847,7 @@
                 <a:ea typeface="Arial"/>
                 <a:cs typeface="Arial"/>
               </a:rPr>
-              <a:t>•  3 design partners</a:t>
+              <a:t>•  1 paid authorized pilot</a:t>
             </a:r>
           </a:p>
           <a:p xmlns:a="http://schemas.openxmlformats.org/drawingml/2006/main">
@@ -14753,7 +14874,7 @@
                 <a:ea typeface="Arial"/>
                 <a:cs typeface="Arial"/>
               </a:rPr>
-              <a:t>•  1 paid authorized pilot</a:t>
+              <a:t>•  Durable evidence store + authentication</a:t>
             </a:r>
           </a:p>
           <a:p xmlns:a="http://schemas.openxmlformats.org/drawingml/2006/main">
@@ -14855,6 +14976,7 @@
           <a:lstStyle xmlns:a="http://schemas.openxmlformats.org/drawingml/2006/main"/>
           <a:p xmlns:a="http://schemas.openxmlformats.org/drawingml/2006/main">
             <a:pPr algn="l">
+              <a:buNone/>
               <a:defRPr sz="1200" b="1">
                 <a:solidFill>
                   <a:srgbClr val="080809"/>
@@ -14913,6 +15035,7 @@
           <a:lstStyle xmlns:a="http://schemas.openxmlformats.org/drawingml/2006/main"/>
           <a:p xmlns:a="http://schemas.openxmlformats.org/drawingml/2006/main">
             <a:pPr algn="l">
+              <a:buNone/>
               <a:defRPr sz="1350" b="1">
                 <a:solidFill>
                   <a:srgbClr val="080809"/>
@@ -14993,7 +15116,7 @@
                 <a:ea typeface="Arial"/>
                 <a:cs typeface="Arial"/>
               </a:rPr>
-              <a:t>Help us prove decision-changing contradictions with a better evidence trail.</a:t>
+              <a:t>Help us test whether one verified contradiction changes a decision.</a:t>
             </a:r>
           </a:p>
         </p:txBody>

</xml_diff>